<commit_message>
Bench not buildable at 7 deg (Dave's deck review): clearance analysis, the proposed 30-deg node (22.5 the alternative), substrates and a real camera pitch -> BRIEF_ccmac_bench_realism.md; deck revised (35 slides): front-end and interferometer layouts at the proposed geometry, parts tables with substrates and camera, clearance backup slide; slice
Co-Authored-By: Claude Fable 5.1 <noreply@anthropic.com>
</commit_message>
<xml_diff>
--- a/demo_session/deck_gauges.pptx
+++ b/demo_session/deck_gauges.pptx
@@ -39,6 +39,7 @@
     <p:sldId id="287" r:id="rId38"/>
     <p:sldId id="288" r:id="rId39"/>
     <p:sldId id="289" r:id="rId40"/>
+    <p:sldId id="290" r:id="rId41"/>
   </p:sldIdLst>
   <p:sldSz cx="12191695" cy="6858000" type="screen4x3"/>
   <p:notesSz cx="6858000" cy="9144000"/>
@@ -3219,7 +3220,7 @@
                 </a:solidFill>
                 <a:latin typeface="Arial"/>
               </a:rPr>
-              <a:t>DRAFT — pending review.  Every number here comes from a committed run of one shared, parameterized model (MACOS, mmacos); the run tags are on the provenance slide.</a:t>
+              <a:t>DRAFT — pending review.  Every number here comes from a committed run of one shared, parameterized model (MACOS, mmacos); the run tags are on the provenance slide.  Bench geometry under revision (2026-09-15): the record's 7° splitter is not buildable; the layouts show the proposed 30° geometry, and the substrates and camera are being added to the model.</a:t>
             </a:r>
           </a:p>
         </p:txBody>
@@ -3462,7 +3463,7 @@
                 </a:solidFill>
                 <a:latin typeface="Arial"/>
               </a:rPr>
-              <a:t>Drawn by pdi_run from the emitted deck (pdi_layout.png in pdi_dm96); the whole train is on the front-end slide.</a:t>
+              <a:t>Drawn by pdi_run from the emitted deck (pdi_layout.png in pdi_dm96); the whole train is on the front-end slide.  The pinhole plate is drawn as a surface and the camera as a plane; the next model round draws the 2-3 mm substrate and the 13 mm sensor.</a:t>
             </a:r>
           </a:p>
         </p:txBody>
@@ -15872,7 +15873,7 @@
                 </a:solidFill>
                 <a:latin typeface="Arial"/>
               </a:rPr>
-              <a:t>Everything shares the front end: a filtered HeNe, a collimator, a 7° plate splitter, a 700 mm leg to the mirror, a focuser to an internal focus, a field lens to a camera at the pupil image</a:t>
+              <a:t>Everything shares the front end: a filtered HeNe, a collimator, a plate splitter at 30°, a 700 mm leg to the mirror, a focuser to an internal focus, a field lens to a camera at the pupil image</a:t>
             </a:r>
           </a:p>
         </p:txBody>
@@ -15923,7 +15924,7 @@
       </p:sp>
       <p:pic>
         <p:nvPicPr>
-          <p:cNvPr id="4" name="Picture 3" descr="crop_lens_vlayout_train.png"/>
+          <p:cNvPr id="4" name="Picture 3" descr="crop_bench_bs30_train.png"/>
           <p:cNvPicPr>
             <a:picLocks noChangeAspect="1"/>
           </p:cNvPicPr>
@@ -15937,8 +15938,8 @@
         </p:blipFill>
         <p:spPr>
           <a:xfrm>
-            <a:off x="2841221" y="1298448"/>
-            <a:ext cx="6509251" cy="1617472"/>
+            <a:off x="4302204" y="1298448"/>
+            <a:ext cx="3587286" cy="2183892"/>
           </a:xfrm>
           <a:prstGeom prst="rect">
             <a:avLst/>
@@ -15953,8 +15954,8 @@
         </p:nvSpPr>
         <p:spPr>
           <a:xfrm>
-            <a:off x="411480" y="2934208"/>
-            <a:ext cx="11368735" cy="394208"/>
+            <a:off x="411480" y="3500628"/>
+            <a:ext cx="11368735" cy="559307"/>
           </a:xfrm>
           <a:prstGeom prst="rect">
             <a:avLst/>
@@ -15979,7 +15980,7 @@
                 </a:solidFill>
                 <a:latin typeface="Arial"/>
               </a:rPr>
-              <a:t>The shared front end as traced by the engine, seen from above: source at left, collimator L1, the 7° plate splitter, the 96 mm mirror on its 700 mm leg (blue), the reference arm and its flat (orange, the interferometer only), the focuser L2 toward the internal focus.  The mask seat at that focus is where the four sensing methods differ.</a:t>
+              <a:t>The shared front end as traced by the engine, seen from above, at the proposed 30° splitter: source at left, collimator L1, the splitter, the 96 mm mirror on its 700 mm leg (blue), the reference arm and its flat (orange, the interferometer only), the focuser L2 toward the internal focus.  The mask seat at that focus is where the four sensing methods differ.</a:t>
             </a:r>
           </a:p>
         </p:txBody>
@@ -15993,8 +15994,8 @@
           <p:nvPr/>
         </p:nvGraphicFramePr>
         <p:xfrm>
-          <a:off x="411480" y="3364992"/>
-          <a:ext cx="5806439" cy="1400175"/>
+          <a:off x="411480" y="4096512"/>
+          <a:ext cx="5806439" cy="1965960"/>
         </p:xfrm>
         <a:graphic>
           <a:graphicData uri="http://schemas.openxmlformats.org/drawingml/2006/table">
@@ -16003,8 +16004,8 @@
                 <a:tableStyleId>{5C22544A-7EE6-4342-B048-85BDC9FD1C3A}</a:tableStyleId>
               </a:tblPr>
               <a:tblGrid>
-                <a:gridCol w="1281941"/>
-                <a:gridCol w="4524498"/>
+                <a:gridCol w="796044"/>
+                <a:gridCol w="5010395"/>
               </a:tblGrid>
               <a:tr h="280035">
                 <a:tc>
@@ -16098,7 +16099,7 @@
                   </a:tcPr>
                 </a:tc>
               </a:tr>
-              <a:tr h="280035">
+              <a:tr h="468630">
                 <a:tc>
                   <a:txBody>
                     <a:bodyPr wrap="square"/>
@@ -16144,7 +16145,7 @@
                   </a:tcPr>
                 </a:tc>
               </a:tr>
-              <a:tr h="280035">
+              <a:tr h="468630">
                 <a:tc>
                   <a:txBody>
                     <a:bodyPr wrap="square"/>
@@ -16179,7 +16180,7 @@
                           </a:solidFill>
                           <a:latin typeface="Arial"/>
                         </a:rPr>
-                        <a:t>7° incidence, 2.6 mm thick, 50/50; compensator plate matched</a:t>
+                        <a:t>30° incidence (proposed; the record's 7° does not clear the node), 2.6 mm thick, 50/50; compensator matched</a:t>
                       </a:r>
                     </a:p>
                   </a:txBody>
@@ -16190,7 +16191,7 @@
                   </a:tcPr>
                 </a:tc>
               </a:tr>
-              <a:tr h="280035">
+              <a:tr h="468630">
                 <a:tc>
                   <a:txBody>
                     <a:bodyPr wrap="square"/>
@@ -16249,8 +16250,8 @@
           <p:nvPr/>
         </p:nvGraphicFramePr>
         <p:xfrm>
-          <a:off x="6400800" y="3364992"/>
-          <a:ext cx="5394960" cy="1314450"/>
+          <a:off x="6400800" y="4096512"/>
+          <a:ext cx="5394960" cy="1485900"/>
         </p:xfrm>
         <a:graphic>
           <a:graphicData uri="http://schemas.openxmlformats.org/drawingml/2006/table">
@@ -16400,7 +16401,7 @@
                   </a:tcPr>
                 </a:tc>
               </a:tr>
-              <a:tr h="262890">
+              <a:tr h="434340">
                 <a:tc>
                   <a:txBody>
                     <a:bodyPr wrap="square"/>
@@ -16435,7 +16436,7 @@
                           </a:solidFill>
                           <a:latin typeface="Arial"/>
                         </a:rPr>
-                        <a:t>385 pixels across the pupil (1 Mpix class), 5 pixels per actuator</a:t>
+                        <a:t>pupil image 9.4 mm: a 6.5 µm sCMOS puts 1450 pixels across it, binned 4 to the modeled 385 (5 per actuator)</a:t>
                       </a:r>
                     </a:p>
                   </a:txBody>
@@ -16504,7 +16505,7 @@
         </p:nvSpPr>
         <p:spPr>
           <a:xfrm>
-            <a:off x="6400800" y="4825746"/>
+            <a:off x="6400800" y="5728716"/>
             <a:ext cx="5394960" cy="274320"/>
           </a:xfrm>
           <a:prstGeom prst="rect">
@@ -16530,7 +16531,7 @@
                 </a:solidFill>
                 <a:latin typeface="Arial"/>
               </a:rPr>
-              <a:t>The reference arm (a 103 mm flat on a piezo stage, 564 mm leg) is the interferometer's; shuttered, the same bench is every other sensor.  Lenses, not off-axis mirrors: the choice is priced on the lenses-versus-mirrors slide.</a:t>
+              <a:t>The reference arm (a 103 mm flat on a piezo stage, 564 mm leg) is the interferometer's; shuttered, the same bench is every other sensor.  Lenses, not off-axis mirrors: the choice is priced on the lenses-versus-mirrors slide.  Why 30°: the backup slide on clearance.</a:t>
             </a:r>
           </a:p>
         </p:txBody>
@@ -19456,7 +19457,7 @@
                 </a:solidFill>
                 <a:latin typeface="Arial"/>
               </a:rPr>
-              <a:t>Backup: provenance</a:t>
+              <a:t>Backup: why the splitter moves from 7° to 30°</a:t>
             </a:r>
           </a:p>
           <a:p>
@@ -19472,7 +19473,7 @@
                 </a:solidFill>
                 <a:latin typeface="Arial"/>
               </a:rPr>
-              <a:t>Every number in this deck has a run tag in a committed run directory of the shared model; the three lane reports carry the full tables</a:t>
+              <a:t>The record's clearance solve cleared the mirror, flat and camera bodies at the leg ends and never looked at the node; two 103 mm beams 2θ apart clear a part at distance d only if d·sin 2θ exceeds about 111 mm</a:t>
             </a:r>
           </a:p>
         </p:txBody>
@@ -19521,6 +19522,710 @@
           </a:p>
         </p:txBody>
       </p:sp>
+      <p:graphicFrame>
+        <p:nvGraphicFramePr>
+          <p:cNvPr id="4" name="Table 3"/>
+          <p:cNvGraphicFramePr>
+            <a:graphicFrameLocks noGrp="1"/>
+          </p:cNvGraphicFramePr>
+          <p:nvPr/>
+        </p:nvGraphicFramePr>
+        <p:xfrm>
+          <a:off x="411480" y="1298448"/>
+          <a:ext cx="5806439" cy="2154555"/>
+        </p:xfrm>
+        <a:graphic>
+          <a:graphicData uri="http://schemas.openxmlformats.org/drawingml/2006/table">
+            <a:tbl>
+              <a:tblPr firstRow="1" bandRow="1">
+                <a:tableStyleId>{5C22544A-7EE6-4342-B048-85BDC9FD1C3A}</a:tableStyleId>
+              </a:tblPr>
+              <a:tblGrid>
+                <a:gridCol w="1235964"/>
+                <a:gridCol w="862353"/>
+                <a:gridCol w="3708122"/>
+              </a:tblGrid>
+              <a:tr h="280035">
+                <a:tc>
+                  <a:txBody>
+                    <a:bodyPr wrap="square"/>
+                    <a:lstStyle/>
+                    <a:p>
+                      <a:r>
+                        <a:rPr sz="1100" b="1">
+                          <a:solidFill>
+                            <a:srgbClr val="FFFFFF"/>
+                          </a:solidFill>
+                          <a:latin typeface="Arial"/>
+                        </a:rPr>
+                        <a:t>splitter</a:t>
+                      </a:r>
+                    </a:p>
+                  </a:txBody>
+                  <a:tcPr marL="54864" marR="54864" marT="18288" marB="18288">
+                    <a:solidFill>
+                      <a:srgbClr val="1F4E79"/>
+                    </a:solidFill>
+                  </a:tcPr>
+                </a:tc>
+                <a:tc>
+                  <a:txBody>
+                    <a:bodyPr wrap="square"/>
+                    <a:lstStyle/>
+                    <a:p>
+                      <a:r>
+                        <a:rPr sz="1100" b="1">
+                          <a:solidFill>
+                            <a:srgbClr val="FFFFFF"/>
+                          </a:solidFill>
+                          <a:latin typeface="Arial"/>
+                        </a:rPr>
+                        <a:t>worst part</a:t>
+                      </a:r>
+                    </a:p>
+                  </a:txBody>
+                  <a:tcPr marL="54864" marR="54864" marT="18288" marB="18288">
+                    <a:solidFill>
+                      <a:srgbClr val="1F4E79"/>
+                    </a:solidFill>
+                  </a:tcPr>
+                </a:tc>
+                <a:tc>
+                  <a:txBody>
+                    <a:bodyPr wrap="square"/>
+                    <a:lstStyle/>
+                    <a:p>
+                      <a:r>
+                        <a:rPr sz="1100" b="1">
+                          <a:solidFill>
+                            <a:srgbClr val="FFFFFF"/>
+                          </a:solidFill>
+                          <a:latin typeface="Arial"/>
+                        </a:rPr>
+                        <a:t>others</a:t>
+                      </a:r>
+                    </a:p>
+                  </a:txBody>
+                  <a:tcPr marL="54864" marR="54864" marT="18288" marB="18288">
+                    <a:solidFill>
+                      <a:srgbClr val="1F4E79"/>
+                    </a:solidFill>
+                  </a:tcPr>
+                </a:tc>
+              </a:tr>
+              <a:tr h="468630">
+                <a:tc>
+                  <a:txBody>
+                    <a:bodyPr wrap="square"/>
+                    <a:lstStyle/>
+                    <a:p>
+                      <a:r>
+                        <a:rPr sz="1100" b="0">
+                          <a:solidFill>
+                            <a:srgbClr val="282828"/>
+                          </a:solidFill>
+                          <a:latin typeface="Arial"/>
+                        </a:rPr>
+                        <a:t>7° (the record)</a:t>
+                      </a:r>
+                    </a:p>
+                  </a:txBody>
+                  <a:tcPr marL="54864" marR="54864" marT="18288" marB="18288">
+                    <a:solidFill>
+                      <a:srgbClr val="FFFFFF"/>
+                    </a:solidFill>
+                  </a:tcPr>
+                </a:tc>
+                <a:tc>
+                  <a:txBody>
+                    <a:bodyPr wrap="square"/>
+                    <a:lstStyle/>
+                    <a:p>
+                      <a:r>
+                        <a:rPr sz="1100" b="0">
+                          <a:solidFill>
+                            <a:srgbClr val="282828"/>
+                          </a:solidFill>
+                          <a:latin typeface="Arial"/>
+                        </a:rPr>
+                        <a:t>output plate −109 mm</a:t>
+                      </a:r>
+                    </a:p>
+                  </a:txBody>
+                  <a:tcPr marL="54864" marR="54864" marT="18288" marB="18288">
+                    <a:solidFill>
+                      <a:srgbClr val="FFFFFF"/>
+                    </a:solidFill>
+                  </a:tcPr>
+                </a:tc>
+                <a:tc>
+                  <a:txBody>
+                    <a:bodyPr wrap="square"/>
+                    <a:lstStyle/>
+                    <a:p>
+                      <a:r>
+                        <a:rPr sz="1100" b="0">
+                          <a:solidFill>
+                            <a:srgbClr val="282828"/>
+                          </a:solidFill>
+                          <a:latin typeface="Arial"/>
+                        </a:rPr>
+                        <a:t>eight parts in another beam: reference plate, analyzer, compensator, L2, polarizer, L1</a:t>
+                      </a:r>
+                    </a:p>
+                  </a:txBody>
+                  <a:tcPr marL="54864" marR="54864" marT="18288" marB="18288">
+                    <a:solidFill>
+                      <a:srgbClr val="FFFFFF"/>
+                    </a:solidFill>
+                  </a:tcPr>
+                </a:tc>
+              </a:tr>
+              <a:tr h="468630">
+                <a:tc>
+                  <a:txBody>
+                    <a:bodyPr wrap="square"/>
+                    <a:lstStyle/>
+                    <a:p>
+                      <a:r>
+                        <a:rPr sz="1100" b="0">
+                          <a:solidFill>
+                            <a:srgbClr val="282828"/>
+                          </a:solidFill>
+                          <a:latin typeface="Arial"/>
+                        </a:rPr>
+                        <a:t>15°</a:t>
+                      </a:r>
+                    </a:p>
+                  </a:txBody>
+                  <a:tcPr marL="54864" marR="54864" marT="18288" marB="18288">
+                    <a:solidFill>
+                      <a:srgbClr val="ECF1F6"/>
+                    </a:solidFill>
+                  </a:tcPr>
+                </a:tc>
+                <a:tc>
+                  <a:txBody>
+                    <a:bodyPr wrap="square"/>
+                    <a:lstStyle/>
+                    <a:p>
+                      <a:r>
+                        <a:rPr sz="1100" b="0">
+                          <a:solidFill>
+                            <a:srgbClr val="282828"/>
+                          </a:solidFill>
+                          <a:latin typeface="Arial"/>
+                        </a:rPr>
+                        <a:t>compensator −27 mm</a:t>
+                      </a:r>
+                    </a:p>
+                  </a:txBody>
+                  <a:tcPr marL="54864" marR="54864" marT="18288" marB="18288">
+                    <a:solidFill>
+                      <a:srgbClr val="ECF1F6"/>
+                    </a:solidFill>
+                  </a:tcPr>
+                </a:tc>
+                <a:tc>
+                  <a:txBody>
+                    <a:bodyPr wrap="square"/>
+                    <a:lstStyle/>
+                    <a:p>
+                      <a:r>
+                        <a:rPr sz="1100" b="0">
+                          <a:solidFill>
+                            <a:srgbClr val="282828"/>
+                          </a:solidFill>
+                          <a:latin typeface="Arial"/>
+                        </a:rPr>
+                        <a:t>output plate −17, analyzer −11, L2 +10</a:t>
+                      </a:r>
+                    </a:p>
+                  </a:txBody>
+                  <a:tcPr marL="54864" marR="54864" marT="18288" marB="18288">
+                    <a:solidFill>
+                      <a:srgbClr val="ECF1F6"/>
+                    </a:solidFill>
+                  </a:tcPr>
+                </a:tc>
+              </a:tr>
+              <a:tr h="468630">
+                <a:tc>
+                  <a:txBody>
+                    <a:bodyPr wrap="square"/>
+                    <a:lstStyle/>
+                    <a:p>
+                      <a:r>
+                        <a:rPr sz="1100" b="0">
+                          <a:solidFill>
+                            <a:srgbClr val="282828"/>
+                          </a:solidFill>
+                          <a:latin typeface="Arial"/>
+                        </a:rPr>
+                        <a:t>22.5°</a:t>
+                      </a:r>
+                    </a:p>
+                  </a:txBody>
+                  <a:tcPr marL="54864" marR="54864" marT="18288" marB="18288">
+                    <a:solidFill>
+                      <a:srgbClr val="FFFFFF"/>
+                    </a:solidFill>
+                  </a:tcPr>
+                </a:tc>
+                <a:tc>
+                  <a:txBody>
+                    <a:bodyPr wrap="square"/>
+                    <a:lstStyle/>
+                    <a:p>
+                      <a:r>
+                        <a:rPr sz="1100" b="0">
+                          <a:solidFill>
+                            <a:srgbClr val="282828"/>
+                          </a:solidFill>
+                          <a:latin typeface="Arial"/>
+                        </a:rPr>
+                        <a:t>compensator +16 mm</a:t>
+                      </a:r>
+                    </a:p>
+                  </a:txBody>
+                  <a:tcPr marL="54864" marR="54864" marT="18288" marB="18288">
+                    <a:solidFill>
+                      <a:srgbClr val="FFFFFF"/>
+                    </a:solidFill>
+                  </a:tcPr>
+                </a:tc>
+                <a:tc>
+                  <a:txBody>
+                    <a:bodyPr wrap="square"/>
+                    <a:lstStyle/>
+                    <a:p>
+                      <a:r>
+                        <a:rPr sz="1100" b="0">
+                          <a:solidFill>
+                            <a:srgbClr val="282828"/>
+                          </a:solidFill>
+                          <a:latin typeface="Arial"/>
+                        </a:rPr>
+                        <a:t>output plate +55, analyzer +65, L2 +100, L1 +153</a:t>
+                      </a:r>
+                    </a:p>
+                  </a:txBody>
+                  <a:tcPr marL="54864" marR="54864" marT="18288" marB="18288">
+                    <a:solidFill>
+                      <a:srgbClr val="FFFFFF"/>
+                    </a:solidFill>
+                  </a:tcPr>
+                </a:tc>
+              </a:tr>
+              <a:tr h="468630">
+                <a:tc>
+                  <a:txBody>
+                    <a:bodyPr wrap="square"/>
+                    <a:lstStyle/>
+                    <a:p>
+                      <a:r>
+                        <a:rPr sz="1100" b="0">
+                          <a:solidFill>
+                            <a:srgbClr val="282828"/>
+                          </a:solidFill>
+                          <a:latin typeface="Arial"/>
+                        </a:rPr>
+                        <a:t>30°</a:t>
+                      </a:r>
+                    </a:p>
+                  </a:txBody>
+                  <a:tcPr marL="54864" marR="54864" marT="18288" marB="18288">
+                    <a:solidFill>
+                      <a:srgbClr val="ECF1F6"/>
+                    </a:solidFill>
+                  </a:tcPr>
+                </a:tc>
+                <a:tc>
+                  <a:txBody>
+                    <a:bodyPr wrap="square"/>
+                    <a:lstStyle/>
+                    <a:p>
+                      <a:r>
+                        <a:rPr sz="1100" b="0">
+                          <a:solidFill>
+                            <a:srgbClr val="282828"/>
+                          </a:solidFill>
+                          <a:latin typeface="Arial"/>
+                        </a:rPr>
+                        <a:t>compensator +57 mm</a:t>
+                      </a:r>
+                    </a:p>
+                  </a:txBody>
+                  <a:tcPr marL="54864" marR="54864" marT="18288" marB="18288">
+                    <a:solidFill>
+                      <a:srgbClr val="ECF1F6"/>
+                    </a:solidFill>
+                  </a:tcPr>
+                </a:tc>
+                <a:tc>
+                  <a:txBody>
+                    <a:bodyPr wrap="square"/>
+                    <a:lstStyle/>
+                    <a:p>
+                      <a:r>
+                        <a:rPr sz="1100" b="0">
+                          <a:solidFill>
+                            <a:srgbClr val="282828"/>
+                          </a:solidFill>
+                          <a:latin typeface="Arial"/>
+                        </a:rPr>
+                        <a:t>output plate +178, analyzer +196, L2 +257, L1 +350</a:t>
+                      </a:r>
+                    </a:p>
+                  </a:txBody>
+                  <a:tcPr marL="54864" marR="54864" marT="18288" marB="18288">
+                    <a:solidFill>
+                      <a:srgbClr val="ECF1F6"/>
+                    </a:solidFill>
+                  </a:tcPr>
+                </a:tc>
+              </a:tr>
+            </a:tbl>
+          </a:graphicData>
+        </a:graphic>
+      </p:graphicFrame>
+      <p:sp>
+        <p:nvSpPr>
+          <p:cNvPr id="5" name="TextBox 4"/>
+          <p:cNvSpPr txBox="1"/>
+          <p:nvPr/>
+        </p:nvSpPr>
+        <p:spPr>
+          <a:xfrm>
+            <a:off x="411480" y="3599307"/>
+            <a:ext cx="5806440" cy="274320"/>
+          </a:xfrm>
+          <a:prstGeom prst="rect">
+            <a:avLst/>
+          </a:prstGeom>
+          <a:noFill/>
+        </p:spPr>
+        <p:txBody>
+          <a:bodyPr wrap="square">
+            <a:spAutoFit/>
+          </a:bodyPr>
+          <a:lstStyle/>
+          <a:p>
+            <a:pPr>
+              <a:spcAft>
+                <a:spcPts val="600"/>
+              </a:spcAft>
+            </a:pPr>
+            <a:r>
+              <a:rPr sz="1200" b="0">
+                <a:solidFill>
+                  <a:srgbClr val="282828"/>
+                </a:solidFill>
+                <a:latin typeface="Arial"/>
+              </a:rPr>
+              <a:t>•  What moves: the output plate and analyzer from 17 and 27 mm behind the splitter to 160 and 170 mm, just ahead of the focuser at 207 mm; nothing else, so the tuned tail is untouched.</a:t>
+            </a:r>
+          </a:p>
+          <a:p>
+            <a:pPr>
+              <a:spcAft>
+                <a:spcPts val="600"/>
+              </a:spcAft>
+            </a:pPr>
+            <a:r>
+              <a:rPr sz="1200" b="0">
+                <a:solidFill>
+                  <a:srgbClr val="282828"/>
+                </a:solidFill>
+                <a:latin typeface="Arial"/>
+              </a:rPr>
+              <a:t>•  What it costs the sensors: nothing.  At 30° the Zernike rows reproduce (0.9943 / 5 pm against 0.9942 / 5), the mask gates pass, and the arm's channel phase difference is 1.69 mrad against 1.63; the plate's diattenuation rises to 10% but uniformly, a non-term with the laser on its eigenaxis.</a:t>
+            </a:r>
+          </a:p>
+        </p:txBody>
+      </p:sp>
+      <p:pic>
+        <p:nvPicPr>
+          <p:cNvPr id="6" name="Picture 5" descr="crop_bench_bs22_node.png"/>
+          <p:cNvPicPr>
+            <a:picLocks noChangeAspect="1"/>
+          </p:cNvPicPr>
+          <p:nvPr/>
+        </p:nvPicPr>
+        <p:blipFill>
+          <a:blip r:embed="rId2"/>
+          <a:stretch>
+            <a:fillRect/>
+          </a:stretch>
+        </p:blipFill>
+        <p:spPr>
+          <a:xfrm>
+            <a:off x="7496678" y="1298448"/>
+            <a:ext cx="3203203" cy="1965451"/>
+          </a:xfrm>
+          <a:prstGeom prst="rect">
+            <a:avLst/>
+          </a:prstGeom>
+        </p:spPr>
+      </p:pic>
+      <p:sp>
+        <p:nvSpPr>
+          <p:cNvPr id="7" name="TextBox 6"/>
+          <p:cNvSpPr txBox="1"/>
+          <p:nvPr/>
+        </p:nvSpPr>
+        <p:spPr>
+          <a:xfrm>
+            <a:off x="6400800" y="3282188"/>
+            <a:ext cx="5394960" cy="229107"/>
+          </a:xfrm>
+          <a:prstGeom prst="rect">
+            <a:avLst/>
+          </a:prstGeom>
+          <a:noFill/>
+        </p:spPr>
+        <p:txBody>
+          <a:bodyPr wrap="square">
+            <a:spAutoFit/>
+          </a:bodyPr>
+          <a:lstStyle/>
+          <a:p>
+            <a:pPr algn="ctr">
+              <a:spcAft>
+                <a:spcPts val="0"/>
+              </a:spcAft>
+            </a:pPr>
+            <a:r>
+              <a:rPr sz="1000" b="0">
+                <a:solidFill>
+                  <a:srgbClr val="6E6E6E"/>
+                </a:solidFill>
+                <a:latin typeface="Arial"/>
+              </a:rPr>
+              <a:t>The node at 22.5°, the alternative: every part clears, the compensator by 16 mm.</a:t>
+            </a:r>
+          </a:p>
+        </p:txBody>
+      </p:sp>
+      <p:pic>
+        <p:nvPicPr>
+          <p:cNvPr id="8" name="Picture 7" descr="crop_bench_bs7_node.png"/>
+          <p:cNvPicPr>
+            <a:picLocks noChangeAspect="1"/>
+          </p:cNvPicPr>
+          <p:nvPr/>
+        </p:nvPicPr>
+        <p:blipFill>
+          <a:blip r:embed="rId3"/>
+          <a:stretch>
+            <a:fillRect/>
+          </a:stretch>
+        </p:blipFill>
+        <p:spPr>
+          <a:xfrm>
+            <a:off x="7414234" y="3547872"/>
+            <a:ext cx="3368090" cy="1965451"/>
+          </a:xfrm>
+          <a:prstGeom prst="rect">
+            <a:avLst/>
+          </a:prstGeom>
+        </p:spPr>
+      </p:pic>
+      <p:sp>
+        <p:nvSpPr>
+          <p:cNvPr id="9" name="TextBox 8"/>
+          <p:cNvSpPr txBox="1"/>
+          <p:nvPr/>
+        </p:nvSpPr>
+        <p:spPr>
+          <a:xfrm>
+            <a:off x="6400800" y="5531611"/>
+            <a:ext cx="5394960" cy="229107"/>
+          </a:xfrm>
+          <a:prstGeom prst="rect">
+            <a:avLst/>
+          </a:prstGeom>
+          <a:noFill/>
+        </p:spPr>
+        <p:txBody>
+          <a:bodyPr wrap="square">
+            <a:spAutoFit/>
+          </a:bodyPr>
+          <a:lstStyle/>
+          <a:p>
+            <a:pPr algn="ctr">
+              <a:spcAft>
+                <a:spcPts val="0"/>
+              </a:spcAft>
+            </a:pPr>
+            <a:r>
+              <a:rPr sz="1000" b="0">
+                <a:solidFill>
+                  <a:srgbClr val="6E6E6E"/>
+                </a:solidFill>
+                <a:latin typeface="Arial"/>
+              </a:rPr>
+              <a:t>The record's node at 7°: eight parts sit in another beam.</a:t>
+            </a:r>
+          </a:p>
+        </p:txBody>
+      </p:sp>
+      <p:sp>
+        <p:nvSpPr>
+          <p:cNvPr id="10" name="TextBox 9"/>
+          <p:cNvSpPr txBox="1"/>
+          <p:nvPr/>
+        </p:nvSpPr>
+        <p:spPr>
+          <a:xfrm>
+            <a:off x="6400800" y="5797295"/>
+            <a:ext cx="5394960" cy="274320"/>
+          </a:xfrm>
+          <a:prstGeom prst="rect">
+            <a:avLst/>
+          </a:prstGeom>
+          <a:noFill/>
+        </p:spPr>
+        <p:txBody>
+          <a:bodyPr wrap="square">
+            <a:spAutoFit/>
+          </a:bodyPr>
+          <a:lstStyle/>
+          <a:p>
+            <a:pPr>
+              <a:spcAft>
+                <a:spcPts val="600"/>
+              </a:spcAft>
+            </a:pPr>
+            <a:r>
+              <a:rPr sz="1050" b="0">
+                <a:solidFill>
+                  <a:srgbClr val="6E6E6E"/>
+                </a:solidFill>
+                <a:latin typeface="Arial"/>
+              </a:rPr>
+              <a:t>Clearance = lateral distance of a beam's chief where it crosses the part's plane, minus the beam radius (51 mm) and the part's radius plus an 8 mm mount.  Tool dmg_bench_clearance; run tag bs30_dev.  The interferometer's snapshot form feels the angle through the plate's polarization; its numbers re-run at the chosen angle.</a:t>
+            </a:r>
+          </a:p>
+        </p:txBody>
+      </p:sp>
+    </p:spTree>
+  </p:cSld>
+  <p:clrMapOvr>
+    <a:masterClrMapping/>
+  </p:clrMapOvr>
+</p:sld>
+</file>
+
+<file path=ppt/slides/slide35.xml><?xml version="1.0" encoding="utf-8"?>
+<p:sld xmlns:a="http://schemas.openxmlformats.org/drawingml/2006/main" xmlns:p="http://schemas.openxmlformats.org/presentationml/2006/main" xmlns:r="http://schemas.openxmlformats.org/officeDocument/2006/relationships">
+  <p:cSld>
+    <p:spTree>
+      <p:nvGrpSpPr>
+        <p:cNvPr id="1" name=""/>
+        <p:cNvGrpSpPr/>
+        <p:nvPr/>
+      </p:nvGrpSpPr>
+      <p:grpSpPr/>
+      <p:sp>
+        <p:nvSpPr>
+          <p:cNvPr id="2" name="TextBox 1"/>
+          <p:cNvSpPr txBox="1"/>
+          <p:nvPr/>
+        </p:nvSpPr>
+        <p:spPr>
+          <a:xfrm>
+            <a:off x="411480" y="201168"/>
+            <a:ext cx="11368735" cy="914400"/>
+          </a:xfrm>
+          <a:prstGeom prst="rect">
+            <a:avLst/>
+          </a:prstGeom>
+          <a:noFill/>
+        </p:spPr>
+        <p:txBody>
+          <a:bodyPr wrap="square">
+            <a:spAutoFit/>
+          </a:bodyPr>
+          <a:lstStyle/>
+          <a:p>
+            <a:pPr>
+              <a:spcAft>
+                <a:spcPts val="400"/>
+              </a:spcAft>
+            </a:pPr>
+            <a:r>
+              <a:rPr sz="2400" b="1">
+                <a:solidFill>
+                  <a:srgbClr val="1F4E79"/>
+                </a:solidFill>
+                <a:latin typeface="Arial"/>
+              </a:rPr>
+              <a:t>Backup: provenance</a:t>
+            </a:r>
+          </a:p>
+          <a:p>
+            <a:pPr>
+              <a:spcAft>
+                <a:spcPts val="0"/>
+              </a:spcAft>
+            </a:pPr>
+            <a:r>
+              <a:rPr sz="1250" b="0">
+                <a:solidFill>
+                  <a:srgbClr val="6E6E6E"/>
+                </a:solidFill>
+                <a:latin typeface="Arial"/>
+              </a:rPr>
+              <a:t>Every number in this deck has a run tag in a committed run directory of the shared model; the three lane reports carry the full tables</a:t>
+            </a:r>
+          </a:p>
+        </p:txBody>
+      </p:sp>
+      <p:sp>
+        <p:nvSpPr>
+          <p:cNvPr id="3" name="Rectangle 2"/>
+          <p:cNvSpPr/>
+          <p:nvPr/>
+        </p:nvSpPr>
+        <p:spPr>
+          <a:xfrm>
+            <a:off x="411480" y="1133856"/>
+            <a:ext cx="11368735" cy="20320"/>
+          </a:xfrm>
+          <a:prstGeom prst="rect">
+            <a:avLst/>
+          </a:prstGeom>
+          <a:solidFill>
+            <a:srgbClr val="B8C6D4"/>
+          </a:solidFill>
+          <a:ln>
+            <a:noFill/>
+          </a:ln>
+          <a:effectLst/>
+        </p:spPr>
+        <p:style>
+          <a:lnRef idx="1">
+            <a:schemeClr val="accent1"/>
+          </a:lnRef>
+          <a:fillRef idx="3">
+            <a:schemeClr val="accent1"/>
+          </a:fillRef>
+          <a:effectRef idx="2">
+            <a:schemeClr val="accent1"/>
+          </a:effectRef>
+          <a:fontRef idx="minor">
+            <a:schemeClr val="lt1"/>
+          </a:fontRef>
+        </p:style>
+        <p:txBody>
+          <a:bodyPr rtlCol="0" anchor="ctr"/>
+          <a:lstStyle/>
+          <a:p>
+            <a:pPr algn="ctr"/>
+          </a:p>
+        </p:txBody>
+      </p:sp>
       <p:sp>
         <p:nvSpPr>
           <p:cNvPr id="4" name="TextBox 3"/>
@@ -19861,7 +20566,7 @@
         </p:nvGraphicFramePr>
         <p:xfrm>
           <a:off x="6400800" y="1298448"/>
-          <a:ext cx="5394960" cy="1828800"/>
+          <a:ext cx="5394959" cy="1828800"/>
         </p:xfrm>
         <a:graphic>
           <a:graphicData uri="http://schemas.openxmlformats.org/drawingml/2006/table">
@@ -19870,8 +20575,8 @@
                 <a:tableStyleId>{5C22544A-7EE6-4342-B048-85BDC9FD1C3A}</a:tableStyleId>
               </a:tblPr>
               <a:tblGrid>
-                <a:gridCol w="3596640"/>
-                <a:gridCol w="1798320"/>
+                <a:gridCol w="2861415"/>
+                <a:gridCol w="2533544"/>
               </a:tblGrid>
               <a:tr h="262890">
                 <a:tc>
@@ -19919,7 +20624,7 @@
                   </a:tcPr>
                 </a:tc>
               </a:tr>
-              <a:tr h="434340">
+              <a:tr h="262890">
                 <a:tc>
                   <a:txBody>
                     <a:bodyPr wrap="square"/>
@@ -20011,7 +20716,7 @@
                   </a:tcPr>
                 </a:tc>
               </a:tr>
-              <a:tr h="434340">
+              <a:tr h="605790">
                 <a:tc>
                   <a:txBody>
                     <a:bodyPr wrap="square"/>
@@ -20046,7 +20751,7 @@
                           </a:solidFill>
                           <a:latin typeface="Arial"/>
                         </a:rPr>
-                        <a:t>zero-order plates; azimuths 45 / 0 / 45 / 0 / 0°</a:t>
+                        <a:t>zero-order plates on 2-3 mm substrates (to be modeled); azimuths 45 / 0 / 45 / 0 / 0°</a:t>
                       </a:r>
                     </a:p>
                   </a:txBody>
@@ -20198,7 +20903,7 @@
                 </a:solidFill>
                 <a:latin typeface="Arial"/>
               </a:rPr>
-              <a:t>Interferometer: the layout</a:t>
+              <a:t>Interferometer: the node, at the proposed 30°</a:t>
             </a:r>
           </a:p>
           <a:p>
@@ -20214,7 +20919,7 @@
                 </a:solidFill>
                 <a:latin typeface="Arial"/>
               </a:rPr>
-              <a:t>The splitter node from above, with the compensator, the recombination, and the snapshot form's polarization optics; the whole train is on the front-end slide</a:t>
+              <a:t>Every part clears every beam it is not in by at least 57 mm: the collimator and input polarizer on the source leg, the compensator on the mirror leg, the output plate and analyzer moved to 160 mm behind the splitter ahead of the focuser</a:t>
             </a:r>
           </a:p>
         </p:txBody>
@@ -20265,7 +20970,7 @@
       </p:sp>
       <p:pic>
         <p:nvPicPr>
-          <p:cNvPr id="4" name="Picture 3" descr="crop_lens_vlayout_node.png"/>
+          <p:cNvPr id="4" name="Picture 3" descr="crop_bench_bs30_node.png"/>
           <p:cNvPicPr>
             <a:picLocks noChangeAspect="1"/>
           </p:cNvPicPr>
@@ -20279,8 +20984,8 @@
         </p:blipFill>
         <p:spPr>
           <a:xfrm>
-            <a:off x="2438406" y="1298448"/>
-            <a:ext cx="7314882" cy="3812032"/>
+            <a:off x="3198559" y="1298448"/>
+            <a:ext cx="5794577" cy="3555492"/>
           </a:xfrm>
           <a:prstGeom prst="rect">
             <a:avLst/>
@@ -20295,8 +21000,8 @@
         </p:nvSpPr>
         <p:spPr>
           <a:xfrm>
-            <a:off x="411480" y="5128767"/>
-            <a:ext cx="11368735" cy="394208"/>
+            <a:off x="411480" y="4872228"/>
+            <a:ext cx="11368735" cy="559307"/>
           </a:xfrm>
           <a:prstGeom prst="rect">
             <a:avLst/>
@@ -20321,7 +21026,7 @@
                 </a:solidFill>
                 <a:latin typeface="Arial"/>
               </a:rPr>
-              <a:t>The reference arm's node, from above, as traced: the input polarizer, the plate splitter and its compensator, the recombination, the output quarter-wave plate and analyzer (snapshot form); test arm blue, reference arm orange.  Axes in bench millimeters.</a:t>
+              <a:t>The splitter node from above, as traced at 30°, ±320 mm about the splitter: L1 and the input polarizer, the splitter, the compensator on the mirror leg, the output quarter-wave plate and analyzer just ahead of the focuser L2; test arm blue, reference arm orange.  The two "QWP" labels at the node mark builder placements; the physical plates sit at the mirror and the flat.</a:t>
             </a:r>
           </a:p>
         </p:txBody>
@@ -20334,7 +21039,7 @@
         </p:nvSpPr>
         <p:spPr>
           <a:xfrm>
-            <a:off x="411480" y="5559551"/>
+            <a:off x="411480" y="5468112"/>
             <a:ext cx="11368735" cy="274320"/>
           </a:xfrm>
           <a:prstGeom prst="rect">
@@ -20360,7 +21065,7 @@
                 </a:solidFill>
                 <a:latin typeface="Arial"/>
               </a:rPr>
-              <a:t>Drawn by tg96_run from the emitted deck (lens_vlayout.png in tg_psi_dm96_oap); the detector tail beyond the focuser is the same as the sensors'.</a:t>
+              <a:t>The plates here (polarizer, quarter-wave plates, analyzer) are drawn as ideal surfaces; the next model round gives each a 2-3 mm substrate, which in these collimated legs adds path only.  Drawn by dmg_bench_clearance.</a:t>
             </a:r>
           </a:p>
         </p:txBody>
@@ -20650,7 +21355,7 @@
                 </a:solidFill>
                 <a:latin typeface="Arial"/>
               </a:rPr>
-              <a:t>Added to the front end: one fused-silica plate with a 3×3 array of etched spots (one in the beam at a time; the 346 nm etch is a quarter wave at 632.8 nm), on a translation stage.  Nothing else.  Run tags matbase, matbase385, loop193.</a:t>
+              <a:t>Added to the front end: one fused-silica plate, 2-3 mm thick, with a 3×3 array of etched spots (one in the beam at a time; the 346 nm etch is a quarter wave at 632.8 nm), on a translation stage.  Nothing else.  The plate's thickness in the F/4.2 beam is 0.03 wave of spherical aberration and a 0.7 mm focus shift the tail absorbs (to be modeled).  Run tags matbase, matbase385, loop193.</a:t>
             </a:r>
           </a:p>
         </p:txBody>
@@ -20853,7 +21558,7 @@
         </p:nvGraphicFramePr>
         <p:xfrm>
           <a:off x="6400800" y="1298448"/>
-          <a:ext cx="5394959" cy="2434590"/>
+          <a:ext cx="5394960" cy="3120390"/>
         </p:xfrm>
         <a:graphic>
           <a:graphicData uri="http://schemas.openxmlformats.org/drawingml/2006/table">
@@ -20862,10 +21567,10 @@
                 <a:tableStyleId>{5C22544A-7EE6-4342-B048-85BDC9FD1C3A}</a:tableStyleId>
               </a:tblPr>
               <a:tblGrid>
-                <a:gridCol w="912993"/>
-                <a:gridCol w="4481966"/>
+                <a:gridCol w="670560"/>
+                <a:gridCol w="4724400"/>
               </a:tblGrid>
-              <a:tr h="434340">
+              <a:tr h="605790">
                 <a:tc>
                   <a:txBody>
                     <a:bodyPr wrap="square"/>
@@ -20957,7 +21662,7 @@
                   </a:tcPr>
                 </a:tc>
               </a:tr>
-              <a:tr h="434340">
+              <a:tr h="605790">
                 <a:tc>
                   <a:txBody>
                     <a:bodyPr wrap="square"/>
@@ -20992,7 +21697,7 @@
                           </a:solidFill>
                           <a:latin typeface="Arial"/>
                         </a:rPr>
-                        <a:t>zero order, fast axis at 45° between the cube's s and p; spec λ/300</a:t>
+                        <a:t>zero order on a 2 mm substrate (0.05 wave of spherical aberration in the F/3.6 leg, to be modeled), fast axis at 45° between the cube's s and p; spec λ/300</a:t>
                       </a:r>
                     </a:p>
                   </a:txBody>
@@ -21049,7 +21754,7 @@
                   </a:tcPr>
                 </a:tc>
               </a:tr>
-              <a:tr h="262890">
+              <a:tr h="434340">
                 <a:tc>
                   <a:txBody>
                     <a:bodyPr wrap="square"/>
@@ -21084,7 +21789,7 @@
                           </a:solidFill>
                           <a:latin typeface="Arial"/>
                         </a:rPr>
-                        <a:t>two, both 20.7 mm behind the cube at the pupil image</a:t>
+                        <a:t>two, both 20.7 mm behind the cube at the 9.4 mm pupil image; a 6.5 µm sCMOS (13 mm sensor) binned 4</a:t>
                       </a:r>
                     </a:p>
                   </a:txBody>
@@ -21095,7 +21800,7 @@
                   </a:tcPr>
                 </a:tc>
               </a:tr>
-              <a:tr h="434340">
+              <a:tr h="605790">
                 <a:tc>
                   <a:txBody>
                     <a:bodyPr wrap="square"/>
@@ -21153,7 +21858,7 @@
         </p:nvSpPr>
         <p:spPr>
           <a:xfrm>
-            <a:off x="6400800" y="3879341"/>
+            <a:off x="6400800" y="4565142"/>
             <a:ext cx="5394960" cy="274320"/>
           </a:xfrm>
           <a:prstGeom prst="rect">
@@ -21398,7 +22103,7 @@
                 </a:solidFill>
                 <a:latin typeface="Arial"/>
               </a:rPr>
-              <a:t>Drawn by zwfs_vlayout.m from the two emitted decks (the engine does not split rays); the whole train is on the front-end slide.</a:t>
+              <a:t>Drawn by zwfs_vlayout.m from the two emitted decks (the engine does not split rays); the whole train is on the front-end slide.  The metasurface and the plate are drawn as ideal surfaces and the cameras as planes; the next model round draws the substrates and the 13 mm sensors.</a:t>
             </a:r>
           </a:p>
         </p:txBody>
@@ -21610,8 +22315,8 @@
                 <a:tableStyleId>{5C22544A-7EE6-4342-B048-85BDC9FD1C3A}</a:tableStyleId>
               </a:tblPr>
               <a:tblGrid>
-                <a:gridCol w="1249359"/>
-                <a:gridCol w="4145600"/>
+                <a:gridCol w="1141241"/>
+                <a:gridCol w="4253718"/>
               </a:tblGrid>
               <a:tr h="434340">
                 <a:tc>
@@ -21694,7 +22399,7 @@
                           </a:solidFill>
                           <a:latin typeface="Arial"/>
                         </a:rPr>
-                        <a:t>fused silica in the mask seat; pinhole 5.27 µm (2.0 λF/D at F/4.2), clear</a:t>
+                        <a:t>fused silica, 2-3 mm, in the mask seat; pinhole 5.27 µm (2.0 λF/D at F/4.2), clear</a:t>
                       </a:r>
                     </a:p>
                   </a:txBody>

</xml_diff>

<commit_message>
Deck: 'How every configuration was analyzed' (the ten-step repeatable path) + the backup table per configuration (38 slides); plan section 12: the path as reference memory and the migration of the deck work from demo_session into templates/40_benches/gauge_deck at the cycle's end (Dave 2026-09-15); slice
Co-Authored-By: Claude Fable 5.1 <noreply@anthropic.com>
</commit_message>
<xml_diff>
--- a/demo_session/deck_gauges.pptx
+++ b/demo_session/deck_gauges.pptx
@@ -41,6 +41,8 @@
     <p:sldId id="289" r:id="rId40"/>
     <p:sldId id="290" r:id="rId41"/>
     <p:sldId id="291" r:id="rId42"/>
+    <p:sldId id="292" r:id="rId43"/>
+    <p:sldId id="293" r:id="rId44"/>
   </p:sldIdLst>
   <p:sldSz cx="12191695" cy="6858000" type="screen4x3"/>
   <p:notesSz cx="6858000" cy="9144000"/>
@@ -14361,7 +14363,7 @@
                 </a:solidFill>
                 <a:latin typeface="Arial"/>
               </a:rPr>
-              <a:t>Run it yourself</a:t>
+              <a:t>How every configuration was analyzed</a:t>
             </a:r>
           </a:p>
           <a:p>
@@ -14377,7 +14379,7 @@
                 </a:solidFill>
                 <a:latin typeface="Arial"/>
               </a:rPr>
-              <a:t>One parameter sheet and one runner per approach, shared code underneath; every number here is reproduced by the commands below</a:t>
+              <a:t>One repeatable path, ten steps, the same for all four approaches: a new sensor is a new reading class in the shared runner plus its gate, then steps 4 to 10 unchanged</a:t>
             </a:r>
           </a:p>
         </p:txBody>
@@ -14426,86 +14428,885 @@
           </a:p>
         </p:txBody>
       </p:sp>
+      <p:graphicFrame>
+        <p:nvGraphicFramePr>
+          <p:cNvPr id="4" name="Table 3"/>
+          <p:cNvGraphicFramePr>
+            <a:graphicFrameLocks noGrp="1"/>
+          </p:cNvGraphicFramePr>
+          <p:nvPr/>
+        </p:nvGraphicFramePr>
+        <p:xfrm>
+          <a:off x="411480" y="1298448"/>
+          <a:ext cx="5806439" cy="3377565"/>
+        </p:xfrm>
+        <a:graphic>
+          <a:graphicData uri="http://schemas.openxmlformats.org/drawingml/2006/table">
+            <a:tbl>
+              <a:tblPr firstRow="1" bandRow="1">
+                <a:tableStyleId>{5C22544A-7EE6-4342-B048-85BDC9FD1C3A}</a:tableStyleId>
+              </a:tblPr>
+              <a:tblGrid>
+                <a:gridCol w="436880"/>
+                <a:gridCol w="2856711"/>
+                <a:gridCol w="2512848"/>
+              </a:tblGrid>
+              <a:tr h="280035">
+                <a:tc>
+                  <a:txBody>
+                    <a:bodyPr wrap="square"/>
+                    <a:lstStyle/>
+                    <a:p>
+                      <a:r>
+                        <a:rPr sz="1100" b="1">
+                          <a:solidFill>
+                            <a:srgbClr val="FFFFFF"/>
+                          </a:solidFill>
+                          <a:latin typeface="Arial"/>
+                        </a:rPr>
+                        <a:t>step</a:t>
+                      </a:r>
+                    </a:p>
+                  </a:txBody>
+                  <a:tcPr marL="54864" marR="54864" marT="18288" marB="18288">
+                    <a:solidFill>
+                      <a:srgbClr val="1F4E79"/>
+                    </a:solidFill>
+                  </a:tcPr>
+                </a:tc>
+                <a:tc>
+                  <a:txBody>
+                    <a:bodyPr wrap="square"/>
+                    <a:lstStyle/>
+                    <a:p>
+                      <a:r>
+                        <a:rPr sz="1100" b="1">
+                          <a:solidFill>
+                            <a:srgbClr val="FFFFFF"/>
+                          </a:solidFill>
+                          <a:latin typeface="Arial"/>
+                        </a:rPr>
+                        <a:t>what</a:t>
+                      </a:r>
+                    </a:p>
+                  </a:txBody>
+                  <a:tcPr marL="54864" marR="54864" marT="18288" marB="18288">
+                    <a:solidFill>
+                      <a:srgbClr val="1F4E79"/>
+                    </a:solidFill>
+                  </a:tcPr>
+                </a:tc>
+                <a:tc>
+                  <a:txBody>
+                    <a:bodyPr wrap="square"/>
+                    <a:lstStyle/>
+                    <a:p>
+                      <a:r>
+                        <a:rPr sz="1100" b="1">
+                          <a:solidFill>
+                            <a:srgbClr val="FFFFFF"/>
+                          </a:solidFill>
+                          <a:latin typeface="Arial"/>
+                        </a:rPr>
+                        <a:t>gate or output</a:t>
+                      </a:r>
+                    </a:p>
+                  </a:txBody>
+                  <a:tcPr marL="54864" marR="54864" marT="18288" marB="18288">
+                    <a:solidFill>
+                      <a:srgbClr val="1F4E79"/>
+                    </a:solidFill>
+                  </a:tcPr>
+                </a:tc>
+              </a:tr>
+              <a:tr h="468630">
+                <a:tc>
+                  <a:txBody>
+                    <a:bodyPr wrap="square"/>
+                    <a:lstStyle/>
+                    <a:p>
+                      <a:r>
+                        <a:rPr sz="1100" b="0">
+                          <a:solidFill>
+                            <a:srgbClr val="282828"/>
+                          </a:solidFill>
+                          <a:latin typeface="Arial"/>
+                        </a:rPr>
+                        <a:t>1</a:t>
+                      </a:r>
+                    </a:p>
+                  </a:txBody>
+                  <a:tcPr marL="54864" marR="54864" marT="18288" marB="18288">
+                    <a:solidFill>
+                      <a:srgbClr val="FFFFFF"/>
+                    </a:solidFill>
+                  </a:tcPr>
+                </a:tc>
+                <a:tc>
+                  <a:txBody>
+                    <a:bodyPr wrap="square"/>
+                    <a:lstStyle/>
+                    <a:p>
+                      <a:r>
+                        <a:rPr sz="1100" b="0">
+                          <a:solidFill>
+                            <a:srgbClr val="282828"/>
+                          </a:solidFill>
+                          <a:latin typeface="Arial"/>
+                        </a:rPr>
+                        <a:t>one parameter sheet and one runner per approach; batch wrappers</a:t>
+                      </a:r>
+                    </a:p>
+                  </a:txBody>
+                  <a:tcPr marL="54864" marR="54864" marT="18288" marB="18288">
+                    <a:solidFill>
+                      <a:srgbClr val="FFFFFF"/>
+                    </a:solidFill>
+                  </a:tcPr>
+                </a:tc>
+                <a:tc>
+                  <a:txBody>
+                    <a:bodyPr wrap="square"/>
+                    <a:lstStyle/>
+                    <a:p>
+                      <a:r>
+                        <a:rPr sz="1100" b="0">
+                          <a:solidFill>
+                            <a:srgbClr val="282828"/>
+                          </a:solidFill>
+                          <a:latin typeface="Arial"/>
+                        </a:rPr>
+                        <a:t>every number has a run tag</a:t>
+                      </a:r>
+                    </a:p>
+                  </a:txBody>
+                  <a:tcPr marL="54864" marR="54864" marT="18288" marB="18288">
+                    <a:solidFill>
+                      <a:srgbClr val="FFFFFF"/>
+                    </a:solidFill>
+                  </a:tcPr>
+                </a:tc>
+              </a:tr>
+              <a:tr h="657225">
+                <a:tc>
+                  <a:txBody>
+                    <a:bodyPr wrap="square"/>
+                    <a:lstStyle/>
+                    <a:p>
+                      <a:r>
+                        <a:rPr sz="1100" b="0">
+                          <a:solidFill>
+                            <a:srgbClr val="282828"/>
+                          </a:solidFill>
+                          <a:latin typeface="Arial"/>
+                        </a:rPr>
+                        <a:t>2</a:t>
+                      </a:r>
+                    </a:p>
+                  </a:txBody>
+                  <a:tcPr marL="54864" marR="54864" marT="18288" marB="18288">
+                    <a:solidFill>
+                      <a:srgbClr val="ECF1F6"/>
+                    </a:solidFill>
+                  </a:tcPr>
+                </a:tc>
+                <a:tc>
+                  <a:txBody>
+                    <a:bodyPr wrap="square"/>
+                    <a:lstStyle/>
+                    <a:p>
+                      <a:r>
+                        <a:rPr sz="1100" b="0">
+                          <a:solidFill>
+                            <a:srgbClr val="282828"/>
+                          </a:solidFill>
+                          <a:latin typeface="Arial"/>
+                        </a:rPr>
+                        <a:t>build the bench from the sheet, trace it; clearance of end bodies and node parts; tail tune; sampling budget</a:t>
+                      </a:r>
+                    </a:p>
+                  </a:txBody>
+                  <a:tcPr marL="54864" marR="54864" marT="18288" marB="18288">
+                    <a:solidFill>
+                      <a:srgbClr val="ECF1F6"/>
+                    </a:solidFill>
+                  </a:tcPr>
+                </a:tc>
+                <a:tc>
+                  <a:txBody>
+                    <a:bodyPr wrap="square"/>
+                    <a:lstStyle/>
+                    <a:p>
+                      <a:r>
+                        <a:rPr sz="1100" b="0">
+                          <a:solidFill>
+                            <a:srgbClr val="282828"/>
+                          </a:solidFill>
+                          <a:latin typeface="Arial"/>
+                        </a:rPr>
+                        <a:t>every part clears by 25 mm; 6 pixels across the mask feature</a:t>
+                      </a:r>
+                    </a:p>
+                  </a:txBody>
+                  <a:tcPr marL="54864" marR="54864" marT="18288" marB="18288">
+                    <a:solidFill>
+                      <a:srgbClr val="ECF1F6"/>
+                    </a:solidFill>
+                  </a:tcPr>
+                </a:tc>
+              </a:tr>
+              <a:tr h="657225">
+                <a:tc>
+                  <a:txBody>
+                    <a:bodyPr wrap="square"/>
+                    <a:lstStyle/>
+                    <a:p>
+                      <a:r>
+                        <a:rPr sz="1100" b="0">
+                          <a:solidFill>
+                            <a:srgbClr val="282828"/>
+                          </a:solidFill>
+                          <a:latin typeface="Arial"/>
+                        </a:rPr>
+                        <a:t>3</a:t>
+                      </a:r>
+                    </a:p>
+                  </a:txBody>
+                  <a:tcPr marL="54864" marR="54864" marT="18288" marB="18288">
+                    <a:solidFill>
+                      <a:srgbClr val="FFFFFF"/>
+                    </a:solidFill>
+                  </a:tcPr>
+                </a:tc>
+                <a:tc>
+                  <a:txBody>
+                    <a:bodyPr wrap="square"/>
+                    <a:lstStyle/>
+                    <a:p>
+                      <a:r>
+                        <a:rPr sz="1100" b="0">
+                          <a:solidFill>
+                            <a:srgbClr val="282828"/>
+                          </a:solidFill>
+                          <a:latin typeface="Arial"/>
+                        </a:rPr>
+                        <a:t>model gates before any number</a:t>
+                      </a:r>
+                    </a:p>
+                  </a:txBody>
+                  <a:tcPr marL="54864" marR="54864" marT="18288" marB="18288">
+                    <a:solidFill>
+                      <a:srgbClr val="FFFFFF"/>
+                    </a:solidFill>
+                  </a:tcPr>
+                </a:tc>
+                <a:tc>
+                  <a:txBody>
+                    <a:bodyPr wrap="square"/>
+                    <a:lstStyle/>
+                    <a:p>
+                      <a:r>
+                        <a:rPr sz="1100" b="0">
+                          <a:solidFill>
+                            <a:srgbClr val="282828"/>
+                          </a:solidFill>
+                          <a:latin typeface="Arial"/>
+                        </a:rPr>
+                        <a:t>mask round trip, reference-wave surrogate, working-state amplitude, the reading on 100 nm pokes</a:t>
+                      </a:r>
+                    </a:p>
+                  </a:txBody>
+                  <a:tcPr marL="54864" marR="54864" marT="18288" marB="18288">
+                    <a:solidFill>
+                      <a:srgbClr val="FFFFFF"/>
+                    </a:solidFill>
+                  </a:tcPr>
+                </a:tc>
+              </a:tr>
+              <a:tr h="657225">
+                <a:tc>
+                  <a:txBody>
+                    <a:bodyPr wrap="square"/>
+                    <a:lstStyle/>
+                    <a:p>
+                      <a:r>
+                        <a:rPr sz="1100" b="0">
+                          <a:solidFill>
+                            <a:srgbClr val="282828"/>
+                          </a:solidFill>
+                          <a:latin typeface="Arial"/>
+                        </a:rPr>
+                        <a:t>4</a:t>
+                      </a:r>
+                    </a:p>
+                  </a:txBody>
+                  <a:tcPr marL="54864" marR="54864" marT="18288" marB="18288">
+                    <a:solidFill>
+                      <a:srgbClr val="ECF1F6"/>
+                    </a:solidFill>
+                  </a:tcPr>
+                </a:tc>
+                <a:tc>
+                  <a:txBody>
+                    <a:bodyPr wrap="square"/>
+                    <a:lstStyle/>
+                    <a:p>
+                      <a:r>
+                        <a:rPr sz="1100" b="0">
+                          <a:solidFill>
+                            <a:srgbClr val="282828"/>
+                          </a:solidFill>
+                          <a:latin typeface="Arial"/>
+                        </a:rPr>
+                        <a:t>calibration: the response matrix measured through the sensor, on the 30 nm working surface</a:t>
+                      </a:r>
+                    </a:p>
+                  </a:txBody>
+                  <a:tcPr marL="54864" marR="54864" marT="18288" marB="18288">
+                    <a:solidFill>
+                      <a:srgbClr val="ECF1F6"/>
+                    </a:solidFill>
+                  </a:tcPr>
+                </a:tc>
+                <a:tc>
+                  <a:txBody>
+                    <a:bodyPr wrap="square"/>
+                    <a:lstStyle/>
+                    <a:p>
+                      <a:r>
+                        <a:rPr sz="1100" b="0">
+                          <a:solidFill>
+                            <a:srgbClr val="282828"/>
+                          </a:solidFill>
+                          <a:latin typeface="Arial"/>
+                        </a:rPr>
+                        <a:t>piston null carried; stencil-site fit</a:t>
+                      </a:r>
+                    </a:p>
+                  </a:txBody>
+                  <a:tcPr marL="54864" marR="54864" marT="18288" marB="18288">
+                    <a:solidFill>
+                      <a:srgbClr val="ECF1F6"/>
+                    </a:solidFill>
+                  </a:tcPr>
+                </a:tc>
+              </a:tr>
+              <a:tr h="657225">
+                <a:tc>
+                  <a:txBody>
+                    <a:bodyPr wrap="square"/>
+                    <a:lstStyle/>
+                    <a:p>
+                      <a:r>
+                        <a:rPr sz="1100" b="0">
+                          <a:solidFill>
+                            <a:srgbClr val="282828"/>
+                          </a:solidFill>
+                          <a:latin typeface="Arial"/>
+                        </a:rPr>
+                        <a:t>5</a:t>
+                      </a:r>
+                    </a:p>
+                  </a:txBody>
+                  <a:tcPr marL="54864" marR="54864" marT="18288" marB="18288">
+                    <a:solidFill>
+                      <a:srgbClr val="FFFFFF"/>
+                    </a:solidFill>
+                  </a:tcPr>
+                </a:tc>
+                <a:tc>
+                  <a:txBody>
+                    <a:bodyPr wrap="square"/>
+                    <a:lstStyle/>
+                    <a:p>
+                      <a:r>
+                        <a:rPr sz="1100" b="0">
+                          <a:solidFill>
+                            <a:srgbClr val="282828"/>
+                          </a:solidFill>
+                          <a:latin typeface="Arial"/>
+                        </a:rPr>
+                        <a:t>rows on the working surface: 10 nm on one actuator; 1 nm on 47 sites; dense 10 nm</a:t>
+                      </a:r>
+                    </a:p>
+                  </a:txBody>
+                  <a:tcPr marL="54864" marR="54864" marT="18288" marB="18288">
+                    <a:solidFill>
+                      <a:srgbClr val="FFFFFF"/>
+                    </a:solidFill>
+                  </a:tcPr>
+                </a:tc>
+                <a:tc>
+                  <a:txBody>
+                    <a:bodyPr wrap="square"/>
+                    <a:lstStyle/>
+                    <a:p>
+                      <a:r>
+                        <a:rPr sz="1100" b="0">
+                          <a:solidFill>
+                            <a:srgbClr val="282828"/>
+                          </a:solidFill>
+                          <a:latin typeface="Arial"/>
+                        </a:rPr>
+                        <a:t>gain, floor, SNR</a:t>
+                      </a:r>
+                    </a:p>
+                  </a:txBody>
+                  <a:tcPr marL="54864" marR="54864" marT="18288" marB="18288">
+                    <a:solidFill>
+                      <a:srgbClr val="FFFFFF"/>
+                    </a:solidFill>
+                  </a:tcPr>
+                </a:tc>
+              </a:tr>
+            </a:tbl>
+          </a:graphicData>
+        </a:graphic>
+      </p:graphicFrame>
+      <p:graphicFrame>
+        <p:nvGraphicFramePr>
+          <p:cNvPr id="5" name="Table 4"/>
+          <p:cNvGraphicFramePr>
+            <a:graphicFrameLocks noGrp="1"/>
+          </p:cNvGraphicFramePr>
+          <p:nvPr/>
+        </p:nvGraphicFramePr>
+        <p:xfrm>
+          <a:off x="6400800" y="1298448"/>
+          <a:ext cx="5394959" cy="2777490"/>
+        </p:xfrm>
+        <a:graphic>
+          <a:graphicData uri="http://schemas.openxmlformats.org/drawingml/2006/table">
+            <a:tbl>
+              <a:tblPr firstRow="1" bandRow="1">
+                <a:tableStyleId>{5C22544A-7EE6-4342-B048-85BDC9FD1C3A}</a:tableStyleId>
+              </a:tblPr>
+              <a:tblGrid>
+                <a:gridCol w="410464"/>
+                <a:gridCol w="3846730"/>
+                <a:gridCol w="1137765"/>
+              </a:tblGrid>
+              <a:tr h="262890">
+                <a:tc>
+                  <a:txBody>
+                    <a:bodyPr wrap="square"/>
+                    <a:lstStyle/>
+                    <a:p>
+                      <a:r>
+                        <a:rPr sz="1000" b="1">
+                          <a:solidFill>
+                            <a:srgbClr val="FFFFFF"/>
+                          </a:solidFill>
+                          <a:latin typeface="Arial"/>
+                        </a:rPr>
+                        <a:t>step</a:t>
+                      </a:r>
+                    </a:p>
+                  </a:txBody>
+                  <a:tcPr marL="54864" marR="54864" marT="18288" marB="18288">
+                    <a:solidFill>
+                      <a:srgbClr val="1F4E79"/>
+                    </a:solidFill>
+                  </a:tcPr>
+                </a:tc>
+                <a:tc>
+                  <a:txBody>
+                    <a:bodyPr wrap="square"/>
+                    <a:lstStyle/>
+                    <a:p>
+                      <a:r>
+                        <a:rPr sz="1000" b="1">
+                          <a:solidFill>
+                            <a:srgbClr val="FFFFFF"/>
+                          </a:solidFill>
+                          <a:latin typeface="Arial"/>
+                        </a:rPr>
+                        <a:t>what</a:t>
+                      </a:r>
+                    </a:p>
+                  </a:txBody>
+                  <a:tcPr marL="54864" marR="54864" marT="18288" marB="18288">
+                    <a:solidFill>
+                      <a:srgbClr val="1F4E79"/>
+                    </a:solidFill>
+                  </a:tcPr>
+                </a:tc>
+                <a:tc>
+                  <a:txBody>
+                    <a:bodyPr wrap="square"/>
+                    <a:lstStyle/>
+                    <a:p>
+                      <a:r>
+                        <a:rPr sz="1000" b="1">
+                          <a:solidFill>
+                            <a:srgbClr val="FFFFFF"/>
+                          </a:solidFill>
+                          <a:latin typeface="Arial"/>
+                        </a:rPr>
+                        <a:t>gate or output</a:t>
+                      </a:r>
+                    </a:p>
+                  </a:txBody>
+                  <a:tcPr marL="54864" marR="54864" marT="18288" marB="18288">
+                    <a:solidFill>
+                      <a:srgbClr val="1F4E79"/>
+                    </a:solidFill>
+                  </a:tcPr>
+                </a:tc>
+              </a:tr>
+              <a:tr h="434340">
+                <a:tc>
+                  <a:txBody>
+                    <a:bodyPr wrap="square"/>
+                    <a:lstStyle/>
+                    <a:p>
+                      <a:r>
+                        <a:rPr sz="1000" b="0">
+                          <a:solidFill>
+                            <a:srgbClr val="282828"/>
+                          </a:solidFill>
+                          <a:latin typeface="Arial"/>
+                        </a:rPr>
+                        <a:t>6</a:t>
+                      </a:r>
+                    </a:p>
+                  </a:txBody>
+                  <a:tcPr marL="54864" marR="54864" marT="18288" marB="18288">
+                    <a:solidFill>
+                      <a:srgbClr val="FFFFFF"/>
+                    </a:solidFill>
+                  </a:tcPr>
+                </a:tc>
+                <a:tc>
+                  <a:txBody>
+                    <a:bodyPr wrap="square"/>
+                    <a:lstStyle/>
+                    <a:p>
+                      <a:r>
+                        <a:rPr sz="1000" b="0">
+                          <a:solidFill>
+                            <a:srgbClr val="282828"/>
+                          </a:solidFill>
+                          <a:latin typeface="Arial"/>
+                        </a:rPr>
+                        <a:t>capture range: the aging ladder to 10%; the matrix re-measured at 60 to 160 nm with its photon cost</a:t>
+                      </a:r>
+                    </a:p>
+                  </a:txBody>
+                  <a:tcPr marL="54864" marR="54864" marT="18288" marB="18288">
+                    <a:solidFill>
+                      <a:srgbClr val="FFFFFF"/>
+                    </a:solidFill>
+                  </a:tcPr>
+                </a:tc>
+                <a:tc>
+                  <a:txBody>
+                    <a:bodyPr wrap="square"/>
+                    <a:lstStyle/>
+                    <a:p>
+                      <a:r>
+                        <a:rPr sz="1000" b="0">
+                          <a:solidFill>
+                            <a:srgbClr val="282828"/>
+                          </a:solidFill>
+                          <a:latin typeface="Arial"/>
+                        </a:rPr>
+                        <a:t>range in nm; photons per rung</a:t>
+                      </a:r>
+                    </a:p>
+                  </a:txBody>
+                  <a:tcPr marL="54864" marR="54864" marT="18288" marB="18288">
+                    <a:solidFill>
+                      <a:srgbClr val="FFFFFF"/>
+                    </a:solidFill>
+                  </a:tcPr>
+                </a:tc>
+              </a:tr>
+              <a:tr h="434340">
+                <a:tc>
+                  <a:txBody>
+                    <a:bodyPr wrap="square"/>
+                    <a:lstStyle/>
+                    <a:p>
+                      <a:r>
+                        <a:rPr sz="1000" b="0">
+                          <a:solidFill>
+                            <a:srgbClr val="282828"/>
+                          </a:solidFill>
+                          <a:latin typeface="Arial"/>
+                        </a:rPr>
+                        <a:t>7</a:t>
+                      </a:r>
+                    </a:p>
+                  </a:txBody>
+                  <a:tcPr marL="54864" marR="54864" marT="18288" marB="18288">
+                    <a:solidFill>
+                      <a:srgbClr val="ECF1F6"/>
+                    </a:solidFill>
+                  </a:tcPr>
+                </a:tc>
+                <a:tc>
+                  <a:txBody>
+                    <a:bodyPr wrap="square"/>
+                    <a:lstStyle/>
+                    <a:p>
+                      <a:r>
+                        <a:rPr sz="1000" b="0">
+                          <a:solidFill>
+                            <a:srgbClr val="282828"/>
+                          </a:solidFill>
+                          <a:latin typeface="Arial"/>
+                        </a:rPr>
+                        <a:t>photons: noise fit over 1e8 to 1e14 per measurement, flat and on-surface matrix</a:t>
+                      </a:r>
+                    </a:p>
+                  </a:txBody>
+                  <a:tcPr marL="54864" marR="54864" marT="18288" marB="18288">
+                    <a:solidFill>
+                      <a:srgbClr val="ECF1F6"/>
+                    </a:solidFill>
+                  </a:tcPr>
+                </a:tc>
+                <a:tc>
+                  <a:txBody>
+                    <a:bodyPr wrap="square"/>
+                    <a:lstStyle/>
+                    <a:p>
+                      <a:r>
+                        <a:rPr sz="1000" b="0">
+                          <a:solidFill>
+                            <a:srgbClr val="282828"/>
+                          </a:solidFill>
+                          <a:latin typeface="Arial"/>
+                        </a:rPr>
+                        <a:t>photons for 1 pm</a:t>
+                      </a:r>
+                    </a:p>
+                  </a:txBody>
+                  <a:tcPr marL="54864" marR="54864" marT="18288" marB="18288">
+                    <a:solidFill>
+                      <a:srgbClr val="ECF1F6"/>
+                    </a:solidFill>
+                  </a:tcPr>
+                </a:tc>
+              </a:tr>
+              <a:tr h="605790">
+                <a:tc>
+                  <a:txBody>
+                    <a:bodyPr wrap="square"/>
+                    <a:lstStyle/>
+                    <a:p>
+                      <a:r>
+                        <a:rPr sz="1000" b="0">
+                          <a:solidFill>
+                            <a:srgbClr val="282828"/>
+                          </a:solidFill>
+                          <a:latin typeface="Arial"/>
+                        </a:rPr>
+                        <a:t>8</a:t>
+                      </a:r>
+                    </a:p>
+                  </a:txBody>
+                  <a:tcPr marL="54864" marR="54864" marT="18288" marB="18288">
+                    <a:solidFill>
+                      <a:srgbClr val="FFFFFF"/>
+                    </a:solidFill>
+                  </a:tcPr>
+                </a:tc>
+                <a:tc>
+                  <a:txBody>
+                    <a:bodyPr wrap="square"/>
+                    <a:lstStyle/>
+                    <a:p>
+                      <a:r>
+                        <a:rPr sz="1000" b="0">
+                          <a:solidFill>
+                            <a:srgbClr val="282828"/>
+                          </a:solidFill>
+                          <a:latin typeface="Arial"/>
+                        </a:rPr>
+                        <a:t>closed loop in the shared loop code: noise, walk, ramp; noiseless step; within-scan drift</a:t>
+                      </a:r>
+                    </a:p>
+                  </a:txBody>
+                  <a:tcPr marL="54864" marR="54864" marT="18288" marB="18288">
+                    <a:solidFill>
+                      <a:srgbClr val="FFFFFF"/>
+                    </a:solidFill>
+                  </a:tcPr>
+                </a:tc>
+                <a:tc>
+                  <a:txBody>
+                    <a:bodyPr wrap="square"/>
+                    <a:lstStyle/>
+                    <a:p>
+                      <a:r>
+                        <a:rPr sz="1000" b="0">
+                          <a:solidFill>
+                            <a:srgbClr val="282828"/>
+                          </a:solidFill>
+                          <a:latin typeface="Arial"/>
+                        </a:rPr>
+                        <a:t>photons per cycle for 3 pm; fixed error</a:t>
+                      </a:r>
+                    </a:p>
+                  </a:txBody>
+                  <a:tcPr marL="54864" marR="54864" marT="18288" marB="18288">
+                    <a:solidFill>
+                      <a:srgbClr val="FFFFFF"/>
+                    </a:solidFill>
+                  </a:tcPr>
+                </a:tc>
+              </a:tr>
+              <a:tr h="434340">
+                <a:tc>
+                  <a:txBody>
+                    <a:bodyPr wrap="square"/>
+                    <a:lstStyle/>
+                    <a:p>
+                      <a:r>
+                        <a:rPr sz="1000" b="0">
+                          <a:solidFill>
+                            <a:srgbClr val="282828"/>
+                          </a:solidFill>
+                          <a:latin typeface="Arial"/>
+                        </a:rPr>
+                        <a:t>9</a:t>
+                      </a:r>
+                    </a:p>
+                  </a:txBody>
+                  <a:tcPr marL="54864" marR="54864" marT="18288" marB="18288">
+                    <a:solidFill>
+                      <a:srgbClr val="ECF1F6"/>
+                    </a:solidFill>
+                  </a:tcPr>
+                </a:tc>
+                <a:tc>
+                  <a:txBody>
+                    <a:bodyPr wrap="square"/>
+                    <a:lstStyle/>
+                    <a:p>
+                      <a:r>
+                        <a:rPr sz="1000" b="0">
+                          <a:solidFill>
+                            <a:srgbClr val="282828"/>
+                          </a:solidFill>
+                          <a:latin typeface="Arial"/>
+                        </a:rPr>
+                        <a:t>descent: the start ladder with unwrapping and recalibration on and off</a:t>
+                      </a:r>
+                    </a:p>
+                  </a:txBody>
+                  <a:tcPr marL="54864" marR="54864" marT="18288" marB="18288">
+                    <a:solidFill>
+                      <a:srgbClr val="ECF1F6"/>
+                    </a:solidFill>
+                  </a:tcPr>
+                </a:tc>
+                <a:tc>
+                  <a:txBody>
+                    <a:bodyPr wrap="square"/>
+                    <a:lstStyle/>
+                    <a:p>
+                      <a:r>
+                        <a:rPr sz="1000" b="0">
+                          <a:solidFill>
+                            <a:srgbClr val="282828"/>
+                          </a:solidFill>
+                          <a:latin typeface="Arial"/>
+                        </a:rPr>
+                        <a:t>largest start brought to 3 pm</a:t>
+                      </a:r>
+                    </a:p>
+                  </a:txBody>
+                  <a:tcPr marL="54864" marR="54864" marT="18288" marB="18288">
+                    <a:solidFill>
+                      <a:srgbClr val="ECF1F6"/>
+                    </a:solidFill>
+                  </a:tcPr>
+                </a:tc>
+              </a:tr>
+              <a:tr h="605790">
+                <a:tc>
+                  <a:txBody>
+                    <a:bodyPr wrap="square"/>
+                    <a:lstStyle/>
+                    <a:p>
+                      <a:r>
+                        <a:rPr sz="1000" b="0">
+                          <a:solidFill>
+                            <a:srgbClr val="282828"/>
+                          </a:solidFill>
+                          <a:latin typeface="Arial"/>
+                        </a:rPr>
+                        <a:t>10</a:t>
+                      </a:r>
+                    </a:p>
+                  </a:txBody>
+                  <a:tcPr marL="54864" marR="54864" marT="18288" marB="18288">
+                    <a:solidFill>
+                      <a:srgbClr val="FFFFFF"/>
+                    </a:solidFill>
+                  </a:tcPr>
+                </a:tc>
+                <a:tc>
+                  <a:txBody>
+                    <a:bodyPr wrap="square"/>
+                    <a:lstStyle/>
+                    <a:p>
+                      <a:r>
+                        <a:rPr sz="1000" b="0">
+                          <a:solidFill>
+                            <a:srgbClr val="282828"/>
+                          </a:solidFill>
+                          <a:latin typeface="Arial"/>
+                        </a:rPr>
+                        <a:t>systematics one at a time, uncalibrated and through the matrix; layout drawn from the emitted deck; parts from the sheet; report numbers first</a:t>
+                      </a:r>
+                    </a:p>
+                  </a:txBody>
+                  <a:tcPr marL="54864" marR="54864" marT="18288" marB="18288">
+                    <a:solidFill>
+                      <a:srgbClr val="FFFFFF"/>
+                    </a:solidFill>
+                  </a:tcPr>
+                </a:tc>
+                <a:tc>
+                  <a:txBody>
+                    <a:bodyPr wrap="square"/>
+                    <a:lstStyle/>
+                    <a:p>
+                      <a:r>
+                        <a:rPr sz="1000" b="0">
+                          <a:solidFill>
+                            <a:srgbClr val="282828"/>
+                          </a:solidFill>
+                          <a:latin typeface="Arial"/>
+                        </a:rPr>
+                        <a:t>one line per term on the systematics slide</a:t>
+                      </a:r>
+                    </a:p>
+                  </a:txBody>
+                  <a:tcPr marL="54864" marR="54864" marT="18288" marB="18288">
+                    <a:solidFill>
+                      <a:srgbClr val="FFFFFF"/>
+                    </a:solidFill>
+                  </a:tcPr>
+                </a:tc>
+              </a:tr>
+            </a:tbl>
+          </a:graphicData>
+        </a:graphic>
+      </p:graphicFrame>
       <p:sp>
         <p:nvSpPr>
-          <p:cNvPr id="4" name="TextBox 3"/>
+          <p:cNvPr id="6" name="TextBox 5"/>
           <p:cNvSpPr txBox="1"/>
           <p:nvPr/>
         </p:nvSpPr>
         <p:spPr>
           <a:xfrm>
-            <a:off x="411480" y="1298448"/>
-            <a:ext cx="5806440" cy="274320"/>
-          </a:xfrm>
-          <a:prstGeom prst="rect">
-            <a:avLst/>
-          </a:prstGeom>
-          <a:noFill/>
-        </p:spPr>
-        <p:txBody>
-          <a:bodyPr wrap="square">
-            <a:spAutoFit/>
-          </a:bodyPr>
-          <a:lstStyle/>
-          <a:p>
-            <a:pPr>
-              <a:spcAft>
-                <a:spcPts val="600"/>
-              </a:spcAft>
-            </a:pPr>
-            <a:r>
-              <a:rPr sz="1200" b="0">
-                <a:solidFill>
-                  <a:srgbClr val="282828"/>
-                </a:solidFill>
-                <a:latin typeface="Arial"/>
-              </a:rPr>
-              <a:t>•  Interferometer (tg_psi_dm96_oap): tg96_run for the lens rig; tg96_run('bench.optics','oap','tag','oap') for the mirror rig; ./tg96_batch.sh lens_deck "'stages',{'bench','deck'},'battery.noise',true"; ./tg96_batch.sh loop_lens "'stages',{'bench','loop','figs'}".</a:t>
-            </a:r>
-          </a:p>
-          <a:p>
-            <a:pPr>
-              <a:spcAft>
-                <a:spcPts val="600"/>
-              </a:spcAft>
-            </a:pPr>
-            <a:r>
-              <a:rPr sz="1200" b="0">
-                <a:solidFill>
-                  <a:srgbClr val="282828"/>
-                </a:solidFill>
-                <a:latin typeface="Arial"/>
-              </a:rPr>
-              <a:t>•  Zernike sensors (zwfs_dm96): out = zwfs_run; (bench + battery + figures); zwfs_run('tag','ng385','NGRID',385); zwfs_run('MODEL',2048,'NGRID',385,'param_file','macos_param_2048.txt'); ./zwfs_batch.sh loop193 "'stages',{'bench','loop','figs'}".</a:t>
-            </a:r>
-          </a:p>
-          <a:p>
-            <a:pPr>
-              <a:spcAft>
-                <a:spcPts val="600"/>
-              </a:spcAft>
-            </a:pPr>
-            <a:r>
-              <a:rPr sz="1200" b="0">
-                <a:solidFill>
-                  <a:srgbClr val="282828"/>
-                </a:solidFill>
-                <a:latin typeface="Arial"/>
-              </a:rPr>
-              <a:t>•  Point-diffraction (pdi_dm96): P = pdi_params; out = pdi_run(P);; pdi_run('pdi.DIA_LAMD',1.0,'stages',{'bench','battery','figs'}); ./pdi_batch.sh TAG "pdi_params, 'stages',{'bench','loop','figs'}".</a:t>
-            </a:r>
-          </a:p>
-        </p:txBody>
-      </p:sp>
-      <p:sp>
-        <p:nvSpPr>
-          <p:cNvPr id="5" name="TextBox 4"/>
-          <p:cNvSpPr txBox="1"/>
-          <p:nvPr/>
-        </p:nvSpPr>
-        <p:spPr>
-          <a:xfrm>
-            <a:off x="6400800" y="1298448"/>
+            <a:off x="6400800" y="4222242"/>
             <a:ext cx="5394960" cy="274320"/>
           </a:xfrm>
           <a:prstGeom prst="rect">
@@ -14525,84 +15326,13 @@
               </a:spcAft>
             </a:pPr>
             <a:r>
-              <a:rPr sz="1200" b="0">
-                <a:solidFill>
-                  <a:srgbClr val="282828"/>
-                </a:solidFill>
-                <a:latin typeface="Arial"/>
-              </a:rPr>
-              <a:t>•  The other gauges on the mirror rig: zwfs_run('bench.optics','oap','bench.coat_oap','bareAl','readings',{'L','S','V','P','PF'},'stages',{'bench','battery','noise','loop'},'mask.v_arm','engine').</a:t>
-            </a:r>
-          </a:p>
-          <a:p>
-            <a:pPr>
-              <a:spcAft>
-                <a:spcPts val="600"/>
-              </a:spcAft>
-            </a:pPr>
-            <a:r>
-              <a:rPr sz="1200" b="0">
-                <a:solidFill>
-                  <a:srgbClr val="282828"/>
-                </a:solidFill>
-                <a:latin typeface="Arial"/>
-              </a:rPr>
-              <a:t>•  Where: MACOS_resources/mmacos/templates/40_benches/{tg_psi_dm96_oap, zwfs_dm96, pdi_dm96}, the shared scoring library dm_gauge_lib, branch dev-candidate.  A model-1024 run needs about 11 GB; the batch wrappers run one at a time.</a:t>
-            </a:r>
-          </a:p>
-          <a:p>
-            <a:pPr>
-              <a:spcAft>
-                <a:spcPts val="600"/>
-              </a:spcAft>
-            </a:pPr>
-            <a:r>
-              <a:rPr sz="1200" b="0">
-                <a:solidFill>
-                  <a:srgbClr val="282828"/>
-                </a:solidFill>
-                <a:latin typeface="Arial"/>
-              </a:rPr>
-              <a:t>•  Gates: every stage asserts its own gates (the mask round trip, the reference-wave surrogate, the fold, the pinhole, the analyzer); tDmgLoop 15/15; the mmacos fast suite 481/0.</a:t>
-            </a:r>
-          </a:p>
-        </p:txBody>
-      </p:sp>
-      <p:sp>
-        <p:nvSpPr>
-          <p:cNvPr id="6" name="TextBox 5"/>
-          <p:cNvSpPr txBox="1"/>
-          <p:nvPr/>
-        </p:nvSpPr>
-        <p:spPr>
-          <a:xfrm>
-            <a:off x="6400800" y="3736848"/>
-            <a:ext cx="5394960" cy="274320"/>
-          </a:xfrm>
-          <a:prstGeom prst="rect">
-            <a:avLst/>
-          </a:prstGeom>
-          <a:noFill/>
-        </p:spPr>
-        <p:txBody>
-          <a:bodyPr wrap="square">
-            <a:spAutoFit/>
-          </a:bodyPr>
-          <a:lstStyle/>
-          <a:p>
-            <a:pPr>
-              <a:spcAft>
-                <a:spcPts val="600"/>
-              </a:spcAft>
-            </a:pPr>
-            <a:r>
               <a:rPr sz="1050" b="0">
                 <a:solidFill>
                   <a:srgbClr val="6E6E6E"/>
                 </a:solidFill>
                 <a:latin typeface="Arial"/>
               </a:rPr>
-              <a:t>Each directory's README carries the full command list and the run-tag index.</a:t>
+              <a:t>The scoring library (the loop, the unwrapper, the arm and analyzer maps, the clearance check) is shared by the three lanes; nothing is copied between them.  The path is recorded as reference memory so the next configuration follows it in a day.</a:t>
             </a:r>
           </a:p>
         </p:txBody>
@@ -14659,7 +15389,7 @@
                 </a:solidFill>
                 <a:latin typeface="Arial"/>
               </a:rPr>
-              <a:t>Backup: the interferometer's three phase-shift forms</a:t>
+              <a:t>Run it yourself</a:t>
             </a:r>
           </a:p>
           <a:p>
@@ -14675,7 +15405,7 @@
                 </a:solidFill>
                 <a:latin typeface="Arial"/>
               </a:rPr>
-              <a:t>The four frames are the same in the model; the forms differ in what they get wrong</a:t>
+              <a:t>One parameter sheet and one runner per approach, shared code underneath; every number here is reproduced by the commands below</a:t>
             </a:r>
           </a:p>
         </p:txBody>
@@ -14724,6 +15454,304 @@
           </a:p>
         </p:txBody>
       </p:sp>
+      <p:sp>
+        <p:nvSpPr>
+          <p:cNvPr id="4" name="TextBox 3"/>
+          <p:cNvSpPr txBox="1"/>
+          <p:nvPr/>
+        </p:nvSpPr>
+        <p:spPr>
+          <a:xfrm>
+            <a:off x="411480" y="1298448"/>
+            <a:ext cx="5806440" cy="274320"/>
+          </a:xfrm>
+          <a:prstGeom prst="rect">
+            <a:avLst/>
+          </a:prstGeom>
+          <a:noFill/>
+        </p:spPr>
+        <p:txBody>
+          <a:bodyPr wrap="square">
+            <a:spAutoFit/>
+          </a:bodyPr>
+          <a:lstStyle/>
+          <a:p>
+            <a:pPr>
+              <a:spcAft>
+                <a:spcPts val="600"/>
+              </a:spcAft>
+            </a:pPr>
+            <a:r>
+              <a:rPr sz="1200" b="0">
+                <a:solidFill>
+                  <a:srgbClr val="282828"/>
+                </a:solidFill>
+                <a:latin typeface="Arial"/>
+              </a:rPr>
+              <a:t>•  Interferometer (tg_psi_dm96_oap): tg96_run for the lens rig; tg96_run('bench.optics','oap','tag','oap') for the mirror rig; ./tg96_batch.sh lens_deck "'stages',{'bench','deck'},'battery.noise',true"; ./tg96_batch.sh loop_lens "'stages',{'bench','loop','figs'}".</a:t>
+            </a:r>
+          </a:p>
+          <a:p>
+            <a:pPr>
+              <a:spcAft>
+                <a:spcPts val="600"/>
+              </a:spcAft>
+            </a:pPr>
+            <a:r>
+              <a:rPr sz="1200" b="0">
+                <a:solidFill>
+                  <a:srgbClr val="282828"/>
+                </a:solidFill>
+                <a:latin typeface="Arial"/>
+              </a:rPr>
+              <a:t>•  Zernike sensors (zwfs_dm96): out = zwfs_run; (bench + battery + figures); zwfs_run('tag','ng385','NGRID',385); zwfs_run('MODEL',2048,'NGRID',385,'param_file','macos_param_2048.txt'); ./zwfs_batch.sh loop193 "'stages',{'bench','loop','figs'}".</a:t>
+            </a:r>
+          </a:p>
+          <a:p>
+            <a:pPr>
+              <a:spcAft>
+                <a:spcPts val="600"/>
+              </a:spcAft>
+            </a:pPr>
+            <a:r>
+              <a:rPr sz="1200" b="0">
+                <a:solidFill>
+                  <a:srgbClr val="282828"/>
+                </a:solidFill>
+                <a:latin typeface="Arial"/>
+              </a:rPr>
+              <a:t>•  Point-diffraction (pdi_dm96): P = pdi_params; out = pdi_run(P);; pdi_run('pdi.DIA_LAMD',1.0,'stages',{'bench','battery','figs'}); ./pdi_batch.sh TAG "pdi_params, 'stages',{'bench','loop','figs'}".</a:t>
+            </a:r>
+          </a:p>
+        </p:txBody>
+      </p:sp>
+      <p:sp>
+        <p:nvSpPr>
+          <p:cNvPr id="5" name="TextBox 4"/>
+          <p:cNvSpPr txBox="1"/>
+          <p:nvPr/>
+        </p:nvSpPr>
+        <p:spPr>
+          <a:xfrm>
+            <a:off x="6400800" y="1298448"/>
+            <a:ext cx="5394960" cy="274320"/>
+          </a:xfrm>
+          <a:prstGeom prst="rect">
+            <a:avLst/>
+          </a:prstGeom>
+          <a:noFill/>
+        </p:spPr>
+        <p:txBody>
+          <a:bodyPr wrap="square">
+            <a:spAutoFit/>
+          </a:bodyPr>
+          <a:lstStyle/>
+          <a:p>
+            <a:pPr>
+              <a:spcAft>
+                <a:spcPts val="600"/>
+              </a:spcAft>
+            </a:pPr>
+            <a:r>
+              <a:rPr sz="1200" b="0">
+                <a:solidFill>
+                  <a:srgbClr val="282828"/>
+                </a:solidFill>
+                <a:latin typeface="Arial"/>
+              </a:rPr>
+              <a:t>•  The other gauges on the mirror rig: zwfs_run('bench.optics','oap','bench.coat_oap','bareAl','readings',{'L','S','V','P','PF'},'stages',{'bench','battery','noise','loop'},'mask.v_arm','engine').</a:t>
+            </a:r>
+          </a:p>
+          <a:p>
+            <a:pPr>
+              <a:spcAft>
+                <a:spcPts val="600"/>
+              </a:spcAft>
+            </a:pPr>
+            <a:r>
+              <a:rPr sz="1200" b="0">
+                <a:solidFill>
+                  <a:srgbClr val="282828"/>
+                </a:solidFill>
+                <a:latin typeface="Arial"/>
+              </a:rPr>
+              <a:t>•  Where: MACOS_resources/mmacos/templates/40_benches/{tg_psi_dm96_oap, zwfs_dm96, pdi_dm96}, the shared scoring library dm_gauge_lib, branch dev-candidate.  A model-1024 run needs about 11 GB; the batch wrappers run one at a time.</a:t>
+            </a:r>
+          </a:p>
+          <a:p>
+            <a:pPr>
+              <a:spcAft>
+                <a:spcPts val="600"/>
+              </a:spcAft>
+            </a:pPr>
+            <a:r>
+              <a:rPr sz="1200" b="0">
+                <a:solidFill>
+                  <a:srgbClr val="282828"/>
+                </a:solidFill>
+                <a:latin typeface="Arial"/>
+              </a:rPr>
+              <a:t>•  Gates: every stage asserts its own gates (the mask round trip, the reference-wave surrogate, the fold, the pinhole, the analyzer); tDmgLoop 15/15; the mmacos fast suite 481/0.</a:t>
+            </a:r>
+          </a:p>
+        </p:txBody>
+      </p:sp>
+      <p:sp>
+        <p:nvSpPr>
+          <p:cNvPr id="6" name="TextBox 5"/>
+          <p:cNvSpPr txBox="1"/>
+          <p:nvPr/>
+        </p:nvSpPr>
+        <p:spPr>
+          <a:xfrm>
+            <a:off x="6400800" y="3736848"/>
+            <a:ext cx="5394960" cy="274320"/>
+          </a:xfrm>
+          <a:prstGeom prst="rect">
+            <a:avLst/>
+          </a:prstGeom>
+          <a:noFill/>
+        </p:spPr>
+        <p:txBody>
+          <a:bodyPr wrap="square">
+            <a:spAutoFit/>
+          </a:bodyPr>
+          <a:lstStyle/>
+          <a:p>
+            <a:pPr>
+              <a:spcAft>
+                <a:spcPts val="600"/>
+              </a:spcAft>
+            </a:pPr>
+            <a:r>
+              <a:rPr sz="1050" b="0">
+                <a:solidFill>
+                  <a:srgbClr val="6E6E6E"/>
+                </a:solidFill>
+                <a:latin typeface="Arial"/>
+              </a:rPr>
+              <a:t>Each directory's README carries the full command list and the run-tag index.</a:t>
+            </a:r>
+          </a:p>
+        </p:txBody>
+      </p:sp>
+    </p:spTree>
+  </p:cSld>
+  <p:clrMapOvr>
+    <a:masterClrMapping/>
+  </p:clrMapOvr>
+</p:sld>
+</file>
+
+<file path=ppt/slides/slide29.xml><?xml version="1.0" encoding="utf-8"?>
+<p:sld xmlns:a="http://schemas.openxmlformats.org/drawingml/2006/main" xmlns:p="http://schemas.openxmlformats.org/presentationml/2006/main" xmlns:r="http://schemas.openxmlformats.org/officeDocument/2006/relationships">
+  <p:cSld>
+    <p:spTree>
+      <p:nvGrpSpPr>
+        <p:cNvPr id="1" name=""/>
+        <p:cNvGrpSpPr/>
+        <p:nvPr/>
+      </p:nvGrpSpPr>
+      <p:grpSpPr/>
+      <p:sp>
+        <p:nvSpPr>
+          <p:cNvPr id="2" name="TextBox 1"/>
+          <p:cNvSpPr txBox="1"/>
+          <p:nvPr/>
+        </p:nvSpPr>
+        <p:spPr>
+          <a:xfrm>
+            <a:off x="411480" y="201168"/>
+            <a:ext cx="11368735" cy="914400"/>
+          </a:xfrm>
+          <a:prstGeom prst="rect">
+            <a:avLst/>
+          </a:prstGeom>
+          <a:noFill/>
+        </p:spPr>
+        <p:txBody>
+          <a:bodyPr wrap="square">
+            <a:spAutoFit/>
+          </a:bodyPr>
+          <a:lstStyle/>
+          <a:p>
+            <a:pPr>
+              <a:spcAft>
+                <a:spcPts val="400"/>
+              </a:spcAft>
+            </a:pPr>
+            <a:r>
+              <a:rPr sz="2400" b="1">
+                <a:solidFill>
+                  <a:srgbClr val="1F4E79"/>
+                </a:solidFill>
+                <a:latin typeface="Arial"/>
+              </a:rPr>
+              <a:t>Backup: the interferometer's three phase-shift forms</a:t>
+            </a:r>
+          </a:p>
+          <a:p>
+            <a:pPr>
+              <a:spcAft>
+                <a:spcPts val="0"/>
+              </a:spcAft>
+            </a:pPr>
+            <a:r>
+              <a:rPr sz="1250" b="0">
+                <a:solidFill>
+                  <a:srgbClr val="6E6E6E"/>
+                </a:solidFill>
+                <a:latin typeface="Arial"/>
+              </a:rPr>
+              <a:t>The four frames are the same in the model; the forms differ in what they get wrong</a:t>
+            </a:r>
+          </a:p>
+        </p:txBody>
+      </p:sp>
+      <p:sp>
+        <p:nvSpPr>
+          <p:cNvPr id="3" name="Rectangle 2"/>
+          <p:cNvSpPr/>
+          <p:nvPr/>
+        </p:nvSpPr>
+        <p:spPr>
+          <a:xfrm>
+            <a:off x="411480" y="1133856"/>
+            <a:ext cx="11368735" cy="20320"/>
+          </a:xfrm>
+          <a:prstGeom prst="rect">
+            <a:avLst/>
+          </a:prstGeom>
+          <a:solidFill>
+            <a:srgbClr val="B8C6D4"/>
+          </a:solidFill>
+          <a:ln>
+            <a:noFill/>
+          </a:ln>
+          <a:effectLst/>
+        </p:spPr>
+        <p:style>
+          <a:lnRef idx="1">
+            <a:schemeClr val="accent1"/>
+          </a:lnRef>
+          <a:fillRef idx="3">
+            <a:schemeClr val="accent1"/>
+          </a:fillRef>
+          <a:effectRef idx="2">
+            <a:schemeClr val="accent1"/>
+          </a:effectRef>
+          <a:fontRef idx="minor">
+            <a:schemeClr val="lt1"/>
+          </a:fontRef>
+        </p:style>
+        <p:txBody>
+          <a:bodyPr rtlCol="0" anchor="ctr"/>
+          <a:lstStyle/>
+          <a:p>
+            <a:pPr algn="ctr"/>
+          </a:p>
+        </p:txBody>
+      </p:sp>
       <p:graphicFrame>
         <p:nvGraphicFramePr>
           <p:cNvPr id="4" name="Table 3"/>
@@ -15159,7 +16187,738 @@
 </p:sld>
 </file>
 
-<file path=ppt/slides/slide29.xml><?xml version="1.0" encoding="utf-8"?>
+<file path=ppt/slides/slide3.xml><?xml version="1.0" encoding="utf-8"?>
+<p:sld xmlns:a="http://schemas.openxmlformats.org/drawingml/2006/main" xmlns:p="http://schemas.openxmlformats.org/presentationml/2006/main" xmlns:r="http://schemas.openxmlformats.org/officeDocument/2006/relationships">
+  <p:cSld>
+    <p:spTree>
+      <p:nvGrpSpPr>
+        <p:cNvPr id="1" name=""/>
+        <p:cNvGrpSpPr/>
+        <p:nvPr/>
+      </p:nvGrpSpPr>
+      <p:grpSpPr/>
+      <p:sp>
+        <p:nvSpPr>
+          <p:cNvPr id="2" name="TextBox 1"/>
+          <p:cNvSpPr txBox="1"/>
+          <p:nvPr/>
+        </p:nvSpPr>
+        <p:spPr>
+          <a:xfrm>
+            <a:off x="411480" y="201168"/>
+            <a:ext cx="11368735" cy="914400"/>
+          </a:xfrm>
+          <a:prstGeom prst="rect">
+            <a:avLst/>
+          </a:prstGeom>
+          <a:noFill/>
+        </p:spPr>
+        <p:txBody>
+          <a:bodyPr wrap="square">
+            <a:spAutoFit/>
+          </a:bodyPr>
+          <a:lstStyle/>
+          <a:p>
+            <a:pPr>
+              <a:spcAft>
+                <a:spcPts val="400"/>
+              </a:spcAft>
+            </a:pPr>
+            <a:r>
+              <a:rPr sz="2400" b="1">
+                <a:solidFill>
+                  <a:srgbClr val="1F4E79"/>
+                </a:solidFill>
+                <a:latin typeface="Arial"/>
+              </a:rPr>
+              <a:t>One bench, four ways of sensing</a:t>
+            </a:r>
+          </a:p>
+          <a:p>
+            <a:pPr>
+              <a:spcAft>
+                <a:spcPts val="0"/>
+              </a:spcAft>
+            </a:pPr>
+            <a:r>
+              <a:rPr sz="1250" b="0">
+                <a:solidFill>
+                  <a:srgbClr val="6E6E6E"/>
+                </a:solidFill>
+                <a:latin typeface="Arial"/>
+              </a:rPr>
+              <a:t>Everything shares the front end: a filtered HeNe, a collimator, a plate splitter at 22.5°, a 700 mm leg to the mirror, a focuser to an internal focus, a field lens to a camera at the pupil image</a:t>
+            </a:r>
+          </a:p>
+        </p:txBody>
+      </p:sp>
+      <p:sp>
+        <p:nvSpPr>
+          <p:cNvPr id="3" name="Rectangle 2"/>
+          <p:cNvSpPr/>
+          <p:nvPr/>
+        </p:nvSpPr>
+        <p:spPr>
+          <a:xfrm>
+            <a:off x="411480" y="1133856"/>
+            <a:ext cx="11368735" cy="20320"/>
+          </a:xfrm>
+          <a:prstGeom prst="rect">
+            <a:avLst/>
+          </a:prstGeom>
+          <a:solidFill>
+            <a:srgbClr val="B8C6D4"/>
+          </a:solidFill>
+          <a:ln>
+            <a:noFill/>
+          </a:ln>
+          <a:effectLst/>
+        </p:spPr>
+        <p:style>
+          <a:lnRef idx="1">
+            <a:schemeClr val="accent1"/>
+          </a:lnRef>
+          <a:fillRef idx="3">
+            <a:schemeClr val="accent1"/>
+          </a:fillRef>
+          <a:effectRef idx="2">
+            <a:schemeClr val="accent1"/>
+          </a:effectRef>
+          <a:fontRef idx="minor">
+            <a:schemeClr val="lt1"/>
+          </a:fontRef>
+        </p:style>
+        <p:txBody>
+          <a:bodyPr rtlCol="0" anchor="ctr"/>
+          <a:lstStyle/>
+          <a:p>
+            <a:pPr algn="ctr"/>
+          </a:p>
+        </p:txBody>
+      </p:sp>
+      <p:pic>
+        <p:nvPicPr>
+          <p:cNvPr id="4" name="Picture 3" descr="crop_bench_bs22_train.png"/>
+          <p:cNvPicPr>
+            <a:picLocks noChangeAspect="1"/>
+          </p:cNvPicPr>
+          <p:nvPr/>
+        </p:nvPicPr>
+        <p:blipFill>
+          <a:blip r:embed="rId2"/>
+          <a:stretch>
+            <a:fillRect/>
+          </a:stretch>
+        </p:blipFill>
+        <p:spPr>
+          <a:xfrm>
+            <a:off x="4061668" y="1298448"/>
+            <a:ext cx="4068357" cy="2348992"/>
+          </a:xfrm>
+          <a:prstGeom prst="rect">
+            <a:avLst/>
+          </a:prstGeom>
+        </p:spPr>
+      </p:pic>
+      <p:sp>
+        <p:nvSpPr>
+          <p:cNvPr id="5" name="TextBox 4"/>
+          <p:cNvSpPr txBox="1"/>
+          <p:nvPr/>
+        </p:nvSpPr>
+        <p:spPr>
+          <a:xfrm>
+            <a:off x="411480" y="3665727"/>
+            <a:ext cx="11368735" cy="394208"/>
+          </a:xfrm>
+          <a:prstGeom prst="rect">
+            <a:avLst/>
+          </a:prstGeom>
+          <a:noFill/>
+        </p:spPr>
+        <p:txBody>
+          <a:bodyPr wrap="square">
+            <a:spAutoFit/>
+          </a:bodyPr>
+          <a:lstStyle/>
+          <a:p>
+            <a:pPr algn="ctr">
+              <a:spcAft>
+                <a:spcPts val="0"/>
+              </a:spcAft>
+            </a:pPr>
+            <a:r>
+              <a:rPr sz="1000" b="0">
+                <a:solidFill>
+                  <a:srgbClr val="6E6E6E"/>
+                </a:solidFill>
+                <a:latin typeface="Arial"/>
+              </a:rPr>
+              <a:t>The shared front end as traced by the engine, seen from above, at the 22.5° splitter: source at left, collimator L1, the splitter, the 96 mm mirror on its 700 mm leg (blue), the reference arm and its flat (orange, the interferometer only), the focuser L2 toward the internal focus.  The mask seat at that focus is where the four sensing methods differ.</a:t>
+            </a:r>
+          </a:p>
+        </p:txBody>
+      </p:sp>
+      <p:graphicFrame>
+        <p:nvGraphicFramePr>
+          <p:cNvPr id="6" name="Table 5"/>
+          <p:cNvGraphicFramePr>
+            <a:graphicFrameLocks noGrp="1"/>
+          </p:cNvGraphicFramePr>
+          <p:nvPr/>
+        </p:nvGraphicFramePr>
+        <p:xfrm>
+          <a:off x="411480" y="4096511"/>
+          <a:ext cx="5806439" cy="1965960"/>
+        </p:xfrm>
+        <a:graphic>
+          <a:graphicData uri="http://schemas.openxmlformats.org/drawingml/2006/table">
+            <a:tbl>
+              <a:tblPr firstRow="1" bandRow="1">
+                <a:tableStyleId>{5C22544A-7EE6-4342-B048-85BDC9FD1C3A}</a:tableStyleId>
+              </a:tblPr>
+              <a:tblGrid>
+                <a:gridCol w="662479"/>
+                <a:gridCol w="5143960"/>
+              </a:tblGrid>
+              <a:tr h="280035">
+                <a:tc>
+                  <a:txBody>
+                    <a:bodyPr wrap="square"/>
+                    <a:lstStyle/>
+                    <a:p>
+                      <a:r>
+                        <a:rPr sz="1100" b="1">
+                          <a:solidFill>
+                            <a:srgbClr val="FFFFFF"/>
+                          </a:solidFill>
+                          <a:latin typeface="Arial"/>
+                        </a:rPr>
+                        <a:t>part</a:t>
+                      </a:r>
+                    </a:p>
+                  </a:txBody>
+                  <a:tcPr marL="54864" marR="54864" marT="18288" marB="18288">
+                    <a:solidFill>
+                      <a:srgbClr val="1F4E79"/>
+                    </a:solidFill>
+                  </a:tcPr>
+                </a:tc>
+                <a:tc>
+                  <a:txBody>
+                    <a:bodyPr wrap="square"/>
+                    <a:lstStyle/>
+                    <a:p>
+                      <a:r>
+                        <a:rPr sz="1100" b="1">
+                          <a:solidFill>
+                            <a:srgbClr val="FFFFFF"/>
+                          </a:solidFill>
+                          <a:latin typeface="Arial"/>
+                        </a:rPr>
+                        <a:t>value</a:t>
+                      </a:r>
+                    </a:p>
+                  </a:txBody>
+                  <a:tcPr marL="54864" marR="54864" marT="18288" marB="18288">
+                    <a:solidFill>
+                      <a:srgbClr val="1F4E79"/>
+                    </a:solidFill>
+                  </a:tcPr>
+                </a:tc>
+              </a:tr>
+              <a:tr h="280035">
+                <a:tc>
+                  <a:txBody>
+                    <a:bodyPr wrap="square"/>
+                    <a:lstStyle/>
+                    <a:p>
+                      <a:r>
+                        <a:rPr sz="1100" b="0">
+                          <a:solidFill>
+                            <a:srgbClr val="282828"/>
+                          </a:solidFill>
+                          <a:latin typeface="Arial"/>
+                        </a:rPr>
+                        <a:t>source</a:t>
+                      </a:r>
+                    </a:p>
+                  </a:txBody>
+                  <a:tcPr marL="54864" marR="54864" marT="18288" marB="18288">
+                    <a:solidFill>
+                      <a:srgbClr val="FFFFFF"/>
+                    </a:solidFill>
+                  </a:tcPr>
+                </a:tc>
+                <a:tc>
+                  <a:txBody>
+                    <a:bodyPr wrap="square"/>
+                    <a:lstStyle/>
+                    <a:p>
+                      <a:r>
+                        <a:rPr sz="1100" b="0">
+                          <a:solidFill>
+                            <a:srgbClr val="282828"/>
+                          </a:solidFill>
+                          <a:latin typeface="Arial"/>
+                        </a:rPr>
+                        <a:t>HeNe 632.8 nm, filtered, 51 mm beam radius</a:t>
+                      </a:r>
+                    </a:p>
+                  </a:txBody>
+                  <a:tcPr marL="54864" marR="54864" marT="18288" marB="18288">
+                    <a:solidFill>
+                      <a:srgbClr val="FFFFFF"/>
+                    </a:solidFill>
+                  </a:tcPr>
+                </a:tc>
+              </a:tr>
+              <a:tr h="468630">
+                <a:tc>
+                  <a:txBody>
+                    <a:bodyPr wrap="square"/>
+                    <a:lstStyle/>
+                    <a:p>
+                      <a:r>
+                        <a:rPr sz="1100" b="0">
+                          <a:solidFill>
+                            <a:srgbClr val="282828"/>
+                          </a:solidFill>
+                          <a:latin typeface="Arial"/>
+                        </a:rPr>
+                        <a:t>collimator L1</a:t>
+                      </a:r>
+                    </a:p>
+                  </a:txBody>
+                  <a:tcPr marL="54864" marR="54864" marT="18288" marB="18288">
+                    <a:solidFill>
+                      <a:srgbClr val="ECF1F6"/>
+                    </a:solidFill>
+                  </a:tcPr>
+                </a:tc>
+                <a:tc>
+                  <a:txBody>
+                    <a:bodyPr wrap="square"/>
+                    <a:lstStyle/>
+                    <a:p>
+                      <a:r>
+                        <a:rPr sz="1100" b="0">
+                          <a:solidFill>
+                            <a:srgbClr val="282828"/>
+                          </a:solidFill>
+                          <a:latin typeface="Arial"/>
+                        </a:rPr>
+                        <a:t>f 857 mm, 103 mm, coated; modeled 5 mm center, 2 mm edge, to be a real 103 mm singlet</a:t>
+                      </a:r>
+                    </a:p>
+                  </a:txBody>
+                  <a:tcPr marL="54864" marR="54864" marT="18288" marB="18288">
+                    <a:solidFill>
+                      <a:srgbClr val="ECF1F6"/>
+                    </a:solidFill>
+                  </a:tcPr>
+                </a:tc>
+              </a:tr>
+              <a:tr h="468630">
+                <a:tc>
+                  <a:txBody>
+                    <a:bodyPr wrap="square"/>
+                    <a:lstStyle/>
+                    <a:p>
+                      <a:r>
+                        <a:rPr sz="1100" b="0">
+                          <a:solidFill>
+                            <a:srgbClr val="282828"/>
+                          </a:solidFill>
+                          <a:latin typeface="Arial"/>
+                        </a:rPr>
+                        <a:t>plate splitter</a:t>
+                      </a:r>
+                    </a:p>
+                  </a:txBody>
+                  <a:tcPr marL="54864" marR="54864" marT="18288" marB="18288">
+                    <a:solidFill>
+                      <a:srgbClr val="FFFFFF"/>
+                    </a:solidFill>
+                  </a:tcPr>
+                </a:tc>
+                <a:tc>
+                  <a:txBody>
+                    <a:bodyPr wrap="square"/>
+                    <a:lstStyle/>
+                    <a:p>
+                      <a:r>
+                        <a:rPr sz="1100" b="0">
+                          <a:solidFill>
+                            <a:srgbClr val="282828"/>
+                          </a:solidFill>
+                          <a:latin typeface="Arial"/>
+                        </a:rPr>
+                        <a:t>22.5° incidence (the record's 7° does not clear the node: next slide), 50/50; compensator matched; modeled 2.6 mm thick, to be 10 mm</a:t>
+                      </a:r>
+                    </a:p>
+                  </a:txBody>
+                  <a:tcPr marL="54864" marR="54864" marT="18288" marB="18288">
+                    <a:solidFill>
+                      <a:srgbClr val="FFFFFF"/>
+                    </a:solidFill>
+                  </a:tcPr>
+                </a:tc>
+              </a:tr>
+              <a:tr h="468630">
+                <a:tc>
+                  <a:txBody>
+                    <a:bodyPr wrap="square"/>
+                    <a:lstStyle/>
+                    <a:p>
+                      <a:r>
+                        <a:rPr sz="1100" b="0">
+                          <a:solidFill>
+                            <a:srgbClr val="282828"/>
+                          </a:solidFill>
+                          <a:latin typeface="Arial"/>
+                        </a:rPr>
+                        <a:t>deformable mirror</a:t>
+                      </a:r>
+                    </a:p>
+                  </a:txBody>
+                  <a:tcPr marL="54864" marR="54864" marT="18288" marB="18288">
+                    <a:solidFill>
+                      <a:srgbClr val="ECF1F6"/>
+                    </a:solidFill>
+                  </a:tcPr>
+                </a:tc>
+                <a:tc>
+                  <a:txBody>
+                    <a:bodyPr wrap="square"/>
+                    <a:lstStyle/>
+                    <a:p>
+                      <a:r>
+                        <a:rPr sz="1100" b="0">
+                          <a:solidFill>
+                            <a:srgbClr val="282828"/>
+                          </a:solidFill>
+                          <a:latin typeface="Arial"/>
+                        </a:rPr>
+                        <a:t>96×96, 1 mm pitch, 96 mm, 700 mm leg</a:t>
+                      </a:r>
+                    </a:p>
+                  </a:txBody>
+                  <a:tcPr marL="54864" marR="54864" marT="18288" marB="18288">
+                    <a:solidFill>
+                      <a:srgbClr val="ECF1F6"/>
+                    </a:solidFill>
+                  </a:tcPr>
+                </a:tc>
+              </a:tr>
+            </a:tbl>
+          </a:graphicData>
+        </a:graphic>
+      </p:graphicFrame>
+      <p:graphicFrame>
+        <p:nvGraphicFramePr>
+          <p:cNvPr id="7" name="Table 6"/>
+          <p:cNvGraphicFramePr>
+            <a:graphicFrameLocks noGrp="1"/>
+          </p:cNvGraphicFramePr>
+          <p:nvPr/>
+        </p:nvGraphicFramePr>
+        <p:xfrm>
+          <a:off x="6400800" y="4096511"/>
+          <a:ext cx="5394960" cy="1657350"/>
+        </p:xfrm>
+        <a:graphic>
+          <a:graphicData uri="http://schemas.openxmlformats.org/drawingml/2006/table">
+            <a:tbl>
+              <a:tblPr firstRow="1" bandRow="1">
+                <a:tableStyleId>{5C22544A-7EE6-4342-B048-85BDC9FD1C3A}</a:tableStyleId>
+              </a:tblPr>
+              <a:tblGrid>
+                <a:gridCol w="806704"/>
+                <a:gridCol w="4588256"/>
+              </a:tblGrid>
+              <a:tr h="262890">
+                <a:tc>
+                  <a:txBody>
+                    <a:bodyPr wrap="square"/>
+                    <a:lstStyle/>
+                    <a:p>
+                      <a:r>
+                        <a:rPr sz="1000" b="1">
+                          <a:solidFill>
+                            <a:srgbClr val="FFFFFF"/>
+                          </a:solidFill>
+                          <a:latin typeface="Arial"/>
+                        </a:rPr>
+                        <a:t>part</a:t>
+                      </a:r>
+                    </a:p>
+                  </a:txBody>
+                  <a:tcPr marL="54864" marR="54864" marT="18288" marB="18288">
+                    <a:solidFill>
+                      <a:srgbClr val="1F4E79"/>
+                    </a:solidFill>
+                  </a:tcPr>
+                </a:tc>
+                <a:tc>
+                  <a:txBody>
+                    <a:bodyPr wrap="square"/>
+                    <a:lstStyle/>
+                    <a:p>
+                      <a:r>
+                        <a:rPr sz="1000" b="1">
+                          <a:solidFill>
+                            <a:srgbClr val="FFFFFF"/>
+                          </a:solidFill>
+                          <a:latin typeface="Arial"/>
+                        </a:rPr>
+                        <a:t>value</a:t>
+                      </a:r>
+                    </a:p>
+                  </a:txBody>
+                  <a:tcPr marL="54864" marR="54864" marT="18288" marB="18288">
+                    <a:solidFill>
+                      <a:srgbClr val="1F4E79"/>
+                    </a:solidFill>
+                  </a:tcPr>
+                </a:tc>
+              </a:tr>
+              <a:tr h="434340">
+                <a:tc>
+                  <a:txBody>
+                    <a:bodyPr wrap="square"/>
+                    <a:lstStyle/>
+                    <a:p>
+                      <a:r>
+                        <a:rPr sz="1000" b="0">
+                          <a:solidFill>
+                            <a:srgbClr val="282828"/>
+                          </a:solidFill>
+                          <a:latin typeface="Arial"/>
+                        </a:rPr>
+                        <a:t>focuser L2</a:t>
+                      </a:r>
+                    </a:p>
+                  </a:txBody>
+                  <a:tcPr marL="54864" marR="54864" marT="18288" marB="18288">
+                    <a:solidFill>
+                      <a:srgbClr val="FFFFFF"/>
+                    </a:solidFill>
+                  </a:tcPr>
+                </a:tc>
+                <a:tc>
+                  <a:txBody>
+                    <a:bodyPr wrap="square"/>
+                    <a:lstStyle/>
+                    <a:p>
+                      <a:r>
+                        <a:rPr sz="1000" b="0">
+                          <a:solidFill>
+                            <a:srgbClr val="282828"/>
+                          </a:solidFill>
+                          <a:latin typeface="Arial"/>
+                        </a:rPr>
+                        <a:t>f 429 mm, 103 mm; internal focus at F/4.2; modeled 8 mm center, to be real</a:t>
+                      </a:r>
+                    </a:p>
+                  </a:txBody>
+                  <a:tcPr marL="54864" marR="54864" marT="18288" marB="18288">
+                    <a:solidFill>
+                      <a:srgbClr val="FFFFFF"/>
+                    </a:solidFill>
+                  </a:tcPr>
+                </a:tc>
+              </a:tr>
+              <a:tr h="262890">
+                <a:tc>
+                  <a:txBody>
+                    <a:bodyPr wrap="square"/>
+                    <a:lstStyle/>
+                    <a:p>
+                      <a:r>
+                        <a:rPr sz="1000" b="0">
+                          <a:solidFill>
+                            <a:srgbClr val="282828"/>
+                          </a:solidFill>
+                          <a:latin typeface="Arial"/>
+                        </a:rPr>
+                        <a:t>field lens</a:t>
+                      </a:r>
+                    </a:p>
+                  </a:txBody>
+                  <a:tcPr marL="54864" marR="54864" marT="18288" marB="18288">
+                    <a:solidFill>
+                      <a:srgbClr val="ECF1F6"/>
+                    </a:solidFill>
+                  </a:tcPr>
+                </a:tc>
+                <a:tc>
+                  <a:txBody>
+                    <a:bodyPr wrap="square"/>
+                    <a:lstStyle/>
+                    <a:p>
+                      <a:r>
+                        <a:rPr sz="1000" b="0">
+                          <a:solidFill>
+                            <a:srgbClr val="282828"/>
+                          </a:solidFill>
+                          <a:latin typeface="Arial"/>
+                        </a:rPr>
+                        <a:t>f 43 mm, 21 mm; pupil image 9.4 mm, 32 mm behind it</a:t>
+                      </a:r>
+                    </a:p>
+                  </a:txBody>
+                  <a:tcPr marL="54864" marR="54864" marT="18288" marB="18288">
+                    <a:solidFill>
+                      <a:srgbClr val="ECF1F6"/>
+                    </a:solidFill>
+                  </a:tcPr>
+                </a:tc>
+              </a:tr>
+              <a:tr h="434340">
+                <a:tc>
+                  <a:txBody>
+                    <a:bodyPr wrap="square"/>
+                    <a:lstStyle/>
+                    <a:p>
+                      <a:r>
+                        <a:rPr sz="1000" b="0">
+                          <a:solidFill>
+                            <a:srgbClr val="282828"/>
+                          </a:solidFill>
+                          <a:latin typeface="Arial"/>
+                        </a:rPr>
+                        <a:t>camera</a:t>
+                      </a:r>
+                    </a:p>
+                  </a:txBody>
+                  <a:tcPr marL="54864" marR="54864" marT="18288" marB="18288">
+                    <a:solidFill>
+                      <a:srgbClr val="FFFFFF"/>
+                    </a:solidFill>
+                  </a:tcPr>
+                </a:tc>
+                <a:tc>
+                  <a:txBody>
+                    <a:bodyPr wrap="square"/>
+                    <a:lstStyle/>
+                    <a:p>
+                      <a:r>
+                        <a:rPr sz="1000" b="0">
+                          <a:solidFill>
+                            <a:srgbClr val="282828"/>
+                          </a:solidFill>
+                          <a:latin typeface="Arial"/>
+                        </a:rPr>
+                        <a:t>pupil image 9.4 mm: a 6.5 µm sCMOS puts 1450 pixels across it, binned 4 to the modeled 385 (5 per actuator)</a:t>
+                      </a:r>
+                    </a:p>
+                  </a:txBody>
+                  <a:tcPr marL="54864" marR="54864" marT="18288" marB="18288">
+                    <a:solidFill>
+                      <a:srgbClr val="FFFFFF"/>
+                    </a:solidFill>
+                  </a:tcPr>
+                </a:tc>
+              </a:tr>
+              <a:tr h="262890">
+                <a:tc>
+                  <a:txBody>
+                    <a:bodyPr wrap="square"/>
+                    <a:lstStyle/>
+                    <a:p>
+                      <a:r>
+                        <a:rPr sz="1000" b="0">
+                          <a:solidFill>
+                            <a:srgbClr val="282828"/>
+                          </a:solidFill>
+                          <a:latin typeface="Arial"/>
+                        </a:rPr>
+                        <a:t>mask seat</a:t>
+                      </a:r>
+                    </a:p>
+                  </a:txBody>
+                  <a:tcPr marL="54864" marR="54864" marT="18288" marB="18288">
+                    <a:solidFill>
+                      <a:srgbClr val="ECF1F6"/>
+                    </a:solidFill>
+                  </a:tcPr>
+                </a:tc>
+                <a:tc>
+                  <a:txBody>
+                    <a:bodyPr wrap="square"/>
+                    <a:lstStyle/>
+                    <a:p>
+                      <a:r>
+                        <a:rPr sz="1000" b="0">
+                          <a:solidFill>
+                            <a:srgbClr val="282828"/>
+                          </a:solidFill>
+                          <a:latin typeface="Arial"/>
+                        </a:rPr>
+                        <a:t>one substrate at the internal focus, translated to select the sensor</a:t>
+                      </a:r>
+                    </a:p>
+                  </a:txBody>
+                  <a:tcPr marL="54864" marR="54864" marT="18288" marB="18288">
+                    <a:solidFill>
+                      <a:srgbClr val="ECF1F6"/>
+                    </a:solidFill>
+                  </a:tcPr>
+                </a:tc>
+              </a:tr>
+            </a:tbl>
+          </a:graphicData>
+        </a:graphic>
+      </p:graphicFrame>
+      <p:sp>
+        <p:nvSpPr>
+          <p:cNvPr id="8" name="TextBox 7"/>
+          <p:cNvSpPr txBox="1"/>
+          <p:nvPr/>
+        </p:nvSpPr>
+        <p:spPr>
+          <a:xfrm>
+            <a:off x="6400800" y="5900166"/>
+            <a:ext cx="5394960" cy="274320"/>
+          </a:xfrm>
+          <a:prstGeom prst="rect">
+            <a:avLst/>
+          </a:prstGeom>
+          <a:noFill/>
+        </p:spPr>
+        <p:txBody>
+          <a:bodyPr wrap="square">
+            <a:spAutoFit/>
+          </a:bodyPr>
+          <a:lstStyle/>
+          <a:p>
+            <a:pPr>
+              <a:spcAft>
+                <a:spcPts val="600"/>
+              </a:spcAft>
+            </a:pPr>
+            <a:r>
+              <a:rPr sz="1050" b="0">
+                <a:solidFill>
+                  <a:srgbClr val="6E6E6E"/>
+                </a:solidFill>
+                <a:latin typeface="Arial"/>
+              </a:rPr>
+              <a:t>The reference arm (a 103 mm flat on a piezo stage, 564 mm leg) is the interferometer's; shuttered, the same bench is every other sensor.  Lenses, not off-axis mirrors: the choice is priced on the lenses-versus-mirrors slide.  The drawings are to scale: the model's parts are the 56 mm rig's scaled up, thinner than 103 mm optics can be built; the next model round gives every part its real thickness.</a:t>
+            </a:r>
+          </a:p>
+        </p:txBody>
+      </p:sp>
+    </p:spTree>
+  </p:cSld>
+  <p:clrMapOvr>
+    <a:masterClrMapping/>
+  </p:clrMapOvr>
+</p:sld>
+</file>
+
+<file path=ppt/slides/slide30.xml><?xml version="1.0" encoding="utf-8"?>
 <p:sld xmlns:a="http://schemas.openxmlformats.org/drawingml/2006/main" xmlns:p="http://schemas.openxmlformats.org/presentationml/2006/main" xmlns:r="http://schemas.openxmlformats.org/officeDocument/2006/relationships">
   <p:cSld>
     <p:spTree>
@@ -16007,738 +17766,7 @@
 </p:sld>
 </file>
 
-<file path=ppt/slides/slide3.xml><?xml version="1.0" encoding="utf-8"?>
-<p:sld xmlns:a="http://schemas.openxmlformats.org/drawingml/2006/main" xmlns:p="http://schemas.openxmlformats.org/presentationml/2006/main" xmlns:r="http://schemas.openxmlformats.org/officeDocument/2006/relationships">
-  <p:cSld>
-    <p:spTree>
-      <p:nvGrpSpPr>
-        <p:cNvPr id="1" name=""/>
-        <p:cNvGrpSpPr/>
-        <p:nvPr/>
-      </p:nvGrpSpPr>
-      <p:grpSpPr/>
-      <p:sp>
-        <p:nvSpPr>
-          <p:cNvPr id="2" name="TextBox 1"/>
-          <p:cNvSpPr txBox="1"/>
-          <p:nvPr/>
-        </p:nvSpPr>
-        <p:spPr>
-          <a:xfrm>
-            <a:off x="411480" y="201168"/>
-            <a:ext cx="11368735" cy="914400"/>
-          </a:xfrm>
-          <a:prstGeom prst="rect">
-            <a:avLst/>
-          </a:prstGeom>
-          <a:noFill/>
-        </p:spPr>
-        <p:txBody>
-          <a:bodyPr wrap="square">
-            <a:spAutoFit/>
-          </a:bodyPr>
-          <a:lstStyle/>
-          <a:p>
-            <a:pPr>
-              <a:spcAft>
-                <a:spcPts val="400"/>
-              </a:spcAft>
-            </a:pPr>
-            <a:r>
-              <a:rPr sz="2400" b="1">
-                <a:solidFill>
-                  <a:srgbClr val="1F4E79"/>
-                </a:solidFill>
-                <a:latin typeface="Arial"/>
-              </a:rPr>
-              <a:t>One bench, four ways of sensing</a:t>
-            </a:r>
-          </a:p>
-          <a:p>
-            <a:pPr>
-              <a:spcAft>
-                <a:spcPts val="0"/>
-              </a:spcAft>
-            </a:pPr>
-            <a:r>
-              <a:rPr sz="1250" b="0">
-                <a:solidFill>
-                  <a:srgbClr val="6E6E6E"/>
-                </a:solidFill>
-                <a:latin typeface="Arial"/>
-              </a:rPr>
-              <a:t>Everything shares the front end: a filtered HeNe, a collimator, a plate splitter at 22.5°, a 700 mm leg to the mirror, a focuser to an internal focus, a field lens to a camera at the pupil image</a:t>
-            </a:r>
-          </a:p>
-        </p:txBody>
-      </p:sp>
-      <p:sp>
-        <p:nvSpPr>
-          <p:cNvPr id="3" name="Rectangle 2"/>
-          <p:cNvSpPr/>
-          <p:nvPr/>
-        </p:nvSpPr>
-        <p:spPr>
-          <a:xfrm>
-            <a:off x="411480" y="1133856"/>
-            <a:ext cx="11368735" cy="20320"/>
-          </a:xfrm>
-          <a:prstGeom prst="rect">
-            <a:avLst/>
-          </a:prstGeom>
-          <a:solidFill>
-            <a:srgbClr val="B8C6D4"/>
-          </a:solidFill>
-          <a:ln>
-            <a:noFill/>
-          </a:ln>
-          <a:effectLst/>
-        </p:spPr>
-        <p:style>
-          <a:lnRef idx="1">
-            <a:schemeClr val="accent1"/>
-          </a:lnRef>
-          <a:fillRef idx="3">
-            <a:schemeClr val="accent1"/>
-          </a:fillRef>
-          <a:effectRef idx="2">
-            <a:schemeClr val="accent1"/>
-          </a:effectRef>
-          <a:fontRef idx="minor">
-            <a:schemeClr val="lt1"/>
-          </a:fontRef>
-        </p:style>
-        <p:txBody>
-          <a:bodyPr rtlCol="0" anchor="ctr"/>
-          <a:lstStyle/>
-          <a:p>
-            <a:pPr algn="ctr"/>
-          </a:p>
-        </p:txBody>
-      </p:sp>
-      <p:pic>
-        <p:nvPicPr>
-          <p:cNvPr id="4" name="Picture 3" descr="crop_bench_bs22_train.png"/>
-          <p:cNvPicPr>
-            <a:picLocks noChangeAspect="1"/>
-          </p:cNvPicPr>
-          <p:nvPr/>
-        </p:nvPicPr>
-        <p:blipFill>
-          <a:blip r:embed="rId2"/>
-          <a:stretch>
-            <a:fillRect/>
-          </a:stretch>
-        </p:blipFill>
-        <p:spPr>
-          <a:xfrm>
-            <a:off x="4061668" y="1298448"/>
-            <a:ext cx="4068357" cy="2348992"/>
-          </a:xfrm>
-          <a:prstGeom prst="rect">
-            <a:avLst/>
-          </a:prstGeom>
-        </p:spPr>
-      </p:pic>
-      <p:sp>
-        <p:nvSpPr>
-          <p:cNvPr id="5" name="TextBox 4"/>
-          <p:cNvSpPr txBox="1"/>
-          <p:nvPr/>
-        </p:nvSpPr>
-        <p:spPr>
-          <a:xfrm>
-            <a:off x="411480" y="3665727"/>
-            <a:ext cx="11368735" cy="394208"/>
-          </a:xfrm>
-          <a:prstGeom prst="rect">
-            <a:avLst/>
-          </a:prstGeom>
-          <a:noFill/>
-        </p:spPr>
-        <p:txBody>
-          <a:bodyPr wrap="square">
-            <a:spAutoFit/>
-          </a:bodyPr>
-          <a:lstStyle/>
-          <a:p>
-            <a:pPr algn="ctr">
-              <a:spcAft>
-                <a:spcPts val="0"/>
-              </a:spcAft>
-            </a:pPr>
-            <a:r>
-              <a:rPr sz="1000" b="0">
-                <a:solidFill>
-                  <a:srgbClr val="6E6E6E"/>
-                </a:solidFill>
-                <a:latin typeface="Arial"/>
-              </a:rPr>
-              <a:t>The shared front end as traced by the engine, seen from above, at the 22.5° splitter: source at left, collimator L1, the splitter, the 96 mm mirror on its 700 mm leg (blue), the reference arm and its flat (orange, the interferometer only), the focuser L2 toward the internal focus.  The mask seat at that focus is where the four sensing methods differ.</a:t>
-            </a:r>
-          </a:p>
-        </p:txBody>
-      </p:sp>
-      <p:graphicFrame>
-        <p:nvGraphicFramePr>
-          <p:cNvPr id="6" name="Table 5"/>
-          <p:cNvGraphicFramePr>
-            <a:graphicFrameLocks noGrp="1"/>
-          </p:cNvGraphicFramePr>
-          <p:nvPr/>
-        </p:nvGraphicFramePr>
-        <p:xfrm>
-          <a:off x="411480" y="4096511"/>
-          <a:ext cx="5806439" cy="1965960"/>
-        </p:xfrm>
-        <a:graphic>
-          <a:graphicData uri="http://schemas.openxmlformats.org/drawingml/2006/table">
-            <a:tbl>
-              <a:tblPr firstRow="1" bandRow="1">
-                <a:tableStyleId>{5C22544A-7EE6-4342-B048-85BDC9FD1C3A}</a:tableStyleId>
-              </a:tblPr>
-              <a:tblGrid>
-                <a:gridCol w="662479"/>
-                <a:gridCol w="5143960"/>
-              </a:tblGrid>
-              <a:tr h="280035">
-                <a:tc>
-                  <a:txBody>
-                    <a:bodyPr wrap="square"/>
-                    <a:lstStyle/>
-                    <a:p>
-                      <a:r>
-                        <a:rPr sz="1100" b="1">
-                          <a:solidFill>
-                            <a:srgbClr val="FFFFFF"/>
-                          </a:solidFill>
-                          <a:latin typeface="Arial"/>
-                        </a:rPr>
-                        <a:t>part</a:t>
-                      </a:r>
-                    </a:p>
-                  </a:txBody>
-                  <a:tcPr marL="54864" marR="54864" marT="18288" marB="18288">
-                    <a:solidFill>
-                      <a:srgbClr val="1F4E79"/>
-                    </a:solidFill>
-                  </a:tcPr>
-                </a:tc>
-                <a:tc>
-                  <a:txBody>
-                    <a:bodyPr wrap="square"/>
-                    <a:lstStyle/>
-                    <a:p>
-                      <a:r>
-                        <a:rPr sz="1100" b="1">
-                          <a:solidFill>
-                            <a:srgbClr val="FFFFFF"/>
-                          </a:solidFill>
-                          <a:latin typeface="Arial"/>
-                        </a:rPr>
-                        <a:t>value</a:t>
-                      </a:r>
-                    </a:p>
-                  </a:txBody>
-                  <a:tcPr marL="54864" marR="54864" marT="18288" marB="18288">
-                    <a:solidFill>
-                      <a:srgbClr val="1F4E79"/>
-                    </a:solidFill>
-                  </a:tcPr>
-                </a:tc>
-              </a:tr>
-              <a:tr h="280035">
-                <a:tc>
-                  <a:txBody>
-                    <a:bodyPr wrap="square"/>
-                    <a:lstStyle/>
-                    <a:p>
-                      <a:r>
-                        <a:rPr sz="1100" b="0">
-                          <a:solidFill>
-                            <a:srgbClr val="282828"/>
-                          </a:solidFill>
-                          <a:latin typeface="Arial"/>
-                        </a:rPr>
-                        <a:t>source</a:t>
-                      </a:r>
-                    </a:p>
-                  </a:txBody>
-                  <a:tcPr marL="54864" marR="54864" marT="18288" marB="18288">
-                    <a:solidFill>
-                      <a:srgbClr val="FFFFFF"/>
-                    </a:solidFill>
-                  </a:tcPr>
-                </a:tc>
-                <a:tc>
-                  <a:txBody>
-                    <a:bodyPr wrap="square"/>
-                    <a:lstStyle/>
-                    <a:p>
-                      <a:r>
-                        <a:rPr sz="1100" b="0">
-                          <a:solidFill>
-                            <a:srgbClr val="282828"/>
-                          </a:solidFill>
-                          <a:latin typeface="Arial"/>
-                        </a:rPr>
-                        <a:t>HeNe 632.8 nm, filtered, 51 mm beam radius</a:t>
-                      </a:r>
-                    </a:p>
-                  </a:txBody>
-                  <a:tcPr marL="54864" marR="54864" marT="18288" marB="18288">
-                    <a:solidFill>
-                      <a:srgbClr val="FFFFFF"/>
-                    </a:solidFill>
-                  </a:tcPr>
-                </a:tc>
-              </a:tr>
-              <a:tr h="468630">
-                <a:tc>
-                  <a:txBody>
-                    <a:bodyPr wrap="square"/>
-                    <a:lstStyle/>
-                    <a:p>
-                      <a:r>
-                        <a:rPr sz="1100" b="0">
-                          <a:solidFill>
-                            <a:srgbClr val="282828"/>
-                          </a:solidFill>
-                          <a:latin typeface="Arial"/>
-                        </a:rPr>
-                        <a:t>collimator L1</a:t>
-                      </a:r>
-                    </a:p>
-                  </a:txBody>
-                  <a:tcPr marL="54864" marR="54864" marT="18288" marB="18288">
-                    <a:solidFill>
-                      <a:srgbClr val="ECF1F6"/>
-                    </a:solidFill>
-                  </a:tcPr>
-                </a:tc>
-                <a:tc>
-                  <a:txBody>
-                    <a:bodyPr wrap="square"/>
-                    <a:lstStyle/>
-                    <a:p>
-                      <a:r>
-                        <a:rPr sz="1100" b="0">
-                          <a:solidFill>
-                            <a:srgbClr val="282828"/>
-                          </a:solidFill>
-                          <a:latin typeface="Arial"/>
-                        </a:rPr>
-                        <a:t>f 857 mm, 103 mm, coated; modeled 5 mm center, 2 mm edge, to be a real 103 mm singlet</a:t>
-                      </a:r>
-                    </a:p>
-                  </a:txBody>
-                  <a:tcPr marL="54864" marR="54864" marT="18288" marB="18288">
-                    <a:solidFill>
-                      <a:srgbClr val="ECF1F6"/>
-                    </a:solidFill>
-                  </a:tcPr>
-                </a:tc>
-              </a:tr>
-              <a:tr h="468630">
-                <a:tc>
-                  <a:txBody>
-                    <a:bodyPr wrap="square"/>
-                    <a:lstStyle/>
-                    <a:p>
-                      <a:r>
-                        <a:rPr sz="1100" b="0">
-                          <a:solidFill>
-                            <a:srgbClr val="282828"/>
-                          </a:solidFill>
-                          <a:latin typeface="Arial"/>
-                        </a:rPr>
-                        <a:t>plate splitter</a:t>
-                      </a:r>
-                    </a:p>
-                  </a:txBody>
-                  <a:tcPr marL="54864" marR="54864" marT="18288" marB="18288">
-                    <a:solidFill>
-                      <a:srgbClr val="FFFFFF"/>
-                    </a:solidFill>
-                  </a:tcPr>
-                </a:tc>
-                <a:tc>
-                  <a:txBody>
-                    <a:bodyPr wrap="square"/>
-                    <a:lstStyle/>
-                    <a:p>
-                      <a:r>
-                        <a:rPr sz="1100" b="0">
-                          <a:solidFill>
-                            <a:srgbClr val="282828"/>
-                          </a:solidFill>
-                          <a:latin typeface="Arial"/>
-                        </a:rPr>
-                        <a:t>22.5° incidence (the record's 7° does not clear the node: next slide), 50/50; compensator matched; modeled 2.6 mm thick, to be 10 mm</a:t>
-                      </a:r>
-                    </a:p>
-                  </a:txBody>
-                  <a:tcPr marL="54864" marR="54864" marT="18288" marB="18288">
-                    <a:solidFill>
-                      <a:srgbClr val="FFFFFF"/>
-                    </a:solidFill>
-                  </a:tcPr>
-                </a:tc>
-              </a:tr>
-              <a:tr h="468630">
-                <a:tc>
-                  <a:txBody>
-                    <a:bodyPr wrap="square"/>
-                    <a:lstStyle/>
-                    <a:p>
-                      <a:r>
-                        <a:rPr sz="1100" b="0">
-                          <a:solidFill>
-                            <a:srgbClr val="282828"/>
-                          </a:solidFill>
-                          <a:latin typeface="Arial"/>
-                        </a:rPr>
-                        <a:t>deformable mirror</a:t>
-                      </a:r>
-                    </a:p>
-                  </a:txBody>
-                  <a:tcPr marL="54864" marR="54864" marT="18288" marB="18288">
-                    <a:solidFill>
-                      <a:srgbClr val="ECF1F6"/>
-                    </a:solidFill>
-                  </a:tcPr>
-                </a:tc>
-                <a:tc>
-                  <a:txBody>
-                    <a:bodyPr wrap="square"/>
-                    <a:lstStyle/>
-                    <a:p>
-                      <a:r>
-                        <a:rPr sz="1100" b="0">
-                          <a:solidFill>
-                            <a:srgbClr val="282828"/>
-                          </a:solidFill>
-                          <a:latin typeface="Arial"/>
-                        </a:rPr>
-                        <a:t>96×96, 1 mm pitch, 96 mm, 700 mm leg</a:t>
-                      </a:r>
-                    </a:p>
-                  </a:txBody>
-                  <a:tcPr marL="54864" marR="54864" marT="18288" marB="18288">
-                    <a:solidFill>
-                      <a:srgbClr val="ECF1F6"/>
-                    </a:solidFill>
-                  </a:tcPr>
-                </a:tc>
-              </a:tr>
-            </a:tbl>
-          </a:graphicData>
-        </a:graphic>
-      </p:graphicFrame>
-      <p:graphicFrame>
-        <p:nvGraphicFramePr>
-          <p:cNvPr id="7" name="Table 6"/>
-          <p:cNvGraphicFramePr>
-            <a:graphicFrameLocks noGrp="1"/>
-          </p:cNvGraphicFramePr>
-          <p:nvPr/>
-        </p:nvGraphicFramePr>
-        <p:xfrm>
-          <a:off x="6400800" y="4096511"/>
-          <a:ext cx="5394960" cy="1657350"/>
-        </p:xfrm>
-        <a:graphic>
-          <a:graphicData uri="http://schemas.openxmlformats.org/drawingml/2006/table">
-            <a:tbl>
-              <a:tblPr firstRow="1" bandRow="1">
-                <a:tableStyleId>{5C22544A-7EE6-4342-B048-85BDC9FD1C3A}</a:tableStyleId>
-              </a:tblPr>
-              <a:tblGrid>
-                <a:gridCol w="806704"/>
-                <a:gridCol w="4588256"/>
-              </a:tblGrid>
-              <a:tr h="262890">
-                <a:tc>
-                  <a:txBody>
-                    <a:bodyPr wrap="square"/>
-                    <a:lstStyle/>
-                    <a:p>
-                      <a:r>
-                        <a:rPr sz="1000" b="1">
-                          <a:solidFill>
-                            <a:srgbClr val="FFFFFF"/>
-                          </a:solidFill>
-                          <a:latin typeface="Arial"/>
-                        </a:rPr>
-                        <a:t>part</a:t>
-                      </a:r>
-                    </a:p>
-                  </a:txBody>
-                  <a:tcPr marL="54864" marR="54864" marT="18288" marB="18288">
-                    <a:solidFill>
-                      <a:srgbClr val="1F4E79"/>
-                    </a:solidFill>
-                  </a:tcPr>
-                </a:tc>
-                <a:tc>
-                  <a:txBody>
-                    <a:bodyPr wrap="square"/>
-                    <a:lstStyle/>
-                    <a:p>
-                      <a:r>
-                        <a:rPr sz="1000" b="1">
-                          <a:solidFill>
-                            <a:srgbClr val="FFFFFF"/>
-                          </a:solidFill>
-                          <a:latin typeface="Arial"/>
-                        </a:rPr>
-                        <a:t>value</a:t>
-                      </a:r>
-                    </a:p>
-                  </a:txBody>
-                  <a:tcPr marL="54864" marR="54864" marT="18288" marB="18288">
-                    <a:solidFill>
-                      <a:srgbClr val="1F4E79"/>
-                    </a:solidFill>
-                  </a:tcPr>
-                </a:tc>
-              </a:tr>
-              <a:tr h="434340">
-                <a:tc>
-                  <a:txBody>
-                    <a:bodyPr wrap="square"/>
-                    <a:lstStyle/>
-                    <a:p>
-                      <a:r>
-                        <a:rPr sz="1000" b="0">
-                          <a:solidFill>
-                            <a:srgbClr val="282828"/>
-                          </a:solidFill>
-                          <a:latin typeface="Arial"/>
-                        </a:rPr>
-                        <a:t>focuser L2</a:t>
-                      </a:r>
-                    </a:p>
-                  </a:txBody>
-                  <a:tcPr marL="54864" marR="54864" marT="18288" marB="18288">
-                    <a:solidFill>
-                      <a:srgbClr val="FFFFFF"/>
-                    </a:solidFill>
-                  </a:tcPr>
-                </a:tc>
-                <a:tc>
-                  <a:txBody>
-                    <a:bodyPr wrap="square"/>
-                    <a:lstStyle/>
-                    <a:p>
-                      <a:r>
-                        <a:rPr sz="1000" b="0">
-                          <a:solidFill>
-                            <a:srgbClr val="282828"/>
-                          </a:solidFill>
-                          <a:latin typeface="Arial"/>
-                        </a:rPr>
-                        <a:t>f 429 mm, 103 mm; internal focus at F/4.2; modeled 8 mm center, to be real</a:t>
-                      </a:r>
-                    </a:p>
-                  </a:txBody>
-                  <a:tcPr marL="54864" marR="54864" marT="18288" marB="18288">
-                    <a:solidFill>
-                      <a:srgbClr val="FFFFFF"/>
-                    </a:solidFill>
-                  </a:tcPr>
-                </a:tc>
-              </a:tr>
-              <a:tr h="262890">
-                <a:tc>
-                  <a:txBody>
-                    <a:bodyPr wrap="square"/>
-                    <a:lstStyle/>
-                    <a:p>
-                      <a:r>
-                        <a:rPr sz="1000" b="0">
-                          <a:solidFill>
-                            <a:srgbClr val="282828"/>
-                          </a:solidFill>
-                          <a:latin typeface="Arial"/>
-                        </a:rPr>
-                        <a:t>field lens</a:t>
-                      </a:r>
-                    </a:p>
-                  </a:txBody>
-                  <a:tcPr marL="54864" marR="54864" marT="18288" marB="18288">
-                    <a:solidFill>
-                      <a:srgbClr val="ECF1F6"/>
-                    </a:solidFill>
-                  </a:tcPr>
-                </a:tc>
-                <a:tc>
-                  <a:txBody>
-                    <a:bodyPr wrap="square"/>
-                    <a:lstStyle/>
-                    <a:p>
-                      <a:r>
-                        <a:rPr sz="1000" b="0">
-                          <a:solidFill>
-                            <a:srgbClr val="282828"/>
-                          </a:solidFill>
-                          <a:latin typeface="Arial"/>
-                        </a:rPr>
-                        <a:t>f 43 mm, 21 mm; pupil image 9.4 mm, 32 mm behind it</a:t>
-                      </a:r>
-                    </a:p>
-                  </a:txBody>
-                  <a:tcPr marL="54864" marR="54864" marT="18288" marB="18288">
-                    <a:solidFill>
-                      <a:srgbClr val="ECF1F6"/>
-                    </a:solidFill>
-                  </a:tcPr>
-                </a:tc>
-              </a:tr>
-              <a:tr h="434340">
-                <a:tc>
-                  <a:txBody>
-                    <a:bodyPr wrap="square"/>
-                    <a:lstStyle/>
-                    <a:p>
-                      <a:r>
-                        <a:rPr sz="1000" b="0">
-                          <a:solidFill>
-                            <a:srgbClr val="282828"/>
-                          </a:solidFill>
-                          <a:latin typeface="Arial"/>
-                        </a:rPr>
-                        <a:t>camera</a:t>
-                      </a:r>
-                    </a:p>
-                  </a:txBody>
-                  <a:tcPr marL="54864" marR="54864" marT="18288" marB="18288">
-                    <a:solidFill>
-                      <a:srgbClr val="FFFFFF"/>
-                    </a:solidFill>
-                  </a:tcPr>
-                </a:tc>
-                <a:tc>
-                  <a:txBody>
-                    <a:bodyPr wrap="square"/>
-                    <a:lstStyle/>
-                    <a:p>
-                      <a:r>
-                        <a:rPr sz="1000" b="0">
-                          <a:solidFill>
-                            <a:srgbClr val="282828"/>
-                          </a:solidFill>
-                          <a:latin typeface="Arial"/>
-                        </a:rPr>
-                        <a:t>pupil image 9.4 mm: a 6.5 µm sCMOS puts 1450 pixels across it, binned 4 to the modeled 385 (5 per actuator)</a:t>
-                      </a:r>
-                    </a:p>
-                  </a:txBody>
-                  <a:tcPr marL="54864" marR="54864" marT="18288" marB="18288">
-                    <a:solidFill>
-                      <a:srgbClr val="FFFFFF"/>
-                    </a:solidFill>
-                  </a:tcPr>
-                </a:tc>
-              </a:tr>
-              <a:tr h="262890">
-                <a:tc>
-                  <a:txBody>
-                    <a:bodyPr wrap="square"/>
-                    <a:lstStyle/>
-                    <a:p>
-                      <a:r>
-                        <a:rPr sz="1000" b="0">
-                          <a:solidFill>
-                            <a:srgbClr val="282828"/>
-                          </a:solidFill>
-                          <a:latin typeface="Arial"/>
-                        </a:rPr>
-                        <a:t>mask seat</a:t>
-                      </a:r>
-                    </a:p>
-                  </a:txBody>
-                  <a:tcPr marL="54864" marR="54864" marT="18288" marB="18288">
-                    <a:solidFill>
-                      <a:srgbClr val="ECF1F6"/>
-                    </a:solidFill>
-                  </a:tcPr>
-                </a:tc>
-                <a:tc>
-                  <a:txBody>
-                    <a:bodyPr wrap="square"/>
-                    <a:lstStyle/>
-                    <a:p>
-                      <a:r>
-                        <a:rPr sz="1000" b="0">
-                          <a:solidFill>
-                            <a:srgbClr val="282828"/>
-                          </a:solidFill>
-                          <a:latin typeface="Arial"/>
-                        </a:rPr>
-                        <a:t>one substrate at the internal focus, translated to select the sensor</a:t>
-                      </a:r>
-                    </a:p>
-                  </a:txBody>
-                  <a:tcPr marL="54864" marR="54864" marT="18288" marB="18288">
-                    <a:solidFill>
-                      <a:srgbClr val="ECF1F6"/>
-                    </a:solidFill>
-                  </a:tcPr>
-                </a:tc>
-              </a:tr>
-            </a:tbl>
-          </a:graphicData>
-        </a:graphic>
-      </p:graphicFrame>
-      <p:sp>
-        <p:nvSpPr>
-          <p:cNvPr id="8" name="TextBox 7"/>
-          <p:cNvSpPr txBox="1"/>
-          <p:nvPr/>
-        </p:nvSpPr>
-        <p:spPr>
-          <a:xfrm>
-            <a:off x="6400800" y="5900166"/>
-            <a:ext cx="5394960" cy="274320"/>
-          </a:xfrm>
-          <a:prstGeom prst="rect">
-            <a:avLst/>
-          </a:prstGeom>
-          <a:noFill/>
-        </p:spPr>
-        <p:txBody>
-          <a:bodyPr wrap="square">
-            <a:spAutoFit/>
-          </a:bodyPr>
-          <a:lstStyle/>
-          <a:p>
-            <a:pPr>
-              <a:spcAft>
-                <a:spcPts val="600"/>
-              </a:spcAft>
-            </a:pPr>
-            <a:r>
-              <a:rPr sz="1050" b="0">
-                <a:solidFill>
-                  <a:srgbClr val="6E6E6E"/>
-                </a:solidFill>
-                <a:latin typeface="Arial"/>
-              </a:rPr>
-              <a:t>The reference arm (a 103 mm flat on a piezo stage, 564 mm leg) is the interferometer's; shuttered, the same bench is every other sensor.  Lenses, not off-axis mirrors: the choice is priced on the lenses-versus-mirrors slide.  The drawings are to scale: the model's parts are the 56 mm rig's scaled up, thinner than 103 mm optics can be built; the next model round gives every part its real thickness.</a:t>
-            </a:r>
-          </a:p>
-        </p:txBody>
-      </p:sp>
-    </p:spTree>
-  </p:cSld>
-  <p:clrMapOvr>
-    <a:masterClrMapping/>
-  </p:clrMapOvr>
-</p:sld>
-</file>
-
-<file path=ppt/slides/slide30.xml><?xml version="1.0" encoding="utf-8"?>
+<file path=ppt/slides/slide31.xml><?xml version="1.0" encoding="utf-8"?>
 <p:sld xmlns:a="http://schemas.openxmlformats.org/drawingml/2006/main" xmlns:p="http://schemas.openxmlformats.org/presentationml/2006/main" xmlns:r="http://schemas.openxmlformats.org/officeDocument/2006/relationships">
   <p:cSld>
     <p:spTree>
@@ -17028,7 +18056,7 @@
 </p:sld>
 </file>
 
-<file path=ppt/slides/slide31.xml><?xml version="1.0" encoding="utf-8"?>
+<file path=ppt/slides/slide32.xml><?xml version="1.0" encoding="utf-8"?>
 <p:sld xmlns:a="http://schemas.openxmlformats.org/drawingml/2006/main" xmlns:p="http://schemas.openxmlformats.org/presentationml/2006/main" xmlns:r="http://schemas.openxmlformats.org/officeDocument/2006/relationships">
   <p:cSld>
     <p:spTree>
@@ -17884,7 +18912,7 @@
 </p:sld>
 </file>
 
-<file path=ppt/slides/slide32.xml><?xml version="1.0" encoding="utf-8"?>
+<file path=ppt/slides/slide33.xml><?xml version="1.0" encoding="utf-8"?>
 <p:sld xmlns:a="http://schemas.openxmlformats.org/drawingml/2006/main" xmlns:p="http://schemas.openxmlformats.org/presentationml/2006/main" xmlns:r="http://schemas.openxmlformats.org/officeDocument/2006/relationships">
   <p:cSld>
     <p:spTree>
@@ -18945,7 +19973,7 @@
 </p:sld>
 </file>
 
-<file path=ppt/slides/slide33.xml><?xml version="1.0" encoding="utf-8"?>
+<file path=ppt/slides/slide34.xml><?xml version="1.0" encoding="utf-8"?>
 <p:sld xmlns:a="http://schemas.openxmlformats.org/drawingml/2006/main" xmlns:p="http://schemas.openxmlformats.org/presentationml/2006/main" xmlns:r="http://schemas.openxmlformats.org/officeDocument/2006/relationships">
   <p:cSld>
     <p:spTree>
@@ -19607,7 +20635,7 @@
 </p:sld>
 </file>
 
-<file path=ppt/slides/slide34.xml><?xml version="1.0" encoding="utf-8"?>
+<file path=ppt/slides/slide35.xml><?xml version="1.0" encoding="utf-8"?>
 <p:sld xmlns:a="http://schemas.openxmlformats.org/drawingml/2006/main" xmlns:p="http://schemas.openxmlformats.org/presentationml/2006/main" xmlns:r="http://schemas.openxmlformats.org/officeDocument/2006/relationships">
   <p:cSld>
     <p:spTree>
@@ -19897,7 +20925,7 @@
 </p:sld>
 </file>
 
-<file path=ppt/slides/slide35.xml><?xml version="1.0" encoding="utf-8"?>
+<file path=ppt/slides/slide36.xml><?xml version="1.0" encoding="utf-8"?>
 <p:sld xmlns:a="http://schemas.openxmlformats.org/drawingml/2006/main" xmlns:p="http://schemas.openxmlformats.org/presentationml/2006/main" xmlns:r="http://schemas.openxmlformats.org/officeDocument/2006/relationships">
   <p:cSld>
     <p:spTree>
@@ -20601,7 +21629,1001 @@
 </p:sld>
 </file>
 
-<file path=ppt/slides/slide36.xml><?xml version="1.0" encoding="utf-8"?>
+<file path=ppt/slides/slide37.xml><?xml version="1.0" encoding="utf-8"?>
+<p:sld xmlns:a="http://schemas.openxmlformats.org/drawingml/2006/main" xmlns:p="http://schemas.openxmlformats.org/presentationml/2006/main" xmlns:r="http://schemas.openxmlformats.org/officeDocument/2006/relationships">
+  <p:cSld>
+    <p:spTree>
+      <p:nvGrpSpPr>
+        <p:cNvPr id="1" name=""/>
+        <p:cNvGrpSpPr/>
+        <p:nvPr/>
+      </p:nvGrpSpPr>
+      <p:grpSpPr/>
+      <p:sp>
+        <p:nvSpPr>
+          <p:cNvPr id="2" name="TextBox 1"/>
+          <p:cNvSpPr txBox="1"/>
+          <p:nvPr/>
+        </p:nvSpPr>
+        <p:spPr>
+          <a:xfrm>
+            <a:off x="411480" y="201168"/>
+            <a:ext cx="11368735" cy="914400"/>
+          </a:xfrm>
+          <a:prstGeom prst="rect">
+            <a:avLst/>
+          </a:prstGeom>
+          <a:noFill/>
+        </p:spPr>
+        <p:txBody>
+          <a:bodyPr wrap="square">
+            <a:spAutoFit/>
+          </a:bodyPr>
+          <a:lstStyle/>
+          <a:p>
+            <a:pPr>
+              <a:spcAft>
+                <a:spcPts val="400"/>
+              </a:spcAft>
+            </a:pPr>
+            <a:r>
+              <a:rPr sz="2400" b="1">
+                <a:solidFill>
+                  <a:srgbClr val="1F4E79"/>
+                </a:solidFill>
+                <a:latin typeface="Arial"/>
+              </a:rPr>
+              <a:t>Backup: the path per configuration</a:t>
+            </a:r>
+          </a:p>
+          <a:p>
+            <a:pPr>
+              <a:spcAft>
+                <a:spcPts val="0"/>
+              </a:spcAft>
+            </a:pPr>
+            <a:r>
+              <a:rPr sz="1250" b="0">
+                <a:solidFill>
+                  <a:srgbClr val="6E6E6E"/>
+                </a:solidFill>
+                <a:latin typeface="Arial"/>
+              </a:rPr>
+              <a:t>The runner stages and knobs each approach went through, in the order they ran</a:t>
+            </a:r>
+          </a:p>
+        </p:txBody>
+      </p:sp>
+      <p:sp>
+        <p:nvSpPr>
+          <p:cNvPr id="3" name="Rectangle 2"/>
+          <p:cNvSpPr/>
+          <p:nvPr/>
+        </p:nvSpPr>
+        <p:spPr>
+          <a:xfrm>
+            <a:off x="411480" y="1133856"/>
+            <a:ext cx="11368735" cy="20320"/>
+          </a:xfrm>
+          <a:prstGeom prst="rect">
+            <a:avLst/>
+          </a:prstGeom>
+          <a:solidFill>
+            <a:srgbClr val="B8C6D4"/>
+          </a:solidFill>
+          <a:ln>
+            <a:noFill/>
+          </a:ln>
+          <a:effectLst/>
+        </p:spPr>
+        <p:style>
+          <a:lnRef idx="1">
+            <a:schemeClr val="accent1"/>
+          </a:lnRef>
+          <a:fillRef idx="3">
+            <a:schemeClr val="accent1"/>
+          </a:fillRef>
+          <a:effectRef idx="2">
+            <a:schemeClr val="accent1"/>
+          </a:effectRef>
+          <a:fontRef idx="minor">
+            <a:schemeClr val="lt1"/>
+          </a:fontRef>
+        </p:style>
+        <p:txBody>
+          <a:bodyPr rtlCol="0" anchor="ctr"/>
+          <a:lstStyle/>
+          <a:p>
+            <a:pPr algn="ctr"/>
+          </a:p>
+        </p:txBody>
+      </p:sp>
+      <p:graphicFrame>
+        <p:nvGraphicFramePr>
+          <p:cNvPr id="4" name="Table 3"/>
+          <p:cNvGraphicFramePr>
+            <a:graphicFrameLocks noGrp="1"/>
+          </p:cNvGraphicFramePr>
+          <p:nvPr/>
+        </p:nvGraphicFramePr>
+        <p:xfrm>
+          <a:off x="411480" y="1298448"/>
+          <a:ext cx="11368733" cy="4217670"/>
+        </p:xfrm>
+        <a:graphic>
+          <a:graphicData uri="http://schemas.openxmlformats.org/drawingml/2006/table">
+            <a:tbl>
+              <a:tblPr firstRow="1" bandRow="1">
+                <a:tableStyleId>{5C22544A-7EE6-4342-B048-85BDC9FD1C3A}</a:tableStyleId>
+              </a:tblPr>
+              <a:tblGrid>
+                <a:gridCol w="1453895"/>
+                <a:gridCol w="2946123"/>
+                <a:gridCol w="3371045"/>
+                <a:gridCol w="3597670"/>
+              </a:tblGrid>
+              <a:tr h="280035">
+                <a:tc>
+                  <a:txBody>
+                    <a:bodyPr wrap="square"/>
+                    <a:lstStyle/>
+                    <a:p>
+                      <a:r>
+                        <a:rPr sz="1100" b="1">
+                          <a:solidFill>
+                            <a:srgbClr val="FFFFFF"/>
+                          </a:solidFill>
+                          <a:latin typeface="Arial"/>
+                        </a:rPr>
+                        <a:t>step</a:t>
+                      </a:r>
+                    </a:p>
+                  </a:txBody>
+                  <a:tcPr marL="54864" marR="54864" marT="18288" marB="18288">
+                    <a:solidFill>
+                      <a:srgbClr val="1F4E79"/>
+                    </a:solidFill>
+                  </a:tcPr>
+                </a:tc>
+                <a:tc>
+                  <a:txBody>
+                    <a:bodyPr wrap="square"/>
+                    <a:lstStyle/>
+                    <a:p>
+                      <a:r>
+                        <a:rPr sz="1100" b="1">
+                          <a:solidFill>
+                            <a:srgbClr val="FFFFFF"/>
+                          </a:solidFill>
+                          <a:latin typeface="Arial"/>
+                        </a:rPr>
+                        <a:t>interferometer (tg96_run)</a:t>
+                      </a:r>
+                    </a:p>
+                  </a:txBody>
+                  <a:tcPr marL="54864" marR="54864" marT="18288" marB="18288">
+                    <a:solidFill>
+                      <a:srgbClr val="1F4E79"/>
+                    </a:solidFill>
+                  </a:tcPr>
+                </a:tc>
+                <a:tc>
+                  <a:txBody>
+                    <a:bodyPr wrap="square"/>
+                    <a:lstStyle/>
+                    <a:p>
+                      <a:r>
+                        <a:rPr sz="1100" b="1">
+                          <a:solidFill>
+                            <a:srgbClr val="FFFFFF"/>
+                          </a:solidFill>
+                          <a:latin typeface="Arial"/>
+                        </a:rPr>
+                        <a:t>Zernike, scalar and vector (zwfs_run)</a:t>
+                      </a:r>
+                    </a:p>
+                  </a:txBody>
+                  <a:tcPr marL="54864" marR="54864" marT="18288" marB="18288">
+                    <a:solidFill>
+                      <a:srgbClr val="1F4E79"/>
+                    </a:solidFill>
+                  </a:tcPr>
+                </a:tc>
+                <a:tc>
+                  <a:txBody>
+                    <a:bodyPr wrap="square"/>
+                    <a:lstStyle/>
+                    <a:p>
+                      <a:r>
+                        <a:rPr sz="1100" b="1">
+                          <a:solidFill>
+                            <a:srgbClr val="FFFFFF"/>
+                          </a:solidFill>
+                          <a:latin typeface="Arial"/>
+                        </a:rPr>
+                        <a:t>point-diffraction (pdi_run over zwfs_run)</a:t>
+                      </a:r>
+                    </a:p>
+                  </a:txBody>
+                  <a:tcPr marL="54864" marR="54864" marT="18288" marB="18288">
+                    <a:solidFill>
+                      <a:srgbClr val="1F4E79"/>
+                    </a:solidFill>
+                  </a:tcPr>
+                </a:tc>
+              </a:tr>
+              <a:tr h="657225">
+                <a:tc>
+                  <a:txBody>
+                    <a:bodyPr wrap="square"/>
+                    <a:lstStyle/>
+                    <a:p>
+                      <a:r>
+                        <a:rPr sz="1100" b="0">
+                          <a:solidFill>
+                            <a:srgbClr val="282828"/>
+                          </a:solidFill>
+                          <a:latin typeface="Arial"/>
+                        </a:rPr>
+                        <a:t>build + gates</a:t>
+                      </a:r>
+                    </a:p>
+                  </a:txBody>
+                  <a:tcPr marL="54864" marR="54864" marT="18288" marB="18288">
+                    <a:solidFill>
+                      <a:srgbClr val="FFFFFF"/>
+                    </a:solidFill>
+                  </a:tcPr>
+                </a:tc>
+                <a:tc>
+                  <a:txBody>
+                    <a:bodyPr wrap="square"/>
+                    <a:lstStyle/>
+                    <a:p>
+                      <a:r>
+                        <a:rPr sz="1100" b="0">
+                          <a:solidFill>
+                            <a:srgbClr val="282828"/>
+                          </a:solidFill>
+                          <a:latin typeface="Arial"/>
+                        </a:rPr>
+                        <a:t>stage A clearance, A2 sampling, B build both arms; the tail from tg96_tail; the wrapped phase difference</a:t>
+                      </a:r>
+                    </a:p>
+                  </a:txBody>
+                  <a:tcPr marL="54864" marR="54864" marT="18288" marB="18288">
+                    <a:solidFill>
+                      <a:srgbClr val="FFFFFF"/>
+                    </a:solidFill>
+                  </a:tcPr>
+                </a:tc>
+                <a:tc>
+                  <a:txBody>
+                    <a:bodyPr wrap="square"/>
+                    <a:lstStyle/>
+                    <a:p>
+                      <a:r>
+                        <a:rPr sz="1100" b="0">
+                          <a:solidFill>
+                            <a:srgbClr val="282828"/>
+                          </a:solidFill>
+                          <a:latin typeface="Arial"/>
+                        </a:rPr>
+                        <a:t>bench: the symmetric mask sandwich (the S7 correction), the mask gauge factory, gates G1 to G4, G8, G9, the mask figure</a:t>
+                      </a:r>
+                    </a:p>
+                  </a:txBody>
+                  <a:tcPr marL="54864" marR="54864" marT="18288" marB="18288">
+                    <a:solidFill>
+                      <a:srgbClr val="FFFFFF"/>
+                    </a:solidFill>
+                  </a:tcPr>
+                </a:tc>
+                <a:tc>
+                  <a:txBody>
+                    <a:bodyPr wrap="square"/>
+                    <a:lstStyle/>
+                    <a:p>
+                      <a:r>
+                        <a:rPr sz="1100" b="0">
+                          <a:solidFill>
+                            <a:srgbClr val="282828"/>
+                          </a:solidFill>
+                          <a:latin typeface="Arial"/>
+                        </a:rPr>
+                        <a:t>the pinhole gauge in the same seat; G5 (pinhole at full transmission equals the stepped Zernike); the P/SRI's two decks, G6, G7</a:t>
+                      </a:r>
+                    </a:p>
+                  </a:txBody>
+                  <a:tcPr marL="54864" marR="54864" marT="18288" marB="18288">
+                    <a:solidFill>
+                      <a:srgbClr val="FFFFFF"/>
+                    </a:solidFill>
+                  </a:tcPr>
+                </a:tc>
+              </a:tr>
+              <a:tr h="657225">
+                <a:tc>
+                  <a:txBody>
+                    <a:bodyPr wrap="square"/>
+                    <a:lstStyle/>
+                    <a:p>
+                      <a:r>
+                        <a:rPr sz="1100" b="0">
+                          <a:solidFill>
+                            <a:srgbClr val="282828"/>
+                          </a:solidFill>
+                          <a:latin typeface="Arial"/>
+                        </a:rPr>
+                        <a:t>calibration + rows</a:t>
+                      </a:r>
+                    </a:p>
+                  </a:txBody>
+                  <a:tcPr marL="54864" marR="54864" marT="18288" marB="18288">
+                    <a:solidFill>
+                      <a:srgbClr val="ECF1F6"/>
+                    </a:solidFill>
+                  </a:tcPr>
+                </a:tc>
+                <a:tc>
+                  <a:txBody>
+                    <a:bodyPr wrap="square"/>
+                    <a:lstStyle/>
+                    <a:p>
+                      <a:r>
+                        <a:rPr sz="1100" b="0">
+                          <a:solidFill>
+                            <a:srgbClr val="282828"/>
+                          </a:solidFill>
+                          <a:latin typeface="Arial"/>
+                        </a:rPr>
+                        <a:t>stage deck: matrix on the 30 nm surface; single, 52-site grid, dense</a:t>
+                      </a:r>
+                    </a:p>
+                  </a:txBody>
+                  <a:tcPr marL="54864" marR="54864" marT="18288" marB="18288">
+                    <a:solidFill>
+                      <a:srgbClr val="ECF1F6"/>
+                    </a:solidFill>
+                  </a:tcPr>
+                </a:tc>
+                <a:tc>
+                  <a:txBody>
+                    <a:bodyPr wrap="square"/>
+                    <a:lstStyle/>
+                    <a:p>
+                      <a:r>
+                        <a:rPr sz="1100" b="0">
+                          <a:solidFill>
+                            <a:srgbClr val="282828"/>
+                          </a:solidFill>
+                          <a:latin typeface="Arial"/>
+                        </a:rPr>
+                        <a:t>battery: matrix on the surface (record mode, stencil fix); the same three rows; readings L, I, I+, S, V</a:t>
+                      </a:r>
+                    </a:p>
+                  </a:txBody>
+                  <a:tcPr marL="54864" marR="54864" marT="18288" marB="18288">
+                    <a:solidFill>
+                      <a:srgbClr val="ECF1F6"/>
+                    </a:solidFill>
+                  </a:tcPr>
+                </a:tc>
+                <a:tc>
+                  <a:txBody>
+                    <a:bodyPr wrap="square"/>
+                    <a:lstStyle/>
+                    <a:p>
+                      <a:r>
+                        <a:rPr sz="1100" b="0">
+                          <a:solidFill>
+                            <a:srgbClr val="282828"/>
+                          </a:solidFill>
+                          <a:latin typeface="Arial"/>
+                        </a:rPr>
+                        <a:t>battery through the shared runner; readings P (five-frame scan, shutter frame), PF (traced reference)</a:t>
+                      </a:r>
+                    </a:p>
+                  </a:txBody>
+                  <a:tcPr marL="54864" marR="54864" marT="18288" marB="18288">
+                    <a:solidFill>
+                      <a:srgbClr val="ECF1F6"/>
+                    </a:solidFill>
+                  </a:tcPr>
+                </a:tc>
+              </a:tr>
+              <a:tr h="468630">
+                <a:tc>
+                  <a:txBody>
+                    <a:bodyPr wrap="square"/>
+                    <a:lstStyle/>
+                    <a:p>
+                      <a:r>
+                        <a:rPr sz="1100" b="0">
+                          <a:solidFill>
+                            <a:srgbClr val="282828"/>
+                          </a:solidFill>
+                          <a:latin typeface="Arial"/>
+                        </a:rPr>
+                        <a:t>capture range</a:t>
+                      </a:r>
+                    </a:p>
+                  </a:txBody>
+                  <a:tcPr marL="54864" marR="54864" marT="18288" marB="18288">
+                    <a:solidFill>
+                      <a:srgbClr val="FFFFFF"/>
+                    </a:solidFill>
+                  </a:tcPr>
+                </a:tc>
+                <a:tc>
+                  <a:txBody>
+                    <a:bodyPr wrap="square"/>
+                    <a:lstStyle/>
+                    <a:p>
+                      <a:r>
+                        <a:rPr sz="1100" b="0">
+                          <a:solidFill>
+                            <a:srgbClr val="282828"/>
+                          </a:solidFill>
+                          <a:latin typeface="Arial"/>
+                        </a:rPr>
+                        <a:t>aging 30 to 480 nm; re-measured to 160; photons</a:t>
+                      </a:r>
+                    </a:p>
+                  </a:txBody>
+                  <a:tcPr marL="54864" marR="54864" marT="18288" marB="18288">
+                    <a:solidFill>
+                      <a:srgbClr val="FFFFFF"/>
+                    </a:solidFill>
+                  </a:tcPr>
+                </a:tc>
+                <a:tc>
+                  <a:txBody>
+                    <a:bodyPr wrap="square"/>
+                    <a:lstStyle/>
+                    <a:p>
+                      <a:r>
+                        <a:rPr sz="1100" b="0">
+                          <a:solidFill>
+                            <a:srgbClr val="282828"/>
+                          </a:solidFill>
+                          <a:latin typeface="Arial"/>
+                        </a:rPr>
+                        <a:t>the ladder with the capture-range print; base_rms rungs; noise stage per rung</a:t>
+                      </a:r>
+                    </a:p>
+                  </a:txBody>
+                  <a:tcPr marL="54864" marR="54864" marT="18288" marB="18288">
+                    <a:solidFill>
+                      <a:srgbClr val="FFFFFF"/>
+                    </a:solidFill>
+                  </a:tcPr>
+                </a:tc>
+                <a:tc>
+                  <a:txBody>
+                    <a:bodyPr wrap="square"/>
+                    <a:lstStyle/>
+                    <a:p>
+                      <a:r>
+                        <a:rPr sz="1100" b="0">
+                          <a:solidFill>
+                            <a:srgbClr val="282828"/>
+                          </a:solidFill>
+                          <a:latin typeface="Arial"/>
+                        </a:rPr>
+                        <a:t>the same knobs; the shutter frame's 480 nm</a:t>
+                      </a:r>
+                    </a:p>
+                  </a:txBody>
+                  <a:tcPr marL="54864" marR="54864" marT="18288" marB="18288">
+                    <a:solidFill>
+                      <a:srgbClr val="FFFFFF"/>
+                    </a:solidFill>
+                  </a:tcPr>
+                </a:tc>
+              </a:tr>
+              <a:tr h="280035">
+                <a:tc>
+                  <a:txBody>
+                    <a:bodyPr wrap="square"/>
+                    <a:lstStyle/>
+                    <a:p>
+                      <a:r>
+                        <a:rPr sz="1100" b="0">
+                          <a:solidFill>
+                            <a:srgbClr val="282828"/>
+                          </a:solidFill>
+                          <a:latin typeface="Arial"/>
+                        </a:rPr>
+                        <a:t>photons</a:t>
+                      </a:r>
+                    </a:p>
+                  </a:txBody>
+                  <a:tcPr marL="54864" marR="54864" marT="18288" marB="18288">
+                    <a:solidFill>
+                      <a:srgbClr val="ECF1F6"/>
+                    </a:solidFill>
+                  </a:tcPr>
+                </a:tc>
+                <a:tc>
+                  <a:txBody>
+                    <a:bodyPr wrap="square"/>
+                    <a:lstStyle/>
+                    <a:p>
+                      <a:r>
+                        <a:rPr sz="1100" b="0">
+                          <a:solidFill>
+                            <a:srgbClr val="282828"/>
+                          </a:solidFill>
+                          <a:latin typeface="Arial"/>
+                        </a:rPr>
+                        <a:t>S5 form and the loop's noise fit</a:t>
+                      </a:r>
+                    </a:p>
+                  </a:txBody>
+                  <a:tcPr marL="54864" marR="54864" marT="18288" marB="18288">
+                    <a:solidFill>
+                      <a:srgbClr val="ECF1F6"/>
+                    </a:solidFill>
+                  </a:tcPr>
+                </a:tc>
+                <a:tc>
+                  <a:txBody>
+                    <a:bodyPr wrap="square"/>
+                    <a:lstStyle/>
+                    <a:p>
+                      <a:r>
+                        <a:rPr sz="1100" b="0">
+                          <a:solidFill>
+                            <a:srgbClr val="282828"/>
+                          </a:solidFill>
+                          <a:latin typeface="Arial"/>
+                        </a:rPr>
+                        <a:t>noise stage: N(1 pm) flat and on-surface</a:t>
+                      </a:r>
+                    </a:p>
+                  </a:txBody>
+                  <a:tcPr marL="54864" marR="54864" marT="18288" marB="18288">
+                    <a:solidFill>
+                      <a:srgbClr val="ECF1F6"/>
+                    </a:solidFill>
+                  </a:tcPr>
+                </a:tc>
+                <a:tc>
+                  <a:txBody>
+                    <a:bodyPr wrap="square"/>
+                    <a:lstStyle/>
+                    <a:p>
+                      <a:r>
+                        <a:rPr sz="1100" b="0">
+                          <a:solidFill>
+                            <a:srgbClr val="282828"/>
+                          </a:solidFill>
+                          <a:latin typeface="Arial"/>
+                        </a:rPr>
+                        <a:t>noise stage; 2.0 vs 1.0 λF/D</a:t>
+                      </a:r>
+                    </a:p>
+                  </a:txBody>
+                  <a:tcPr marL="54864" marR="54864" marT="18288" marB="18288">
+                    <a:solidFill>
+                      <a:srgbClr val="ECF1F6"/>
+                    </a:solidFill>
+                  </a:tcPr>
+                </a:tc>
+              </a:tr>
+              <a:tr h="468630">
+                <a:tc>
+                  <a:txBody>
+                    <a:bodyPr wrap="square"/>
+                    <a:lstStyle/>
+                    <a:p>
+                      <a:r>
+                        <a:rPr sz="1100" b="0">
+                          <a:solidFill>
+                            <a:srgbClr val="282828"/>
+                          </a:solidFill>
+                          <a:latin typeface="Arial"/>
+                        </a:rPr>
+                        <a:t>loop</a:t>
+                      </a:r>
+                    </a:p>
+                  </a:txBody>
+                  <a:tcPr marL="54864" marR="54864" marT="18288" marB="18288">
+                    <a:solidFill>
+                      <a:srgbClr val="FFFFFF"/>
+                    </a:solidFill>
+                  </a:tcPr>
+                </a:tc>
+                <a:tc>
+                  <a:txBody>
+                    <a:bodyPr wrap="square"/>
+                    <a:lstStyle/>
+                    <a:p>
+                      <a:r>
+                        <a:rPr sz="1100" b="0">
+                          <a:solidFill>
+                            <a:srgbClr val="282828"/>
+                          </a:solidFill>
+                          <a:latin typeface="Arial"/>
+                        </a:rPr>
+                        <a:t>shared loop; PZT step error; camera and DM within-scan walks</a:t>
+                      </a:r>
+                    </a:p>
+                  </a:txBody>
+                  <a:tcPr marL="54864" marR="54864" marT="18288" marB="18288">
+                    <a:solidFill>
+                      <a:srgbClr val="FFFFFF"/>
+                    </a:solidFill>
+                  </a:tcPr>
+                </a:tc>
+                <a:tc>
+                  <a:txBody>
+                    <a:bodyPr wrap="square"/>
+                    <a:lstStyle/>
+                    <a:p>
+                      <a:r>
+                        <a:rPr sz="1100" b="0">
+                          <a:solidFill>
+                            <a:srgbClr val="282828"/>
+                          </a:solidFill>
+                          <a:latin typeface="Arial"/>
+                        </a:rPr>
+                        <a:t>shared loop: noise, walk, ramp, step; camera drift forms</a:t>
+                      </a:r>
+                    </a:p>
+                  </a:txBody>
+                  <a:tcPr marL="54864" marR="54864" marT="18288" marB="18288">
+                    <a:solidFill>
+                      <a:srgbClr val="FFFFFF"/>
+                    </a:solidFill>
+                  </a:tcPr>
+                </a:tc>
+                <a:tc>
+                  <a:txBody>
+                    <a:bodyPr wrap="square"/>
+                    <a:lstStyle/>
+                    <a:p>
+                      <a:r>
+                        <a:rPr sz="1100" b="0">
+                          <a:solidFill>
+                            <a:srgbClr val="282828"/>
+                          </a:solidFill>
+                          <a:latin typeface="Arial"/>
+                        </a:rPr>
+                        <a:t>shared loop; within-scan drift; reference-arm walk</a:t>
+                      </a:r>
+                    </a:p>
+                  </a:txBody>
+                  <a:tcPr marL="54864" marR="54864" marT="18288" marB="18288">
+                    <a:solidFill>
+                      <a:srgbClr val="FFFFFF"/>
+                    </a:solidFill>
+                  </a:tcPr>
+                </a:tc>
+              </a:tr>
+              <a:tr h="468630">
+                <a:tc>
+                  <a:txBody>
+                    <a:bodyPr wrap="square"/>
+                    <a:lstStyle/>
+                    <a:p>
+                      <a:r>
+                        <a:rPr sz="1100" b="0">
+                          <a:solidFill>
+                            <a:srgbClr val="282828"/>
+                          </a:solidFill>
+                          <a:latin typeface="Arial"/>
+                        </a:rPr>
+                        <a:t>descent</a:t>
+                      </a:r>
+                    </a:p>
+                  </a:txBody>
+                  <a:tcPr marL="54864" marR="54864" marT="18288" marB="18288">
+                    <a:solidFill>
+                      <a:srgbClr val="ECF1F6"/>
+                    </a:solidFill>
+                  </a:tcPr>
+                </a:tc>
+                <a:tc>
+                  <a:txBody>
+                    <a:bodyPr wrap="square"/>
+                    <a:lstStyle/>
+                    <a:p>
+                      <a:r>
+                        <a:rPr sz="1100" b="0">
+                          <a:solidFill>
+                            <a:srgbClr val="282828"/>
+                          </a:solidFill>
+                          <a:latin typeface="Arial"/>
+                        </a:rPr>
+                        <a:t>unwrap alone: 60 to 300 nm starts</a:t>
+                      </a:r>
+                    </a:p>
+                  </a:txBody>
+                  <a:tcPr marL="54864" marR="54864" marT="18288" marB="18288">
+                    <a:solidFill>
+                      <a:srgbClr val="ECF1F6"/>
+                    </a:solidFill>
+                  </a:tcPr>
+                </a:tc>
+                <a:tc>
+                  <a:txBody>
+                    <a:bodyPr wrap="square"/>
+                    <a:lstStyle/>
+                    <a:p>
+                      <a:r>
+                        <a:rPr sz="1100" b="0">
+                          <a:solidFill>
+                            <a:srgbClr val="282828"/>
+                          </a:solidFill>
+                          <a:latin typeface="Arial"/>
+                        </a:rPr>
+                        <a:t>the start ladder: self-referenced readings blind past 60 nm</a:t>
+                      </a:r>
+                    </a:p>
+                  </a:txBody>
+                  <a:tcPr marL="54864" marR="54864" marT="18288" marB="18288">
+                    <a:solidFill>
+                      <a:srgbClr val="ECF1F6"/>
+                    </a:solidFill>
+                  </a:tcPr>
+                </a:tc>
+                <a:tc>
+                  <a:txBody>
+                    <a:bodyPr wrap="square"/>
+                    <a:lstStyle/>
+                    <a:p>
+                      <a:r>
+                        <a:rPr sz="1100" b="0">
+                          <a:solidFill>
+                            <a:srgbClr val="282828"/>
+                          </a:solidFill>
+                          <a:latin typeface="Arial"/>
+                        </a:rPr>
+                        <a:t>unwrap + recalibration: 100 nm with the shutter frame</a:t>
+                      </a:r>
+                    </a:p>
+                  </a:txBody>
+                  <a:tcPr marL="54864" marR="54864" marT="18288" marB="18288">
+                    <a:solidFill>
+                      <a:srgbClr val="ECF1F6"/>
+                    </a:solidFill>
+                  </a:tcPr>
+                </a:tc>
+              </a:tr>
+              <a:tr h="468630">
+                <a:tc>
+                  <a:txBody>
+                    <a:bodyPr wrap="square"/>
+                    <a:lstStyle/>
+                    <a:p>
+                      <a:r>
+                        <a:rPr sz="1100" b="0">
+                          <a:solidFill>
+                            <a:srgbClr val="282828"/>
+                          </a:solidFill>
+                          <a:latin typeface="Arial"/>
+                        </a:rPr>
+                        <a:t>systematics</a:t>
+                      </a:r>
+                    </a:p>
+                  </a:txBody>
+                  <a:tcPr marL="54864" marR="54864" marT="18288" marB="18288">
+                    <a:solidFill>
+                      <a:srgbClr val="FFFFFF"/>
+                    </a:solidFill>
+                  </a:tcPr>
+                </a:tc>
+                <a:tc>
+                  <a:txBody>
+                    <a:bodyPr wrap="square"/>
+                    <a:lstStyle/>
+                    <a:p>
+                      <a:r>
+                        <a:rPr sz="1100" b="0">
+                          <a:solidFill>
+                            <a:srgbClr val="282828"/>
+                          </a:solidFill>
+                          <a:latin typeface="Arial"/>
+                        </a:rPr>
+                        <a:t>the three phase-shift forms; coatings; alignment (D4); OAP seat trim</a:t>
+                      </a:r>
+                    </a:p>
+                  </a:txBody>
+                  <a:tcPr marL="54864" marR="54864" marT="18288" marB="18288">
+                    <a:solidFill>
+                      <a:srgbClr val="FFFFFF"/>
+                    </a:solidFill>
+                  </a:tcPr>
+                </a:tc>
+                <a:tc>
+                  <a:txBody>
+                    <a:bodyPr wrap="square"/>
+                    <a:lstStyle/>
+                    <a:p>
+                      <a:r>
+                        <a:rPr sz="1100" b="0">
+                          <a:solidFill>
+                            <a:srgbClr val="282828"/>
+                          </a:solidFill>
+                          <a:latin typeface="Arial"/>
+                        </a:rPr>
+                        <a:t>V2 metasurface, V3 arm maps, V4 analyzer, V5 clear frame; color; sampling</a:t>
+                      </a:r>
+                    </a:p>
+                  </a:txBody>
+                  <a:tcPr marL="54864" marR="54864" marT="18288" marB="18288">
+                    <a:solidFill>
+                      <a:srgbClr val="FFFFFF"/>
+                    </a:solidFill>
+                  </a:tcPr>
+                </a:tc>
+                <a:tc>
+                  <a:txBody>
+                    <a:bodyPr wrap="square"/>
+                    <a:lstStyle/>
+                    <a:p>
+                      <a:r>
+                        <a:rPr sz="1100" b="0">
+                          <a:solidFill>
+                            <a:srgbClr val="282828"/>
+                          </a:solidFill>
+                          <a:latin typeface="Arial"/>
+                        </a:rPr>
+                        <a:t>step schemes; camera drift; reference motion and walk; pinhole diameter</a:t>
+                      </a:r>
+                    </a:p>
+                  </a:txBody>
+                  <a:tcPr marL="54864" marR="54864" marT="18288" marB="18288">
+                    <a:solidFill>
+                      <a:srgbClr val="FFFFFF"/>
+                    </a:solidFill>
+                  </a:tcPr>
+                </a:tc>
+              </a:tr>
+              <a:tr h="468630">
+                <a:tc>
+                  <a:txBody>
+                    <a:bodyPr wrap="square"/>
+                    <a:lstStyle/>
+                    <a:p>
+                      <a:r>
+                        <a:rPr sz="1100" b="0">
+                          <a:solidFill>
+                            <a:srgbClr val="282828"/>
+                          </a:solidFill>
+                          <a:latin typeface="Arial"/>
+                        </a:rPr>
+                        <a:t>layout + parts</a:t>
+                      </a:r>
+                    </a:p>
+                  </a:txBody>
+                  <a:tcPr marL="54864" marR="54864" marT="18288" marB="18288">
+                    <a:solidFill>
+                      <a:srgbClr val="ECF1F6"/>
+                    </a:solidFill>
+                  </a:tcPr>
+                </a:tc>
+                <a:tc>
+                  <a:txBody>
+                    <a:bodyPr wrap="square"/>
+                    <a:lstStyle/>
+                    <a:p>
+                      <a:r>
+                        <a:rPr sz="1100" b="0">
+                          <a:solidFill>
+                            <a:srgbClr val="282828"/>
+                          </a:solidFill>
+                          <a:latin typeface="Arial"/>
+                        </a:rPr>
+                        <a:t>the view_rx recipe: train, node, tail</a:t>
+                      </a:r>
+                    </a:p>
+                  </a:txBody>
+                  <a:tcPr marL="54864" marR="54864" marT="18288" marB="18288">
+                    <a:solidFill>
+                      <a:srgbClr val="ECF1F6"/>
+                    </a:solidFill>
+                  </a:tcPr>
+                </a:tc>
+                <a:tc>
+                  <a:txBody>
+                    <a:bodyPr wrap="square"/>
+                    <a:lstStyle/>
+                    <a:p>
+                      <a:r>
+                        <a:rPr sz="1100" b="0">
+                          <a:solidFill>
+                            <a:srgbClr val="282828"/>
+                          </a:solidFill>
+                          <a:latin typeface="Arial"/>
+                        </a:rPr>
+                        <a:t>zwfs_vlayout: both channel decks; the bench clearance tool</a:t>
+                      </a:r>
+                    </a:p>
+                  </a:txBody>
+                  <a:tcPr marL="54864" marR="54864" marT="18288" marB="18288">
+                    <a:solidFill>
+                      <a:srgbClr val="ECF1F6"/>
+                    </a:solidFill>
+                  </a:tcPr>
+                </a:tc>
+                <a:tc>
+                  <a:txBody>
+                    <a:bodyPr wrap="square"/>
+                    <a:lstStyle/>
+                    <a:p>
+                      <a:r>
+                        <a:rPr sz="1100" b="0">
+                          <a:solidFill>
+                            <a:srgbClr val="282828"/>
+                          </a:solidFill>
+                          <a:latin typeface="Arial"/>
+                        </a:rPr>
+                        <a:t>pdi_vfig_util: pinhole and P/SRI layouts</a:t>
+                      </a:r>
+                    </a:p>
+                  </a:txBody>
+                  <a:tcPr marL="54864" marR="54864" marT="18288" marB="18288">
+                    <a:solidFill>
+                      <a:srgbClr val="ECF1F6"/>
+                    </a:solidFill>
+                  </a:tcPr>
+                </a:tc>
+              </a:tr>
+            </a:tbl>
+          </a:graphicData>
+        </a:graphic>
+      </p:graphicFrame>
+      <p:sp>
+        <p:nvSpPr>
+          <p:cNvPr id="5" name="TextBox 4"/>
+          <p:cNvSpPr txBox="1"/>
+          <p:nvPr/>
+        </p:nvSpPr>
+        <p:spPr>
+          <a:xfrm>
+            <a:off x="411480" y="5662422"/>
+            <a:ext cx="11368735" cy="274320"/>
+          </a:xfrm>
+          <a:prstGeom prst="rect">
+            <a:avLst/>
+          </a:prstGeom>
+          <a:noFill/>
+        </p:spPr>
+        <p:txBody>
+          <a:bodyPr wrap="square">
+            <a:spAutoFit/>
+          </a:bodyPr>
+          <a:lstStyle/>
+          <a:p>
+            <a:pPr>
+              <a:spcAft>
+                <a:spcPts val="600"/>
+              </a:spcAft>
+            </a:pPr>
+            <a:r>
+              <a:rPr sz="1050" b="0">
+                <a:solidFill>
+                  <a:srgbClr val="6E6E6E"/>
+                </a:solidFill>
+                <a:latin typeface="Arial"/>
+              </a:rPr>
+              <a:t>Directories tg_psi_dm96_oap, zwfs_dm96, pdi_dm96 and the shared dm_gauge_lib under MACOS_resources/mmacos/templates/40_benches; each README's "run it yourself" reproduces its column.</a:t>
+            </a:r>
+          </a:p>
+        </p:txBody>
+      </p:sp>
+    </p:spTree>
+  </p:cSld>
+  <p:clrMapOvr>
+    <a:masterClrMapping/>
+  </p:clrMapOvr>
+</p:sld>
+</file>
+
+<file path=ppt/slides/slide38.xml><?xml version="1.0" encoding="utf-8"?>
 <p:sld xmlns:a="http://schemas.openxmlformats.org/drawingml/2006/main" xmlns:p="http://schemas.openxmlformats.org/presentationml/2006/main" xmlns:r="http://schemas.openxmlformats.org/officeDocument/2006/relationships">
   <p:cSld>
     <p:spTree>

</xml_diff>

<commit_message>
Deck: the side-by-side slide's footnote carries the sensor rows re-run on the 22.5-deg bench of record (gate22_193: stepped 0.989/5 pm, vector 0.994/3, pinhole 0.994/3; grid 0.998/4, 0.998/3, 0.998/3) + provenance tags stations193 / gate22_193; slice: post-compaction status (TO alive on the reflective brief, items 1-2 committed, oap22d live)
Co-Authored-By: Claude Fable 5.1 <noreply@anthropic.com>
</commit_message>
<xml_diff>
--- a/demo_session/deck_gauges.pptx
+++ b/demo_session/deck_gauges.pptx
@@ -6816,7 +6816,7 @@
                 </a:solidFill>
                 <a:latin typeface="Arial"/>
               </a:rPr>
-              <a:t>Run tags: lens_deck, oap_deck, matbase, matbase385, v193base, pdi193fbase, pfdeck.  The interferometer rows are at 385 pixels per pupil, the rest at 193; the 385 checks read the same.</a:t>
+              <a:t>Run tags: lens_deck, oap_deck, matbase, matbase385, v193base, pdi193fbase, pfdeck.  The interferometer rows are at 385 pixels per pupil, the rest at 193; the 385 checks read the same.  The sensor rows re-run on the 22.5° bench of record (gate22_193) hold to the digit: stepped 0.989 / 5 pm, vector 0.994 / 3, pinhole 0.994 / 3 on one actuator; 0.998 / 4, 0.998 / 3, 0.998 / 3 on 47 sites.</a:t>
             </a:r>
           </a:p>
         </p:txBody>
@@ -25629,7 +25629,7 @@
                 </a:solidFill>
                 <a:latin typeface="Arial"/>
               </a:rPr>
-              <a:t>•  Zernike sensors (zwfs_dm96/runs): matbase, matbase385, m2048, m2048_lat, cap385, cap385_b60-b160, noise193_b30-b160, rec193full, loop193, loop385, v193base, v193noise, vloop193, fold_diag, v2g, v2loop, v3arm, v3s, v3loop, an193_ref/cube/q300/q100/az1/bound/clear.  README.md (CCL) and deck_zwfs.md.</a:t>
+              <a:t>•  Zernike sensors (zwfs_dm96/runs): matbase, matbase385, m2048, m2048_lat, cap385, cap385_b60-b160, noise193_b30-b160, rec193full, loop193, loop385, v193base, v193noise, vloop193, fold_diag, v2g, v2loop, v3arm, v3s, v3loop, an193_ref/cube/q300/q100/az1/bound/clear, stations193, gate22_193 (the 22.5° bench).  README.md (CCL) and deck_zwfs.md.</a:t>
             </a:r>
           </a:p>
           <a:p>

</xml_diff>

<commit_message>
Deck slide 13 (vector Zernike layout): the interferometer's polarization camera would replace the cube and one camera -- the two circular channels are the array's 0/90-deg pixels, registered by construction; half the pixels per channel and the array's extinction in place of the cube's (Dave 2026-09-15)
Co-Authored-By: Claude Fable 5.1 <noreply@anthropic.com>
</commit_message>
<xml_diff>
--- a/demo_session/deck_gauges.pptx
+++ b/demo_session/deck_gauges.pptx
@@ -4469,8 +4469,8 @@
         </p:blipFill>
         <p:spPr>
           <a:xfrm>
-            <a:off x="2555258" y="1298448"/>
-            <a:ext cx="7081177" cy="3994912"/>
+            <a:off x="3041504" y="1298448"/>
+            <a:ext cx="6108686" cy="3446272"/>
           </a:xfrm>
           <a:prstGeom prst="rect">
             <a:avLst/>
@@ -4485,7 +4485,7 @@
         </p:nvSpPr>
         <p:spPr>
           <a:xfrm>
-            <a:off x="411480" y="5311647"/>
+            <a:off x="411480" y="4763008"/>
             <a:ext cx="11368735" cy="394208"/>
           </a:xfrm>
           <a:prstGeom prst="rect">
@@ -4524,7 +4524,46 @@
         </p:nvSpPr>
         <p:spPr>
           <a:xfrm>
-            <a:off x="411480" y="5742431"/>
+            <a:off x="411480" y="5193792"/>
+            <a:ext cx="11368735" cy="274320"/>
+          </a:xfrm>
+          <a:prstGeom prst="rect">
+            <a:avLst/>
+          </a:prstGeom>
+          <a:noFill/>
+        </p:spPr>
+        <p:txBody>
+          <a:bodyPr wrap="square">
+            <a:spAutoFit/>
+          </a:bodyPr>
+          <a:lstStyle/>
+          <a:p>
+            <a:pPr>
+              <a:spcAft>
+                <a:spcPts val="600"/>
+              </a:spcAft>
+            </a:pPr>
+            <a:r>
+              <a:rPr sz="1500" b="0">
+                <a:solidFill>
+                  <a:srgbClr val="282828"/>
+                </a:solidFill>
+                <a:latin typeface="Arial"/>
+              </a:rPr>
+              <a:t>•  The same polarization camera as the interferometer's snapshot form would replace the cube and one camera: behind the quarter-wave plate the two circular channels are the 0° and 90° pixels of the micro-polarizer array, so the two images land on one sensor, registered by construction.  The price is half the pixels per channel and the array's extinction in place of the cube's, a term the model already carries (the analyzer, on the systematics slide).</a:t>
+            </a:r>
+          </a:p>
+        </p:txBody>
+      </p:sp>
+      <p:sp>
+        <p:nvSpPr>
+          <p:cNvPr id="7" name="TextBox 6"/>
+          <p:cNvSpPr txBox="1"/>
+          <p:nvPr/>
+        </p:nvSpPr>
+        <p:spPr>
+          <a:xfrm>
+            <a:off x="411480" y="6361175"/>
             <a:ext cx="11368735" cy="274320"/>
           </a:xfrm>
           <a:prstGeom prst="rect">

</xml_diff>

<commit_message>
Deck slide 3: the lens rig and the redesigned reflective rig side by side (both the tools' own renders) with a for / against / where-it-stands table; the parts tables move off the slide (slides 5-7 carry them) (Dave 2026-09-15)
Co-Authored-By: Claude Fable 5.1 <noreply@anthropic.com>
</commit_message>
<xml_diff>
--- a/demo_session/deck_gauges.pptx
+++ b/demo_session/deck_gauges.pptx
@@ -15759,7 +15759,7 @@
                 </a:solidFill>
                 <a:latin typeface="Arial"/>
               </a:rPr>
-              <a:t>Everything shares the front end: a filtered HeNe, a collimator, a plate splitter at 22.5°, a 700 mm leg to the mirror, a focuser to an internal focus, a field lens to a camera at the pupil image</a:t>
+              <a:t>Everything shares the front end: a filtered HeNe, a collimator, a plate splitter at 22.5°, a 700 mm leg to the mirror, a focuser to an internal focus, a field lens to a camera at the pupil image; the collimator and focuser are lenses or off-axis parabolas</a:t>
             </a:r>
           </a:p>
         </p:txBody>
@@ -15824,8 +15824,8 @@
         </p:blipFill>
         <p:spPr>
           <a:xfrm>
-            <a:off x="4061668" y="1298448"/>
-            <a:ext cx="4068357" cy="2348992"/>
+            <a:off x="1645652" y="1298448"/>
+            <a:ext cx="3338094" cy="1927352"/>
           </a:xfrm>
           <a:prstGeom prst="rect">
             <a:avLst/>
@@ -15840,8 +15840,8 @@
         </p:nvSpPr>
         <p:spPr>
           <a:xfrm>
-            <a:off x="411480" y="3665727"/>
-            <a:ext cx="11368735" cy="394208"/>
+            <a:off x="411480" y="3244088"/>
+            <a:ext cx="5806440" cy="724408"/>
           </a:xfrm>
           <a:prstGeom prst="rect">
             <a:avLst/>
@@ -15866,22 +15866,85 @@
                 </a:solidFill>
                 <a:latin typeface="Arial"/>
               </a:rPr>
-              <a:t>The shared front end as traced by the engine, seen from above, at the 22.5° splitter: source at left, collimator L1, the splitter, the 96 mm mirror on its 700 mm leg (blue), the reference arm and its flat (orange, the interferometer only), the focuser L2 toward the internal focus.  The mask seat at that focus is where the four sensing methods differ.</a:t>
+              <a:t>The lens rig as traced by the engine, from above: source at left, collimator L1, the 22.5° splitter, the 96 mm mirror on its 700 mm leg (blue), the reference arm and its flat (orange, the interferometer only), the focuser L2 toward the internal focus.  The mask seat at that focus is where the four sensing methods differ.</a:t>
+            </a:r>
+          </a:p>
+        </p:txBody>
+      </p:sp>
+      <p:pic>
+        <p:nvPicPr>
+          <p:cNvPr id="6" name="Picture 5" descr="crop_oapdraw3_train.png"/>
+          <p:cNvPicPr>
+            <a:picLocks noChangeAspect="1"/>
+          </p:cNvPicPr>
+          <p:nvPr/>
+        </p:nvPicPr>
+        <p:blipFill>
+          <a:blip r:embed="rId3"/>
+          <a:stretch>
+            <a:fillRect/>
+          </a:stretch>
+        </p:blipFill>
+        <p:spPr>
+          <a:xfrm>
+            <a:off x="8033856" y="1298448"/>
+            <a:ext cx="2128847" cy="1927352"/>
+          </a:xfrm>
+          <a:prstGeom prst="rect">
+            <a:avLst/>
+          </a:prstGeom>
+        </p:spPr>
+      </p:pic>
+      <p:sp>
+        <p:nvSpPr>
+          <p:cNvPr id="7" name="TextBox 6"/>
+          <p:cNvSpPr txBox="1"/>
+          <p:nvPr/>
+        </p:nvSpPr>
+        <p:spPr>
+          <a:xfrm>
+            <a:off x="6400800" y="3244088"/>
+            <a:ext cx="5394960" cy="724408"/>
+          </a:xfrm>
+          <a:prstGeom prst="rect">
+            <a:avLst/>
+          </a:prstGeom>
+          <a:noFill/>
+        </p:spPr>
+        <p:txBody>
+          <a:bodyPr wrap="square">
+            <a:spAutoFit/>
+          </a:bodyPr>
+          <a:lstStyle/>
+          <a:p>
+            <a:pPr algn="ctr">
+              <a:spcAft>
+                <a:spcPts val="0"/>
+              </a:spcAft>
+            </a:pPr>
+            <a:r>
+              <a:rPr sz="1000" b="0">
+                <a:solidFill>
+                  <a:srgbClr val="6E6E6E"/>
+                </a:solidFill>
+                <a:latin typeface="Arial"/>
+              </a:rPr>
+              <a:t>The reflective rig, redesigned on the same splitter: the source and input polarizer in the diverging leg, OAP1 collimating at a 20° fold, the same node, OAP2 focusing at 25° toward the mask seat.  Both drawings are the tools' own renders to scale; parts and thicknesses are on the next slides.</a:t>
             </a:r>
           </a:p>
         </p:txBody>
       </p:sp>
       <p:graphicFrame>
         <p:nvGraphicFramePr>
-          <p:cNvPr id="6" name="Table 5"/>
+          <p:cNvPr id="8" name="Table 7"/>
           <p:cNvGraphicFramePr>
             <a:graphicFrameLocks noGrp="1"/>
           </p:cNvGraphicFramePr>
           <p:nvPr/>
         </p:nvGraphicFramePr>
         <p:xfrm>
-          <a:off x="411480" y="4096511"/>
-          <a:ext cx="5806439" cy="1965960"/>
+          <a:off x="411480" y="4005072"/>
+          <a:ext cx="11368735" cy="2251710"/>
         </p:xfrm>
         <a:graphic>
           <a:graphicData uri="http://schemas.openxmlformats.org/drawingml/2006/table">
@@ -15890,14 +15953,27 @@
                 <a:tableStyleId>{5C22544A-7EE6-4342-B048-85BDC9FD1C3A}</a:tableStyleId>
               </a:tblPr>
               <a:tblGrid>
-                <a:gridCol w="662479"/>
-                <a:gridCol w="5143960"/>
+                <a:gridCol w="1235964"/>
+                <a:gridCol w="3759959"/>
+                <a:gridCol w="6372812"/>
               </a:tblGrid>
               <a:tr h="280035">
                 <a:tc>
                   <a:txBody>
                     <a:bodyPr wrap="square"/>
                     <a:lstStyle/>
+                    <a:p/>
+                  </a:txBody>
+                  <a:tcPr marL="54864" marR="54864" marT="18288" marB="18288">
+                    <a:solidFill>
+                      <a:srgbClr val="1F4E79"/>
+                    </a:solidFill>
+                  </a:tcPr>
+                </a:tc>
+                <a:tc>
+                  <a:txBody>
+                    <a:bodyPr wrap="square"/>
+                    <a:lstStyle/>
                     <a:p>
                       <a:r>
                         <a:rPr sz="1100" b="1">
@@ -15906,7 +15982,7 @@
                           </a:solidFill>
                           <a:latin typeface="Arial"/>
                         </a:rPr>
-                        <a:t>part</a:t>
+                        <a:t>lenses (L1, L2: 103 mm singlets)</a:t>
                       </a:r>
                     </a:p>
                   </a:txBody>
@@ -15928,7 +16004,7 @@
                           </a:solidFill>
                           <a:latin typeface="Arial"/>
                         </a:rPr>
-                        <a:t>value</a:t>
+                        <a:t>off-axis parabolas (OAP1 20°, OAP2 25°)</a:t>
                       </a:r>
                     </a:p>
                   </a:txBody>
@@ -15939,48 +16015,138 @@
                   </a:tcPr>
                 </a:tc>
               </a:tr>
-              <a:tr h="280035">
-                <a:tc>
-                  <a:txBody>
-                    <a:bodyPr wrap="square"/>
-                    <a:lstStyle/>
-                    <a:p>
-                      <a:r>
-                        <a:rPr sz="1100" b="0">
-                          <a:solidFill>
-                            <a:srgbClr val="282828"/>
-                          </a:solidFill>
-                          <a:latin typeface="Arial"/>
-                        </a:rPr>
-                        <a:t>source</a:t>
-                      </a:r>
-                    </a:p>
-                  </a:txBody>
-                  <a:tcPr marL="54864" marR="54864" marT="18288" marB="18288">
-                    <a:solidFill>
-                      <a:srgbClr val="FFFFFF"/>
-                    </a:solidFill>
-                  </a:tcPr>
-                </a:tc>
-                <a:tc>
-                  <a:txBody>
-                    <a:bodyPr wrap="square"/>
-                    <a:lstStyle/>
-                    <a:p>
-                      <a:r>
-                        <a:rPr sz="1100" b="0">
-                          <a:solidFill>
-                            <a:srgbClr val="282828"/>
-                          </a:solidFill>
-                          <a:latin typeface="Arial"/>
-                        </a:rPr>
-                        <a:t>HeNe 632.8 nm, filtered, 51 mm beam radius</a:t>
-                      </a:r>
-                    </a:p>
-                  </a:txBody>
-                  <a:tcPr marL="54864" marR="54864" marT="18288" marB="18288">
-                    <a:solidFill>
-                      <a:srgbClr val="FFFFFF"/>
+              <a:tr h="657225">
+                <a:tc>
+                  <a:txBody>
+                    <a:bodyPr wrap="square"/>
+                    <a:lstStyle/>
+                    <a:p>
+                      <a:r>
+                        <a:rPr sz="1100" b="0">
+                          <a:solidFill>
+                            <a:srgbClr val="282828"/>
+                          </a:solidFill>
+                          <a:latin typeface="Arial"/>
+                        </a:rPr>
+                        <a:t>for</a:t>
+                      </a:r>
+                    </a:p>
+                  </a:txBody>
+                  <a:tcPr marL="54864" marR="54864" marT="18288" marB="18288">
+                    <a:solidFill>
+                      <a:srgbClr val="FFFFFF"/>
+                    </a:solidFill>
+                  </a:tcPr>
+                </a:tc>
+                <a:tc>
+                  <a:txBody>
+                    <a:bodyPr wrap="square"/>
+                    <a:lstStyle/>
+                    <a:p>
+                      <a:r>
+                        <a:rPr sz="1100" b="0">
+                          <a:solidFill>
+                            <a:srgbClr val="282828"/>
+                          </a:solidFill>
+                          <a:latin typeface="Arial"/>
+                        </a:rPr>
+                        <a:t>on axis, no fold polarization; cheap parts; the record's readings were all measured on it</a:t>
+                      </a:r>
+                    </a:p>
+                  </a:txBody>
+                  <a:tcPr marL="54864" marR="54864" marT="18288" marB="18288">
+                    <a:solidFill>
+                      <a:srgbClr val="FFFFFF"/>
+                    </a:solidFill>
+                  </a:tcPr>
+                </a:tc>
+                <a:tc>
+                  <a:txBody>
+                    <a:bodyPr wrap="square"/>
+                    <a:lstStyle/>
+                    <a:p>
+                      <a:r>
+                        <a:rPr sz="1100" b="0">
+                          <a:solidFill>
+                            <a:srgbClr val="282828"/>
+                          </a:solidFill>
+                          <a:latin typeface="Arial"/>
+                        </a:rPr>
+                        <a:t>no glass in the beam: achromatic (a second color for capture is free), no ghosts; fed at its focus the mask seat is diffraction-limited at zero trim, and the untuned tail nulls 0.029 nm against the lens rig's tuned 0.134; every part clears by 33 mm</a:t>
+                      </a:r>
+                    </a:p>
+                  </a:txBody>
+                  <a:tcPr marL="54864" marR="54864" marT="18288" marB="18288">
+                    <a:solidFill>
+                      <a:srgbClr val="FFFFFF"/>
+                    </a:solidFill>
+                  </a:tcPr>
+                </a:tc>
+              </a:tr>
+              <a:tr h="845820">
+                <a:tc>
+                  <a:txBody>
+                    <a:bodyPr wrap="square"/>
+                    <a:lstStyle/>
+                    <a:p>
+                      <a:r>
+                        <a:rPr sz="1100" b="0">
+                          <a:solidFill>
+                            <a:srgbClr val="282828"/>
+                          </a:solidFill>
+                          <a:latin typeface="Arial"/>
+                        </a:rPr>
+                        <a:t>against</a:t>
+                      </a:r>
+                    </a:p>
+                  </a:txBody>
+                  <a:tcPr marL="54864" marR="54864" marT="18288" marB="18288">
+                    <a:solidFill>
+                      <a:srgbClr val="ECF1F6"/>
+                    </a:solidFill>
+                  </a:tcPr>
+                </a:tc>
+                <a:tc>
+                  <a:txBody>
+                    <a:bodyPr wrap="square"/>
+                    <a:lstStyle/>
+                    <a:p>
+                      <a:r>
+                        <a:rPr sz="1100" b="0">
+                          <a:solidFill>
+                            <a:srgbClr val="282828"/>
+                          </a:solidFill>
+                          <a:latin typeface="Arial"/>
+                        </a:rPr>
+                        <a:t>one wavelength (a second color refocuses); substrates in the converging legs (0.03 wave W040 per 2 mm); the tail needs a tuned solve; faces need AR coating in the interferometer</a:t>
+                      </a:r>
+                    </a:p>
+                  </a:txBody>
+                  <a:tcPr marL="54864" marR="54864" marT="18288" marB="18288">
+                    <a:solidFill>
+                      <a:srgbClr val="ECF1F6"/>
+                    </a:solidFill>
+                  </a:tcPr>
+                </a:tc>
+                <a:tc>
+                  <a:txBody>
+                    <a:bodyPr wrap="square"/>
+                    <a:lstStyle/>
+                    <a:p>
+                      <a:r>
+                        <a:rPr sz="1100" b="0">
+                          <a:solidFill>
+                            <a:srgbClr val="282828"/>
+                          </a:solidFill>
+                          <a:latin typeface="Arial"/>
+                        </a:rPr>
+                        <a:t>fold polarization: bare aluminum at these angles gives the vector reading 0.1 rad of channel phase, at the edge of its calibration (a quarter-wave overcoat is expected to fix it); 10 µrad of mirror tilt moves the null 95-103 nm; capture range on a deep surface pending (the seed tail wraps at 120 nm)</a:t>
+                      </a:r>
+                    </a:p>
+                  </a:txBody>
+                  <a:tcPr marL="54864" marR="54864" marT="18288" marB="18288">
+                    <a:solidFill>
+                      <a:srgbClr val="ECF1F6"/>
                     </a:solidFill>
                   </a:tcPr>
                 </a:tc>
@@ -15998,383 +16164,57 @@
                           </a:solidFill>
                           <a:latin typeface="Arial"/>
                         </a:rPr>
-                        <a:t>collimator L1</a:t>
-                      </a:r>
-                    </a:p>
-                  </a:txBody>
-                  <a:tcPr marL="54864" marR="54864" marT="18288" marB="18288">
-                    <a:solidFill>
-                      <a:srgbClr val="ECF1F6"/>
-                    </a:solidFill>
-                  </a:tcPr>
-                </a:tc>
-                <a:tc>
-                  <a:txBody>
-                    <a:bodyPr wrap="square"/>
-                    <a:lstStyle/>
-                    <a:p>
-                      <a:r>
-                        <a:rPr sz="1100" b="0">
-                          <a:solidFill>
-                            <a:srgbClr val="282828"/>
-                          </a:solidFill>
-                          <a:latin typeface="Arial"/>
-                        </a:rPr>
-                        <a:t>f 857 mm, 103 mm, coated; modeled 5 mm center, 2 mm edge, to be a real 103 mm singlet</a:t>
-                      </a:r>
-                    </a:p>
-                  </a:txBody>
-                  <a:tcPr marL="54864" marR="54864" marT="18288" marB="18288">
-                    <a:solidFill>
-                      <a:srgbClr val="ECF1F6"/>
-                    </a:solidFill>
-                  </a:tcPr>
-                </a:tc>
-              </a:tr>
-              <a:tr h="468630">
-                <a:tc>
-                  <a:txBody>
-                    <a:bodyPr wrap="square"/>
-                    <a:lstStyle/>
-                    <a:p>
-                      <a:r>
-                        <a:rPr sz="1100" b="0">
-                          <a:solidFill>
-                            <a:srgbClr val="282828"/>
-                          </a:solidFill>
-                          <a:latin typeface="Arial"/>
-                        </a:rPr>
-                        <a:t>plate splitter</a:t>
-                      </a:r>
-                    </a:p>
-                  </a:txBody>
-                  <a:tcPr marL="54864" marR="54864" marT="18288" marB="18288">
-                    <a:solidFill>
-                      <a:srgbClr val="FFFFFF"/>
-                    </a:solidFill>
-                  </a:tcPr>
-                </a:tc>
-                <a:tc>
-                  <a:txBody>
-                    <a:bodyPr wrap="square"/>
-                    <a:lstStyle/>
-                    <a:p>
-                      <a:r>
-                        <a:rPr sz="1100" b="0">
-                          <a:solidFill>
-                            <a:srgbClr val="282828"/>
-                          </a:solidFill>
-                          <a:latin typeface="Arial"/>
-                        </a:rPr>
-                        <a:t>22.5° incidence (the record's 7° does not clear the node: next slide), 50/50; compensator matched; modeled 2.6 mm thick, to be 10 mm</a:t>
-                      </a:r>
-                    </a:p>
-                  </a:txBody>
-                  <a:tcPr marL="54864" marR="54864" marT="18288" marB="18288">
-                    <a:solidFill>
-                      <a:srgbClr val="FFFFFF"/>
-                    </a:solidFill>
-                  </a:tcPr>
-                </a:tc>
-              </a:tr>
-              <a:tr h="468630">
-                <a:tc>
-                  <a:txBody>
-                    <a:bodyPr wrap="square"/>
-                    <a:lstStyle/>
-                    <a:p>
-                      <a:r>
-                        <a:rPr sz="1100" b="0">
-                          <a:solidFill>
-                            <a:srgbClr val="282828"/>
-                          </a:solidFill>
-                          <a:latin typeface="Arial"/>
-                        </a:rPr>
-                        <a:t>deformable mirror</a:t>
-                      </a:r>
-                    </a:p>
-                  </a:txBody>
-                  <a:tcPr marL="54864" marR="54864" marT="18288" marB="18288">
-                    <a:solidFill>
-                      <a:srgbClr val="ECF1F6"/>
-                    </a:solidFill>
-                  </a:tcPr>
-                </a:tc>
-                <a:tc>
-                  <a:txBody>
-                    <a:bodyPr wrap="square"/>
-                    <a:lstStyle/>
-                    <a:p>
-                      <a:r>
-                        <a:rPr sz="1100" b="0">
-                          <a:solidFill>
-                            <a:srgbClr val="282828"/>
-                          </a:solidFill>
-                          <a:latin typeface="Arial"/>
-                        </a:rPr>
-                        <a:t>96×96, 1 mm pitch, 96 mm, 700 mm leg</a:t>
-                      </a:r>
-                    </a:p>
-                  </a:txBody>
-                  <a:tcPr marL="54864" marR="54864" marT="18288" marB="18288">
-                    <a:solidFill>
-                      <a:srgbClr val="ECF1F6"/>
-                    </a:solidFill>
-                  </a:tcPr>
-                </a:tc>
-              </a:tr>
-            </a:tbl>
-          </a:graphicData>
-        </a:graphic>
-      </p:graphicFrame>
-      <p:graphicFrame>
-        <p:nvGraphicFramePr>
-          <p:cNvPr id="7" name="Table 6"/>
-          <p:cNvGraphicFramePr>
-            <a:graphicFrameLocks noGrp="1"/>
-          </p:cNvGraphicFramePr>
-          <p:nvPr/>
-        </p:nvGraphicFramePr>
-        <p:xfrm>
-          <a:off x="6400800" y="4096511"/>
-          <a:ext cx="5394960" cy="1657350"/>
-        </p:xfrm>
-        <a:graphic>
-          <a:graphicData uri="http://schemas.openxmlformats.org/drawingml/2006/table">
-            <a:tbl>
-              <a:tblPr firstRow="1" bandRow="1">
-                <a:tableStyleId>{5C22544A-7EE6-4342-B048-85BDC9FD1C3A}</a:tableStyleId>
-              </a:tblPr>
-              <a:tblGrid>
-                <a:gridCol w="806704"/>
-                <a:gridCol w="4588256"/>
-              </a:tblGrid>
-              <a:tr h="262890">
-                <a:tc>
-                  <a:txBody>
-                    <a:bodyPr wrap="square"/>
-                    <a:lstStyle/>
-                    <a:p>
-                      <a:r>
-                        <a:rPr sz="1000" b="1">
-                          <a:solidFill>
-                            <a:srgbClr val="FFFFFF"/>
-                          </a:solidFill>
-                          <a:latin typeface="Arial"/>
-                        </a:rPr>
-                        <a:t>part</a:t>
-                      </a:r>
-                    </a:p>
-                  </a:txBody>
-                  <a:tcPr marL="54864" marR="54864" marT="18288" marB="18288">
-                    <a:solidFill>
-                      <a:srgbClr val="1F4E79"/>
-                    </a:solidFill>
-                  </a:tcPr>
-                </a:tc>
-                <a:tc>
-                  <a:txBody>
-                    <a:bodyPr wrap="square"/>
-                    <a:lstStyle/>
-                    <a:p>
-                      <a:r>
-                        <a:rPr sz="1000" b="1">
-                          <a:solidFill>
-                            <a:srgbClr val="FFFFFF"/>
-                          </a:solidFill>
-                          <a:latin typeface="Arial"/>
-                        </a:rPr>
-                        <a:t>value</a:t>
-                      </a:r>
-                    </a:p>
-                  </a:txBody>
-                  <a:tcPr marL="54864" marR="54864" marT="18288" marB="18288">
-                    <a:solidFill>
-                      <a:srgbClr val="1F4E79"/>
-                    </a:solidFill>
-                  </a:tcPr>
-                </a:tc>
-              </a:tr>
-              <a:tr h="434340">
-                <a:tc>
-                  <a:txBody>
-                    <a:bodyPr wrap="square"/>
-                    <a:lstStyle/>
-                    <a:p>
-                      <a:r>
-                        <a:rPr sz="1000" b="0">
-                          <a:solidFill>
-                            <a:srgbClr val="282828"/>
-                          </a:solidFill>
-                          <a:latin typeface="Arial"/>
-                        </a:rPr>
-                        <a:t>focuser L2</a:t>
-                      </a:r>
-                    </a:p>
-                  </a:txBody>
-                  <a:tcPr marL="54864" marR="54864" marT="18288" marB="18288">
-                    <a:solidFill>
-                      <a:srgbClr val="FFFFFF"/>
-                    </a:solidFill>
-                  </a:tcPr>
-                </a:tc>
-                <a:tc>
-                  <a:txBody>
-                    <a:bodyPr wrap="square"/>
-                    <a:lstStyle/>
-                    <a:p>
-                      <a:r>
-                        <a:rPr sz="1000" b="0">
-                          <a:solidFill>
-                            <a:srgbClr val="282828"/>
-                          </a:solidFill>
-                          <a:latin typeface="Arial"/>
-                        </a:rPr>
-                        <a:t>f 429 mm, 103 mm; internal focus at F/4.2; modeled 8 mm center, to be real</a:t>
-                      </a:r>
-                    </a:p>
-                  </a:txBody>
-                  <a:tcPr marL="54864" marR="54864" marT="18288" marB="18288">
-                    <a:solidFill>
-                      <a:srgbClr val="FFFFFF"/>
-                    </a:solidFill>
-                  </a:tcPr>
-                </a:tc>
-              </a:tr>
-              <a:tr h="262890">
-                <a:tc>
-                  <a:txBody>
-                    <a:bodyPr wrap="square"/>
-                    <a:lstStyle/>
-                    <a:p>
-                      <a:r>
-                        <a:rPr sz="1000" b="0">
-                          <a:solidFill>
-                            <a:srgbClr val="282828"/>
-                          </a:solidFill>
-                          <a:latin typeface="Arial"/>
-                        </a:rPr>
-                        <a:t>field lens</a:t>
-                      </a:r>
-                    </a:p>
-                  </a:txBody>
-                  <a:tcPr marL="54864" marR="54864" marT="18288" marB="18288">
-                    <a:solidFill>
-                      <a:srgbClr val="ECF1F6"/>
-                    </a:solidFill>
-                  </a:tcPr>
-                </a:tc>
-                <a:tc>
-                  <a:txBody>
-                    <a:bodyPr wrap="square"/>
-                    <a:lstStyle/>
-                    <a:p>
-                      <a:r>
-                        <a:rPr sz="1000" b="0">
-                          <a:solidFill>
-                            <a:srgbClr val="282828"/>
-                          </a:solidFill>
-                          <a:latin typeface="Arial"/>
-                        </a:rPr>
-                        <a:t>f 43 mm, 21 mm; pupil image 9.4 mm, 32 mm behind it</a:t>
-                      </a:r>
-                    </a:p>
-                  </a:txBody>
-                  <a:tcPr marL="54864" marR="54864" marT="18288" marB="18288">
-                    <a:solidFill>
-                      <a:srgbClr val="ECF1F6"/>
-                    </a:solidFill>
-                  </a:tcPr>
-                </a:tc>
-              </a:tr>
-              <a:tr h="434340">
-                <a:tc>
-                  <a:txBody>
-                    <a:bodyPr wrap="square"/>
-                    <a:lstStyle/>
-                    <a:p>
-                      <a:r>
-                        <a:rPr sz="1000" b="0">
-                          <a:solidFill>
-                            <a:srgbClr val="282828"/>
-                          </a:solidFill>
-                          <a:latin typeface="Arial"/>
-                        </a:rPr>
-                        <a:t>camera</a:t>
-                      </a:r>
-                    </a:p>
-                  </a:txBody>
-                  <a:tcPr marL="54864" marR="54864" marT="18288" marB="18288">
-                    <a:solidFill>
-                      <a:srgbClr val="FFFFFF"/>
-                    </a:solidFill>
-                  </a:tcPr>
-                </a:tc>
-                <a:tc>
-                  <a:txBody>
-                    <a:bodyPr wrap="square"/>
-                    <a:lstStyle/>
-                    <a:p>
-                      <a:r>
-                        <a:rPr sz="1000" b="0">
-                          <a:solidFill>
-                            <a:srgbClr val="282828"/>
-                          </a:solidFill>
-                          <a:latin typeface="Arial"/>
-                        </a:rPr>
-                        <a:t>pupil image 9.4 mm: a 6.5 µm sCMOS puts 1450 pixels across it, binned 4 to the modeled 385 (5 per actuator)</a:t>
-                      </a:r>
-                    </a:p>
-                  </a:txBody>
-                  <a:tcPr marL="54864" marR="54864" marT="18288" marB="18288">
-                    <a:solidFill>
-                      <a:srgbClr val="FFFFFF"/>
-                    </a:solidFill>
-                  </a:tcPr>
-                </a:tc>
-              </a:tr>
-              <a:tr h="262890">
-                <a:tc>
-                  <a:txBody>
-                    <a:bodyPr wrap="square"/>
-                    <a:lstStyle/>
-                    <a:p>
-                      <a:r>
-                        <a:rPr sz="1000" b="0">
-                          <a:solidFill>
-                            <a:srgbClr val="282828"/>
-                          </a:solidFill>
-                          <a:latin typeface="Arial"/>
-                        </a:rPr>
-                        <a:t>mask seat</a:t>
-                      </a:r>
-                    </a:p>
-                  </a:txBody>
-                  <a:tcPr marL="54864" marR="54864" marT="18288" marB="18288">
-                    <a:solidFill>
-                      <a:srgbClr val="ECF1F6"/>
-                    </a:solidFill>
-                  </a:tcPr>
-                </a:tc>
-                <a:tc>
-                  <a:txBody>
-                    <a:bodyPr wrap="square"/>
-                    <a:lstStyle/>
-                    <a:p>
-                      <a:r>
-                        <a:rPr sz="1000" b="0">
-                          <a:solidFill>
-                            <a:srgbClr val="282828"/>
-                          </a:solidFill>
-                          <a:latin typeface="Arial"/>
-                        </a:rPr>
-                        <a:t>one substrate at the internal focus, translated to select the sensor</a:t>
-                      </a:r>
-                    </a:p>
-                  </a:txBody>
-                  <a:tcPr marL="54864" marR="54864" marT="18288" marB="18288">
-                    <a:solidFill>
-                      <a:srgbClr val="ECF1F6"/>
+                        <a:t>where it stands</a:t>
+                      </a:r>
+                    </a:p>
+                  </a:txBody>
+                  <a:tcPr marL="54864" marR="54864" marT="18288" marB="18288">
+                    <a:solidFill>
+                      <a:srgbClr val="FFFFFF"/>
+                    </a:solidFill>
+                  </a:tcPr>
+                </a:tc>
+                <a:tc>
+                  <a:txBody>
+                    <a:bodyPr wrap="square"/>
+                    <a:lstStyle/>
+                    <a:p>
+                      <a:r>
+                        <a:rPr sz="1100" b="0">
+                          <a:solidFill>
+                            <a:srgbClr val="282828"/>
+                          </a:solidFill>
+                          <a:latin typeface="Arial"/>
+                        </a:rPr>
+                        <a:t>the record</a:t>
+                      </a:r>
+                    </a:p>
+                  </a:txBody>
+                  <a:tcPr marL="54864" marR="54864" marT="18288" marB="18288">
+                    <a:solidFill>
+                      <a:srgbClr val="FFFFFF"/>
+                    </a:solidFill>
+                  </a:tcPr>
+                </a:tc>
+                <a:tc>
+                  <a:txBody>
+                    <a:bodyPr wrap="square"/>
+                    <a:lstStyle/>
+                    <a:p>
+                      <a:r>
+                        <a:rPr sz="1100" b="0">
+                          <a:solidFill>
+                            <a:srgbClr val="282828"/>
+                          </a:solidFill>
+                          <a:latin typeface="Arial"/>
+                        </a:rPr>
+                        <a:t>rows read at 0.99 / 2.4 pm and 0.99 / 161 pm, cross-talk 0.006-0.02 (the lens rig's own); pinhole recovers; vector pair and interferometer servo being re-measured</a:t>
+                      </a:r>
+                    </a:p>
+                  </a:txBody>
+                  <a:tcPr marL="54864" marR="54864" marT="18288" marB="18288">
+                    <a:solidFill>
+                      <a:srgbClr val="FFFFFF"/>
                     </a:solidFill>
                   </a:tcPr>
                 </a:tc>
@@ -16385,14 +16225,14 @@
       </p:graphicFrame>
       <p:sp>
         <p:nvSpPr>
-          <p:cNvPr id="8" name="TextBox 7"/>
+          <p:cNvPr id="9" name="TextBox 8"/>
           <p:cNvSpPr txBox="1"/>
           <p:nvPr/>
         </p:nvSpPr>
         <p:spPr>
           <a:xfrm>
-            <a:off x="6400800" y="5900166"/>
-            <a:ext cx="5394960" cy="274320"/>
+            <a:off x="411480" y="6403086"/>
+            <a:ext cx="11368735" cy="274320"/>
           </a:xfrm>
           <a:prstGeom prst="rect">
             <a:avLst/>
@@ -16417,7 +16257,7 @@
                 </a:solidFill>
                 <a:latin typeface="Arial"/>
               </a:rPr>
-              <a:t>The reference arm (a 103 mm flat on a piezo stage, 564 mm leg) is the interferometer's; shuttered, the same bench is every other sensor.  Lenses, not off-axis mirrors: the choice is priced on the lenses-versus-mirrors slide.  The drawings are to scale: the model's parts are the 56 mm rig's scaled up, thinner than 103 mm optics can be built; the next model round gives every part its real thickness.</a:t>
+              <a:t>The reference arm (a 103 mm flat on a piezo, 564 mm leg) is the interferometer's; shuttered, the same bench is every other sensor.  Run tags bench_bs22, oapdraw3, oapifo2, oapsens22; the priced comparison is on the lenses-versus-mirrors slides.</a:t>
             </a:r>
           </a:p>
         </p:txBody>

</xml_diff>

<commit_message>
Deck: plain language -- slide 3's for/against in bench terms (focus adjustment, residual with a flat mirror, the reading folds over), 'tail' -> 'detector leg' and 'rows' -> 'performance rows' across the deck, gate names out of prose; slide 15: the phase stepping is ideal ('magic'), the photonic shifter and stage physics not yet modeled (Dave 2026-09-15)
Co-Authored-By: Claude Fable 5.1 <noreply@anthropic.com>
</commit_message>
<xml_diff>
--- a/demo_session/deck_gauges.pptx
+++ b/demo_session/deck_gauges.pptx
@@ -3802,7 +3802,7 @@
                 </a:solidFill>
                 <a:latin typeface="Arial"/>
               </a:rPr>
-              <a:t>The residual column is the raw pixel map against the engine's field, before any calibration; the rows and the servo use the calibrated estimate.</a:t>
+              <a:t>The residual column is the raw pixel map against the engine's field, before any calibration; the performance rows and the servo use the calibrated estimate.</a:t>
             </a:r>
           </a:p>
         </p:txBody>
@@ -4404,7 +4404,7 @@
                 </a:solidFill>
                 <a:latin typeface="Arial"/>
               </a:rPr>
-              <a:t>The tail from the focus to the two cameras, both channel decks traced by the engine</a:t>
+              <a:t>The leg from the focus to the two cameras, both channel decks traced by the engine</a:t>
             </a:r>
           </a:p>
         </p:txBody>
@@ -4847,7 +4847,7 @@
                 </a:solidFill>
                 <a:latin typeface="Arial"/>
               </a:rPr>
-              <a:t>The 25 pm is the raw absolute map's error on a 30 nm surface with the flat's calibration; the rows on the same surface read 0.9935 / 4 pm through the matrix.</a:t>
+              <a:t>The 25 pm is the raw absolute map's error on a 30 nm surface with the flat's calibration; on the same surface the calibrated reading is 0.9935 / 4 pm.</a:t>
             </a:r>
           </a:p>
         </p:txBody>
@@ -5038,6 +5038,22 @@
               <a:t>•  Servo: 3 pm from 2.3e12 photons per cycle noise only, 7.0e12 under the walk; no fixed error.  The shutter frame is what lets it read to 480 nm of surface (next slides).</a:t>
             </a:r>
           </a:p>
+          <a:p>
+            <a:pPr>
+              <a:spcAft>
+                <a:spcPts val="600"/>
+              </a:spcAft>
+            </a:pPr>
+            <a:r>
+              <a:rPr sz="1200" b="0">
+                <a:solidFill>
+                  <a:srgbClr val="282828"/>
+                </a:solidFill>
+                <a:latin typeface="Arial"/>
+              </a:rPr>
+              <a:t>•  Not yet modeled: how the phase is stepped.  These results step the surround's phase by an ideal increment ("magic"), with a step-error knob only.  The photonic phase shifter of the two-arm form, and the stage or etched steps of this one, have no device physics yet: coupling, loss, drift.</a:t>
+            </a:r>
+          </a:p>
         </p:txBody>
       </p:sp>
       <p:graphicFrame>
@@ -5403,7 +5419,7 @@
                 </a:solidFill>
                 <a:latin typeface="Arial"/>
               </a:rPr>
-              <a:t>The tail from the focuser to the camera, with the pinhole substrate at the internal focus</a:t>
+              <a:t>The leg from the focuser to the camera, with the pinhole substrate at the internal focus</a:t>
             </a:r>
           </a:p>
         </p:txBody>
@@ -12723,7 +12739,7 @@
                 </a:solidFill>
                 <a:latin typeface="Arial"/>
               </a:rPr>
-              <a:t>Fed at its focus and re-solved at the 22.5° splitter, the mirror rig is buildable (every part clears by 33 mm), its mask seat is diffraction-limited at zero trim, and its untuned tail nulls 4.6× better than the lens rig's tuned one; the rows are running</a:t>
+              <a:t>Fed at its focus and re-solved at the 22.5° splitter, the mirror rig is buildable (every part clears by 33 mm), its focus lands on the mask seat without adjustment, and its residual with a flat mirror is 4.6× smaller than the lens rig's; its performance is being measured</a:t>
             </a:r>
           </a:p>
         </p:txBody>
@@ -12845,7 +12861,7 @@
         </p:nvGraphicFramePr>
         <p:xfrm>
           <a:off x="6400800" y="1298448"/>
-          <a:ext cx="5394959" cy="2263140"/>
+          <a:ext cx="5394958" cy="2263140"/>
         </p:xfrm>
         <a:graphic>
           <a:graphicData uri="http://schemas.openxmlformats.org/drawingml/2006/table">
@@ -12854,9 +12870,9 @@
                 <a:tableStyleId>{5C22544A-7EE6-4342-B048-85BDC9FD1C3A}</a:tableStyleId>
               </a:tblPr>
               <a:tblGrid>
-                <a:gridCol w="1940292"/>
-                <a:gridCol w="1656347"/>
-                <a:gridCol w="1798320"/>
+                <a:gridCol w="1496081"/>
+                <a:gridCol w="1586752"/>
+                <a:gridCol w="2312125"/>
               </a:tblGrid>
               <a:tr h="262890">
                 <a:tc>
@@ -13065,7 +13081,7 @@
                           </a:solidFill>
                           <a:latin typeface="Arial"/>
                         </a:rPr>
-                        <a:t>flat-mirror null, tail as tuned / untuned</a:t>
+                        <a:t>residual with a flat mirror</a:t>
                       </a:r>
                     </a:p>
                   </a:txBody>
@@ -13087,7 +13103,7 @@
                           </a:solidFill>
                           <a:latin typeface="Arial"/>
                         </a:rPr>
-                        <a:t>12.9 nm tuned</a:t>
+                        <a:t>12.9 nm after focus adjustment</a:t>
                       </a:r>
                     </a:p>
                   </a:txBody>
@@ -13109,7 +13125,7 @@
                           </a:solidFill>
                           <a:latin typeface="Arial"/>
                         </a:rPr>
-                        <a:t>0.029 nm untuned (lens rig 0.13 tuned)</a:t>
+                        <a:t>0.029 nm with none (lens rig 0.13 after adjustment)</a:t>
                       </a:r>
                     </a:p>
                   </a:txBody>
@@ -15686,7 +15702,7 @@
                 </a:solidFill>
                 <a:latin typeface="Arial"/>
               </a:rPr>
-              <a:t>Run tag an193_clear; the runner's mask.v_clear reading and gate G9.  On orbit with starlight, the field's amplitude is what the second mirror's control needs.</a:t>
+              <a:t>Run tag an193_clear; the runner's mask.v_clear reading and its amplitude-dip check.  On orbit with starlight, the field's amplitude is what the second mirror's control needs.</a:t>
             </a:r>
           </a:p>
         </p:txBody>
@@ -15824,8 +15840,8 @@
         </p:blipFill>
         <p:spPr>
           <a:xfrm>
-            <a:off x="1645652" y="1298448"/>
-            <a:ext cx="3338094" cy="1927352"/>
+            <a:off x="1883208" y="1298448"/>
+            <a:ext cx="2862983" cy="1653032"/>
           </a:xfrm>
           <a:prstGeom prst="rect">
             <a:avLst/>
@@ -15840,7 +15856,7 @@
         </p:nvSpPr>
         <p:spPr>
           <a:xfrm>
-            <a:off x="411480" y="3244088"/>
+            <a:off x="411480" y="2969768"/>
             <a:ext cx="5806440" cy="724408"/>
           </a:xfrm>
           <a:prstGeom prst="rect">
@@ -15887,8 +15903,8 @@
         </p:blipFill>
         <p:spPr>
           <a:xfrm>
-            <a:off x="8033856" y="1298448"/>
-            <a:ext cx="2128847" cy="1927352"/>
+            <a:off x="8185355" y="1298448"/>
+            <a:ext cx="1825848" cy="1653032"/>
           </a:xfrm>
           <a:prstGeom prst="rect">
             <a:avLst/>
@@ -15903,7 +15919,7 @@
         </p:nvSpPr>
         <p:spPr>
           <a:xfrm>
-            <a:off x="6400800" y="3244088"/>
+            <a:off x="6400800" y="2969768"/>
             <a:ext cx="5394960" cy="724408"/>
           </a:xfrm>
           <a:prstGeom prst="rect">
@@ -15943,8 +15959,8 @@
           <p:nvPr/>
         </p:nvGraphicFramePr>
         <p:xfrm>
-          <a:off x="411480" y="4005072"/>
-          <a:ext cx="11368735" cy="2251710"/>
+          <a:off x="411480" y="3730752"/>
+          <a:ext cx="11368735" cy="2440305"/>
         </p:xfrm>
         <a:graphic>
           <a:graphicData uri="http://schemas.openxmlformats.org/drawingml/2006/table">
@@ -15954,8 +15970,8 @@
               </a:tblPr>
               <a:tblGrid>
                 <a:gridCol w="1235964"/>
-                <a:gridCol w="3759959"/>
-                <a:gridCol w="6372812"/>
+                <a:gridCol w="3790407"/>
+                <a:gridCol w="6342364"/>
               </a:tblGrid>
               <a:tr h="280035">
                 <a:tc>
@@ -16050,29 +16066,29 @@
                           </a:solidFill>
                           <a:latin typeface="Arial"/>
                         </a:rPr>
-                        <a:t>on axis, no fold polarization; cheap parts; the record's readings were all measured on it</a:t>
-                      </a:r>
-                    </a:p>
-                  </a:txBody>
-                  <a:tcPr marL="54864" marR="54864" marT="18288" marB="18288">
-                    <a:solidFill>
-                      <a:srgbClr val="FFFFFF"/>
-                    </a:solidFill>
-                  </a:tcPr>
-                </a:tc>
-                <a:tc>
-                  <a:txBody>
-                    <a:bodyPr wrap="square"/>
-                    <a:lstStyle/>
-                    <a:p>
-                      <a:r>
-                        <a:rPr sz="1100" b="0">
-                          <a:solidFill>
-                            <a:srgbClr val="282828"/>
-                          </a:solidFill>
-                          <a:latin typeface="Arial"/>
-                        </a:rPr>
-                        <a:t>no glass in the beam: achromatic (a second color for capture is free), no ghosts; fed at its focus the mask seat is diffraction-limited at zero trim, and the untuned tail nulls 0.029 nm against the lens rig's tuned 0.134; every part clears by 33 mm</a:t>
+                        <a:t>on axis, no polarization from folds; inexpensive parts; every record reading was measured on it</a:t>
+                      </a:r>
+                    </a:p>
+                  </a:txBody>
+                  <a:tcPr marL="54864" marR="54864" marT="18288" marB="18288">
+                    <a:solidFill>
+                      <a:srgbClr val="FFFFFF"/>
+                    </a:solidFill>
+                  </a:tcPr>
+                </a:tc>
+                <a:tc>
+                  <a:txBody>
+                    <a:bodyPr wrap="square"/>
+                    <a:lstStyle/>
+                    <a:p>
+                      <a:r>
+                        <a:rPr sz="1100" b="0">
+                          <a:solidFill>
+                            <a:srgbClr val="282828"/>
+                          </a:solidFill>
+                          <a:latin typeface="Arial"/>
+                        </a:rPr>
+                        <a:t>no glass in the beam: works at any color (a second color for capture is free), no ghosts; the focus lands on the mask without adjustment, and the residual with a flat mirror is 0.029 nm against the lens rig's 0.13; every part clears by 33 mm</a:t>
                       </a:r>
                     </a:p>
                   </a:txBody>
@@ -16118,7 +16134,7 @@
                           </a:solidFill>
                           <a:latin typeface="Arial"/>
                         </a:rPr>
-                        <a:t>one wavelength (a second color refocuses); substrates in the converging legs (0.03 wave W040 per 2 mm); the tail needs a tuned solve; faces need AR coating in the interferometer</a:t>
+                        <a:t>one color at a time; each plate in the converging beam adds aberration (0.03 wave per 2 mm); the detector leg reaches its best focus only after a numerical adjustment; faces need anti-reflection coating</a:t>
                       </a:r>
                     </a:p>
                   </a:txBody>
@@ -16140,7 +16156,7 @@
                           </a:solidFill>
                           <a:latin typeface="Arial"/>
                         </a:rPr>
-                        <a:t>fold polarization: bare aluminum at these angles gives the vector reading 0.1 rad of channel phase, at the edge of its calibration (a quarter-wave overcoat is expected to fix it); 10 µrad of mirror tilt moves the null 95-103 nm; capture range on a deep surface pending (the seed tail wraps at 120 nm)</a:t>
+                        <a:t>the folds polarize: bare aluminum at these angles gives the vector reading a 0.1 rad channel error, at the edge of what its calibration removes (a quarter-wave overcoat should fix it); 10 µrad of mirror tilt moves the null 95-103 nm; on a 120 nm surface the reading folds over, which the lens rig's does not (being re-run with unwrapping)</a:t>
                       </a:r>
                     </a:p>
                   </a:txBody>
@@ -16151,7 +16167,7 @@
                   </a:tcPr>
                 </a:tc>
               </a:tr>
-              <a:tr h="468630">
+              <a:tr h="657225">
                 <a:tc>
                   <a:txBody>
                     <a:bodyPr wrap="square"/>
@@ -16208,7 +16224,7 @@
                           </a:solidFill>
                           <a:latin typeface="Arial"/>
                         </a:rPr>
-                        <a:t>rows read at 0.99 / 2.4 pm and 0.99 / 161 pm, cross-talk 0.006-0.02 (the lens rig's own); pinhole recovers; vector pair and interferometer servo being re-measured</a:t>
+                        <a:t>reads 0.99 / 2.4 pm and 0.99 / 161 pm with the lens rig's own cross-talk (0.006-0.02); the pinhole recovers; the vector pair and the interferometer servo are being re-measured</a:t>
                       </a:r>
                     </a:p>
                   </a:txBody>
@@ -16231,7 +16247,7 @@
         </p:nvSpPr>
         <p:spPr>
           <a:xfrm>
-            <a:off x="411480" y="6403086"/>
+            <a:off x="411480" y="6317361"/>
             <a:ext cx="11368735" cy="274320"/>
           </a:xfrm>
           <a:prstGeom prst="rect">
@@ -17644,7 +17660,7 @@
         </p:nvGraphicFramePr>
         <p:xfrm>
           <a:off x="411480" y="1298448"/>
-          <a:ext cx="5806439" cy="3377565"/>
+          <a:ext cx="5806439" cy="3188970"/>
         </p:xfrm>
         <a:graphic>
           <a:graphicData uri="http://schemas.openxmlformats.org/drawingml/2006/table">
@@ -17654,8 +17670,8 @@
               </a:tblPr>
               <a:tblGrid>
                 <a:gridCol w="436880"/>
-                <a:gridCol w="2856711"/>
-                <a:gridCol w="2512848"/>
+                <a:gridCol w="2963389"/>
+                <a:gridCol w="2406170"/>
               </a:tblGrid>
               <a:tr h="280035">
                 <a:tc>
@@ -17828,7 +17844,7 @@
                           </a:solidFill>
                           <a:latin typeface="Arial"/>
                         </a:rPr>
-                        <a:t>build the bench from the sheet, trace it; clearance of end bodies and node parts; tail tune; sampling budget</a:t>
+                        <a:t>build the bench from the sheet, trace it; clearance of end bodies and node parts; detector-leg focus; sampling budget</a:t>
                       </a:r>
                     </a:p>
                   </a:txBody>
@@ -17997,7 +18013,7 @@
                   </a:tcPr>
                 </a:tc>
               </a:tr>
-              <a:tr h="657225">
+              <a:tr h="468630">
                 <a:tc>
                   <a:txBody>
                     <a:bodyPr wrap="square"/>
@@ -24877,7 +24893,7 @@
                 </a:solidFill>
                 <a:latin typeface="Arial"/>
               </a:rPr>
-              <a:t>•  What moves: the output plate and analyzer from 17 and 27 mm behind the splitter to 160 and 170 mm, just ahead of the focuser at 207 mm; nothing else, so the tuned tail is untouched.</a:t>
+              <a:t>•  What moves: the output plate and analyzer from 17 and 27 mm behind the splitter to 160 and 170 mm, just ahead of the focuser at 207 mm; nothing else, so the focused detector leg is untouched.</a:t>
             </a:r>
           </a:p>
           <a:p>
@@ -25200,9 +25216,9 @@
               </a:tblPr>
               <a:tblGrid>
                 <a:gridCol w="1453895"/>
-                <a:gridCol w="2946123"/>
-                <a:gridCol w="3371045"/>
-                <a:gridCol w="3597670"/>
+                <a:gridCol w="3250766"/>
+                <a:gridCol w="3223677"/>
+                <a:gridCol w="3440395"/>
               </a:tblGrid>
               <a:tr h="280035">
                 <a:tc>
@@ -25329,7 +25345,7 @@
                           </a:solidFill>
                           <a:latin typeface="Arial"/>
                         </a:rPr>
-                        <a:t>stage A clearance, A2 sampling, B build both arms; the tail from tg96_tail; the wrapped phase difference</a:t>
+                        <a:t>stage A clearance, A2 sampling, B build both arms; the detector leg's focus from tg96_tail; the wrapped phase difference</a:t>
                       </a:r>
                     </a:p>
                   </a:txBody>
@@ -25959,7 +25975,7 @@
                           </a:solidFill>
                           <a:latin typeface="Arial"/>
                         </a:rPr>
-                        <a:t>the view_rx recipe: train, node, tail</a:t>
+                        <a:t>the view_rx recipe: train, node, detector leg</a:t>
                       </a:r>
                     </a:p>
                   </a:txBody>
@@ -26384,7 +26400,7 @@
                 </a:solidFill>
                 <a:latin typeface="Arial"/>
               </a:rPr>
-              <a:t>The front end and the detector tail, from the parameter sheet; thicknesses are the scaled model's and are being made real</a:t>
+              <a:t>The front end and the detector leg, from the parameter sheet; thicknesses are the scaled model's and are being made real</a:t>
             </a:r>
           </a:p>
         </p:txBody>
@@ -27728,7 +27744,7 @@
                 </a:solidFill>
                 <a:latin typeface="Arial"/>
               </a:rPr>
-              <a:t>The tail (focuser, mask seat, field lens, camera) is tuned once and shared; only the mask seat's contents and what follows the field lens change between configurations.</a:t>
+              <a:t>The detector leg (focuser, mask seat, field lens, camera) is focused once and shared; only the mask seat's contents and what follows the field lens change between configurations.</a:t>
             </a:r>
           </a:p>
         </p:txBody>

</xml_diff>

<commit_message>
Deck: contents slide made concise (section names and slide ranges only)
Co-Authored-By: Claude Fable 5.1 <noreply@anthropic.com>
</commit_message>
<xml_diff>
--- a/demo_session/deck_gauges.pptx
+++ b/demo_session/deck_gauges.pptx
@@ -6376,7 +6376,7 @@
                 </a:solidFill>
                 <a:latin typeface="Arial"/>
               </a:rPr>
-              <a:t>Three jobs, one bench, four ways of sensing; the record on a 30 nm working surface; lenses or mirrors; what remains</a:t>
+              <a:t>Three jobs, one bench, four ways of sensing</a:t>
             </a:r>
           </a:p>
         </p:txBody>
@@ -6459,7 +6459,7 @@
                 </a:solidFill>
                 <a:latin typeface="Arial"/>
               </a:rPr>
-              <a:t>•  The jobs and the bench (3-8): measure, capture, hold; one bench, four ways of sensing; the splitter angle; parts common to every configuration, the interferometer's, the sensors'.</a:t>
+              <a:t>•  3-8 The jobs; the bench and its parts</a:t>
             </a:r>
           </a:p>
           <a:p>
@@ -6475,7 +6475,7 @@
                 </a:solidFill>
                 <a:latin typeface="Arial"/>
               </a:rPr>
-              <a:t>•  The four approaches (9-19): the Twyman-Green interferometer, its node and its stations; the Zernike dimple and its stations; the vector Zernike, its layout and stations; the stepped pinhole, its layout and stations.</a:t>
+              <a:t>•  9-19 The four approaches: interferometer, Zernike, vector Zernike, pinhole</a:t>
             </a:r>
           </a:p>
           <a:p>
@@ -6491,7 +6491,7 @@
                 </a:solidFill>
                 <a:latin typeface="Arial"/>
               </a:rPr>
-              <a:t>•  Performance on the working surface (20-25): side by side; capture range and its photon price; photons for 1 pm; the servo; capturing the initial figure.</a:t>
+              <a:t>•  20-25 Performance on the working surface: rows, capture, photons, servo</a:t>
             </a:r>
           </a:p>
           <a:p>
@@ -6507,7 +6507,7 @@
                 </a:solidFill>
                 <a:latin typeface="Arial"/>
               </a:rPr>
-              <a:t>•  Lenses or off-axis mirrors (26-28): the record; the reflective front end redesigned; measured.</a:t>
+              <a:t>•  26-28 Lenses or off-axis mirrors</a:t>
             </a:r>
           </a:p>
         </p:txBody>
@@ -6546,7 +6546,7 @@
                 </a:solidFill>
                 <a:latin typeface="Arial"/>
               </a:rPr>
-              <a:t>•  Systematics and the recommendation (29-30).</a:t>
+              <a:t>•  29-30 Systematics; recommendation</a:t>
             </a:r>
           </a:p>
           <a:p>
@@ -6562,7 +6562,7 @@
                 </a:solidFill>
                 <a:latin typeface="Arial"/>
               </a:rPr>
-              <a:t>•  Operating the gauge (31-33): the modes from launch to hold; the complex amplitude for two-mirror control; one bench, every mode.</a:t>
+              <a:t>•  31-33 Operating the gauge</a:t>
             </a:r>
           </a:p>
           <a:p>
@@ -6578,7 +6578,7 @@
                 </a:solidFill>
                 <a:latin typeface="Arial"/>
               </a:rPr>
-              <a:t>•  Future work (34-36): a second color for capture; other approaches; from this model to as-built performance.</a:t>
+              <a:t>•  34-36 Future work</a:t>
             </a:r>
           </a:p>
           <a:p>
@@ -6594,7 +6594,7 @@
                 </a:solidFill>
                 <a:latin typeface="Arial"/>
               </a:rPr>
-              <a:t>•  Method (37-38): how every configuration was analyzed; run it yourself.</a:t>
+              <a:t>•  37-38 Method; run it yourself</a:t>
             </a:r>
           </a:p>
           <a:p>
@@ -6610,46 +6610,7 @@
                 </a:solidFill>
                 <a:latin typeface="Arial"/>
               </a:rPr>
-              <a:t>•  Backup (39-48): the three phase-shift forms; the record's mirror rig; the Zernike readings that lost; the pinhole trades; drift within a measurement; the vector sensor's polarization terms; sampling and color; the clearance scan; the path per configuration; provenance.</a:t>
-            </a:r>
-          </a:p>
-        </p:txBody>
-      </p:sp>
-      <p:sp>
-        <p:nvSpPr>
-          <p:cNvPr id="6" name="TextBox 5"/>
-          <p:cNvSpPr txBox="1"/>
-          <p:nvPr/>
-        </p:nvSpPr>
-        <p:spPr>
-          <a:xfrm>
-            <a:off x="6400800" y="4215384"/>
-            <a:ext cx="5394960" cy="274320"/>
-          </a:xfrm>
-          <a:prstGeom prst="rect">
-            <a:avLst/>
-          </a:prstGeom>
-          <a:noFill/>
-        </p:spPr>
-        <p:txBody>
-          <a:bodyPr wrap="square">
-            <a:spAutoFit/>
-          </a:bodyPr>
-          <a:lstStyle/>
-          <a:p>
-            <a:pPr>
-              <a:spcAft>
-                <a:spcPts val="600"/>
-              </a:spcAft>
-            </a:pPr>
-            <a:r>
-              <a:rPr sz="1050" b="0">
-                <a:solidFill>
-                  <a:srgbClr val="6E6E6E"/>
-                </a:solidFill>
-                <a:latin typeface="Arial"/>
-              </a:rPr>
-              <a:t>Every number carries a run tag on its slide; the tags resolve to committed run directories of the shared model (provenance, slide 48).</a:t>
+              <a:t>•  39-48 Backup</a:t>
             </a:r>
           </a:p>
         </p:txBody>

</xml_diff>

<commit_message>
Deck: TO's close-out results -- the raw four-step wraps between 60 and 120 nm on BOTH rigs (item 2(a) closed: capture is set by the reading, not the optics), the 10 mm plates attenuate the interferometer's reading 13% (floor and SNR, not gain), the station figure at its 1800 px width (stnoap); editing copy re-synced
Co-Authored-By: Claude Fable 5.1 <noreply@anthropic.com>
</commit_message>
<xml_diff>
--- a/demo_session/deck_gauges.pptx
+++ b/demo_session/deck_gauges.pptx
@@ -3600,7 +3600,7 @@
       </p:sp>
       <p:pic>
         <p:nvPicPr>
-          <p:cNvPr id="4" name="Picture 3" descr="oapifol2_stations.png"/>
+          <p:cNvPr id="4" name="Picture 3" descr="stnoap_stations.png"/>
           <p:cNvPicPr>
             <a:picLocks noChangeAspect="1"/>
           </p:cNvPicPr>
@@ -3614,8 +3614,8 @@
         </p:blipFill>
         <p:spPr>
           <a:xfrm>
-            <a:off x="2231570" y="1298448"/>
-            <a:ext cx="7728554" cy="2531872"/>
+            <a:off x="2026767" y="1298448"/>
+            <a:ext cx="8138160" cy="2531872"/>
           </a:xfrm>
           <a:prstGeom prst="rect">
             <a:avLst/>
@@ -3734,7 +3734,7 @@
                 </a:solidFill>
                 <a:latin typeface="Arial"/>
               </a:rPr>
-              <a:t>Run tag oapifol2 (seed detector leg, record resolution); the lens rig's figure is being regenerated at the same width.</a:t>
+              <a:t>Run tag stnoap (the redesigned mirror rig, seed detector leg; bit-identical to the servo run's figure).  The lens rig's figure exists but its residual panel reads 62 nm against the engine, a misregistration under investigation, so it is not shown.</a:t>
             </a:r>
           </a:p>
         </p:txBody>
@@ -8467,9 +8467,9 @@
                 <a:tableStyleId>{5C22544A-7EE6-4342-B048-85BDC9FD1C3A}</a:tableStyleId>
               </a:tblPr>
               <a:tblGrid>
-                <a:gridCol w="1721163"/>
-                <a:gridCol w="7020533"/>
-                <a:gridCol w="2627038"/>
+                <a:gridCol w="1435255"/>
+                <a:gridCol w="7742826"/>
+                <a:gridCol w="2190653"/>
               </a:tblGrid>
               <a:tr h="468630">
                 <a:tc>
@@ -9028,7 +9028,7 @@
                           </a:solidFill>
                           <a:latin typeface="Arial"/>
                         </a:rPr>
-                        <a:t>interferometer, mirror rig, redesigned</a:t>
+                        <a:t>interferometer, either rig</a:t>
                       </a:r>
                     </a:p>
                   </a:txBody>
@@ -9050,7 +9050,7 @@
                           </a:solidFill>
                           <a:latin typeface="Arial"/>
                         </a:rPr>
-                        <a:t>0.99 / 2 pm to 60 nm; the raw reading folds at 120 nm (lens rig at 240): two wrapped maps subtracted, an arithmetic of the ladder, not a limit of the bench</a:t>
+                        <a:t>0.99 / 2 pm to 60 nm; between 60 and 120 nm the raw four-step reading wraps (the base past λ/2 of surface reads 91 nm rms whatever it is) on lens and mirror rigs alike; unwrapping restores it (next slides)</a:t>
                       </a:r>
                     </a:p>
                   </a:txBody>
@@ -14673,7 +14673,7 @@
                 </a:solidFill>
                 <a:latin typeface="Arial"/>
               </a:rPr>
-              <a:t>•  Open: the raw interferometer reading folds at 120 nm of surface on this rig and at 240 on the lens rig, which is the ladder subtracting two wrapped maps rather than a bench limit; both rigs capture with unwrapping.  The detector leg here is the geometric seed (the tuner's objective prefers a leg that does not read: a known defect, being fixed).</a:t>
+              <a:t>•  Closed: the raw interferometer reading wraps between 60 and 120 nm of surface on both rigs, lens and mirror alike (a base the four-step cannot follow reads λ/2 ÷ √12 = 91 nm rms, measured 89-92 on both); the capture range is set by the reading, not the optics, and unwrapping restores it.  The detector leg here is the geometric seed (the tuner's objective prefers a leg that does not read: a known defect, being fixed).</a:t>
             </a:r>
           </a:p>
         </p:txBody>
@@ -14686,7 +14686,7 @@
         </p:nvSpPr>
         <p:spPr>
           <a:xfrm>
-            <a:off x="411480" y="5487924"/>
+            <a:off x="411480" y="5735574"/>
             <a:ext cx="11368735" cy="274320"/>
           </a:xfrm>
           <a:prstGeom prst="rect">
@@ -21051,7 +21051,7 @@
         </p:nvGraphicFramePr>
         <p:xfrm>
           <a:off x="411480" y="3730752"/>
-          <a:ext cx="11368734" cy="2440305"/>
+          <a:ext cx="11368735" cy="2628900"/>
         </p:xfrm>
         <a:graphic>
           <a:graphicData uri="http://schemas.openxmlformats.org/drawingml/2006/table">
@@ -21061,8 +21061,8 @@
               </a:tblPr>
               <a:tblGrid>
                 <a:gridCol w="1235964"/>
-                <a:gridCol w="3898704"/>
-                <a:gridCol w="6234066"/>
+                <a:gridCol w="3635559"/>
+                <a:gridCol w="6497212"/>
               </a:tblGrid>
               <a:tr h="280035">
                 <a:tc>
@@ -21190,7 +21190,7 @@
                   </a:tcPr>
                 </a:tc>
               </a:tr>
-              <a:tr h="845820">
+              <a:tr h="1034415">
                 <a:tc>
                   <a:txBody>
                     <a:bodyPr wrap="square"/>
@@ -21247,7 +21247,7 @@
                           </a:solidFill>
                           <a:latin typeface="Arial"/>
                         </a:rPr>
-                        <a:t>the metal folds polarize: the vector reading needs its two channels calibrated (634 pm raw, 0.054 pm calibrated; a quarter-wave overcoat halves the raw error); 10 µrad of mirror tilt moves the null 95-103 nm; the raw reading folds over at 120 nm of surface where the lens rig's does at 240, and both capture with unwrapping</a:t>
+                        <a:t>the metal folds polarize: the vector reading needs its two channels calibrated (634 pm raw, 0.054 pm calibrated; a quarter-wave overcoat halves the raw error); 10 µrad of mirror tilt moves the null 95-103 nm; the raw four-step reading wraps between 60 and 120 nm of surface on both rigs (a base past λ/2 reads 91 nm whatever it is); both capture with unwrapping</a:t>
                       </a:r>
                     </a:p>
                   </a:txBody>
@@ -21338,7 +21338,7 @@
         </p:nvSpPr>
         <p:spPr>
           <a:xfrm>
-            <a:off x="411480" y="6317361"/>
+            <a:off x="411480" y="6505956"/>
             <a:ext cx="11368735" cy="274320"/>
           </a:xfrm>
           <a:prstGeom prst="rect">
@@ -27225,7 +27225,7 @@
                 </a:solidFill>
                 <a:latin typeface="Arial"/>
               </a:rPr>
-              <a:t>•  Interferometer (tg_psi_dm96_oap/runs): lens_deck, lens_deck_se2, lens_deck_se5, loop_lens, loop_lens_cam, loop_lens_intra, loop_lens_se2, descent_lens, oap_deck, loop_oap, descent_oap, oap_bareAl, oap_coat, oap_jones, zoap (the 7° rigs); lens22, lens22g, lens22h, node22t, fold1-4, loss, loss_src, loss_a2, conj, zseat, zseat2, oap22d, oapdraw3, oap22d_tail, tailA, tailB, oapifo2, oapifol2, oapdesc2, oapuw2, lensuw2, thk22, sub22, aoi_lens22, aoi_oap22, gate3_win, gate3_lens (the 22.5° bench and the redesigned reflective rig); pdi_dm96/runs/psriclear2 (the P/SRI bench through the clearance tool).  Reports REPORT_gauge_ifo.md (CCMac) with REPORT_oap.md, REPORT_bench_realism.md and REPORT_reflective.md (TO), and README.md.</a:t>
+              <a:t>•  Interferometer (tg_psi_dm96_oap/runs): lens_deck, lens_deck_se2, lens_deck_se5, loop_lens, loop_lens_cam, loop_lens_intra, loop_lens_se2, descent_lens, oap_deck, loop_oap, descent_oap, oap_bareAl, oap_coat, oap_jones, zoap (the 7° rigs); lens22, lens22g, lens22h, node22t, fold1-4, loss, loss_src, loss_a2, conj, zseat, zseat2, oap22d, oapdraw3, oap22d_tail, tailA, tailB, oapifo2, oapifol2, oapdesc2, oapuw2, lensuw2, thk22, sub22, aoi_lens22, aoi_oap22, gate3_win, gate3_lens, wrapoap, wraplens, stnoap, stnlens (the 22.5° bench and the redesigned reflective rig); pdi_dm96/runs/psriclear2 (the P/SRI bench through the clearance tool).  Reports REPORT_gauge_ifo.md (CCMac) with REPORT_oap.md, REPORT_bench_realism.md and REPORT_reflective.md (TO), and README.md.</a:t>
             </a:r>
           </a:p>
           <a:p>
@@ -28427,7 +28427,7 @@
         </p:nvGraphicFramePr>
         <p:xfrm>
           <a:off x="411480" y="1298448"/>
-          <a:ext cx="11368734" cy="6852285"/>
+          <a:ext cx="11368734" cy="8549640"/>
         </p:xfrm>
         <a:graphic>
           <a:graphicData uri="http://schemas.openxmlformats.org/drawingml/2006/table">
@@ -28437,10 +28437,10 @@
               </a:tblPr>
               <a:tblGrid>
                 <a:gridCol w="1962404"/>
-                <a:gridCol w="5406970"/>
+                <a:gridCol w="5700809"/>
                 <a:gridCol w="2180336"/>
                 <a:gridCol w="509524"/>
-                <a:gridCol w="1309500"/>
+                <a:gridCol w="1015661"/>
               </a:tblGrid>
               <a:tr h="280035">
                 <a:tc>
@@ -28554,7 +28554,7 @@
                   </a:tcPr>
                 </a:tc>
               </a:tr>
-              <a:tr h="657225">
+              <a:tr h="845820">
                 <a:tc>
                   <a:txBody>
                     <a:bodyPr wrap="square"/>
@@ -28778,6 +28778,118 @@
                   </a:tcPr>
                 </a:tc>
               </a:tr>
+              <a:tr h="1034415">
+                <a:tc>
+                  <a:txBody>
+                    <a:bodyPr wrap="square"/>
+                    <a:lstStyle/>
+                    <a:p>
+                      <a:r>
+                        <a:rPr sz="1100" b="0">
+                          <a:solidFill>
+                            <a:srgbClr val="282828"/>
+                          </a:solidFill>
+                          <a:latin typeface="Arial"/>
+                        </a:rPr>
+                        <a:t>plate splitter</a:t>
+                      </a:r>
+                    </a:p>
+                  </a:txBody>
+                  <a:tcPr marL="54864" marR="54864" marT="18288" marB="18288">
+                    <a:solidFill>
+                      <a:srgbClr val="FFFFFF"/>
+                    </a:solidFill>
+                  </a:tcPr>
+                </a:tc>
+                <a:tc>
+                  <a:txBody>
+                    <a:bodyPr wrap="square"/>
+                    <a:lstStyle/>
+                    <a:p>
+                      <a:r>
+                        <a:rPr sz="1100" b="0">
+                          <a:solidFill>
+                            <a:srgbClr val="282828"/>
+                          </a:solidFill>
+                          <a:latin typeface="Arial"/>
+                        </a:rPr>
+                        <a:t>103 mm, 22.5° incidence, 50/50; 10 mm thick (modeled): shifts the transmitted beam 1.39 mm, which the compensator cannot undo; the interferometer's flat null rises from 0.13 to 20 nm and its reading is attenuated 13%, a cost in floor and SNR, not gain (differential rows 1.00-1.01, single actuator 0.989; capture unchanged); the sensors do not move</a:t>
+                      </a:r>
+                    </a:p>
+                  </a:txBody>
+                  <a:tcPr marL="54864" marR="54864" marT="18288" marB="18288">
+                    <a:solidFill>
+                      <a:srgbClr val="FFFFFF"/>
+                    </a:solidFill>
+                  </a:tcPr>
+                </a:tc>
+                <a:tc>
+                  <a:txBody>
+                    <a:bodyPr wrap="square"/>
+                    <a:lstStyle/>
+                    <a:p>
+                      <a:r>
+                        <a:rPr sz="1100" b="0">
+                          <a:solidFill>
+                            <a:srgbClr val="282828"/>
+                          </a:solidFill>
+                          <a:latin typeface="Arial"/>
+                        </a:rPr>
+                        <a:t>50/50 front coating, AR back</a:t>
+                      </a:r>
+                    </a:p>
+                  </a:txBody>
+                  <a:tcPr marL="54864" marR="54864" marT="18288" marB="18288">
+                    <a:solidFill>
+                      <a:srgbClr val="FFFFFF"/>
+                    </a:solidFill>
+                  </a:tcPr>
+                </a:tc>
+                <a:tc>
+                  <a:txBody>
+                    <a:bodyPr wrap="square"/>
+                    <a:lstStyle/>
+                    <a:p>
+                      <a:r>
+                        <a:rPr sz="1100" b="0">
+                          <a:solidFill>
+                            <a:srgbClr val="282828"/>
+                          </a:solidFill>
+                          <a:latin typeface="Arial"/>
+                        </a:rPr>
+                        <a:t>1</a:t>
+                      </a:r>
+                    </a:p>
+                  </a:txBody>
+                  <a:tcPr marL="54864" marR="54864" marT="18288" marB="18288">
+                    <a:solidFill>
+                      <a:srgbClr val="FFFFFF"/>
+                    </a:solidFill>
+                  </a:tcPr>
+                </a:tc>
+                <a:tc>
+                  <a:txBody>
+                    <a:bodyPr wrap="square"/>
+                    <a:lstStyle/>
+                    <a:p>
+                      <a:r>
+                        <a:rPr sz="1100" b="0">
+                          <a:solidFill>
+                            <a:srgbClr val="282828"/>
+                          </a:solidFill>
+                          <a:latin typeface="Arial"/>
+                        </a:rPr>
+                        <a:t>splits to the mirror and the reference arm</a:t>
+                      </a:r>
+                    </a:p>
+                  </a:txBody>
+                  <a:tcPr marL="54864" marR="54864" marT="18288" marB="18288">
+                    <a:solidFill>
+                      <a:srgbClr val="FFFFFF"/>
+                    </a:solidFill>
+                  </a:tcPr>
+                </a:tc>
+              </a:tr>
               <a:tr h="845820">
                 <a:tc>
                   <a:txBody>
@@ -28791,57 +28903,57 @@
                           </a:solidFill>
                           <a:latin typeface="Arial"/>
                         </a:rPr>
-                        <a:t>plate splitter</a:t>
-                      </a:r>
-                    </a:p>
-                  </a:txBody>
-                  <a:tcPr marL="54864" marR="54864" marT="18288" marB="18288">
-                    <a:solidFill>
-                      <a:srgbClr val="FFFFFF"/>
-                    </a:solidFill>
-                  </a:tcPr>
-                </a:tc>
-                <a:tc>
-                  <a:txBody>
-                    <a:bodyPr wrap="square"/>
-                    <a:lstStyle/>
-                    <a:p>
-                      <a:r>
-                        <a:rPr sz="1100" b="0">
-                          <a:solidFill>
-                            <a:srgbClr val="282828"/>
-                          </a:solidFill>
-                          <a:latin typeface="Arial"/>
-                        </a:rPr>
-                        <a:t>103 mm, 22.5° incidence, 50/50; 10 mm thick (modeled): shifts the transmitted beam 1.39 mm, which the compensator cannot undo, so the interferometer's flat null rises from 0.13 to 20 nm (its differential rows are being re-measured; the sensors do not move)</a:t>
-                      </a:r>
-                    </a:p>
-                  </a:txBody>
-                  <a:tcPr marL="54864" marR="54864" marT="18288" marB="18288">
-                    <a:solidFill>
-                      <a:srgbClr val="FFFFFF"/>
-                    </a:solidFill>
-                  </a:tcPr>
-                </a:tc>
-                <a:tc>
-                  <a:txBody>
-                    <a:bodyPr wrap="square"/>
-                    <a:lstStyle/>
-                    <a:p>
-                      <a:r>
-                        <a:rPr sz="1100" b="0">
-                          <a:solidFill>
-                            <a:srgbClr val="282828"/>
-                          </a:solidFill>
-                          <a:latin typeface="Arial"/>
-                        </a:rPr>
-                        <a:t>50/50 front coating, AR back</a:t>
-                      </a:r>
-                    </a:p>
-                  </a:txBody>
-                  <a:tcPr marL="54864" marR="54864" marT="18288" marB="18288">
-                    <a:solidFill>
-                      <a:srgbClr val="FFFFFF"/>
+                        <a:t>compensator plate</a:t>
+                      </a:r>
+                    </a:p>
+                  </a:txBody>
+                  <a:tcPr marL="54864" marR="54864" marT="18288" marB="18288">
+                    <a:solidFill>
+                      <a:srgbClr val="ECF1F6"/>
+                    </a:solidFill>
+                  </a:tcPr>
+                </a:tc>
+                <a:tc>
+                  <a:txBody>
+                    <a:bodyPr wrap="square"/>
+                    <a:lstStyle/>
+                    <a:p>
+                      <a:r>
+                        <a:rPr sz="1100" b="0">
+                          <a:solidFill>
+                            <a:srgbClr val="282828"/>
+                          </a:solidFill>
+                          <a:latin typeface="Arial"/>
+                        </a:rPr>
+                        <a:t>103 mm, matched to the splitter, in the mirror leg</a:t>
+                      </a:r>
+                    </a:p>
+                  </a:txBody>
+                  <a:tcPr marL="54864" marR="54864" marT="18288" marB="18288">
+                    <a:solidFill>
+                      <a:srgbClr val="ECF1F6"/>
+                    </a:solidFill>
+                  </a:tcPr>
+                </a:tc>
+                <a:tc>
+                  <a:txBody>
+                    <a:bodyPr wrap="square"/>
+                    <a:lstStyle/>
+                    <a:p>
+                      <a:r>
+                        <a:rPr sz="1100" b="0">
+                          <a:solidFill>
+                            <a:srgbClr val="282828"/>
+                          </a:solidFill>
+                          <a:latin typeface="Arial"/>
+                        </a:rPr>
+                        <a:t>AR</a:t>
+                      </a:r>
+                    </a:p>
+                  </a:txBody>
+                  <a:tcPr marL="54864" marR="54864" marT="18288" marB="18288">
+                    <a:solidFill>
+                      <a:srgbClr val="ECF1F6"/>
                     </a:solidFill>
                   </a:tcPr>
                 </a:tc>
@@ -28863,29 +28975,477 @@
                   </a:txBody>
                   <a:tcPr marL="54864" marR="54864" marT="18288" marB="18288">
                     <a:solidFill>
-                      <a:srgbClr val="FFFFFF"/>
-                    </a:solidFill>
-                  </a:tcPr>
-                </a:tc>
-                <a:tc>
-                  <a:txBody>
-                    <a:bodyPr wrap="square"/>
-                    <a:lstStyle/>
-                    <a:p>
-                      <a:r>
-                        <a:rPr sz="1100" b="0">
-                          <a:solidFill>
-                            <a:srgbClr val="282828"/>
-                          </a:solidFill>
-                          <a:latin typeface="Arial"/>
-                        </a:rPr>
-                        <a:t>splits to the mirror and the reference arm</a:t>
-                      </a:r>
-                    </a:p>
-                  </a:txBody>
-                  <a:tcPr marL="54864" marR="54864" marT="18288" marB="18288">
-                    <a:solidFill>
-                      <a:srgbClr val="FFFFFF"/>
+                      <a:srgbClr val="ECF1F6"/>
+                    </a:solidFill>
+                  </a:tcPr>
+                </a:tc>
+                <a:tc>
+                  <a:txBody>
+                    <a:bodyPr wrap="square"/>
+                    <a:lstStyle/>
+                    <a:p>
+                      <a:r>
+                        <a:rPr sz="1100" b="0">
+                          <a:solidFill>
+                            <a:srgbClr val="282828"/>
+                          </a:solidFill>
+                          <a:latin typeface="Arial"/>
+                        </a:rPr>
+                        <a:t>balances the glass path through the splitter</a:t>
+                      </a:r>
+                    </a:p>
+                  </a:txBody>
+                  <a:tcPr marL="54864" marR="54864" marT="18288" marB="18288">
+                    <a:solidFill>
+                      <a:srgbClr val="ECF1F6"/>
+                    </a:solidFill>
+                  </a:tcPr>
+                </a:tc>
+              </a:tr>
+              <a:tr h="845820">
+                <a:tc>
+                  <a:txBody>
+                    <a:bodyPr wrap="square"/>
+                    <a:lstStyle/>
+                    <a:p>
+                      <a:r>
+                        <a:rPr sz="1100" b="0">
+                          <a:solidFill>
+                            <a:srgbClr val="282828"/>
+                          </a:solidFill>
+                          <a:latin typeface="Arial"/>
+                        </a:rPr>
+                        <a:t>deformable mirror</a:t>
+                      </a:r>
+                    </a:p>
+                  </a:txBody>
+                  <a:tcPr marL="54864" marR="54864" marT="18288" marB="18288">
+                    <a:solidFill>
+                      <a:srgbClr val="FFFFFF"/>
+                    </a:solidFill>
+                  </a:tcPr>
+                </a:tc>
+                <a:tc>
+                  <a:txBody>
+                    <a:bodyPr wrap="square"/>
+                    <a:lstStyle/>
+                    <a:p>
+                      <a:r>
+                        <a:rPr sz="1100" b="0">
+                          <a:solidFill>
+                            <a:srgbClr val="282828"/>
+                          </a:solidFill>
+                          <a:latin typeface="Arial"/>
+                        </a:rPr>
+                        <a:t>96×96, 1 mm pitch, 96 mm, 700 mm leg</a:t>
+                      </a:r>
+                    </a:p>
+                  </a:txBody>
+                  <a:tcPr marL="54864" marR="54864" marT="18288" marB="18288">
+                    <a:solidFill>
+                      <a:srgbClr val="FFFFFF"/>
+                    </a:solidFill>
+                  </a:tcPr>
+                </a:tc>
+                <a:tc>
+                  <a:txBody>
+                    <a:bodyPr wrap="square"/>
+                    <a:lstStyle/>
+                    <a:p>
+                      <a:r>
+                        <a:rPr sz="1100" b="0">
+                          <a:solidFill>
+                            <a:srgbClr val="282828"/>
+                          </a:solidFill>
+                          <a:latin typeface="Arial"/>
+                        </a:rPr>
+                        <a:t>protected aluminum</a:t>
+                      </a:r>
+                    </a:p>
+                  </a:txBody>
+                  <a:tcPr marL="54864" marR="54864" marT="18288" marB="18288">
+                    <a:solidFill>
+                      <a:srgbClr val="FFFFFF"/>
+                    </a:solidFill>
+                  </a:tcPr>
+                </a:tc>
+                <a:tc>
+                  <a:txBody>
+                    <a:bodyPr wrap="square"/>
+                    <a:lstStyle/>
+                    <a:p>
+                      <a:r>
+                        <a:rPr sz="1100" b="0">
+                          <a:solidFill>
+                            <a:srgbClr val="282828"/>
+                          </a:solidFill>
+                          <a:latin typeface="Arial"/>
+                        </a:rPr>
+                        <a:t>1</a:t>
+                      </a:r>
+                    </a:p>
+                  </a:txBody>
+                  <a:tcPr marL="54864" marR="54864" marT="18288" marB="18288">
+                    <a:solidFill>
+                      <a:srgbClr val="FFFFFF"/>
+                    </a:solidFill>
+                  </a:tcPr>
+                </a:tc>
+                <a:tc>
+                  <a:txBody>
+                    <a:bodyPr wrap="square"/>
+                    <a:lstStyle/>
+                    <a:p>
+                      <a:r>
+                        <a:rPr sz="1100" b="0">
+                          <a:solidFill>
+                            <a:srgbClr val="282828"/>
+                          </a:solidFill>
+                          <a:latin typeface="Arial"/>
+                        </a:rPr>
+                        <a:t>the test object; its surface is the measurand</a:t>
+                      </a:r>
+                    </a:p>
+                  </a:txBody>
+                  <a:tcPr marL="54864" marR="54864" marT="18288" marB="18288">
+                    <a:solidFill>
+                      <a:srgbClr val="FFFFFF"/>
+                    </a:solidFill>
+                  </a:tcPr>
+                </a:tc>
+              </a:tr>
+              <a:tr h="845820">
+                <a:tc>
+                  <a:txBody>
+                    <a:bodyPr wrap="square"/>
+                    <a:lstStyle/>
+                    <a:p>
+                      <a:r>
+                        <a:rPr sz="1100" b="0">
+                          <a:solidFill>
+                            <a:srgbClr val="282828"/>
+                          </a:solidFill>
+                          <a:latin typeface="Arial"/>
+                        </a:rPr>
+                        <a:t>focuser L2</a:t>
+                      </a:r>
+                    </a:p>
+                  </a:txBody>
+                  <a:tcPr marL="54864" marR="54864" marT="18288" marB="18288">
+                    <a:solidFill>
+                      <a:srgbClr val="ECF1F6"/>
+                    </a:solidFill>
+                  </a:tcPr>
+                </a:tc>
+                <a:tc>
+                  <a:txBody>
+                    <a:bodyPr wrap="square"/>
+                    <a:lstStyle/>
+                    <a:p>
+                      <a:r>
+                        <a:rPr sz="1100" b="0">
+                          <a:solidFill>
+                            <a:srgbClr val="282828"/>
+                          </a:solidFill>
+                          <a:latin typeface="Arial"/>
+                        </a:rPr>
+                        <a:t>f 429 mm, 103 mm, plano-convex conic; modeled 8 mm center</a:t>
+                      </a:r>
+                    </a:p>
+                  </a:txBody>
+                  <a:tcPr marL="54864" marR="54864" marT="18288" marB="18288">
+                    <a:solidFill>
+                      <a:srgbClr val="ECF1F6"/>
+                    </a:solidFill>
+                  </a:tcPr>
+                </a:tc>
+                <a:tc>
+                  <a:txBody>
+                    <a:bodyPr wrap="square"/>
+                    <a:lstStyle/>
+                    <a:p>
+                      <a:r>
+                        <a:rPr sz="1100" b="0">
+                          <a:solidFill>
+                            <a:srgbClr val="282828"/>
+                          </a:solidFill>
+                          <a:latin typeface="Arial"/>
+                        </a:rPr>
+                        <a:t>AR</a:t>
+                      </a:r>
+                    </a:p>
+                  </a:txBody>
+                  <a:tcPr marL="54864" marR="54864" marT="18288" marB="18288">
+                    <a:solidFill>
+                      <a:srgbClr val="ECF1F6"/>
+                    </a:solidFill>
+                  </a:tcPr>
+                </a:tc>
+                <a:tc>
+                  <a:txBody>
+                    <a:bodyPr wrap="square"/>
+                    <a:lstStyle/>
+                    <a:p>
+                      <a:r>
+                        <a:rPr sz="1100" b="0">
+                          <a:solidFill>
+                            <a:srgbClr val="282828"/>
+                          </a:solidFill>
+                          <a:latin typeface="Arial"/>
+                        </a:rPr>
+                        <a:t>1</a:t>
+                      </a:r>
+                    </a:p>
+                  </a:txBody>
+                  <a:tcPr marL="54864" marR="54864" marT="18288" marB="18288">
+                    <a:solidFill>
+                      <a:srgbClr val="ECF1F6"/>
+                    </a:solidFill>
+                  </a:tcPr>
+                </a:tc>
+                <a:tc>
+                  <a:txBody>
+                    <a:bodyPr wrap="square"/>
+                    <a:lstStyle/>
+                    <a:p>
+                      <a:r>
+                        <a:rPr sz="1100" b="0">
+                          <a:solidFill>
+                            <a:srgbClr val="282828"/>
+                          </a:solidFill>
+                          <a:latin typeface="Arial"/>
+                        </a:rPr>
+                        <a:t>the internal focus at F/4.2 where the masks sit</a:t>
+                      </a:r>
+                    </a:p>
+                  </a:txBody>
+                  <a:tcPr marL="54864" marR="54864" marT="18288" marB="18288">
+                    <a:solidFill>
+                      <a:srgbClr val="ECF1F6"/>
+                    </a:solidFill>
+                  </a:tcPr>
+                </a:tc>
+              </a:tr>
+              <a:tr h="1034415">
+                <a:tc>
+                  <a:txBody>
+                    <a:bodyPr wrap="square"/>
+                    <a:lstStyle/>
+                    <a:p>
+                      <a:r>
+                        <a:rPr sz="1100" b="0">
+                          <a:solidFill>
+                            <a:srgbClr val="282828"/>
+                          </a:solidFill>
+                          <a:latin typeface="Arial"/>
+                        </a:rPr>
+                        <a:t>mask seat</a:t>
+                      </a:r>
+                    </a:p>
+                  </a:txBody>
+                  <a:tcPr marL="54864" marR="54864" marT="18288" marB="18288">
+                    <a:solidFill>
+                      <a:srgbClr val="FFFFFF"/>
+                    </a:solidFill>
+                  </a:tcPr>
+                </a:tc>
+                <a:tc>
+                  <a:txBody>
+                    <a:bodyPr wrap="square"/>
+                    <a:lstStyle/>
+                    <a:p>
+                      <a:r>
+                        <a:rPr sz="1100" b="0">
+                          <a:solidFill>
+                            <a:srgbClr val="282828"/>
+                          </a:solidFill>
+                          <a:latin typeface="Arial"/>
+                        </a:rPr>
+                        <a:t>translation stage at the internal focus</a:t>
+                      </a:r>
+                    </a:p>
+                  </a:txBody>
+                  <a:tcPr marL="54864" marR="54864" marT="18288" marB="18288">
+                    <a:solidFill>
+                      <a:srgbClr val="FFFFFF"/>
+                    </a:solidFill>
+                  </a:tcPr>
+                </a:tc>
+                <a:tc>
+                  <a:txBody>
+                    <a:bodyPr wrap="square"/>
+                    <a:lstStyle/>
+                    <a:p>
+                      <a:r>
+                        <a:rPr sz="1100" b="0">
+                          <a:solidFill>
+                            <a:srgbClr val="282828"/>
+                          </a:solidFill>
+                          <a:latin typeface="Arial"/>
+                        </a:rPr>
+                        <a:t>—</a:t>
+                      </a:r>
+                    </a:p>
+                  </a:txBody>
+                  <a:tcPr marL="54864" marR="54864" marT="18288" marB="18288">
+                    <a:solidFill>
+                      <a:srgbClr val="FFFFFF"/>
+                    </a:solidFill>
+                  </a:tcPr>
+                </a:tc>
+                <a:tc>
+                  <a:txBody>
+                    <a:bodyPr wrap="square"/>
+                    <a:lstStyle/>
+                    <a:p>
+                      <a:r>
+                        <a:rPr sz="1100" b="0">
+                          <a:solidFill>
+                            <a:srgbClr val="282828"/>
+                          </a:solidFill>
+                          <a:latin typeface="Arial"/>
+                        </a:rPr>
+                        <a:t>1</a:t>
+                      </a:r>
+                    </a:p>
+                  </a:txBody>
+                  <a:tcPr marL="54864" marR="54864" marT="18288" marB="18288">
+                    <a:solidFill>
+                      <a:srgbClr val="FFFFFF"/>
+                    </a:solidFill>
+                  </a:tcPr>
+                </a:tc>
+                <a:tc>
+                  <a:txBody>
+                    <a:bodyPr wrap="square"/>
+                    <a:lstStyle/>
+                    <a:p>
+                      <a:r>
+                        <a:rPr sz="1100" b="0">
+                          <a:solidFill>
+                            <a:srgbClr val="282828"/>
+                          </a:solidFill>
+                          <a:latin typeface="Arial"/>
+                        </a:rPr>
+                        <a:t>selects the sensor: clear window, dimple, metasurface, pinhole</a:t>
+                      </a:r>
+                    </a:p>
+                  </a:txBody>
+                  <a:tcPr marL="54864" marR="54864" marT="18288" marB="18288">
+                    <a:solidFill>
+                      <a:srgbClr val="FFFFFF"/>
+                    </a:solidFill>
+                  </a:tcPr>
+                </a:tc>
+              </a:tr>
+              <a:tr h="1034415">
+                <a:tc>
+                  <a:txBody>
+                    <a:bodyPr wrap="square"/>
+                    <a:lstStyle/>
+                    <a:p>
+                      <a:r>
+                        <a:rPr sz="1100" b="0">
+                          <a:solidFill>
+                            <a:srgbClr val="282828"/>
+                          </a:solidFill>
+                          <a:latin typeface="Arial"/>
+                        </a:rPr>
+                        <a:t>field lens</a:t>
+                      </a:r>
+                    </a:p>
+                  </a:txBody>
+                  <a:tcPr marL="54864" marR="54864" marT="18288" marB="18288">
+                    <a:solidFill>
+                      <a:srgbClr val="ECF1F6"/>
+                    </a:solidFill>
+                  </a:tcPr>
+                </a:tc>
+                <a:tc>
+                  <a:txBody>
+                    <a:bodyPr wrap="square"/>
+                    <a:lstStyle/>
+                    <a:p>
+                      <a:r>
+                        <a:rPr sz="1100" b="0">
+                          <a:solidFill>
+                            <a:srgbClr val="282828"/>
+                          </a:solidFill>
+                          <a:latin typeface="Arial"/>
+                        </a:rPr>
+                        <a:t>f 43 mm, 21 mm</a:t>
+                      </a:r>
+                    </a:p>
+                  </a:txBody>
+                  <a:tcPr marL="54864" marR="54864" marT="18288" marB="18288">
+                    <a:solidFill>
+                      <a:srgbClr val="ECF1F6"/>
+                    </a:solidFill>
+                  </a:tcPr>
+                </a:tc>
+                <a:tc>
+                  <a:txBody>
+                    <a:bodyPr wrap="square"/>
+                    <a:lstStyle/>
+                    <a:p>
+                      <a:r>
+                        <a:rPr sz="1100" b="0">
+                          <a:solidFill>
+                            <a:srgbClr val="282828"/>
+                          </a:solidFill>
+                          <a:latin typeface="Arial"/>
+                        </a:rPr>
+                        <a:t>AR</a:t>
+                      </a:r>
+                    </a:p>
+                  </a:txBody>
+                  <a:tcPr marL="54864" marR="54864" marT="18288" marB="18288">
+                    <a:solidFill>
+                      <a:srgbClr val="ECF1F6"/>
+                    </a:solidFill>
+                  </a:tcPr>
+                </a:tc>
+                <a:tc>
+                  <a:txBody>
+                    <a:bodyPr wrap="square"/>
+                    <a:lstStyle/>
+                    <a:p>
+                      <a:r>
+                        <a:rPr sz="1100" b="0">
+                          <a:solidFill>
+                            <a:srgbClr val="282828"/>
+                          </a:solidFill>
+                          <a:latin typeface="Arial"/>
+                        </a:rPr>
+                        <a:t>1</a:t>
+                      </a:r>
+                    </a:p>
+                  </a:txBody>
+                  <a:tcPr marL="54864" marR="54864" marT="18288" marB="18288">
+                    <a:solidFill>
+                      <a:srgbClr val="ECF1F6"/>
+                    </a:solidFill>
+                  </a:tcPr>
+                </a:tc>
+                <a:tc>
+                  <a:txBody>
+                    <a:bodyPr wrap="square"/>
+                    <a:lstStyle/>
+                    <a:p>
+                      <a:r>
+                        <a:rPr sz="1100" b="0">
+                          <a:solidFill>
+                            <a:srgbClr val="282828"/>
+                          </a:solidFill>
+                          <a:latin typeface="Arial"/>
+                        </a:rPr>
+                        <a:t>reimages the pupil (7.5-7.8 mm as traced) 32 mm behind it</a:t>
+                      </a:r>
+                    </a:p>
+                  </a:txBody>
+                  <a:tcPr marL="54864" marR="54864" marT="18288" marB="18288">
+                    <a:solidFill>
+                      <a:srgbClr val="ECF1F6"/>
                     </a:solidFill>
                   </a:tcPr>
                 </a:tc>
@@ -28903,57 +29463,57 @@
                           </a:solidFill>
                           <a:latin typeface="Arial"/>
                         </a:rPr>
-                        <a:t>compensator plate</a:t>
-                      </a:r>
-                    </a:p>
-                  </a:txBody>
-                  <a:tcPr marL="54864" marR="54864" marT="18288" marB="18288">
-                    <a:solidFill>
-                      <a:srgbClr val="ECF1F6"/>
-                    </a:solidFill>
-                  </a:tcPr>
-                </a:tc>
-                <a:tc>
-                  <a:txBody>
-                    <a:bodyPr wrap="square"/>
-                    <a:lstStyle/>
-                    <a:p>
-                      <a:r>
-                        <a:rPr sz="1100" b="0">
-                          <a:solidFill>
-                            <a:srgbClr val="282828"/>
-                          </a:solidFill>
-                          <a:latin typeface="Arial"/>
-                        </a:rPr>
-                        <a:t>103 mm, matched to the splitter, in the mirror leg</a:t>
-                      </a:r>
-                    </a:p>
-                  </a:txBody>
-                  <a:tcPr marL="54864" marR="54864" marT="18288" marB="18288">
-                    <a:solidFill>
-                      <a:srgbClr val="ECF1F6"/>
-                    </a:solidFill>
-                  </a:tcPr>
-                </a:tc>
-                <a:tc>
-                  <a:txBody>
-                    <a:bodyPr wrap="square"/>
-                    <a:lstStyle/>
-                    <a:p>
-                      <a:r>
-                        <a:rPr sz="1100" b="0">
-                          <a:solidFill>
-                            <a:srgbClr val="282828"/>
-                          </a:solidFill>
-                          <a:latin typeface="Arial"/>
-                        </a:rPr>
-                        <a:t>AR</a:t>
-                      </a:r>
-                    </a:p>
-                  </a:txBody>
-                  <a:tcPr marL="54864" marR="54864" marT="18288" marB="18288">
-                    <a:solidFill>
-                      <a:srgbClr val="ECF1F6"/>
+                        <a:t>camera A</a:t>
+                      </a:r>
+                    </a:p>
+                  </a:txBody>
+                  <a:tcPr marL="54864" marR="54864" marT="18288" marB="18288">
+                    <a:solidFill>
+                      <a:srgbClr val="FFFFFF"/>
+                    </a:solidFill>
+                  </a:tcPr>
+                </a:tc>
+                <a:tc>
+                  <a:txBody>
+                    <a:bodyPr wrap="square"/>
+                    <a:lstStyle/>
+                    <a:p>
+                      <a:r>
+                        <a:rPr sz="1100" b="0">
+                          <a:solidFill>
+                            <a:srgbClr val="282828"/>
+                          </a:solidFill>
+                          <a:latin typeface="Arial"/>
+                        </a:rPr>
+                        <a:t>sCMOS 2048×2048, 6.5 µm (13.3 mm): 1155 raw pixels across the 7.5 mm pupil image, binned 3 to 385 or 6 to the modeled 193</a:t>
+                      </a:r>
+                    </a:p>
+                  </a:txBody>
+                  <a:tcPr marL="54864" marR="54864" marT="18288" marB="18288">
+                    <a:solidFill>
+                      <a:srgbClr val="FFFFFF"/>
+                    </a:solidFill>
+                  </a:tcPr>
+                </a:tc>
+                <a:tc>
+                  <a:txBody>
+                    <a:bodyPr wrap="square"/>
+                    <a:lstStyle/>
+                    <a:p>
+                      <a:r>
+                        <a:rPr sz="1100" b="0">
+                          <a:solidFill>
+                            <a:srgbClr val="282828"/>
+                          </a:solidFill>
+                          <a:latin typeface="Arial"/>
+                        </a:rPr>
+                        <a:t>—</a:t>
+                      </a:r>
+                    </a:p>
+                  </a:txBody>
+                  <a:tcPr marL="54864" marR="54864" marT="18288" marB="18288">
+                    <a:solidFill>
+                      <a:srgbClr val="FFFFFF"/>
                     </a:solidFill>
                   </a:tcPr>
                 </a:tc>
@@ -28975,594 +29535,34 @@
                   </a:txBody>
                   <a:tcPr marL="54864" marR="54864" marT="18288" marB="18288">
                     <a:solidFill>
-                      <a:srgbClr val="ECF1F6"/>
-                    </a:solidFill>
-                  </a:tcPr>
-                </a:tc>
-                <a:tc>
-                  <a:txBody>
-                    <a:bodyPr wrap="square"/>
-                    <a:lstStyle/>
-                    <a:p>
-                      <a:r>
-                        <a:rPr sz="1100" b="0">
-                          <a:solidFill>
-                            <a:srgbClr val="282828"/>
-                          </a:solidFill>
-                          <a:latin typeface="Arial"/>
-                        </a:rPr>
-                        <a:t>balances the glass path through the splitter</a:t>
-                      </a:r>
-                    </a:p>
-                  </a:txBody>
-                  <a:tcPr marL="54864" marR="54864" marT="18288" marB="18288">
-                    <a:solidFill>
-                      <a:srgbClr val="ECF1F6"/>
+                      <a:srgbClr val="FFFFFF"/>
+                    </a:solidFill>
+                  </a:tcPr>
+                </a:tc>
+                <a:tc>
+                  <a:txBody>
+                    <a:bodyPr wrap="square"/>
+                    <a:lstStyle/>
+                    <a:p>
+                      <a:r>
+                        <a:rPr sz="1100" b="0">
+                          <a:solidFill>
+                            <a:srgbClr val="282828"/>
+                          </a:solidFill>
+                          <a:latin typeface="Arial"/>
+                        </a:rPr>
+                        <a:t>every configuration's pupil image</a:t>
+                      </a:r>
+                    </a:p>
+                  </a:txBody>
+                  <a:tcPr marL="54864" marR="54864" marT="18288" marB="18288">
+                    <a:solidFill>
+                      <a:srgbClr val="FFFFFF"/>
                     </a:solidFill>
                   </a:tcPr>
                 </a:tc>
               </a:tr>
               <a:tr h="657225">
-                <a:tc>
-                  <a:txBody>
-                    <a:bodyPr wrap="square"/>
-                    <a:lstStyle/>
-                    <a:p>
-                      <a:r>
-                        <a:rPr sz="1100" b="0">
-                          <a:solidFill>
-                            <a:srgbClr val="282828"/>
-                          </a:solidFill>
-                          <a:latin typeface="Arial"/>
-                        </a:rPr>
-                        <a:t>deformable mirror</a:t>
-                      </a:r>
-                    </a:p>
-                  </a:txBody>
-                  <a:tcPr marL="54864" marR="54864" marT="18288" marB="18288">
-                    <a:solidFill>
-                      <a:srgbClr val="FFFFFF"/>
-                    </a:solidFill>
-                  </a:tcPr>
-                </a:tc>
-                <a:tc>
-                  <a:txBody>
-                    <a:bodyPr wrap="square"/>
-                    <a:lstStyle/>
-                    <a:p>
-                      <a:r>
-                        <a:rPr sz="1100" b="0">
-                          <a:solidFill>
-                            <a:srgbClr val="282828"/>
-                          </a:solidFill>
-                          <a:latin typeface="Arial"/>
-                        </a:rPr>
-                        <a:t>96×96, 1 mm pitch, 96 mm, 700 mm leg</a:t>
-                      </a:r>
-                    </a:p>
-                  </a:txBody>
-                  <a:tcPr marL="54864" marR="54864" marT="18288" marB="18288">
-                    <a:solidFill>
-                      <a:srgbClr val="FFFFFF"/>
-                    </a:solidFill>
-                  </a:tcPr>
-                </a:tc>
-                <a:tc>
-                  <a:txBody>
-                    <a:bodyPr wrap="square"/>
-                    <a:lstStyle/>
-                    <a:p>
-                      <a:r>
-                        <a:rPr sz="1100" b="0">
-                          <a:solidFill>
-                            <a:srgbClr val="282828"/>
-                          </a:solidFill>
-                          <a:latin typeface="Arial"/>
-                        </a:rPr>
-                        <a:t>protected aluminum</a:t>
-                      </a:r>
-                    </a:p>
-                  </a:txBody>
-                  <a:tcPr marL="54864" marR="54864" marT="18288" marB="18288">
-                    <a:solidFill>
-                      <a:srgbClr val="FFFFFF"/>
-                    </a:solidFill>
-                  </a:tcPr>
-                </a:tc>
-                <a:tc>
-                  <a:txBody>
-                    <a:bodyPr wrap="square"/>
-                    <a:lstStyle/>
-                    <a:p>
-                      <a:r>
-                        <a:rPr sz="1100" b="0">
-                          <a:solidFill>
-                            <a:srgbClr val="282828"/>
-                          </a:solidFill>
-                          <a:latin typeface="Arial"/>
-                        </a:rPr>
-                        <a:t>1</a:t>
-                      </a:r>
-                    </a:p>
-                  </a:txBody>
-                  <a:tcPr marL="54864" marR="54864" marT="18288" marB="18288">
-                    <a:solidFill>
-                      <a:srgbClr val="FFFFFF"/>
-                    </a:solidFill>
-                  </a:tcPr>
-                </a:tc>
-                <a:tc>
-                  <a:txBody>
-                    <a:bodyPr wrap="square"/>
-                    <a:lstStyle/>
-                    <a:p>
-                      <a:r>
-                        <a:rPr sz="1100" b="0">
-                          <a:solidFill>
-                            <a:srgbClr val="282828"/>
-                          </a:solidFill>
-                          <a:latin typeface="Arial"/>
-                        </a:rPr>
-                        <a:t>the test object; its surface is the measurand</a:t>
-                      </a:r>
-                    </a:p>
-                  </a:txBody>
-                  <a:tcPr marL="54864" marR="54864" marT="18288" marB="18288">
-                    <a:solidFill>
-                      <a:srgbClr val="FFFFFF"/>
-                    </a:solidFill>
-                  </a:tcPr>
-                </a:tc>
-              </a:tr>
-              <a:tr h="657225">
-                <a:tc>
-                  <a:txBody>
-                    <a:bodyPr wrap="square"/>
-                    <a:lstStyle/>
-                    <a:p>
-                      <a:r>
-                        <a:rPr sz="1100" b="0">
-                          <a:solidFill>
-                            <a:srgbClr val="282828"/>
-                          </a:solidFill>
-                          <a:latin typeface="Arial"/>
-                        </a:rPr>
-                        <a:t>focuser L2</a:t>
-                      </a:r>
-                    </a:p>
-                  </a:txBody>
-                  <a:tcPr marL="54864" marR="54864" marT="18288" marB="18288">
-                    <a:solidFill>
-                      <a:srgbClr val="ECF1F6"/>
-                    </a:solidFill>
-                  </a:tcPr>
-                </a:tc>
-                <a:tc>
-                  <a:txBody>
-                    <a:bodyPr wrap="square"/>
-                    <a:lstStyle/>
-                    <a:p>
-                      <a:r>
-                        <a:rPr sz="1100" b="0">
-                          <a:solidFill>
-                            <a:srgbClr val="282828"/>
-                          </a:solidFill>
-                          <a:latin typeface="Arial"/>
-                        </a:rPr>
-                        <a:t>f 429 mm, 103 mm, plano-convex conic; modeled 8 mm center</a:t>
-                      </a:r>
-                    </a:p>
-                  </a:txBody>
-                  <a:tcPr marL="54864" marR="54864" marT="18288" marB="18288">
-                    <a:solidFill>
-                      <a:srgbClr val="ECF1F6"/>
-                    </a:solidFill>
-                  </a:tcPr>
-                </a:tc>
-                <a:tc>
-                  <a:txBody>
-                    <a:bodyPr wrap="square"/>
-                    <a:lstStyle/>
-                    <a:p>
-                      <a:r>
-                        <a:rPr sz="1100" b="0">
-                          <a:solidFill>
-                            <a:srgbClr val="282828"/>
-                          </a:solidFill>
-                          <a:latin typeface="Arial"/>
-                        </a:rPr>
-                        <a:t>AR</a:t>
-                      </a:r>
-                    </a:p>
-                  </a:txBody>
-                  <a:tcPr marL="54864" marR="54864" marT="18288" marB="18288">
-                    <a:solidFill>
-                      <a:srgbClr val="ECF1F6"/>
-                    </a:solidFill>
-                  </a:tcPr>
-                </a:tc>
-                <a:tc>
-                  <a:txBody>
-                    <a:bodyPr wrap="square"/>
-                    <a:lstStyle/>
-                    <a:p>
-                      <a:r>
-                        <a:rPr sz="1100" b="0">
-                          <a:solidFill>
-                            <a:srgbClr val="282828"/>
-                          </a:solidFill>
-                          <a:latin typeface="Arial"/>
-                        </a:rPr>
-                        <a:t>1</a:t>
-                      </a:r>
-                    </a:p>
-                  </a:txBody>
-                  <a:tcPr marL="54864" marR="54864" marT="18288" marB="18288">
-                    <a:solidFill>
-                      <a:srgbClr val="ECF1F6"/>
-                    </a:solidFill>
-                  </a:tcPr>
-                </a:tc>
-                <a:tc>
-                  <a:txBody>
-                    <a:bodyPr wrap="square"/>
-                    <a:lstStyle/>
-                    <a:p>
-                      <a:r>
-                        <a:rPr sz="1100" b="0">
-                          <a:solidFill>
-                            <a:srgbClr val="282828"/>
-                          </a:solidFill>
-                          <a:latin typeface="Arial"/>
-                        </a:rPr>
-                        <a:t>the internal focus at F/4.2 where the masks sit</a:t>
-                      </a:r>
-                    </a:p>
-                  </a:txBody>
-                  <a:tcPr marL="54864" marR="54864" marT="18288" marB="18288">
-                    <a:solidFill>
-                      <a:srgbClr val="ECF1F6"/>
-                    </a:solidFill>
-                  </a:tcPr>
-                </a:tc>
-              </a:tr>
-              <a:tr h="845820">
-                <a:tc>
-                  <a:txBody>
-                    <a:bodyPr wrap="square"/>
-                    <a:lstStyle/>
-                    <a:p>
-                      <a:r>
-                        <a:rPr sz="1100" b="0">
-                          <a:solidFill>
-                            <a:srgbClr val="282828"/>
-                          </a:solidFill>
-                          <a:latin typeface="Arial"/>
-                        </a:rPr>
-                        <a:t>mask seat</a:t>
-                      </a:r>
-                    </a:p>
-                  </a:txBody>
-                  <a:tcPr marL="54864" marR="54864" marT="18288" marB="18288">
-                    <a:solidFill>
-                      <a:srgbClr val="FFFFFF"/>
-                    </a:solidFill>
-                  </a:tcPr>
-                </a:tc>
-                <a:tc>
-                  <a:txBody>
-                    <a:bodyPr wrap="square"/>
-                    <a:lstStyle/>
-                    <a:p>
-                      <a:r>
-                        <a:rPr sz="1100" b="0">
-                          <a:solidFill>
-                            <a:srgbClr val="282828"/>
-                          </a:solidFill>
-                          <a:latin typeface="Arial"/>
-                        </a:rPr>
-                        <a:t>translation stage at the internal focus</a:t>
-                      </a:r>
-                    </a:p>
-                  </a:txBody>
-                  <a:tcPr marL="54864" marR="54864" marT="18288" marB="18288">
-                    <a:solidFill>
-                      <a:srgbClr val="FFFFFF"/>
-                    </a:solidFill>
-                  </a:tcPr>
-                </a:tc>
-                <a:tc>
-                  <a:txBody>
-                    <a:bodyPr wrap="square"/>
-                    <a:lstStyle/>
-                    <a:p>
-                      <a:r>
-                        <a:rPr sz="1100" b="0">
-                          <a:solidFill>
-                            <a:srgbClr val="282828"/>
-                          </a:solidFill>
-                          <a:latin typeface="Arial"/>
-                        </a:rPr>
-                        <a:t>—</a:t>
-                      </a:r>
-                    </a:p>
-                  </a:txBody>
-                  <a:tcPr marL="54864" marR="54864" marT="18288" marB="18288">
-                    <a:solidFill>
-                      <a:srgbClr val="FFFFFF"/>
-                    </a:solidFill>
-                  </a:tcPr>
-                </a:tc>
-                <a:tc>
-                  <a:txBody>
-                    <a:bodyPr wrap="square"/>
-                    <a:lstStyle/>
-                    <a:p>
-                      <a:r>
-                        <a:rPr sz="1100" b="0">
-                          <a:solidFill>
-                            <a:srgbClr val="282828"/>
-                          </a:solidFill>
-                          <a:latin typeface="Arial"/>
-                        </a:rPr>
-                        <a:t>1</a:t>
-                      </a:r>
-                    </a:p>
-                  </a:txBody>
-                  <a:tcPr marL="54864" marR="54864" marT="18288" marB="18288">
-                    <a:solidFill>
-                      <a:srgbClr val="FFFFFF"/>
-                    </a:solidFill>
-                  </a:tcPr>
-                </a:tc>
-                <a:tc>
-                  <a:txBody>
-                    <a:bodyPr wrap="square"/>
-                    <a:lstStyle/>
-                    <a:p>
-                      <a:r>
-                        <a:rPr sz="1100" b="0">
-                          <a:solidFill>
-                            <a:srgbClr val="282828"/>
-                          </a:solidFill>
-                          <a:latin typeface="Arial"/>
-                        </a:rPr>
-                        <a:t>selects the sensor: clear window, dimple, metasurface, pinhole</a:t>
-                      </a:r>
-                    </a:p>
-                  </a:txBody>
-                  <a:tcPr marL="54864" marR="54864" marT="18288" marB="18288">
-                    <a:solidFill>
-                      <a:srgbClr val="FFFFFF"/>
-                    </a:solidFill>
-                  </a:tcPr>
-                </a:tc>
-              </a:tr>
-              <a:tr h="845820">
-                <a:tc>
-                  <a:txBody>
-                    <a:bodyPr wrap="square"/>
-                    <a:lstStyle/>
-                    <a:p>
-                      <a:r>
-                        <a:rPr sz="1100" b="0">
-                          <a:solidFill>
-                            <a:srgbClr val="282828"/>
-                          </a:solidFill>
-                          <a:latin typeface="Arial"/>
-                        </a:rPr>
-                        <a:t>field lens</a:t>
-                      </a:r>
-                    </a:p>
-                  </a:txBody>
-                  <a:tcPr marL="54864" marR="54864" marT="18288" marB="18288">
-                    <a:solidFill>
-                      <a:srgbClr val="ECF1F6"/>
-                    </a:solidFill>
-                  </a:tcPr>
-                </a:tc>
-                <a:tc>
-                  <a:txBody>
-                    <a:bodyPr wrap="square"/>
-                    <a:lstStyle/>
-                    <a:p>
-                      <a:r>
-                        <a:rPr sz="1100" b="0">
-                          <a:solidFill>
-                            <a:srgbClr val="282828"/>
-                          </a:solidFill>
-                          <a:latin typeface="Arial"/>
-                        </a:rPr>
-                        <a:t>f 43 mm, 21 mm</a:t>
-                      </a:r>
-                    </a:p>
-                  </a:txBody>
-                  <a:tcPr marL="54864" marR="54864" marT="18288" marB="18288">
-                    <a:solidFill>
-                      <a:srgbClr val="ECF1F6"/>
-                    </a:solidFill>
-                  </a:tcPr>
-                </a:tc>
-                <a:tc>
-                  <a:txBody>
-                    <a:bodyPr wrap="square"/>
-                    <a:lstStyle/>
-                    <a:p>
-                      <a:r>
-                        <a:rPr sz="1100" b="0">
-                          <a:solidFill>
-                            <a:srgbClr val="282828"/>
-                          </a:solidFill>
-                          <a:latin typeface="Arial"/>
-                        </a:rPr>
-                        <a:t>AR</a:t>
-                      </a:r>
-                    </a:p>
-                  </a:txBody>
-                  <a:tcPr marL="54864" marR="54864" marT="18288" marB="18288">
-                    <a:solidFill>
-                      <a:srgbClr val="ECF1F6"/>
-                    </a:solidFill>
-                  </a:tcPr>
-                </a:tc>
-                <a:tc>
-                  <a:txBody>
-                    <a:bodyPr wrap="square"/>
-                    <a:lstStyle/>
-                    <a:p>
-                      <a:r>
-                        <a:rPr sz="1100" b="0">
-                          <a:solidFill>
-                            <a:srgbClr val="282828"/>
-                          </a:solidFill>
-                          <a:latin typeface="Arial"/>
-                        </a:rPr>
-                        <a:t>1</a:t>
-                      </a:r>
-                    </a:p>
-                  </a:txBody>
-                  <a:tcPr marL="54864" marR="54864" marT="18288" marB="18288">
-                    <a:solidFill>
-                      <a:srgbClr val="ECF1F6"/>
-                    </a:solidFill>
-                  </a:tcPr>
-                </a:tc>
-                <a:tc>
-                  <a:txBody>
-                    <a:bodyPr wrap="square"/>
-                    <a:lstStyle/>
-                    <a:p>
-                      <a:r>
-                        <a:rPr sz="1100" b="0">
-                          <a:solidFill>
-                            <a:srgbClr val="282828"/>
-                          </a:solidFill>
-                          <a:latin typeface="Arial"/>
-                        </a:rPr>
-                        <a:t>reimages the pupil (7.5-7.8 mm as traced) 32 mm behind it</a:t>
-                      </a:r>
-                    </a:p>
-                  </a:txBody>
-                  <a:tcPr marL="54864" marR="54864" marT="18288" marB="18288">
-                    <a:solidFill>
-                      <a:srgbClr val="ECF1F6"/>
-                    </a:solidFill>
-                  </a:tcPr>
-                </a:tc>
-              </a:tr>
-              <a:tr h="468630">
-                <a:tc>
-                  <a:txBody>
-                    <a:bodyPr wrap="square"/>
-                    <a:lstStyle/>
-                    <a:p>
-                      <a:r>
-                        <a:rPr sz="1100" b="0">
-                          <a:solidFill>
-                            <a:srgbClr val="282828"/>
-                          </a:solidFill>
-                          <a:latin typeface="Arial"/>
-                        </a:rPr>
-                        <a:t>camera A</a:t>
-                      </a:r>
-                    </a:p>
-                  </a:txBody>
-                  <a:tcPr marL="54864" marR="54864" marT="18288" marB="18288">
-                    <a:solidFill>
-                      <a:srgbClr val="FFFFFF"/>
-                    </a:solidFill>
-                  </a:tcPr>
-                </a:tc>
-                <a:tc>
-                  <a:txBody>
-                    <a:bodyPr wrap="square"/>
-                    <a:lstStyle/>
-                    <a:p>
-                      <a:r>
-                        <a:rPr sz="1100" b="0">
-                          <a:solidFill>
-                            <a:srgbClr val="282828"/>
-                          </a:solidFill>
-                          <a:latin typeface="Arial"/>
-                        </a:rPr>
-                        <a:t>sCMOS 2048×2048, 6.5 µm (13.3 mm): 1155 raw pixels across the 7.5 mm pupil image, binned 3 to 385 or 6 to the modeled 193</a:t>
-                      </a:r>
-                    </a:p>
-                  </a:txBody>
-                  <a:tcPr marL="54864" marR="54864" marT="18288" marB="18288">
-                    <a:solidFill>
-                      <a:srgbClr val="FFFFFF"/>
-                    </a:solidFill>
-                  </a:tcPr>
-                </a:tc>
-                <a:tc>
-                  <a:txBody>
-                    <a:bodyPr wrap="square"/>
-                    <a:lstStyle/>
-                    <a:p>
-                      <a:r>
-                        <a:rPr sz="1100" b="0">
-                          <a:solidFill>
-                            <a:srgbClr val="282828"/>
-                          </a:solidFill>
-                          <a:latin typeface="Arial"/>
-                        </a:rPr>
-                        <a:t>—</a:t>
-                      </a:r>
-                    </a:p>
-                  </a:txBody>
-                  <a:tcPr marL="54864" marR="54864" marT="18288" marB="18288">
-                    <a:solidFill>
-                      <a:srgbClr val="FFFFFF"/>
-                    </a:solidFill>
-                  </a:tcPr>
-                </a:tc>
-                <a:tc>
-                  <a:txBody>
-                    <a:bodyPr wrap="square"/>
-                    <a:lstStyle/>
-                    <a:p>
-                      <a:r>
-                        <a:rPr sz="1100" b="0">
-                          <a:solidFill>
-                            <a:srgbClr val="282828"/>
-                          </a:solidFill>
-                          <a:latin typeface="Arial"/>
-                        </a:rPr>
-                        <a:t>1</a:t>
-                      </a:r>
-                    </a:p>
-                  </a:txBody>
-                  <a:tcPr marL="54864" marR="54864" marT="18288" marB="18288">
-                    <a:solidFill>
-                      <a:srgbClr val="FFFFFF"/>
-                    </a:solidFill>
-                  </a:tcPr>
-                </a:tc>
-                <a:tc>
-                  <a:txBody>
-                    <a:bodyPr wrap="square"/>
-                    <a:lstStyle/>
-                    <a:p>
-                      <a:r>
-                        <a:rPr sz="1100" b="0">
-                          <a:solidFill>
-                            <a:srgbClr val="282828"/>
-                          </a:solidFill>
-                          <a:latin typeface="Arial"/>
-                        </a:rPr>
-                        <a:t>every configuration's pupil image</a:t>
-                      </a:r>
-                    </a:p>
-                  </a:txBody>
-                  <a:tcPr marL="54864" marR="54864" marT="18288" marB="18288">
-                    <a:solidFill>
-                      <a:srgbClr val="FFFFFF"/>
-                    </a:solidFill>
-                  </a:tcPr>
-                </a:tc>
-              </a:tr>
-              <a:tr h="468630">
                 <a:tc>
                   <a:txBody>
                     <a:bodyPr wrap="square"/>
@@ -29686,7 +29686,7 @@
         </p:nvSpPr>
         <p:spPr>
           <a:xfrm>
-            <a:off x="411480" y="8297037"/>
+            <a:off x="411480" y="9994392"/>
             <a:ext cx="11368735" cy="274320"/>
           </a:xfrm>
           <a:prstGeom prst="rect">

</xml_diff>

<commit_message>
Deck + report: the sensors' servo on the redesigned mirror rig from the Mac run oaploop22 (vector 1.7e12 / 5.7e12, pinhole 2.5e12 / 7.4e12, stepped 2.7e12 / 7.9e12; within 10% of the lens rig); the tuner gate closed (relative to the seed); editing copy re-synced; slice
Co-Authored-By: Claude Fable 5.1 <noreply@anthropic.com>
</commit_message>
<xml_diff>
--- a/demo_session/deck_gauges.pptx
+++ b/demo_session/deck_gauges.pptx
@@ -10023,7 +10023,7 @@
                 </a:solidFill>
                 <a:latin typeface="Arial"/>
               </a:rPr>
-              <a:t>In closed loop at gain 0.5 the vector Zernike holds 3 pm from 1.5e12 photons per cycle, the pinhole and stepped Zernike from 2.3-2.6e12, the interferometer from 5.4-5.5e12 on either front end — and the sensors carry no fixed error</a:t>
+              <a:t>In closed loop at gain 0.5 the vector Zernike holds 3 pm from 1.5-1.7e12 photons per cycle, the pinhole and stepped Zernike from 2.3-2.7e12, the interferometer from 5.4-5.5e12, on either front end — and the sensors carry no fixed error</a:t>
             </a:r>
           </a:p>
         </p:txBody>
@@ -10082,7 +10082,7 @@
         </p:nvGraphicFramePr>
         <p:xfrm>
           <a:off x="411480" y="1298448"/>
-          <a:ext cx="5806437" cy="3463290"/>
+          <a:ext cx="5806437" cy="4869180"/>
         </p:xfrm>
         <a:graphic>
           <a:graphicData uri="http://schemas.openxmlformats.org/drawingml/2006/table">
@@ -10894,73 +10894,73 @@
                           </a:solidFill>
                           <a:latin typeface="Arial"/>
                         </a:rPr>
-                        <a:t>interferometer, mirror rig, redesigned</a:t>
-                      </a:r>
-                    </a:p>
-                  </a:txBody>
-                  <a:tcPr marL="54864" marR="54864" marT="18288" marB="18288">
-                    <a:solidFill>
-                      <a:srgbClr val="FFFFFF"/>
-                    </a:solidFill>
-                  </a:tcPr>
-                </a:tc>
-                <a:tc>
-                  <a:txBody>
-                    <a:bodyPr wrap="square"/>
-                    <a:lstStyle/>
-                    <a:p>
-                      <a:r>
-                        <a:rPr sz="1100" b="0">
-                          <a:solidFill>
-                            <a:srgbClr val="282828"/>
-                          </a:solidFill>
-                          <a:latin typeface="Arial"/>
-                        </a:rPr>
-                        <a:t>5.4e12</a:t>
-                      </a:r>
-                    </a:p>
-                  </a:txBody>
-                  <a:tcPr marL="54864" marR="54864" marT="18288" marB="18288">
-                    <a:solidFill>
-                      <a:srgbClr val="FFFFFF"/>
-                    </a:solidFill>
-                  </a:tcPr>
-                </a:tc>
-                <a:tc>
-                  <a:txBody>
-                    <a:bodyPr wrap="square"/>
-                    <a:lstStyle/>
-                    <a:p>
-                      <a:r>
-                        <a:rPr sz="1100" b="0">
-                          <a:solidFill>
-                            <a:srgbClr val="282828"/>
-                          </a:solidFill>
-                          <a:latin typeface="Arial"/>
-                        </a:rPr>
-                        <a:t>1.7e13</a:t>
-                      </a:r>
-                    </a:p>
-                  </a:txBody>
-                  <a:tcPr marL="54864" marR="54864" marT="18288" marB="18288">
-                    <a:solidFill>
-                      <a:srgbClr val="FFFFFF"/>
-                    </a:solidFill>
-                  </a:tcPr>
-                </a:tc>
-                <a:tc>
-                  <a:txBody>
-                    <a:bodyPr wrap="square"/>
-                    <a:lstStyle/>
-                    <a:p>
-                      <a:r>
-                        <a:rPr sz="1100" b="0">
-                          <a:solidFill>
-                            <a:srgbClr val="282828"/>
-                          </a:solidFill>
-                          <a:latin typeface="Arial"/>
-                        </a:rPr>
-                        <a:t>10.0 pm</a:t>
+                        <a:t>vector Zernike, mirror rig</a:t>
+                      </a:r>
+                    </a:p>
+                  </a:txBody>
+                  <a:tcPr marL="54864" marR="54864" marT="18288" marB="18288">
+                    <a:solidFill>
+                      <a:srgbClr val="FFFFFF"/>
+                    </a:solidFill>
+                  </a:tcPr>
+                </a:tc>
+                <a:tc>
+                  <a:txBody>
+                    <a:bodyPr wrap="square"/>
+                    <a:lstStyle/>
+                    <a:p>
+                      <a:r>
+                        <a:rPr sz="1100" b="0">
+                          <a:solidFill>
+                            <a:srgbClr val="282828"/>
+                          </a:solidFill>
+                          <a:latin typeface="Arial"/>
+                        </a:rPr>
+                        <a:t>1.7e12</a:t>
+                      </a:r>
+                    </a:p>
+                  </a:txBody>
+                  <a:tcPr marL="54864" marR="54864" marT="18288" marB="18288">
+                    <a:solidFill>
+                      <a:srgbClr val="FFFFFF"/>
+                    </a:solidFill>
+                  </a:tcPr>
+                </a:tc>
+                <a:tc>
+                  <a:txBody>
+                    <a:bodyPr wrap="square"/>
+                    <a:lstStyle/>
+                    <a:p>
+                      <a:r>
+                        <a:rPr sz="1100" b="0">
+                          <a:solidFill>
+                            <a:srgbClr val="282828"/>
+                          </a:solidFill>
+                          <a:latin typeface="Arial"/>
+                        </a:rPr>
+                        <a:t>5.7e12</a:t>
+                      </a:r>
+                    </a:p>
+                  </a:txBody>
+                  <a:tcPr marL="54864" marR="54864" marT="18288" marB="18288">
+                    <a:solidFill>
+                      <a:srgbClr val="FFFFFF"/>
+                    </a:solidFill>
+                  </a:tcPr>
+                </a:tc>
+                <a:tc>
+                  <a:txBody>
+                    <a:bodyPr wrap="square"/>
+                    <a:lstStyle/>
+                    <a:p>
+                      <a:r>
+                        <a:rPr sz="1100" b="0">
+                          <a:solidFill>
+                            <a:srgbClr val="282828"/>
+                          </a:solidFill>
+                          <a:latin typeface="Arial"/>
+                        </a:rPr>
+                        <a:t>9.8 pm</a:t>
                       </a:r>
                     </a:p>
                   </a:txBody>
@@ -11006,13 +11006,349 @@
                           </a:solidFill>
                           <a:latin typeface="Arial"/>
                         </a:rPr>
+                        <a:t>stepped pinhole, mirror rig</a:t>
+                      </a:r>
+                    </a:p>
+                  </a:txBody>
+                  <a:tcPr marL="54864" marR="54864" marT="18288" marB="18288">
+                    <a:solidFill>
+                      <a:srgbClr val="ECF1F6"/>
+                    </a:solidFill>
+                  </a:tcPr>
+                </a:tc>
+                <a:tc>
+                  <a:txBody>
+                    <a:bodyPr wrap="square"/>
+                    <a:lstStyle/>
+                    <a:p>
+                      <a:r>
+                        <a:rPr sz="1100" b="0">
+                          <a:solidFill>
+                            <a:srgbClr val="282828"/>
+                          </a:solidFill>
+                          <a:latin typeface="Arial"/>
+                        </a:rPr>
+                        <a:t>2.5e12</a:t>
+                      </a:r>
+                    </a:p>
+                  </a:txBody>
+                  <a:tcPr marL="54864" marR="54864" marT="18288" marB="18288">
+                    <a:solidFill>
+                      <a:srgbClr val="ECF1F6"/>
+                    </a:solidFill>
+                  </a:tcPr>
+                </a:tc>
+                <a:tc>
+                  <a:txBody>
+                    <a:bodyPr wrap="square"/>
+                    <a:lstStyle/>
+                    <a:p>
+                      <a:r>
+                        <a:rPr sz="1100" b="0">
+                          <a:solidFill>
+                            <a:srgbClr val="282828"/>
+                          </a:solidFill>
+                          <a:latin typeface="Arial"/>
+                        </a:rPr>
+                        <a:t>7.4e12</a:t>
+                      </a:r>
+                    </a:p>
+                  </a:txBody>
+                  <a:tcPr marL="54864" marR="54864" marT="18288" marB="18288">
+                    <a:solidFill>
+                      <a:srgbClr val="ECF1F6"/>
+                    </a:solidFill>
+                  </a:tcPr>
+                </a:tc>
+                <a:tc>
+                  <a:txBody>
+                    <a:bodyPr wrap="square"/>
+                    <a:lstStyle/>
+                    <a:p>
+                      <a:r>
+                        <a:rPr sz="1100" b="0">
+                          <a:solidFill>
+                            <a:srgbClr val="282828"/>
+                          </a:solidFill>
+                          <a:latin typeface="Arial"/>
+                        </a:rPr>
+                        <a:t>9.9 pm</a:t>
+                      </a:r>
+                    </a:p>
+                  </a:txBody>
+                  <a:tcPr marL="54864" marR="54864" marT="18288" marB="18288">
+                    <a:solidFill>
+                      <a:srgbClr val="ECF1F6"/>
+                    </a:solidFill>
+                  </a:tcPr>
+                </a:tc>
+                <a:tc>
+                  <a:txBody>
+                    <a:bodyPr wrap="square"/>
+                    <a:lstStyle/>
+                    <a:p>
+                      <a:r>
+                        <a:rPr sz="1100" b="0">
+                          <a:solidFill>
+                            <a:srgbClr val="282828"/>
+                          </a:solidFill>
+                          <a:latin typeface="Arial"/>
+                        </a:rPr>
+                        <a:t>—</a:t>
+                      </a:r>
+                    </a:p>
+                  </a:txBody>
+                  <a:tcPr marL="54864" marR="54864" marT="18288" marB="18288">
+                    <a:solidFill>
+                      <a:srgbClr val="ECF1F6"/>
+                    </a:solidFill>
+                  </a:tcPr>
+                </a:tc>
+              </a:tr>
+              <a:tr h="468630">
+                <a:tc>
+                  <a:txBody>
+                    <a:bodyPr wrap="square"/>
+                    <a:lstStyle/>
+                    <a:p>
+                      <a:r>
+                        <a:rPr sz="1100" b="0">
+                          <a:solidFill>
+                            <a:srgbClr val="282828"/>
+                          </a:solidFill>
+                          <a:latin typeface="Arial"/>
+                        </a:rPr>
+                        <a:t>Zernike stepped, mirror rig</a:t>
+                      </a:r>
+                    </a:p>
+                  </a:txBody>
+                  <a:tcPr marL="54864" marR="54864" marT="18288" marB="18288">
+                    <a:solidFill>
+                      <a:srgbClr val="FFFFFF"/>
+                    </a:solidFill>
+                  </a:tcPr>
+                </a:tc>
+                <a:tc>
+                  <a:txBody>
+                    <a:bodyPr wrap="square"/>
+                    <a:lstStyle/>
+                    <a:p>
+                      <a:r>
+                        <a:rPr sz="1100" b="0">
+                          <a:solidFill>
+                            <a:srgbClr val="282828"/>
+                          </a:solidFill>
+                          <a:latin typeface="Arial"/>
+                        </a:rPr>
+                        <a:t>2.7e12</a:t>
+                      </a:r>
+                    </a:p>
+                  </a:txBody>
+                  <a:tcPr marL="54864" marR="54864" marT="18288" marB="18288">
+                    <a:solidFill>
+                      <a:srgbClr val="FFFFFF"/>
+                    </a:solidFill>
+                  </a:tcPr>
+                </a:tc>
+                <a:tc>
+                  <a:txBody>
+                    <a:bodyPr wrap="square"/>
+                    <a:lstStyle/>
+                    <a:p>
+                      <a:r>
+                        <a:rPr sz="1100" b="0">
+                          <a:solidFill>
+                            <a:srgbClr val="282828"/>
+                          </a:solidFill>
+                          <a:latin typeface="Arial"/>
+                        </a:rPr>
+                        <a:t>7.9e12</a:t>
+                      </a:r>
+                    </a:p>
+                  </a:txBody>
+                  <a:tcPr marL="54864" marR="54864" marT="18288" marB="18288">
+                    <a:solidFill>
+                      <a:srgbClr val="FFFFFF"/>
+                    </a:solidFill>
+                  </a:tcPr>
+                </a:tc>
+                <a:tc>
+                  <a:txBody>
+                    <a:bodyPr wrap="square"/>
+                    <a:lstStyle/>
+                    <a:p>
+                      <a:r>
+                        <a:rPr sz="1100" b="0">
+                          <a:solidFill>
+                            <a:srgbClr val="282828"/>
+                          </a:solidFill>
+                          <a:latin typeface="Arial"/>
+                        </a:rPr>
+                        <a:t>10.0 pm</a:t>
+                      </a:r>
+                    </a:p>
+                  </a:txBody>
+                  <a:tcPr marL="54864" marR="54864" marT="18288" marB="18288">
+                    <a:solidFill>
+                      <a:srgbClr val="FFFFFF"/>
+                    </a:solidFill>
+                  </a:tcPr>
+                </a:tc>
+                <a:tc>
+                  <a:txBody>
+                    <a:bodyPr wrap="square"/>
+                    <a:lstStyle/>
+                    <a:p>
+                      <a:r>
+                        <a:rPr sz="1100" b="0">
+                          <a:solidFill>
+                            <a:srgbClr val="282828"/>
+                          </a:solidFill>
+                          <a:latin typeface="Arial"/>
+                        </a:rPr>
+                        <a:t>—</a:t>
+                      </a:r>
+                    </a:p>
+                  </a:txBody>
+                  <a:tcPr marL="54864" marR="54864" marT="18288" marB="18288">
+                    <a:solidFill>
+                      <a:srgbClr val="FFFFFF"/>
+                    </a:solidFill>
+                  </a:tcPr>
+                </a:tc>
+              </a:tr>
+              <a:tr h="468630">
+                <a:tc>
+                  <a:txBody>
+                    <a:bodyPr wrap="square"/>
+                    <a:lstStyle/>
+                    <a:p>
+                      <a:r>
+                        <a:rPr sz="1100" b="0">
+                          <a:solidFill>
+                            <a:srgbClr val="282828"/>
+                          </a:solidFill>
+                          <a:latin typeface="Arial"/>
+                        </a:rPr>
+                        <a:t>interferometer, mirror rig, redesigned</a:t>
+                      </a:r>
+                    </a:p>
+                  </a:txBody>
+                  <a:tcPr marL="54864" marR="54864" marT="18288" marB="18288">
+                    <a:solidFill>
+                      <a:srgbClr val="ECF1F6"/>
+                    </a:solidFill>
+                  </a:tcPr>
+                </a:tc>
+                <a:tc>
+                  <a:txBody>
+                    <a:bodyPr wrap="square"/>
+                    <a:lstStyle/>
+                    <a:p>
+                      <a:r>
+                        <a:rPr sz="1100" b="0">
+                          <a:solidFill>
+                            <a:srgbClr val="282828"/>
+                          </a:solidFill>
+                          <a:latin typeface="Arial"/>
+                        </a:rPr>
+                        <a:t>5.4e12</a:t>
+                      </a:r>
+                    </a:p>
+                  </a:txBody>
+                  <a:tcPr marL="54864" marR="54864" marT="18288" marB="18288">
+                    <a:solidFill>
+                      <a:srgbClr val="ECF1F6"/>
+                    </a:solidFill>
+                  </a:tcPr>
+                </a:tc>
+                <a:tc>
+                  <a:txBody>
+                    <a:bodyPr wrap="square"/>
+                    <a:lstStyle/>
+                    <a:p>
+                      <a:r>
+                        <a:rPr sz="1100" b="0">
+                          <a:solidFill>
+                            <a:srgbClr val="282828"/>
+                          </a:solidFill>
+                          <a:latin typeface="Arial"/>
+                        </a:rPr>
+                        <a:t>1.7e13</a:t>
+                      </a:r>
+                    </a:p>
+                  </a:txBody>
+                  <a:tcPr marL="54864" marR="54864" marT="18288" marB="18288">
+                    <a:solidFill>
+                      <a:srgbClr val="ECF1F6"/>
+                    </a:solidFill>
+                  </a:tcPr>
+                </a:tc>
+                <a:tc>
+                  <a:txBody>
+                    <a:bodyPr wrap="square"/>
+                    <a:lstStyle/>
+                    <a:p>
+                      <a:r>
+                        <a:rPr sz="1100" b="0">
+                          <a:solidFill>
+                            <a:srgbClr val="282828"/>
+                          </a:solidFill>
+                          <a:latin typeface="Arial"/>
+                        </a:rPr>
+                        <a:t>10.0 pm</a:t>
+                      </a:r>
+                    </a:p>
+                  </a:txBody>
+                  <a:tcPr marL="54864" marR="54864" marT="18288" marB="18288">
+                    <a:solidFill>
+                      <a:srgbClr val="ECF1F6"/>
+                    </a:solidFill>
+                  </a:tcPr>
+                </a:tc>
+                <a:tc>
+                  <a:txBody>
+                    <a:bodyPr wrap="square"/>
+                    <a:lstStyle/>
+                    <a:p>
+                      <a:r>
+                        <a:rPr sz="1100" b="0">
+                          <a:solidFill>
+                            <a:srgbClr val="282828"/>
+                          </a:solidFill>
+                          <a:latin typeface="Arial"/>
+                        </a:rPr>
+                        <a:t>—</a:t>
+                      </a:r>
+                    </a:p>
+                  </a:txBody>
+                  <a:tcPr marL="54864" marR="54864" marT="18288" marB="18288">
+                    <a:solidFill>
+                      <a:srgbClr val="ECF1F6"/>
+                    </a:solidFill>
+                  </a:tcPr>
+                </a:tc>
+              </a:tr>
+              <a:tr h="468630">
+                <a:tc>
+                  <a:txBody>
+                    <a:bodyPr wrap="square"/>
+                    <a:lstStyle/>
+                    <a:p>
+                      <a:r>
+                        <a:rPr sz="1100" b="0">
+                          <a:solidFill>
+                            <a:srgbClr val="282828"/>
+                          </a:solidFill>
+                          <a:latin typeface="Arial"/>
+                        </a:rPr>
                         <a:t>interferometer, mirror rig, record (7°)</a:t>
                       </a:r>
                     </a:p>
                   </a:txBody>
                   <a:tcPr marL="54864" marR="54864" marT="18288" marB="18288">
                     <a:solidFill>
-                      <a:srgbClr val="ECF1F6"/>
+                      <a:srgbClr val="FFFFFF"/>
                     </a:solidFill>
                   </a:tcPr>
                 </a:tc>
@@ -11034,7 +11370,7 @@
                   </a:txBody>
                   <a:tcPr marL="54864" marR="54864" marT="18288" marB="18288">
                     <a:solidFill>
-                      <a:srgbClr val="ECF1F6"/>
+                      <a:srgbClr val="FFFFFF"/>
                     </a:solidFill>
                   </a:tcPr>
                 </a:tc>
@@ -11056,7 +11392,7 @@
                   </a:txBody>
                   <a:tcPr marL="54864" marR="54864" marT="18288" marB="18288">
                     <a:solidFill>
-                      <a:srgbClr val="ECF1F6"/>
+                      <a:srgbClr val="FFFFFF"/>
                     </a:solidFill>
                   </a:tcPr>
                 </a:tc>
@@ -11078,7 +11414,7 @@
                   </a:txBody>
                   <a:tcPr marL="54864" marR="54864" marT="18288" marB="18288">
                     <a:solidFill>
-                      <a:srgbClr val="ECF1F6"/>
+                      <a:srgbClr val="FFFFFF"/>
                     </a:solidFill>
                   </a:tcPr>
                 </a:tc>
@@ -11100,7 +11436,7 @@
                   </a:txBody>
                   <a:tcPr marL="54864" marR="54864" marT="18288" marB="18288">
                     <a:solidFill>
-                      <a:srgbClr val="ECF1F6"/>
+                      <a:srgbClr val="FFFFFF"/>
                     </a:solidFill>
                   </a:tcPr>
                 </a:tc>
@@ -11206,7 +11542,7 @@
                 </a:solidFill>
                 <a:latin typeface="Arial"/>
               </a:rPr>
-              <a:t>7.5e12 photons per cycle is 2.4 µJ, 9 ms of a 1 mW laser.  The ramp floor of 10 pm is the loop's lag (rate ÷ gain), the same for every reading with no fixed error, and it is low-order: 9.2 of its 10 pm sits below 4 cycles per aperture, so a faster or higher-gain low-order loop removes it while light buys nothing.  Both drift floors are the textbook formulas, reproduced by the engine to 1%.  The exact one-frame Zernike reading diverges in the loop.  Run tags vloop193, ploop193, loop193, pfdeck_loop, loop_lens, loop_oap, oapifol2.</a:t>
+              <a:t>7.5e12 photons per cycle is 2.4 µJ, 9 ms of a 1 mW laser.  The ramp floor of 10 pm is the loop's lag (rate ÷ gain), the same for every reading with no fixed error, and it is low-order: 9.2 of its 10 pm sits below 4 cycles per aperture, so a faster or higher-gain low-order loop removes it while light buys nothing.  Both drift floors are the textbook formulas, reproduced by the engine to 1%.  The exact one-frame Zernike reading diverges in the loop.  Run tags vloop193, ploop193, loop193, pfdeck_loop, loop_lens, loop_oap, oapifol2, oaploop22 (the sensors on the mirror rig).</a:t>
             </a:r>
           </a:p>
         </p:txBody>
@@ -13895,7 +14231,7 @@
         </p:nvGraphicFramePr>
         <p:xfrm>
           <a:off x="411480" y="1298448"/>
-          <a:ext cx="11368735" cy="2240280"/>
+          <a:ext cx="11368735" cy="2520315"/>
         </p:xfrm>
         <a:graphic>
           <a:graphicData uri="http://schemas.openxmlformats.org/drawingml/2006/table">
@@ -13904,9 +14240,9 @@
                 <a:tableStyleId>{5C22544A-7EE6-4342-B048-85BDC9FD1C3A}</a:tableStyleId>
               </a:tblPr>
               <a:tblGrid>
-                <a:gridCol w="3830648"/>
+                <a:gridCol w="4350344"/>
                 <a:gridCol w="1889760"/>
-                <a:gridCol w="3395347"/>
+                <a:gridCol w="2875651"/>
                 <a:gridCol w="2252980"/>
               </a:tblGrid>
               <a:tr h="280035">
@@ -14272,7 +14608,7 @@
                           </a:solidFill>
                           <a:latin typeface="Arial"/>
                         </a:rPr>
-                        <a:t>servo: 3 pm noise only / under the 2 pm walk</a:t>
+                        <a:t>interferometer servo: 3 pm noise only / under the 2 pm walk</a:t>
                       </a:r>
                     </a:p>
                   </a:txBody>
@@ -14362,73 +14698,73 @@
                           </a:solidFill>
                           <a:latin typeface="Arial"/>
                         </a:rPr>
-                        <a:t>capture with unwrapping</a:t>
-                      </a:r>
-                    </a:p>
-                  </a:txBody>
-                  <a:tcPr marL="54864" marR="54864" marT="18288" marB="18288">
-                    <a:solidFill>
-                      <a:srgbClr val="FFFFFF"/>
-                    </a:solidFill>
-                  </a:tcPr>
-                </a:tc>
-                <a:tc>
-                  <a:txBody>
-                    <a:bodyPr wrap="square"/>
-                    <a:lstStyle/>
-                    <a:p>
-                      <a:r>
-                        <a:rPr sz="1100" b="0">
-                          <a:solidFill>
-                            <a:srgbClr val="282828"/>
-                          </a:solidFill>
-                          <a:latin typeface="Arial"/>
-                        </a:rPr>
-                        <a:t>stalls from 60 nm</a:t>
-                      </a:r>
-                    </a:p>
-                  </a:txBody>
-                  <a:tcPr marL="54864" marR="54864" marT="18288" marB="18288">
-                    <a:solidFill>
-                      <a:srgbClr val="FFFFFF"/>
-                    </a:solidFill>
-                  </a:tcPr>
-                </a:tc>
-                <a:tc>
-                  <a:txBody>
-                    <a:bodyPr wrap="square"/>
-                    <a:lstStyle/>
-                    <a:p>
-                      <a:r>
-                        <a:rPr sz="1100" b="0">
-                          <a:solidFill>
-                            <a:srgbClr val="282828"/>
-                          </a:solidFill>
-                          <a:latin typeface="Arial"/>
-                        </a:rPr>
-                        <a:t>3 pm from 200 nm in 19 cycles</a:t>
-                      </a:r>
-                    </a:p>
-                  </a:txBody>
-                  <a:tcPr marL="54864" marR="54864" marT="18288" marB="18288">
-                    <a:solidFill>
-                      <a:srgbClr val="FFFFFF"/>
-                    </a:solidFill>
-                  </a:tcPr>
-                </a:tc>
-                <a:tc>
-                  <a:txBody>
-                    <a:bodyPr wrap="square"/>
-                    <a:lstStyle/>
-                    <a:p>
-                      <a:r>
-                        <a:rPr sz="1100" b="0">
-                          <a:solidFill>
-                            <a:srgbClr val="282828"/>
-                          </a:solidFill>
-                          <a:latin typeface="Arial"/>
-                        </a:rPr>
-                        <a:t>3 pm from 300 nm in 43 cycles</a:t>
+                        <a:t>sensors' servo under the walk: vector / pinhole / stepped</a:t>
+                      </a:r>
+                    </a:p>
+                  </a:txBody>
+                  <a:tcPr marL="54864" marR="54864" marT="18288" marB="18288">
+                    <a:solidFill>
+                      <a:srgbClr val="FFFFFF"/>
+                    </a:solidFill>
+                  </a:tcPr>
+                </a:tc>
+                <a:tc>
+                  <a:txBody>
+                    <a:bodyPr wrap="square"/>
+                    <a:lstStyle/>
+                    <a:p>
+                      <a:r>
+                        <a:rPr sz="1100" b="0">
+                          <a:solidFill>
+                            <a:srgbClr val="282828"/>
+                          </a:solidFill>
+                          <a:latin typeface="Arial"/>
+                        </a:rPr>
+                        <a:t>—</a:t>
+                      </a:r>
+                    </a:p>
+                  </a:txBody>
+                  <a:tcPr marL="54864" marR="54864" marT="18288" marB="18288">
+                    <a:solidFill>
+                      <a:srgbClr val="FFFFFF"/>
+                    </a:solidFill>
+                  </a:tcPr>
+                </a:tc>
+                <a:tc>
+                  <a:txBody>
+                    <a:bodyPr wrap="square"/>
+                    <a:lstStyle/>
+                    <a:p>
+                      <a:r>
+                        <a:rPr sz="1100" b="0">
+                          <a:solidFill>
+                            <a:srgbClr val="282828"/>
+                          </a:solidFill>
+                          <a:latin typeface="Arial"/>
+                        </a:rPr>
+                        <a:t>5.7e12 / 7.4e12 / 7.9e12</a:t>
+                      </a:r>
+                    </a:p>
+                  </a:txBody>
+                  <a:tcPr marL="54864" marR="54864" marT="18288" marB="18288">
+                    <a:solidFill>
+                      <a:srgbClr val="FFFFFF"/>
+                    </a:solidFill>
+                  </a:tcPr>
+                </a:tc>
+                <a:tc>
+                  <a:txBody>
+                    <a:bodyPr wrap="square"/>
+                    <a:lstStyle/>
+                    <a:p>
+                      <a:r>
+                        <a:rPr sz="1100" b="0">
+                          <a:solidFill>
+                            <a:srgbClr val="282828"/>
+                          </a:solidFill>
+                          <a:latin typeface="Arial"/>
+                        </a:rPr>
+                        <a:t>5.3e12 / 7.0e12 / 7.5e12</a:t>
                       </a:r>
                     </a:p>
                   </a:txBody>
@@ -14452,7 +14788,7 @@
                           </a:solidFill>
                           <a:latin typeface="Arial"/>
                         </a:rPr>
-                        <a:t>vector Zernike, 100 nm pokes (fold gate)</a:t>
+                        <a:t>capture with unwrapping</a:t>
                       </a:r>
                     </a:p>
                   </a:txBody>
@@ -14474,7 +14810,7 @@
                           </a:solidFill>
                           <a:latin typeface="Arial"/>
                         </a:rPr>
-                        <a:t>19.6 pm, fails</a:t>
+                        <a:t>stalls from 60 nm</a:t>
                       </a:r>
                     </a:p>
                   </a:txBody>
@@ -14496,7 +14832,7 @@
                           </a:solidFill>
                           <a:latin typeface="Arial"/>
                         </a:rPr>
-                        <a:t>634 pm raw; 0.054 pm calibrated: passes</a:t>
+                        <a:t>3 pm from 200 nm in 19 cycles</a:t>
                       </a:r>
                     </a:p>
                   </a:txBody>
@@ -14518,7 +14854,7 @@
                           </a:solidFill>
                           <a:latin typeface="Arial"/>
                         </a:rPr>
-                        <a:t>0.05 pm</a:t>
+                        <a:t>3 pm from 300 nm in 43 cycles</a:t>
                       </a:r>
                     </a:p>
                   </a:txBody>
@@ -14542,13 +14878,103 @@
                           </a:solidFill>
                           <a:latin typeface="Arial"/>
                         </a:rPr>
+                        <a:t>vector Zernike, 100 nm pokes (fold gate)</a:t>
+                      </a:r>
+                    </a:p>
+                  </a:txBody>
+                  <a:tcPr marL="54864" marR="54864" marT="18288" marB="18288">
+                    <a:solidFill>
+                      <a:srgbClr val="FFFFFF"/>
+                    </a:solidFill>
+                  </a:tcPr>
+                </a:tc>
+                <a:tc>
+                  <a:txBody>
+                    <a:bodyPr wrap="square"/>
+                    <a:lstStyle/>
+                    <a:p>
+                      <a:r>
+                        <a:rPr sz="1100" b="0">
+                          <a:solidFill>
+                            <a:srgbClr val="282828"/>
+                          </a:solidFill>
+                          <a:latin typeface="Arial"/>
+                        </a:rPr>
+                        <a:t>19.6 pm, fails</a:t>
+                      </a:r>
+                    </a:p>
+                  </a:txBody>
+                  <a:tcPr marL="54864" marR="54864" marT="18288" marB="18288">
+                    <a:solidFill>
+                      <a:srgbClr val="FFFFFF"/>
+                    </a:solidFill>
+                  </a:tcPr>
+                </a:tc>
+                <a:tc>
+                  <a:txBody>
+                    <a:bodyPr wrap="square"/>
+                    <a:lstStyle/>
+                    <a:p>
+                      <a:r>
+                        <a:rPr sz="1100" b="0">
+                          <a:solidFill>
+                            <a:srgbClr val="282828"/>
+                          </a:solidFill>
+                          <a:latin typeface="Arial"/>
+                        </a:rPr>
+                        <a:t>634 pm raw; 0.054 pm calibrated: passes</a:t>
+                      </a:r>
+                    </a:p>
+                  </a:txBody>
+                  <a:tcPr marL="54864" marR="54864" marT="18288" marB="18288">
+                    <a:solidFill>
+                      <a:srgbClr val="FFFFFF"/>
+                    </a:solidFill>
+                  </a:tcPr>
+                </a:tc>
+                <a:tc>
+                  <a:txBody>
+                    <a:bodyPr wrap="square"/>
+                    <a:lstStyle/>
+                    <a:p>
+                      <a:r>
+                        <a:rPr sz="1100" b="0">
+                          <a:solidFill>
+                            <a:srgbClr val="282828"/>
+                          </a:solidFill>
+                          <a:latin typeface="Arial"/>
+                        </a:rPr>
+                        <a:t>0.05 pm</a:t>
+                      </a:r>
+                    </a:p>
+                  </a:txBody>
+                  <a:tcPr marL="54864" marR="54864" marT="18288" marB="18288">
+                    <a:solidFill>
+                      <a:srgbClr val="FFFFFF"/>
+                    </a:solidFill>
+                  </a:tcPr>
+                </a:tc>
+              </a:tr>
+              <a:tr h="280035">
+                <a:tc>
+                  <a:txBody>
+                    <a:bodyPr wrap="square"/>
+                    <a:lstStyle/>
+                    <a:p>
+                      <a:r>
+                        <a:rPr sz="1100" b="0">
+                          <a:solidFill>
+                            <a:srgbClr val="282828"/>
+                          </a:solidFill>
+                          <a:latin typeface="Arial"/>
+                        </a:rPr>
                         <a:t>stepped pinhole, 100 nm pokes</a:t>
                       </a:r>
                     </a:p>
                   </a:txBody>
                   <a:tcPr marL="54864" marR="54864" marT="18288" marB="18288">
                     <a:solidFill>
-                      <a:srgbClr val="FFFFFF"/>
+                      <a:srgbClr val="ECF1F6"/>
                     </a:solidFill>
                   </a:tcPr>
                 </a:tc>
@@ -14570,7 +14996,7 @@
                   </a:txBody>
                   <a:tcPr marL="54864" marR="54864" marT="18288" marB="18288">
                     <a:solidFill>
-                      <a:srgbClr val="FFFFFF"/>
+                      <a:srgbClr val="ECF1F6"/>
                     </a:solidFill>
                   </a:tcPr>
                 </a:tc>
@@ -14592,7 +15018,7 @@
                   </a:txBody>
                   <a:tcPr marL="54864" marR="54864" marT="18288" marB="18288">
                     <a:solidFill>
-                      <a:srgbClr val="FFFFFF"/>
+                      <a:srgbClr val="ECF1F6"/>
                     </a:solidFill>
                   </a:tcPr>
                 </a:tc>
@@ -14614,7 +15040,7 @@
                   </a:txBody>
                   <a:tcPr marL="54864" marR="54864" marT="18288" marB="18288">
                     <a:solidFill>
-                      <a:srgbClr val="FFFFFF"/>
+                      <a:srgbClr val="ECF1F6"/>
                     </a:solidFill>
                   </a:tcPr>
                 </a:tc>
@@ -14631,7 +15057,7 @@
         </p:nvSpPr>
         <p:spPr>
           <a:xfrm>
-            <a:off x="411480" y="3685032"/>
+            <a:off x="411480" y="3965066"/>
             <a:ext cx="11368735" cy="274320"/>
           </a:xfrm>
           <a:prstGeom prst="rect">
@@ -14673,7 +15099,7 @@
                 </a:solidFill>
                 <a:latin typeface="Arial"/>
               </a:rPr>
-              <a:t>•  Closed: the raw interferometer reading wraps between 60 and 120 nm of surface on both rigs, lens and mirror alike (a base the four-step cannot follow reads λ/2 ÷ √12 = 91 nm rms, measured 89-92 on both); the capture range is set by the reading, not the optics, and unwrapping restores it.  The detector leg here is the geometric seed (the tuner's objective prefers a leg that does not read: a known defect, being fixed).</a:t>
+              <a:t>•  Closed: the raw interferometer reading wraps between 60 and 120 nm of surface on both rigs, lens and mirror alike (a base the four-step cannot follow reads λ/2 ÷ √12 = 91 nm rms, measured 89-92 on both); the capture range is set by the reading, not the optics, and unwrapping restores it.  The detector leg here is the geometric seed; the tuner's winner is now gated against the seed through the same estimator, so a leg that does not read cannot be handed to a bench.</a:t>
             </a:r>
           </a:p>
         </p:txBody>
@@ -14686,7 +15112,7 @@
         </p:nvSpPr>
         <p:spPr>
           <a:xfrm>
-            <a:off x="411480" y="5735574"/>
+            <a:off x="411480" y="6015608"/>
             <a:ext cx="11368735" cy="274320"/>
           </a:xfrm>
           <a:prstGeom prst="rect">
@@ -14712,7 +15138,7 @@
                 </a:solidFill>
                 <a:latin typeface="Arial"/>
               </a:rPr>
-              <a:t>Run tags oapifo2, oapifol2, oapdesc2, oapsens22, vqw22, vmap22, oapuw2, lensuw2; tg_psi_dm96_oap/REPORT_reflective.md (TO, 2026-09-16).</a:t>
+              <a:t>Run tags oapifo2, oapifol2, oapdesc2, oapsens22, vqw22, vmap22, oapuw2, lensuw2, oaploop22; tg_psi_dm96_oap/REPORT_reflective.md (TO, 2026-09-16).</a:t>
             </a:r>
           </a:p>
         </p:txBody>
@@ -16711,7 +17137,7 @@
                 </a:solidFill>
                 <a:latin typeface="Arial"/>
               </a:rPr>
-              <a:t>•  Front end: either builds.  The redesigned mirror rig matches the lens rig on the rows, the servo (1.7e13 vs 2.0e13 photons per cycle) and capture (200 nm), and its sensors pass once calibrated; it buys any color and no glass in the beam, and costs alignment tolerance (10 µrad = 100 nm of null) and a polarization calibration of the vector reading.  The record's stance was lenses; the measured trade is now on the table for a ruling.</a:t>
+              <a:t>•  Front end: either builds.  The redesigned mirror rig matches the lens rig on the rows, the servo (interferometer 1.7e13 vs 2.0e13 photons per cycle; the sensors within 10%) and capture (200 nm), and its sensors pass once calibrated; it buys any color and no glass in the beam, and costs alignment tolerance (10 µrad = 100 nm of null) and a polarization calibration of the vector reading.  The record's stance was lenses; the measured trade is now on the table for a ruling.</a:t>
             </a:r>
           </a:p>
         </p:txBody>
@@ -27241,7 +27667,7 @@
                 </a:solidFill>
                 <a:latin typeface="Arial"/>
               </a:rPr>
-              <a:t>•  Zernike sensors (zwfs_dm96/runs): matbase, matbase385, m2048, m2048_lat, cap385, cap385_b60-b160, noise193_b30-b160, rec193full, loop193, loop385, v193base, v193noise, vloop193, fold_diag, v2g, v2loop, v3arm, v3s, v3loop, an193_ref/cube/q300/q100/az1/bound/clear, stations193, gate22_193, sub22, thk22 (the 22.5° bench with substrates and thicknesses), oapsens22, oapsens22n, vqw22, vmap22 (the sensors on the redesigned mirror rig).  README.md (CCL) and deck_zwfs.md.</a:t>
+              <a:t>•  Zernike sensors (zwfs_dm96/runs): matbase, matbase385, m2048, m2048_lat, cap385, cap385_b60-b160, noise193_b30-b160, rec193full, loop193, loop385, v193base, v193noise, vloop193, fold_diag, v2g, v2loop, v3arm, v3s, v3loop, an193_ref/cube/q300/q100/az1/bound/clear, stations193, gate22_193, sub22, thk22 (the 22.5° bench with substrates and thicknesses), oapsens22, oapsens22n, vqw22, vmap22, oaploop22 (the sensors on the redesigned mirror rig).  README.md (CCL) and deck_zwfs.md.</a:t>
             </a:r>
           </a:p>
           <a:p>
@@ -27302,7 +27728,7 @@
         </p:nvSpPr>
         <p:spPr>
           <a:xfrm>
-            <a:off x="411480" y="6989064"/>
+            <a:off x="411480" y="7236714"/>
             <a:ext cx="11368735" cy="274320"/>
           </a:xfrm>
           <a:prstGeom prst="rect">

</xml_diff>

<commit_message>
Deck + report: photons for 1 pm on the redesigned mirror rig from the Mac run oapnoise22 (stepped 5.8e13, vector 7.3e13, pinhole 8.5e13 on the surface; the lens rig's 8.8 / 6.1 / 9.8e13)
Co-Authored-By: Claude Fable 5.1 <noreply@anthropic.com>
</commit_message>
<xml_diff>
--- a/demo_session/deck_gauges.pptx
+++ b/demo_session/deck_gauges.pptx
@@ -9233,7 +9233,7 @@
                 </a:solidFill>
                 <a:latin typeface="Arial"/>
               </a:rPr>
-              <a:t>On the flat calibration the sensors need 3-6e13 photons per measurement and the interferometer 1.4-2.5e14; on the working surface the sensors' cost roughly doubles and the two-arm instruments' does not</a:t>
+              <a:t>On the flat calibration the sensors need 3-6e13 photons per measurement and the interferometer 1.4-2.5e14; on the working surface the sensors' cost roughly doubles, on either front end, and the two-arm instruments' does not</a:t>
             </a:r>
           </a:p>
         </p:txBody>
@@ -9292,7 +9292,7 @@
         </p:nvGraphicFramePr>
         <p:xfrm>
           <a:off x="411480" y="1298448"/>
-          <a:ext cx="5806438" cy="2617470"/>
+          <a:ext cx="5806439" cy="3086100"/>
         </p:xfrm>
         <a:graphic>
           <a:graphicData uri="http://schemas.openxmlformats.org/drawingml/2006/table">
@@ -9301,9 +9301,9 @@
                 <a:tableStyleId>{5C22544A-7EE6-4342-B048-85BDC9FD1C3A}</a:tableStyleId>
               </a:tblPr>
               <a:tblGrid>
-                <a:gridCol w="2148382"/>
-                <a:gridCol w="1683867"/>
-                <a:gridCol w="1974189"/>
+                <a:gridCol w="3116692"/>
+                <a:gridCol w="1238137"/>
+                <a:gridCol w="1451610"/>
               </a:tblGrid>
               <a:tr h="468630">
                 <a:tc>
@@ -9713,6 +9713,74 @@
                   </a:tcPr>
                 </a:tc>
               </a:tr>
+              <a:tr h="468630">
+                <a:tc>
+                  <a:txBody>
+                    <a:bodyPr wrap="square"/>
+                    <a:lstStyle/>
+                    <a:p>
+                      <a:r>
+                        <a:rPr sz="1100" b="0">
+                          <a:solidFill>
+                            <a:srgbClr val="282828"/>
+                          </a:solidFill>
+                          <a:latin typeface="Arial"/>
+                        </a:rPr>
+                        <a:t>interferometer, lens rig</a:t>
+                      </a:r>
+                    </a:p>
+                  </a:txBody>
+                  <a:tcPr marL="54864" marR="54864" marT="18288" marB="18288">
+                    <a:solidFill>
+                      <a:srgbClr val="ECF1F6"/>
+                    </a:solidFill>
+                  </a:tcPr>
+                </a:tc>
+                <a:tc>
+                  <a:txBody>
+                    <a:bodyPr wrap="square"/>
+                    <a:lstStyle/>
+                    <a:p>
+                      <a:r>
+                        <a:rPr sz="1100" b="0">
+                          <a:solidFill>
+                            <a:srgbClr val="282828"/>
+                          </a:solidFill>
+                          <a:latin typeface="Arial"/>
+                        </a:rPr>
+                        <a:t>1.4e14 (servo form)</a:t>
+                      </a:r>
+                    </a:p>
+                  </a:txBody>
+                  <a:tcPr marL="54864" marR="54864" marT="18288" marB="18288">
+                    <a:solidFill>
+                      <a:srgbClr val="ECF1F6"/>
+                    </a:solidFill>
+                  </a:tcPr>
+                </a:tc>
+                <a:tc>
+                  <a:txBody>
+                    <a:bodyPr wrap="square"/>
+                    <a:lstStyle/>
+                    <a:p>
+                      <a:r>
+                        <a:rPr sz="1100" b="0">
+                          <a:solidFill>
+                            <a:srgbClr val="282828"/>
+                          </a:solidFill>
+                          <a:latin typeface="Arial"/>
+                        </a:rPr>
+                        <a:t>2.5e14</a:t>
+                      </a:r>
+                    </a:p>
+                  </a:txBody>
+                  <a:tcPr marL="54864" marR="54864" marT="18288" marB="18288">
+                    <a:solidFill>
+                      <a:srgbClr val="ECF1F6"/>
+                    </a:solidFill>
+                  </a:tcPr>
+                </a:tc>
+              </a:tr>
               <a:tr h="280035">
                 <a:tc>
                   <a:txBody>
@@ -9726,57 +9794,57 @@
                           </a:solidFill>
                           <a:latin typeface="Arial"/>
                         </a:rPr>
-                        <a:t>interferometer, lens rig</a:t>
-                      </a:r>
-                    </a:p>
-                  </a:txBody>
-                  <a:tcPr marL="54864" marR="54864" marT="18288" marB="18288">
-                    <a:solidFill>
-                      <a:srgbClr val="ECF1F6"/>
-                    </a:solidFill>
-                  </a:tcPr>
-                </a:tc>
-                <a:tc>
-                  <a:txBody>
-                    <a:bodyPr wrap="square"/>
-                    <a:lstStyle/>
-                    <a:p>
-                      <a:r>
-                        <a:rPr sz="1100" b="0">
-                          <a:solidFill>
-                            <a:srgbClr val="282828"/>
-                          </a:solidFill>
-                          <a:latin typeface="Arial"/>
-                        </a:rPr>
-                        <a:t>1.4e14 (servo form)</a:t>
-                      </a:r>
-                    </a:p>
-                  </a:txBody>
-                  <a:tcPr marL="54864" marR="54864" marT="18288" marB="18288">
-                    <a:solidFill>
-                      <a:srgbClr val="ECF1F6"/>
-                    </a:solidFill>
-                  </a:tcPr>
-                </a:tc>
-                <a:tc>
-                  <a:txBody>
-                    <a:bodyPr wrap="square"/>
-                    <a:lstStyle/>
-                    <a:p>
-                      <a:r>
-                        <a:rPr sz="1100" b="0">
-                          <a:solidFill>
-                            <a:srgbClr val="282828"/>
-                          </a:solidFill>
-                          <a:latin typeface="Arial"/>
-                        </a:rPr>
-                        <a:t>2.5e14</a:t>
-                      </a:r>
-                    </a:p>
-                  </a:txBody>
-                  <a:tcPr marL="54864" marR="54864" marT="18288" marB="18288">
-                    <a:solidFill>
-                      <a:srgbClr val="ECF1F6"/>
+                        <a:t>interferometer, mirror rig, record 7°</a:t>
+                      </a:r>
+                    </a:p>
+                  </a:txBody>
+                  <a:tcPr marL="54864" marR="54864" marT="18288" marB="18288">
+                    <a:solidFill>
+                      <a:srgbClr val="FFFFFF"/>
+                    </a:solidFill>
+                  </a:tcPr>
+                </a:tc>
+                <a:tc>
+                  <a:txBody>
+                    <a:bodyPr wrap="square"/>
+                    <a:lstStyle/>
+                    <a:p>
+                      <a:r>
+                        <a:rPr sz="1100" b="0">
+                          <a:solidFill>
+                            <a:srgbClr val="282828"/>
+                          </a:solidFill>
+                          <a:latin typeface="Arial"/>
+                        </a:rPr>
+                        <a:t>4.9e14</a:t>
+                      </a:r>
+                    </a:p>
+                  </a:txBody>
+                  <a:tcPr marL="54864" marR="54864" marT="18288" marB="18288">
+                    <a:solidFill>
+                      <a:srgbClr val="FFFFFF"/>
+                    </a:solidFill>
+                  </a:tcPr>
+                </a:tc>
+                <a:tc>
+                  <a:txBody>
+                    <a:bodyPr wrap="square"/>
+                    <a:lstStyle/>
+                    <a:p>
+                      <a:r>
+                        <a:rPr sz="1100" b="0">
+                          <a:solidFill>
+                            <a:srgbClr val="282828"/>
+                          </a:solidFill>
+                          <a:latin typeface="Arial"/>
+                        </a:rPr>
+                        <a:t>6.2e14</a:t>
+                      </a:r>
+                    </a:p>
+                  </a:txBody>
+                  <a:tcPr marL="54864" marR="54864" marT="18288" marB="18288">
+                    <a:solidFill>
+                      <a:srgbClr val="FFFFFF"/>
                     </a:solidFill>
                   </a:tcPr>
                 </a:tc>
@@ -9794,57 +9862,57 @@
                           </a:solidFill>
                           <a:latin typeface="Arial"/>
                         </a:rPr>
-                        <a:t>interferometer, mirror rig, record 7°</a:t>
-                      </a:r>
-                    </a:p>
-                  </a:txBody>
-                  <a:tcPr marL="54864" marR="54864" marT="18288" marB="18288">
-                    <a:solidFill>
-                      <a:srgbClr val="FFFFFF"/>
-                    </a:solidFill>
-                  </a:tcPr>
-                </a:tc>
-                <a:tc>
-                  <a:txBody>
-                    <a:bodyPr wrap="square"/>
-                    <a:lstStyle/>
-                    <a:p>
-                      <a:r>
-                        <a:rPr sz="1100" b="0">
-                          <a:solidFill>
-                            <a:srgbClr val="282828"/>
-                          </a:solidFill>
-                          <a:latin typeface="Arial"/>
-                        </a:rPr>
-                        <a:t>4.9e14</a:t>
-                      </a:r>
-                    </a:p>
-                  </a:txBody>
-                  <a:tcPr marL="54864" marR="54864" marT="18288" marB="18288">
-                    <a:solidFill>
-                      <a:srgbClr val="FFFFFF"/>
-                    </a:solidFill>
-                  </a:tcPr>
-                </a:tc>
-                <a:tc>
-                  <a:txBody>
-                    <a:bodyPr wrap="square"/>
-                    <a:lstStyle/>
-                    <a:p>
-                      <a:r>
-                        <a:rPr sz="1100" b="0">
-                          <a:solidFill>
-                            <a:srgbClr val="282828"/>
-                          </a:solidFill>
-                          <a:latin typeface="Arial"/>
-                        </a:rPr>
-                        <a:t>6.2e14</a:t>
-                      </a:r>
-                    </a:p>
-                  </a:txBody>
-                  <a:tcPr marL="54864" marR="54864" marT="18288" marB="18288">
-                    <a:solidFill>
-                      <a:srgbClr val="FFFFFF"/>
+                        <a:t>stepped pinhole / vector Zernike / Zernike stepped, redesigned mirror rig</a:t>
+                      </a:r>
+                    </a:p>
+                  </a:txBody>
+                  <a:tcPr marL="54864" marR="54864" marT="18288" marB="18288">
+                    <a:solidFill>
+                      <a:srgbClr val="ECF1F6"/>
+                    </a:solidFill>
+                  </a:tcPr>
+                </a:tc>
+                <a:tc>
+                  <a:txBody>
+                    <a:bodyPr wrap="square"/>
+                    <a:lstStyle/>
+                    <a:p>
+                      <a:r>
+                        <a:rPr sz="1100" b="0">
+                          <a:solidFill>
+                            <a:srgbClr val="282828"/>
+                          </a:solidFill>
+                          <a:latin typeface="Arial"/>
+                        </a:rPr>
+                        <a:t>—</a:t>
+                      </a:r>
+                    </a:p>
+                  </a:txBody>
+                  <a:tcPr marL="54864" marR="54864" marT="18288" marB="18288">
+                    <a:solidFill>
+                      <a:srgbClr val="ECF1F6"/>
+                    </a:solidFill>
+                  </a:tcPr>
+                </a:tc>
+                <a:tc>
+                  <a:txBody>
+                    <a:bodyPr wrap="square"/>
+                    <a:lstStyle/>
+                    <a:p>
+                      <a:r>
+                        <a:rPr sz="1100" b="0">
+                          <a:solidFill>
+                            <a:srgbClr val="282828"/>
+                          </a:solidFill>
+                          <a:latin typeface="Arial"/>
+                        </a:rPr>
+                        <a:t>8.5e13 / 7.3e13 / 5.8e13</a:t>
+                      </a:r>
+                    </a:p>
+                  </a:txBody>
+                  <a:tcPr marL="54864" marR="54864" marT="18288" marB="18288">
+                    <a:solidFill>
+                      <a:srgbClr val="ECF1F6"/>
                     </a:solidFill>
                   </a:tcPr>
                 </a:tc>
@@ -9950,7 +10018,7 @@
                 </a:solidFill>
                 <a:latin typeface="Arial"/>
               </a:rPr>
-              <a:t>One measurement at 1e14 photons is 31 µJ: 0.13 s of a 1 mW laser at 25% throughput.  The camera's well depth, not the laser, sets the time (future-work slide).  Run tags pdi193f, v193noise, rec193full, noise193_b30, noise193p_b30, pfdeck, loop_lens, lens_deck, oap_deck.</a:t>
+              <a:t>One measurement at 1e14 photons is 31 µJ: 0.13 s of a 1 mW laser at 25% throughput.  The camera's well depth, not the laser, sets the time (future-work slide).  Run tags pdi193f, v193noise, rec193full, noise193_b30, noise193p_b30, pfdeck, loop_lens, lens_deck, oap_deck, oapnoise22 (the sensors on the mirror rig).</a:t>
             </a:r>
           </a:p>
         </p:txBody>
@@ -27667,7 +27735,7 @@
                 </a:solidFill>
                 <a:latin typeface="Arial"/>
               </a:rPr>
-              <a:t>•  Zernike sensors (zwfs_dm96/runs): matbase, matbase385, m2048, m2048_lat, cap385, cap385_b60-b160, noise193_b30-b160, rec193full, loop193, loop385, v193base, v193noise, vloop193, fold_diag, v2g, v2loop, v3arm, v3s, v3loop, an193_ref/cube/q300/q100/az1/bound/clear, stations193, gate22_193, sub22, thk22 (the 22.5° bench with substrates and thicknesses), oapsens22, oapsens22n, vqw22, vmap22, oaploop22 (the sensors on the redesigned mirror rig).  README.md (CCL) and deck_zwfs.md.</a:t>
+              <a:t>•  Zernike sensors (zwfs_dm96/runs): matbase, matbase385, m2048, m2048_lat, cap385, cap385_b60-b160, noise193_b30-b160, rec193full, loop193, loop385, v193base, v193noise, vloop193, fold_diag, v2g, v2loop, v3arm, v3s, v3loop, an193_ref/cube/q300/q100/az1/bound/clear, stations193, gate22_193, sub22, thk22 (the 22.5° bench with substrates and thicknesses), oapsens22, oapsens22n, vqw22, vmap22, oaploop22, oapnoise22 (the sensors on the redesigned mirror rig).  README.md (CCL) and deck_zwfs.md.</a:t>
             </a:r>
           </a:p>
           <a:p>

</xml_diff>

<commit_message>
Deck: contents slide as Dave's guide (15 entries with slide numbers)
Co-Authored-By: Claude Fable 5.1 <noreply@anthropic.com>
</commit_message>
<xml_diff>
--- a/demo_session/deck_gauges.pptx
+++ b/demo_session/deck_gauges.pptx
@@ -6459,7 +6459,7 @@
                 </a:solidFill>
                 <a:latin typeface="Arial"/>
               </a:rPr>
-              <a:t>•  3-8 The jobs; the bench and its parts</a:t>
+              <a:t>•  3 Introduction: the three jobs and how they are scored</a:t>
             </a:r>
           </a:p>
           <a:p>
@@ -6475,7 +6475,7 @@
                 </a:solidFill>
                 <a:latin typeface="Arial"/>
               </a:rPr>
-              <a:t>•  9-19 The four approaches: interferometer, Zernike, vector Zernike, pinhole</a:t>
+              <a:t>•  4 The bench layout</a:t>
             </a:r>
           </a:p>
           <a:p>
@@ -6491,7 +6491,7 @@
                 </a:solidFill>
                 <a:latin typeface="Arial"/>
               </a:rPr>
-              <a:t>•  20-25 Performance on the working surface: rows, capture, photons, servo</a:t>
+              <a:t>•  6 Parts</a:t>
             </a:r>
           </a:p>
           <a:p>
@@ -6507,7 +6507,71 @@
                 </a:solidFill>
                 <a:latin typeface="Arial"/>
               </a:rPr>
-              <a:t>•  26-28 Lenses or off-axis mirrors</a:t>
+              <a:t>•  9 Twyman-Green interferometer</a:t>
+            </a:r>
+          </a:p>
+          <a:p>
+            <a:pPr>
+              <a:spcAft>
+                <a:spcPts val="600"/>
+              </a:spcAft>
+            </a:pPr>
+            <a:r>
+              <a:rPr sz="1200" b="0">
+                <a:solidFill>
+                  <a:srgbClr val="282828"/>
+                </a:solidFill>
+                <a:latin typeface="Arial"/>
+              </a:rPr>
+              <a:t>•  12 Zernike sensor</a:t>
+            </a:r>
+          </a:p>
+          <a:p>
+            <a:pPr>
+              <a:spcAft>
+                <a:spcPts val="600"/>
+              </a:spcAft>
+            </a:pPr>
+            <a:r>
+              <a:rPr sz="1200" b="0">
+                <a:solidFill>
+                  <a:srgbClr val="282828"/>
+                </a:solidFill>
+                <a:latin typeface="Arial"/>
+              </a:rPr>
+              <a:t>•  14 Vector Zernike sensor</a:t>
+            </a:r>
+          </a:p>
+          <a:p>
+            <a:pPr>
+              <a:spcAft>
+                <a:spcPts val="600"/>
+              </a:spcAft>
+            </a:pPr>
+            <a:r>
+              <a:rPr sz="1200" b="0">
+                <a:solidFill>
+                  <a:srgbClr val="282828"/>
+                </a:solidFill>
+                <a:latin typeface="Arial"/>
+              </a:rPr>
+              <a:t>•  17 Point-diffraction sensor</a:t>
+            </a:r>
+          </a:p>
+          <a:p>
+            <a:pPr>
+              <a:spcAft>
+                <a:spcPts val="600"/>
+              </a:spcAft>
+            </a:pPr>
+            <a:r>
+              <a:rPr sz="1200" b="0">
+                <a:solidFill>
+                  <a:srgbClr val="282828"/>
+                </a:solidFill>
+                <a:latin typeface="Arial"/>
+              </a:rPr>
+              <a:t>•  20 Performance: rows, capture, photons, servo</a:t>
             </a:r>
           </a:p>
         </p:txBody>
@@ -6546,7 +6610,7 @@
                 </a:solidFill>
                 <a:latin typeface="Arial"/>
               </a:rPr>
-              <a:t>•  29-30 Systematics; recommendation</a:t>
+              <a:t>•  26 Lenses versus off-axis parabolas</a:t>
             </a:r>
           </a:p>
           <a:p>
@@ -6562,7 +6626,7 @@
                 </a:solidFill>
                 <a:latin typeface="Arial"/>
               </a:rPr>
-              <a:t>•  31-33 Operating the gauge</a:t>
+              <a:t>•  27 The reflective front end and its performance</a:t>
             </a:r>
           </a:p>
           <a:p>
@@ -6578,7 +6642,7 @@
                 </a:solidFill>
                 <a:latin typeface="Arial"/>
               </a:rPr>
-              <a:t>•  34-36 Future work</a:t>
+              <a:t>•  29 Comparison and recommendation</a:t>
             </a:r>
           </a:p>
           <a:p>
@@ -6594,7 +6658,7 @@
                 </a:solidFill>
                 <a:latin typeface="Arial"/>
               </a:rPr>
-              <a:t>•  37-38 Method; run it yourself</a:t>
+              <a:t>•  32 Complex amplitude</a:t>
             </a:r>
           </a:p>
           <a:p>
@@ -6610,7 +6674,39 @@
                 </a:solidFill>
                 <a:latin typeface="Arial"/>
               </a:rPr>
-              <a:t>•  39-48 Backup</a:t>
+              <a:t>•  33 Summary and future work</a:t>
+            </a:r>
+          </a:p>
+          <a:p>
+            <a:pPr>
+              <a:spcAft>
+                <a:spcPts val="600"/>
+              </a:spcAft>
+            </a:pPr>
+            <a:r>
+              <a:rPr sz="1200" b="0">
+                <a:solidFill>
+                  <a:srgbClr val="282828"/>
+                </a:solidFill>
+                <a:latin typeface="Arial"/>
+              </a:rPr>
+              <a:t>•  38 Run it yourself</a:t>
+            </a:r>
+          </a:p>
+          <a:p>
+            <a:pPr>
+              <a:spcAft>
+                <a:spcPts val="600"/>
+              </a:spcAft>
+            </a:pPr>
+            <a:r>
+              <a:rPr sz="1200" b="0">
+                <a:solidFill>
+                  <a:srgbClr val="282828"/>
+                </a:solidFill>
+                <a:latin typeface="Arial"/>
+              </a:rPr>
+              <a:t>•  39 Backup</a:t>
             </a:r>
           </a:p>
         </p:txBody>

</xml_diff>

<commit_message>
Deck: parts slide 6 trimmed to fit (splitter, field lens, camera cells); editing copy synced.  Slice: the afternoon's rulings, the Mac's cycle-2 fold, the interim deck state.
Co-Authored-By: Claude Fable 5.1 <noreply@anthropic.com>
</commit_message>
<xml_diff>
--- a/demo_session/deck_gauges.pptx
+++ b/demo_session/deck_gauges.pptx
@@ -32489,7 +32489,7 @@
         </p:nvGraphicFramePr>
         <p:xfrm>
           <a:off x="411480" y="1298448"/>
-          <a:ext cx="11368734" cy="7229475"/>
+          <a:ext cx="11368735" cy="5532120"/>
         </p:xfrm>
         <a:graphic>
           <a:graphicData uri="http://schemas.openxmlformats.org/drawingml/2006/table">
@@ -32499,10 +32499,10 @@
               </a:tblPr>
               <a:tblGrid>
                 <a:gridCol w="1962404"/>
-                <a:gridCol w="5148308"/>
+                <a:gridCol w="4818338"/>
                 <a:gridCol w="2180336"/>
                 <a:gridCol w="509524"/>
-                <a:gridCol w="1568162"/>
+                <a:gridCol w="1898133"/>
               </a:tblGrid>
               <a:tr h="280035">
                 <a:tc>
@@ -32616,7 +32616,7 @@
                   </a:tcPr>
                 </a:tc>
               </a:tr>
-              <a:tr h="657225">
+              <a:tr h="468630">
                 <a:tc>
                   <a:txBody>
                     <a:bodyPr wrap="square"/>
@@ -32840,7 +32840,7 @@
                   </a:tcPr>
                 </a:tc>
               </a:tr>
-              <a:tr h="1034415">
+              <a:tr h="657225">
                 <a:tc>
                   <a:txBody>
                     <a:bodyPr wrap="square"/>
@@ -32875,7 +32875,7 @@
                           </a:solidFill>
                           <a:latin typeface="Arial"/>
                         </a:rPr>
-                        <a:t>103 mm, 22.5° incidence, 50/50; 10 mm thick (modeled): shifts the transmitted beam 1.39 mm, which the compensator cannot undo; the interferometer's flat null rises from 0.13 to 20 nm and its reading is attenuated 13%, a cost in floor and SNR, not gain (differential rows 1.00-1.01, single actuator 0.989; capture unchanged); the sensors do not move</a:t>
+                        <a:t>103 mm, 22.5° incidence, 50/50; 10 mm thick: shifts the transmitted beam 1.39 mm, the flat null 0.13 → 20 nm, the reading attenuated 13% (floor, not gain; rows hold)</a:t>
                       </a:r>
                     </a:p>
                   </a:txBody>
@@ -32948,6 +32948,342 @@
                   <a:tcPr marL="54864" marR="54864" marT="18288" marB="18288">
                     <a:solidFill>
                       <a:srgbClr val="FFFFFF"/>
+                    </a:solidFill>
+                  </a:tcPr>
+                </a:tc>
+              </a:tr>
+              <a:tr h="468630">
+                <a:tc>
+                  <a:txBody>
+                    <a:bodyPr wrap="square"/>
+                    <a:lstStyle/>
+                    <a:p>
+                      <a:r>
+                        <a:rPr sz="1100" b="0">
+                          <a:solidFill>
+                            <a:srgbClr val="282828"/>
+                          </a:solidFill>
+                          <a:latin typeface="Arial"/>
+                        </a:rPr>
+                        <a:t>compensator plate</a:t>
+                      </a:r>
+                    </a:p>
+                  </a:txBody>
+                  <a:tcPr marL="54864" marR="54864" marT="18288" marB="18288">
+                    <a:solidFill>
+                      <a:srgbClr val="ECF1F6"/>
+                    </a:solidFill>
+                  </a:tcPr>
+                </a:tc>
+                <a:tc>
+                  <a:txBody>
+                    <a:bodyPr wrap="square"/>
+                    <a:lstStyle/>
+                    <a:p>
+                      <a:r>
+                        <a:rPr sz="1100" b="0">
+                          <a:solidFill>
+                            <a:srgbClr val="282828"/>
+                          </a:solidFill>
+                          <a:latin typeface="Arial"/>
+                        </a:rPr>
+                        <a:t>103 mm, matched to the splitter, in the mirror leg</a:t>
+                      </a:r>
+                    </a:p>
+                  </a:txBody>
+                  <a:tcPr marL="54864" marR="54864" marT="18288" marB="18288">
+                    <a:solidFill>
+                      <a:srgbClr val="ECF1F6"/>
+                    </a:solidFill>
+                  </a:tcPr>
+                </a:tc>
+                <a:tc>
+                  <a:txBody>
+                    <a:bodyPr wrap="square"/>
+                    <a:lstStyle/>
+                    <a:p>
+                      <a:r>
+                        <a:rPr sz="1100" b="0">
+                          <a:solidFill>
+                            <a:srgbClr val="282828"/>
+                          </a:solidFill>
+                          <a:latin typeface="Arial"/>
+                        </a:rPr>
+                        <a:t>AR</a:t>
+                      </a:r>
+                    </a:p>
+                  </a:txBody>
+                  <a:tcPr marL="54864" marR="54864" marT="18288" marB="18288">
+                    <a:solidFill>
+                      <a:srgbClr val="ECF1F6"/>
+                    </a:solidFill>
+                  </a:tcPr>
+                </a:tc>
+                <a:tc>
+                  <a:txBody>
+                    <a:bodyPr wrap="square"/>
+                    <a:lstStyle/>
+                    <a:p>
+                      <a:r>
+                        <a:rPr sz="1100" b="0">
+                          <a:solidFill>
+                            <a:srgbClr val="282828"/>
+                          </a:solidFill>
+                          <a:latin typeface="Arial"/>
+                        </a:rPr>
+                        <a:t>1</a:t>
+                      </a:r>
+                    </a:p>
+                  </a:txBody>
+                  <a:tcPr marL="54864" marR="54864" marT="18288" marB="18288">
+                    <a:solidFill>
+                      <a:srgbClr val="ECF1F6"/>
+                    </a:solidFill>
+                  </a:tcPr>
+                </a:tc>
+                <a:tc>
+                  <a:txBody>
+                    <a:bodyPr wrap="square"/>
+                    <a:lstStyle/>
+                    <a:p>
+                      <a:r>
+                        <a:rPr sz="1100" b="0">
+                          <a:solidFill>
+                            <a:srgbClr val="282828"/>
+                          </a:solidFill>
+                          <a:latin typeface="Arial"/>
+                        </a:rPr>
+                        <a:t>balances the glass path through the splitter</a:t>
+                      </a:r>
+                    </a:p>
+                  </a:txBody>
+                  <a:tcPr marL="54864" marR="54864" marT="18288" marB="18288">
+                    <a:solidFill>
+                      <a:srgbClr val="ECF1F6"/>
+                    </a:solidFill>
+                  </a:tcPr>
+                </a:tc>
+              </a:tr>
+              <a:tr h="468630">
+                <a:tc>
+                  <a:txBody>
+                    <a:bodyPr wrap="square"/>
+                    <a:lstStyle/>
+                    <a:p>
+                      <a:r>
+                        <a:rPr sz="1100" b="0">
+                          <a:solidFill>
+                            <a:srgbClr val="282828"/>
+                          </a:solidFill>
+                          <a:latin typeface="Arial"/>
+                        </a:rPr>
+                        <a:t>deformable mirror</a:t>
+                      </a:r>
+                    </a:p>
+                  </a:txBody>
+                  <a:tcPr marL="54864" marR="54864" marT="18288" marB="18288">
+                    <a:solidFill>
+                      <a:srgbClr val="FFFFFF"/>
+                    </a:solidFill>
+                  </a:tcPr>
+                </a:tc>
+                <a:tc>
+                  <a:txBody>
+                    <a:bodyPr wrap="square"/>
+                    <a:lstStyle/>
+                    <a:p>
+                      <a:r>
+                        <a:rPr sz="1100" b="0">
+                          <a:solidFill>
+                            <a:srgbClr val="282828"/>
+                          </a:solidFill>
+                          <a:latin typeface="Arial"/>
+                        </a:rPr>
+                        <a:t>96×96, 1 mm pitch, 96 mm, 700 mm leg</a:t>
+                      </a:r>
+                    </a:p>
+                  </a:txBody>
+                  <a:tcPr marL="54864" marR="54864" marT="18288" marB="18288">
+                    <a:solidFill>
+                      <a:srgbClr val="FFFFFF"/>
+                    </a:solidFill>
+                  </a:tcPr>
+                </a:tc>
+                <a:tc>
+                  <a:txBody>
+                    <a:bodyPr wrap="square"/>
+                    <a:lstStyle/>
+                    <a:p>
+                      <a:r>
+                        <a:rPr sz="1100" b="0">
+                          <a:solidFill>
+                            <a:srgbClr val="282828"/>
+                          </a:solidFill>
+                          <a:latin typeface="Arial"/>
+                        </a:rPr>
+                        <a:t>protected aluminum</a:t>
+                      </a:r>
+                    </a:p>
+                  </a:txBody>
+                  <a:tcPr marL="54864" marR="54864" marT="18288" marB="18288">
+                    <a:solidFill>
+                      <a:srgbClr val="FFFFFF"/>
+                    </a:solidFill>
+                  </a:tcPr>
+                </a:tc>
+                <a:tc>
+                  <a:txBody>
+                    <a:bodyPr wrap="square"/>
+                    <a:lstStyle/>
+                    <a:p>
+                      <a:r>
+                        <a:rPr sz="1100" b="0">
+                          <a:solidFill>
+                            <a:srgbClr val="282828"/>
+                          </a:solidFill>
+                          <a:latin typeface="Arial"/>
+                        </a:rPr>
+                        <a:t>1</a:t>
+                      </a:r>
+                    </a:p>
+                  </a:txBody>
+                  <a:tcPr marL="54864" marR="54864" marT="18288" marB="18288">
+                    <a:solidFill>
+                      <a:srgbClr val="FFFFFF"/>
+                    </a:solidFill>
+                  </a:tcPr>
+                </a:tc>
+                <a:tc>
+                  <a:txBody>
+                    <a:bodyPr wrap="square"/>
+                    <a:lstStyle/>
+                    <a:p>
+                      <a:r>
+                        <a:rPr sz="1100" b="0">
+                          <a:solidFill>
+                            <a:srgbClr val="282828"/>
+                          </a:solidFill>
+                          <a:latin typeface="Arial"/>
+                        </a:rPr>
+                        <a:t>the test object; its surface is the measurand</a:t>
+                      </a:r>
+                    </a:p>
+                  </a:txBody>
+                  <a:tcPr marL="54864" marR="54864" marT="18288" marB="18288">
+                    <a:solidFill>
+                      <a:srgbClr val="FFFFFF"/>
+                    </a:solidFill>
+                  </a:tcPr>
+                </a:tc>
+              </a:tr>
+              <a:tr h="468630">
+                <a:tc>
+                  <a:txBody>
+                    <a:bodyPr wrap="square"/>
+                    <a:lstStyle/>
+                    <a:p>
+                      <a:r>
+                        <a:rPr sz="1100" b="0">
+                          <a:solidFill>
+                            <a:srgbClr val="282828"/>
+                          </a:solidFill>
+                          <a:latin typeface="Arial"/>
+                        </a:rPr>
+                        <a:t>focuser L2</a:t>
+                      </a:r>
+                    </a:p>
+                  </a:txBody>
+                  <a:tcPr marL="54864" marR="54864" marT="18288" marB="18288">
+                    <a:solidFill>
+                      <a:srgbClr val="ECF1F6"/>
+                    </a:solidFill>
+                  </a:tcPr>
+                </a:tc>
+                <a:tc>
+                  <a:txBody>
+                    <a:bodyPr wrap="square"/>
+                    <a:lstStyle/>
+                    <a:p>
+                      <a:r>
+                        <a:rPr sz="1100" b="0">
+                          <a:solidFill>
+                            <a:srgbClr val="282828"/>
+                          </a:solidFill>
+                          <a:latin typeface="Arial"/>
+                        </a:rPr>
+                        <a:t>f 429 mm, 103 mm, plano-convex conic; modeled 8 mm center</a:t>
+                      </a:r>
+                    </a:p>
+                  </a:txBody>
+                  <a:tcPr marL="54864" marR="54864" marT="18288" marB="18288">
+                    <a:solidFill>
+                      <a:srgbClr val="ECF1F6"/>
+                    </a:solidFill>
+                  </a:tcPr>
+                </a:tc>
+                <a:tc>
+                  <a:txBody>
+                    <a:bodyPr wrap="square"/>
+                    <a:lstStyle/>
+                    <a:p>
+                      <a:r>
+                        <a:rPr sz="1100" b="0">
+                          <a:solidFill>
+                            <a:srgbClr val="282828"/>
+                          </a:solidFill>
+                          <a:latin typeface="Arial"/>
+                        </a:rPr>
+                        <a:t>AR</a:t>
+                      </a:r>
+                    </a:p>
+                  </a:txBody>
+                  <a:tcPr marL="54864" marR="54864" marT="18288" marB="18288">
+                    <a:solidFill>
+                      <a:srgbClr val="ECF1F6"/>
+                    </a:solidFill>
+                  </a:tcPr>
+                </a:tc>
+                <a:tc>
+                  <a:txBody>
+                    <a:bodyPr wrap="square"/>
+                    <a:lstStyle/>
+                    <a:p>
+                      <a:r>
+                        <a:rPr sz="1100" b="0">
+                          <a:solidFill>
+                            <a:srgbClr val="282828"/>
+                          </a:solidFill>
+                          <a:latin typeface="Arial"/>
+                        </a:rPr>
+                        <a:t>1</a:t>
+                      </a:r>
+                    </a:p>
+                  </a:txBody>
+                  <a:tcPr marL="54864" marR="54864" marT="18288" marB="18288">
+                    <a:solidFill>
+                      <a:srgbClr val="ECF1F6"/>
+                    </a:solidFill>
+                  </a:tcPr>
+                </a:tc>
+                <a:tc>
+                  <a:txBody>
+                    <a:bodyPr wrap="square"/>
+                    <a:lstStyle/>
+                    <a:p>
+                      <a:r>
+                        <a:rPr sz="1100" b="0">
+                          <a:solidFill>
+                            <a:srgbClr val="282828"/>
+                          </a:solidFill>
+                          <a:latin typeface="Arial"/>
+                        </a:rPr>
+                        <a:t>the internal focus at F/4.2 where the masks sit</a:t>
+                      </a:r>
+                    </a:p>
+                  </a:txBody>
+                  <a:tcPr marL="54864" marR="54864" marT="18288" marB="18288">
+                    <a:solidFill>
+                      <a:srgbClr val="ECF1F6"/>
                     </a:solidFill>
                   </a:tcPr>
                 </a:tc>
@@ -32965,57 +33301,57 @@
                           </a:solidFill>
                           <a:latin typeface="Arial"/>
                         </a:rPr>
-                        <a:t>compensator plate</a:t>
-                      </a:r>
-                    </a:p>
-                  </a:txBody>
-                  <a:tcPr marL="54864" marR="54864" marT="18288" marB="18288">
-                    <a:solidFill>
-                      <a:srgbClr val="ECF1F6"/>
-                    </a:solidFill>
-                  </a:tcPr>
-                </a:tc>
-                <a:tc>
-                  <a:txBody>
-                    <a:bodyPr wrap="square"/>
-                    <a:lstStyle/>
-                    <a:p>
-                      <a:r>
-                        <a:rPr sz="1100" b="0">
-                          <a:solidFill>
-                            <a:srgbClr val="282828"/>
-                          </a:solidFill>
-                          <a:latin typeface="Arial"/>
-                        </a:rPr>
-                        <a:t>103 mm, matched to the splitter, in the mirror leg</a:t>
-                      </a:r>
-                    </a:p>
-                  </a:txBody>
-                  <a:tcPr marL="54864" marR="54864" marT="18288" marB="18288">
-                    <a:solidFill>
-                      <a:srgbClr val="ECF1F6"/>
-                    </a:solidFill>
-                  </a:tcPr>
-                </a:tc>
-                <a:tc>
-                  <a:txBody>
-                    <a:bodyPr wrap="square"/>
-                    <a:lstStyle/>
-                    <a:p>
-                      <a:r>
-                        <a:rPr sz="1100" b="0">
-                          <a:solidFill>
-                            <a:srgbClr val="282828"/>
-                          </a:solidFill>
-                          <a:latin typeface="Arial"/>
-                        </a:rPr>
-                        <a:t>AR</a:t>
-                      </a:r>
-                    </a:p>
-                  </a:txBody>
-                  <a:tcPr marL="54864" marR="54864" marT="18288" marB="18288">
-                    <a:solidFill>
-                      <a:srgbClr val="ECF1F6"/>
+                        <a:t>mask seat</a:t>
+                      </a:r>
+                    </a:p>
+                  </a:txBody>
+                  <a:tcPr marL="54864" marR="54864" marT="18288" marB="18288">
+                    <a:solidFill>
+                      <a:srgbClr val="FFFFFF"/>
+                    </a:solidFill>
+                  </a:tcPr>
+                </a:tc>
+                <a:tc>
+                  <a:txBody>
+                    <a:bodyPr wrap="square"/>
+                    <a:lstStyle/>
+                    <a:p>
+                      <a:r>
+                        <a:rPr sz="1100" b="0">
+                          <a:solidFill>
+                            <a:srgbClr val="282828"/>
+                          </a:solidFill>
+                          <a:latin typeface="Arial"/>
+                        </a:rPr>
+                        <a:t>translation stage at the internal focus</a:t>
+                      </a:r>
+                    </a:p>
+                  </a:txBody>
+                  <a:tcPr marL="54864" marR="54864" marT="18288" marB="18288">
+                    <a:solidFill>
+                      <a:srgbClr val="FFFFFF"/>
+                    </a:solidFill>
+                  </a:tcPr>
+                </a:tc>
+                <a:tc>
+                  <a:txBody>
+                    <a:bodyPr wrap="square"/>
+                    <a:lstStyle/>
+                    <a:p>
+                      <a:r>
+                        <a:rPr sz="1100" b="0">
+                          <a:solidFill>
+                            <a:srgbClr val="282828"/>
+                          </a:solidFill>
+                          <a:latin typeface="Arial"/>
+                        </a:rPr>
+                        <a:t>—</a:t>
+                      </a:r>
+                    </a:p>
+                  </a:txBody>
+                  <a:tcPr marL="54864" marR="54864" marT="18288" marB="18288">
+                    <a:solidFill>
+                      <a:srgbClr val="FFFFFF"/>
                     </a:solidFill>
                   </a:tcPr>
                 </a:tc>
@@ -33037,29 +33373,29 @@
                   </a:txBody>
                   <a:tcPr marL="54864" marR="54864" marT="18288" marB="18288">
                     <a:solidFill>
-                      <a:srgbClr val="ECF1F6"/>
-                    </a:solidFill>
-                  </a:tcPr>
-                </a:tc>
-                <a:tc>
-                  <a:txBody>
-                    <a:bodyPr wrap="square"/>
-                    <a:lstStyle/>
-                    <a:p>
-                      <a:r>
-                        <a:rPr sz="1100" b="0">
-                          <a:solidFill>
-                            <a:srgbClr val="282828"/>
-                          </a:solidFill>
-                          <a:latin typeface="Arial"/>
-                        </a:rPr>
-                        <a:t>balances the glass path through the splitter</a:t>
-                      </a:r>
-                    </a:p>
-                  </a:txBody>
-                  <a:tcPr marL="54864" marR="54864" marT="18288" marB="18288">
-                    <a:solidFill>
-                      <a:srgbClr val="ECF1F6"/>
+                      <a:srgbClr val="FFFFFF"/>
+                    </a:solidFill>
+                  </a:tcPr>
+                </a:tc>
+                <a:tc>
+                  <a:txBody>
+                    <a:bodyPr wrap="square"/>
+                    <a:lstStyle/>
+                    <a:p>
+                      <a:r>
+                        <a:rPr sz="1100" b="0">
+                          <a:solidFill>
+                            <a:srgbClr val="282828"/>
+                          </a:solidFill>
+                          <a:latin typeface="Arial"/>
+                        </a:rPr>
+                        <a:t>selects the sensor: clear window, dimple, metasurface, pinhole</a:t>
+                      </a:r>
+                    </a:p>
+                  </a:txBody>
+                  <a:tcPr marL="54864" marR="54864" marT="18288" marB="18288">
+                    <a:solidFill>
+                      <a:srgbClr val="FFFFFF"/>
                     </a:solidFill>
                   </a:tcPr>
                 </a:tc>
@@ -33077,57 +33413,57 @@
                           </a:solidFill>
                           <a:latin typeface="Arial"/>
                         </a:rPr>
-                        <a:t>deformable mirror</a:t>
-                      </a:r>
-                    </a:p>
-                  </a:txBody>
-                  <a:tcPr marL="54864" marR="54864" marT="18288" marB="18288">
-                    <a:solidFill>
-                      <a:srgbClr val="FFFFFF"/>
-                    </a:solidFill>
-                  </a:tcPr>
-                </a:tc>
-                <a:tc>
-                  <a:txBody>
-                    <a:bodyPr wrap="square"/>
-                    <a:lstStyle/>
-                    <a:p>
-                      <a:r>
-                        <a:rPr sz="1100" b="0">
-                          <a:solidFill>
-                            <a:srgbClr val="282828"/>
-                          </a:solidFill>
-                          <a:latin typeface="Arial"/>
-                        </a:rPr>
-                        <a:t>96×96, 1 mm pitch, 96 mm, 700 mm leg</a:t>
-                      </a:r>
-                    </a:p>
-                  </a:txBody>
-                  <a:tcPr marL="54864" marR="54864" marT="18288" marB="18288">
-                    <a:solidFill>
-                      <a:srgbClr val="FFFFFF"/>
-                    </a:solidFill>
-                  </a:tcPr>
-                </a:tc>
-                <a:tc>
-                  <a:txBody>
-                    <a:bodyPr wrap="square"/>
-                    <a:lstStyle/>
-                    <a:p>
-                      <a:r>
-                        <a:rPr sz="1100" b="0">
-                          <a:solidFill>
-                            <a:srgbClr val="282828"/>
-                          </a:solidFill>
-                          <a:latin typeface="Arial"/>
-                        </a:rPr>
-                        <a:t>protected aluminum</a:t>
-                      </a:r>
-                    </a:p>
-                  </a:txBody>
-                  <a:tcPr marL="54864" marR="54864" marT="18288" marB="18288">
-                    <a:solidFill>
-                      <a:srgbClr val="FFFFFF"/>
+                        <a:t>field lens</a:t>
+                      </a:r>
+                    </a:p>
+                  </a:txBody>
+                  <a:tcPr marL="54864" marR="54864" marT="18288" marB="18288">
+                    <a:solidFill>
+                      <a:srgbClr val="ECF1F6"/>
+                    </a:solidFill>
+                  </a:tcPr>
+                </a:tc>
+                <a:tc>
+                  <a:txBody>
+                    <a:bodyPr wrap="square"/>
+                    <a:lstStyle/>
+                    <a:p>
+                      <a:r>
+                        <a:rPr sz="1100" b="0">
+                          <a:solidFill>
+                            <a:srgbClr val="282828"/>
+                          </a:solidFill>
+                          <a:latin typeface="Arial"/>
+                        </a:rPr>
+                        <a:t>f 43 mm, 21 mm; at the seed station 10.8 mm past the focus (slide 15)</a:t>
+                      </a:r>
+                    </a:p>
+                  </a:txBody>
+                  <a:tcPr marL="54864" marR="54864" marT="18288" marB="18288">
+                    <a:solidFill>
+                      <a:srgbClr val="ECF1F6"/>
+                    </a:solidFill>
+                  </a:tcPr>
+                </a:tc>
+                <a:tc>
+                  <a:txBody>
+                    <a:bodyPr wrap="square"/>
+                    <a:lstStyle/>
+                    <a:p>
+                      <a:r>
+                        <a:rPr sz="1100" b="0">
+                          <a:solidFill>
+                            <a:srgbClr val="282828"/>
+                          </a:solidFill>
+                          <a:latin typeface="Arial"/>
+                        </a:rPr>
+                        <a:t>AR</a:t>
+                      </a:r>
+                    </a:p>
+                  </a:txBody>
+                  <a:tcPr marL="54864" marR="54864" marT="18288" marB="18288">
+                    <a:solidFill>
+                      <a:srgbClr val="ECF1F6"/>
                     </a:solidFill>
                   </a:tcPr>
                 </a:tc>
@@ -33149,370 +33485,34 @@
                   </a:txBody>
                   <a:tcPr marL="54864" marR="54864" marT="18288" marB="18288">
                     <a:solidFill>
-                      <a:srgbClr val="FFFFFF"/>
-                    </a:solidFill>
-                  </a:tcPr>
-                </a:tc>
-                <a:tc>
-                  <a:txBody>
-                    <a:bodyPr wrap="square"/>
-                    <a:lstStyle/>
-                    <a:p>
-                      <a:r>
-                        <a:rPr sz="1100" b="0">
-                          <a:solidFill>
-                            <a:srgbClr val="282828"/>
-                          </a:solidFill>
-                          <a:latin typeface="Arial"/>
-                        </a:rPr>
-                        <a:t>the test object; its surface is the measurand</a:t>
-                      </a:r>
-                    </a:p>
-                  </a:txBody>
-                  <a:tcPr marL="54864" marR="54864" marT="18288" marB="18288">
-                    <a:solidFill>
-                      <a:srgbClr val="FFFFFF"/>
+                      <a:srgbClr val="ECF1F6"/>
+                    </a:solidFill>
+                  </a:tcPr>
+                </a:tc>
+                <a:tc>
+                  <a:txBody>
+                    <a:bodyPr wrap="square"/>
+                    <a:lstStyle/>
+                    <a:p>
+                      <a:r>
+                        <a:rPr sz="1100" b="0">
+                          <a:solidFill>
+                            <a:srgbClr val="282828"/>
+                          </a:solidFill>
+                          <a:latin typeface="Arial"/>
+                        </a:rPr>
+                        <a:t>reimages the DM: 9.8 mm across on the 96 mm beam, 38 mm behind it</a:t>
+                      </a:r>
+                    </a:p>
+                  </a:txBody>
+                  <a:tcPr marL="54864" marR="54864" marT="18288" marB="18288">
+                    <a:solidFill>
+                      <a:srgbClr val="ECF1F6"/>
                     </a:solidFill>
                   </a:tcPr>
                 </a:tc>
               </a:tr>
-              <a:tr h="657225">
-                <a:tc>
-                  <a:txBody>
-                    <a:bodyPr wrap="square"/>
-                    <a:lstStyle/>
-                    <a:p>
-                      <a:r>
-                        <a:rPr sz="1100" b="0">
-                          <a:solidFill>
-                            <a:srgbClr val="282828"/>
-                          </a:solidFill>
-                          <a:latin typeface="Arial"/>
-                        </a:rPr>
-                        <a:t>focuser L2</a:t>
-                      </a:r>
-                    </a:p>
-                  </a:txBody>
-                  <a:tcPr marL="54864" marR="54864" marT="18288" marB="18288">
-                    <a:solidFill>
-                      <a:srgbClr val="ECF1F6"/>
-                    </a:solidFill>
-                  </a:tcPr>
-                </a:tc>
-                <a:tc>
-                  <a:txBody>
-                    <a:bodyPr wrap="square"/>
-                    <a:lstStyle/>
-                    <a:p>
-                      <a:r>
-                        <a:rPr sz="1100" b="0">
-                          <a:solidFill>
-                            <a:srgbClr val="282828"/>
-                          </a:solidFill>
-                          <a:latin typeface="Arial"/>
-                        </a:rPr>
-                        <a:t>f 429 mm, 103 mm, plano-convex conic; modeled 8 mm center</a:t>
-                      </a:r>
-                    </a:p>
-                  </a:txBody>
-                  <a:tcPr marL="54864" marR="54864" marT="18288" marB="18288">
-                    <a:solidFill>
-                      <a:srgbClr val="ECF1F6"/>
-                    </a:solidFill>
-                  </a:tcPr>
-                </a:tc>
-                <a:tc>
-                  <a:txBody>
-                    <a:bodyPr wrap="square"/>
-                    <a:lstStyle/>
-                    <a:p>
-                      <a:r>
-                        <a:rPr sz="1100" b="0">
-                          <a:solidFill>
-                            <a:srgbClr val="282828"/>
-                          </a:solidFill>
-                          <a:latin typeface="Arial"/>
-                        </a:rPr>
-                        <a:t>AR</a:t>
-                      </a:r>
-                    </a:p>
-                  </a:txBody>
-                  <a:tcPr marL="54864" marR="54864" marT="18288" marB="18288">
-                    <a:solidFill>
-                      <a:srgbClr val="ECF1F6"/>
-                    </a:solidFill>
-                  </a:tcPr>
-                </a:tc>
-                <a:tc>
-                  <a:txBody>
-                    <a:bodyPr wrap="square"/>
-                    <a:lstStyle/>
-                    <a:p>
-                      <a:r>
-                        <a:rPr sz="1100" b="0">
-                          <a:solidFill>
-                            <a:srgbClr val="282828"/>
-                          </a:solidFill>
-                          <a:latin typeface="Arial"/>
-                        </a:rPr>
-                        <a:t>1</a:t>
-                      </a:r>
-                    </a:p>
-                  </a:txBody>
-                  <a:tcPr marL="54864" marR="54864" marT="18288" marB="18288">
-                    <a:solidFill>
-                      <a:srgbClr val="ECF1F6"/>
-                    </a:solidFill>
-                  </a:tcPr>
-                </a:tc>
-                <a:tc>
-                  <a:txBody>
-                    <a:bodyPr wrap="square"/>
-                    <a:lstStyle/>
-                    <a:p>
-                      <a:r>
-                        <a:rPr sz="1100" b="0">
-                          <a:solidFill>
-                            <a:srgbClr val="282828"/>
-                          </a:solidFill>
-                          <a:latin typeface="Arial"/>
-                        </a:rPr>
-                        <a:t>the internal focus at F/4.2 where the masks sit</a:t>
-                      </a:r>
-                    </a:p>
-                  </a:txBody>
-                  <a:tcPr marL="54864" marR="54864" marT="18288" marB="18288">
-                    <a:solidFill>
-                      <a:srgbClr val="ECF1F6"/>
-                    </a:solidFill>
-                  </a:tcPr>
-                </a:tc>
-              </a:tr>
-              <a:tr h="657225">
-                <a:tc>
-                  <a:txBody>
-                    <a:bodyPr wrap="square"/>
-                    <a:lstStyle/>
-                    <a:p>
-                      <a:r>
-                        <a:rPr sz="1100" b="0">
-                          <a:solidFill>
-                            <a:srgbClr val="282828"/>
-                          </a:solidFill>
-                          <a:latin typeface="Arial"/>
-                        </a:rPr>
-                        <a:t>mask seat</a:t>
-                      </a:r>
-                    </a:p>
-                  </a:txBody>
-                  <a:tcPr marL="54864" marR="54864" marT="18288" marB="18288">
-                    <a:solidFill>
-                      <a:srgbClr val="FFFFFF"/>
-                    </a:solidFill>
-                  </a:tcPr>
-                </a:tc>
-                <a:tc>
-                  <a:txBody>
-                    <a:bodyPr wrap="square"/>
-                    <a:lstStyle/>
-                    <a:p>
-                      <a:r>
-                        <a:rPr sz="1100" b="0">
-                          <a:solidFill>
-                            <a:srgbClr val="282828"/>
-                          </a:solidFill>
-                          <a:latin typeface="Arial"/>
-                        </a:rPr>
-                        <a:t>translation stage at the internal focus</a:t>
-                      </a:r>
-                    </a:p>
-                  </a:txBody>
-                  <a:tcPr marL="54864" marR="54864" marT="18288" marB="18288">
-                    <a:solidFill>
-                      <a:srgbClr val="FFFFFF"/>
-                    </a:solidFill>
-                  </a:tcPr>
-                </a:tc>
-                <a:tc>
-                  <a:txBody>
-                    <a:bodyPr wrap="square"/>
-                    <a:lstStyle/>
-                    <a:p>
-                      <a:r>
-                        <a:rPr sz="1100" b="0">
-                          <a:solidFill>
-                            <a:srgbClr val="282828"/>
-                          </a:solidFill>
-                          <a:latin typeface="Arial"/>
-                        </a:rPr>
-                        <a:t>—</a:t>
-                      </a:r>
-                    </a:p>
-                  </a:txBody>
-                  <a:tcPr marL="54864" marR="54864" marT="18288" marB="18288">
-                    <a:solidFill>
-                      <a:srgbClr val="FFFFFF"/>
-                    </a:solidFill>
-                  </a:tcPr>
-                </a:tc>
-                <a:tc>
-                  <a:txBody>
-                    <a:bodyPr wrap="square"/>
-                    <a:lstStyle/>
-                    <a:p>
-                      <a:r>
-                        <a:rPr sz="1100" b="0">
-                          <a:solidFill>
-                            <a:srgbClr val="282828"/>
-                          </a:solidFill>
-                          <a:latin typeface="Arial"/>
-                        </a:rPr>
-                        <a:t>1</a:t>
-                      </a:r>
-                    </a:p>
-                  </a:txBody>
-                  <a:tcPr marL="54864" marR="54864" marT="18288" marB="18288">
-                    <a:solidFill>
-                      <a:srgbClr val="FFFFFF"/>
-                    </a:solidFill>
-                  </a:tcPr>
-                </a:tc>
-                <a:tc>
-                  <a:txBody>
-                    <a:bodyPr wrap="square"/>
-                    <a:lstStyle/>
-                    <a:p>
-                      <a:r>
-                        <a:rPr sz="1100" b="0">
-                          <a:solidFill>
-                            <a:srgbClr val="282828"/>
-                          </a:solidFill>
-                          <a:latin typeface="Arial"/>
-                        </a:rPr>
-                        <a:t>selects the sensor: clear window, dimple, metasurface, pinhole</a:t>
-                      </a:r>
-                    </a:p>
-                  </a:txBody>
-                  <a:tcPr marL="54864" marR="54864" marT="18288" marB="18288">
-                    <a:solidFill>
-                      <a:srgbClr val="FFFFFF"/>
-                    </a:solidFill>
-                  </a:tcPr>
-                </a:tc>
-              </a:tr>
-              <a:tr h="1034415">
-                <a:tc>
-                  <a:txBody>
-                    <a:bodyPr wrap="square"/>
-                    <a:lstStyle/>
-                    <a:p>
-                      <a:r>
-                        <a:rPr sz="1100" b="0">
-                          <a:solidFill>
-                            <a:srgbClr val="282828"/>
-                          </a:solidFill>
-                          <a:latin typeface="Arial"/>
-                        </a:rPr>
-                        <a:t>field lens</a:t>
-                      </a:r>
-                    </a:p>
-                  </a:txBody>
-                  <a:tcPr marL="54864" marR="54864" marT="18288" marB="18288">
-                    <a:solidFill>
-                      <a:srgbClr val="ECF1F6"/>
-                    </a:solidFill>
-                  </a:tcPr>
-                </a:tc>
-                <a:tc>
-                  <a:txBody>
-                    <a:bodyPr wrap="square"/>
-                    <a:lstStyle/>
-                    <a:p>
-                      <a:r>
-                        <a:rPr sz="1100" b="0">
-                          <a:solidFill>
-                            <a:srgbClr val="282828"/>
-                          </a:solidFill>
-                          <a:latin typeface="Arial"/>
-                        </a:rPr>
-                        <a:t>f 43 mm, 21 mm, at the seed station 10.8 mm past the focus (the null-tuned station 39.8 mm back bowled the pupil image; slide 15)</a:t>
-                      </a:r>
-                    </a:p>
-                  </a:txBody>
-                  <a:tcPr marL="54864" marR="54864" marT="18288" marB="18288">
-                    <a:solidFill>
-                      <a:srgbClr val="ECF1F6"/>
-                    </a:solidFill>
-                  </a:tcPr>
-                </a:tc>
-                <a:tc>
-                  <a:txBody>
-                    <a:bodyPr wrap="square"/>
-                    <a:lstStyle/>
-                    <a:p>
-                      <a:r>
-                        <a:rPr sz="1100" b="0">
-                          <a:solidFill>
-                            <a:srgbClr val="282828"/>
-                          </a:solidFill>
-                          <a:latin typeface="Arial"/>
-                        </a:rPr>
-                        <a:t>AR</a:t>
-                      </a:r>
-                    </a:p>
-                  </a:txBody>
-                  <a:tcPr marL="54864" marR="54864" marT="18288" marB="18288">
-                    <a:solidFill>
-                      <a:srgbClr val="ECF1F6"/>
-                    </a:solidFill>
-                  </a:tcPr>
-                </a:tc>
-                <a:tc>
-                  <a:txBody>
-                    <a:bodyPr wrap="square"/>
-                    <a:lstStyle/>
-                    <a:p>
-                      <a:r>
-                        <a:rPr sz="1100" b="0">
-                          <a:solidFill>
-                            <a:srgbClr val="282828"/>
-                          </a:solidFill>
-                          <a:latin typeface="Arial"/>
-                        </a:rPr>
-                        <a:t>1</a:t>
-                      </a:r>
-                    </a:p>
-                  </a:txBody>
-                  <a:tcPr marL="54864" marR="54864" marT="18288" marB="18288">
-                    <a:solidFill>
-                      <a:srgbClr val="ECF1F6"/>
-                    </a:solidFill>
-                  </a:tcPr>
-                </a:tc>
-                <a:tc>
-                  <a:txBody>
-                    <a:bodyPr wrap="square"/>
-                    <a:lstStyle/>
-                    <a:p>
-                      <a:r>
-                        <a:rPr sz="1100" b="0">
-                          <a:solidFill>
-                            <a:srgbClr val="282828"/>
-                          </a:solidFill>
-                          <a:latin typeface="Arial"/>
-                        </a:rPr>
-                        <a:t>reimages the DM, 9.8 mm across on the full 96 mm beam (7.8 mm on the record's 77 mm beam), 38 mm behind it</a:t>
-                      </a:r>
-                    </a:p>
-                  </a:txBody>
-                  <a:tcPr marL="54864" marR="54864" marT="18288" marB="18288">
-                    <a:solidFill>
-                      <a:srgbClr val="ECF1F6"/>
-                    </a:solidFill>
-                  </a:tcPr>
-                </a:tc>
-              </a:tr>
-              <a:tr h="657225">
+              <a:tr h="468630">
                 <a:tc>
                   <a:txBody>
                     <a:bodyPr wrap="square"/>
@@ -33547,7 +33547,7 @@
                           </a:solidFill>
                           <a:latin typeface="Arial"/>
                         </a:rPr>
-                        <a:t>sCMOS 2048×2048, 6.5 µm: 1500 raw pixels across the 9.8 mm pupil image, binned 4 to 377 (26 µm); or a 24 µm-pixel camera unbinned (408 across); both to be priced by the runner</a:t>
+                        <a:t>sCMOS 2048×2048, 6.5 µm, binned 4 to 377 px across the 9.8 mm image; or a 24 µm-pixel camera unbinned (408)</a:t>
                       </a:r>
                     </a:p>
                   </a:txBody>
@@ -33748,7 +33748,7 @@
         </p:nvSpPr>
         <p:spPr>
           <a:xfrm>
-            <a:off x="411480" y="8674227"/>
+            <a:off x="411480" y="6976872"/>
             <a:ext cx="11368735" cy="274320"/>
           </a:xfrm>
           <a:prstGeom prst="rect">

</xml_diff>

<commit_message>
Mac cycle 3a folded: backup slide (substrates in, full beam, seed tail: the lens rig's 92 nm null and broken grid row = the case for package A; the mirror rig holds), brief section 7, slice
Co-Authored-By: Claude Fable 5.1 <noreply@anthropic.com>
</commit_message>
<xml_diff>
--- a/demo_session/deck_gauges.pptx
+++ b/demo_session/deck_gauges.pptx
@@ -58,6 +58,7 @@
     <p:sldId id="306" r:id="rId57"/>
     <p:sldId id="307" r:id="rId58"/>
     <p:sldId id="308" r:id="rId59"/>
+    <p:sldId id="309" r:id="rId60"/>
   </p:sldIdLst>
   <p:sldSz cx="12191695" cy="6858000" type="screen4x3"/>
   <p:notesSz cx="6858000" cy="9144000"/>
@@ -25483,6 +25484,785 @@
                 </a:solidFill>
                 <a:latin typeface="Arial"/>
               </a:rPr>
+              <a:t>Backup: the substrates in, the full beam, the seed tail (Mac cycle 3a, 2026-09-17)</a:t>
+            </a:r>
+          </a:p>
+          <a:p>
+            <a:pPr>
+              <a:spcAft>
+                <a:spcPts val="0"/>
+              </a:spcAft>
+            </a:pPr>
+            <a:r>
+              <a:rPr sz="1250" b="0">
+                <a:solidFill>
+                  <a:srgbClr val="6E6E6E"/>
+                </a:solidFill>
+                <a:latin typeface="Arial"/>
+              </a:rPr>
+              <a:t>On the bench as it will be built but before the collimator fix, the mirror rig reads; the lens rig's flat null grows to 92 nm on the record's misfed collimator and the multi-site row breaks, which is the redo's package A in one number</a:t>
+            </a:r>
+          </a:p>
+        </p:txBody>
+      </p:sp>
+      <p:sp>
+        <p:nvSpPr>
+          <p:cNvPr id="3" name="Rectangle 2"/>
+          <p:cNvSpPr/>
+          <p:nvPr/>
+        </p:nvSpPr>
+        <p:spPr>
+          <a:xfrm>
+            <a:off x="411480" y="1133856"/>
+            <a:ext cx="11368735" cy="20320"/>
+          </a:xfrm>
+          <a:prstGeom prst="rect">
+            <a:avLst/>
+          </a:prstGeom>
+          <a:solidFill>
+            <a:srgbClr val="B8C6D4"/>
+          </a:solidFill>
+          <a:ln>
+            <a:noFill/>
+          </a:ln>
+          <a:effectLst/>
+        </p:spPr>
+        <p:style>
+          <a:lnRef idx="1">
+            <a:schemeClr val="accent1"/>
+          </a:lnRef>
+          <a:fillRef idx="3">
+            <a:schemeClr val="accent1"/>
+          </a:fillRef>
+          <a:effectRef idx="2">
+            <a:schemeClr val="accent1"/>
+          </a:effectRef>
+          <a:fontRef idx="minor">
+            <a:schemeClr val="lt1"/>
+          </a:fontRef>
+        </p:style>
+        <p:txBody>
+          <a:bodyPr rtlCol="0" anchor="ctr"/>
+          <a:lstStyle/>
+          <a:p>
+            <a:pPr algn="ctr"/>
+          </a:p>
+        </p:txBody>
+      </p:sp>
+      <p:graphicFrame>
+        <p:nvGraphicFramePr>
+          <p:cNvPr id="4" name="Table 3"/>
+          <p:cNvGraphicFramePr>
+            <a:graphicFrameLocks noGrp="1"/>
+          </p:cNvGraphicFramePr>
+          <p:nvPr/>
+        </p:nvGraphicFramePr>
+        <p:xfrm>
+          <a:off x="411480" y="1298448"/>
+          <a:ext cx="11368733" cy="2057400"/>
+        </p:xfrm>
+        <a:graphic>
+          <a:graphicData uri="http://schemas.openxmlformats.org/drawingml/2006/table">
+            <a:tbl>
+              <a:tblPr firstRow="1" bandRow="1">
+                <a:tableStyleId>{5C22544A-7EE6-4342-B048-85BDC9FD1C3A}</a:tableStyleId>
+              </a:tblPr>
+              <a:tblGrid>
+                <a:gridCol w="3100564"/>
+                <a:gridCol w="2735791"/>
+                <a:gridCol w="2188633"/>
+                <a:gridCol w="3343745"/>
+              </a:tblGrid>
+              <a:tr h="468630">
+                <a:tc>
+                  <a:txBody>
+                    <a:bodyPr wrap="square"/>
+                    <a:lstStyle/>
+                    <a:p>
+                      <a:r>
+                        <a:rPr sz="1100" b="1">
+                          <a:solidFill>
+                            <a:srgbClr val="FFFFFF"/>
+                          </a:solidFill>
+                          <a:latin typeface="Arial"/>
+                        </a:rPr>
+                        <a:t>rows on the 30 nm surface, matrix on it (four-step)</a:t>
+                      </a:r>
+                    </a:p>
+                  </a:txBody>
+                  <a:tcPr marL="54864" marR="54864" marT="18288" marB="18288">
+                    <a:solidFill>
+                      <a:srgbClr val="1F4E79"/>
+                    </a:solidFill>
+                  </a:tcPr>
+                </a:tc>
+                <a:tc>
+                  <a:txBody>
+                    <a:bodyPr wrap="square"/>
+                    <a:lstStyle/>
+                    <a:p>
+                      <a:r>
+                        <a:rPr sz="1100" b="1">
+                          <a:solidFill>
+                            <a:srgbClr val="FFFFFF"/>
+                          </a:solidFill>
+                          <a:latin typeface="Arial"/>
+                        </a:rPr>
+                        <a:t>lens rig, seed tail, substrates in</a:t>
+                      </a:r>
+                    </a:p>
+                  </a:txBody>
+                  <a:tcPr marL="54864" marR="54864" marT="18288" marB="18288">
+                    <a:solidFill>
+                      <a:srgbClr val="1F4E79"/>
+                    </a:solidFill>
+                  </a:tcPr>
+                </a:tc>
+                <a:tc>
+                  <a:txBody>
+                    <a:bodyPr wrap="square"/>
+                    <a:lstStyle/>
+                    <a:p>
+                      <a:r>
+                        <a:rPr sz="1100" b="1">
+                          <a:solidFill>
+                            <a:srgbClr val="FFFFFF"/>
+                          </a:solidFill>
+                          <a:latin typeface="Arial"/>
+                        </a:rPr>
+                        <a:t>mirror rig, seed tail, substrates in</a:t>
+                      </a:r>
+                    </a:p>
+                  </a:txBody>
+                  <a:tcPr marL="54864" marR="54864" marT="18288" marB="18288">
+                    <a:solidFill>
+                      <a:srgbClr val="1F4E79"/>
+                    </a:solidFill>
+                  </a:tcPr>
+                </a:tc>
+                <a:tc>
+                  <a:txBody>
+                    <a:bodyPr wrap="square"/>
+                    <a:lstStyle/>
+                    <a:p>
+                      <a:r>
+                        <a:rPr sz="1100" b="1">
+                          <a:solidFill>
+                            <a:srgbClr val="FFFFFF"/>
+                          </a:solidFill>
+                          <a:latin typeface="Arial"/>
+                        </a:rPr>
+                        <a:t>the record (tuned tail, no substrates, 77 / 82 mm beam)</a:t>
+                      </a:r>
+                    </a:p>
+                  </a:txBody>
+                  <a:tcPr marL="54864" marR="54864" marT="18288" marB="18288">
+                    <a:solidFill>
+                      <a:srgbClr val="1F4E79"/>
+                    </a:solidFill>
+                  </a:tcPr>
+                </a:tc>
+              </a:tr>
+              <a:tr h="280035">
+                <a:tc>
+                  <a:txBody>
+                    <a:bodyPr wrap="square"/>
+                    <a:lstStyle/>
+                    <a:p>
+                      <a:r>
+                        <a:rPr sz="1100" b="0">
+                          <a:solidFill>
+                            <a:srgbClr val="282828"/>
+                          </a:solidFill>
+                          <a:latin typeface="Arial"/>
+                        </a:rPr>
+                        <a:t>flat-mirror null</a:t>
+                      </a:r>
+                    </a:p>
+                  </a:txBody>
+                  <a:tcPr marL="54864" marR="54864" marT="18288" marB="18288">
+                    <a:solidFill>
+                      <a:srgbClr val="FFFFFF"/>
+                    </a:solidFill>
+                  </a:tcPr>
+                </a:tc>
+                <a:tc>
+                  <a:txBody>
+                    <a:bodyPr wrap="square"/>
+                    <a:lstStyle/>
+                    <a:p>
+                      <a:r>
+                        <a:rPr sz="1100" b="0">
+                          <a:solidFill>
+                            <a:srgbClr val="282828"/>
+                          </a:solidFill>
+                          <a:latin typeface="Arial"/>
+                        </a:rPr>
+                        <a:t>92.4 nm rms</a:t>
+                      </a:r>
+                    </a:p>
+                  </a:txBody>
+                  <a:tcPr marL="54864" marR="54864" marT="18288" marB="18288">
+                    <a:solidFill>
+                      <a:srgbClr val="FFFFFF"/>
+                    </a:solidFill>
+                  </a:tcPr>
+                </a:tc>
+                <a:tc>
+                  <a:txBody>
+                    <a:bodyPr wrap="square"/>
+                    <a:lstStyle/>
+                    <a:p>
+                      <a:r>
+                        <a:rPr sz="1100" b="0">
+                          <a:solidFill>
+                            <a:srgbClr val="282828"/>
+                          </a:solidFill>
+                          <a:latin typeface="Arial"/>
+                        </a:rPr>
+                        <a:t>26.3 nm</a:t>
+                      </a:r>
+                    </a:p>
+                  </a:txBody>
+                  <a:tcPr marL="54864" marR="54864" marT="18288" marB="18288">
+                    <a:solidFill>
+                      <a:srgbClr val="FFFFFF"/>
+                    </a:solidFill>
+                  </a:tcPr>
+                </a:tc>
+                <a:tc>
+                  <a:txBody>
+                    <a:bodyPr wrap="square"/>
+                    <a:lstStyle/>
+                    <a:p>
+                      <a:r>
+                        <a:rPr sz="1100" b="0">
+                          <a:solidFill>
+                            <a:srgbClr val="282828"/>
+                          </a:solidFill>
+                          <a:latin typeface="Arial"/>
+                        </a:rPr>
+                        <a:t>0.13 nm lens / 0.03 mirrors</a:t>
+                      </a:r>
+                    </a:p>
+                  </a:txBody>
+                  <a:tcPr marL="54864" marR="54864" marT="18288" marB="18288">
+                    <a:solidFill>
+                      <a:srgbClr val="FFFFFF"/>
+                    </a:solidFill>
+                  </a:tcPr>
+                </a:tc>
+              </a:tr>
+              <a:tr h="280035">
+                <a:tc>
+                  <a:txBody>
+                    <a:bodyPr wrap="square"/>
+                    <a:lstStyle/>
+                    <a:p>
+                      <a:r>
+                        <a:rPr sz="1100" b="0">
+                          <a:solidFill>
+                            <a:srgbClr val="282828"/>
+                          </a:solidFill>
+                          <a:latin typeface="Arial"/>
+                        </a:rPr>
+                        <a:t>10 nm on one actuator: gain / error / SNR</a:t>
+                      </a:r>
+                    </a:p>
+                  </a:txBody>
+                  <a:tcPr marL="54864" marR="54864" marT="18288" marB="18288">
+                    <a:solidFill>
+                      <a:srgbClr val="ECF1F6"/>
+                    </a:solidFill>
+                  </a:tcPr>
+                </a:tc>
+                <a:tc>
+                  <a:txBody>
+                    <a:bodyPr wrap="square"/>
+                    <a:lstStyle/>
+                    <a:p>
+                      <a:r>
+                        <a:rPr sz="1100" b="0">
+                          <a:solidFill>
+                            <a:srgbClr val="282828"/>
+                          </a:solidFill>
+                          <a:latin typeface="Arial"/>
+                        </a:rPr>
+                        <a:t>1.003 / 1 pm / 10645</a:t>
+                      </a:r>
+                    </a:p>
+                  </a:txBody>
+                  <a:tcPr marL="54864" marR="54864" marT="18288" marB="18288">
+                    <a:solidFill>
+                      <a:srgbClr val="ECF1F6"/>
+                    </a:solidFill>
+                  </a:tcPr>
+                </a:tc>
+                <a:tc>
+                  <a:txBody>
+                    <a:bodyPr wrap="square"/>
+                    <a:lstStyle/>
+                    <a:p>
+                      <a:r>
+                        <a:rPr sz="1100" b="0">
+                          <a:solidFill>
+                            <a:srgbClr val="282828"/>
+                          </a:solidFill>
+                          <a:latin typeface="Arial"/>
+                        </a:rPr>
+                        <a:t>0.986 / 2.2 pm / 6472</a:t>
+                      </a:r>
+                    </a:p>
+                  </a:txBody>
+                  <a:tcPr marL="54864" marR="54864" marT="18288" marB="18288">
+                    <a:solidFill>
+                      <a:srgbClr val="ECF1F6"/>
+                    </a:solidFill>
+                  </a:tcPr>
+                </a:tc>
+                <a:tc>
+                  <a:txBody>
+                    <a:bodyPr wrap="square"/>
+                    <a:lstStyle/>
+                    <a:p>
+                      <a:r>
+                        <a:rPr sz="1100" b="0">
+                          <a:solidFill>
+                            <a:srgbClr val="282828"/>
+                          </a:solidFill>
+                          <a:latin typeface="Arial"/>
+                        </a:rPr>
+                        <a:t>0.992 / 2.2 pm (lens), 0.992 / 2.4 (mirrors)</a:t>
+                      </a:r>
+                    </a:p>
+                  </a:txBody>
+                  <a:tcPr marL="54864" marR="54864" marT="18288" marB="18288">
+                    <a:solidFill>
+                      <a:srgbClr val="ECF1F6"/>
+                    </a:solidFill>
+                  </a:tcPr>
+                </a:tc>
+              </a:tr>
+              <a:tr h="280035">
+                <a:tc>
+                  <a:txBody>
+                    <a:bodyPr wrap="square"/>
+                    <a:lstStyle/>
+                    <a:p>
+                      <a:r>
+                        <a:rPr sz="1100" b="0">
+                          <a:solidFill>
+                            <a:srgbClr val="282828"/>
+                          </a:solidFill>
+                          <a:latin typeface="Arial"/>
+                        </a:rPr>
+                        <a:t>1 nm on a 112-site grid</a:t>
+                      </a:r>
+                    </a:p>
+                  </a:txBody>
+                  <a:tcPr marL="54864" marR="54864" marT="18288" marB="18288">
+                    <a:solidFill>
+                      <a:srgbClr val="FFFFFF"/>
+                    </a:solidFill>
+                  </a:tcPr>
+                </a:tc>
+                <a:tc>
+                  <a:txBody>
+                    <a:bodyPr wrap="square"/>
+                    <a:lstStyle/>
+                    <a:p>
+                      <a:r>
+                        <a:rPr sz="1100" b="0">
+                          <a:solidFill>
+                            <a:srgbClr val="282828"/>
+                          </a:solidFill>
+                          <a:latin typeface="Arial"/>
+                        </a:rPr>
+                        <a:t>0.754 / 61.5 pm / 135</a:t>
+                      </a:r>
+                    </a:p>
+                  </a:txBody>
+                  <a:tcPr marL="54864" marR="54864" marT="18288" marB="18288">
+                    <a:solidFill>
+                      <a:srgbClr val="FFFFFF"/>
+                    </a:solidFill>
+                  </a:tcPr>
+                </a:tc>
+                <a:tc>
+                  <a:txBody>
+                    <a:bodyPr wrap="square"/>
+                    <a:lstStyle/>
+                    <a:p>
+                      <a:r>
+                        <a:rPr sz="1100" b="0">
+                          <a:solidFill>
+                            <a:srgbClr val="282828"/>
+                          </a:solidFill>
+                          <a:latin typeface="Arial"/>
+                        </a:rPr>
+                        <a:t>0.981 / 4.5 pm / 309</a:t>
+                      </a:r>
+                    </a:p>
+                  </a:txBody>
+                  <a:tcPr marL="54864" marR="54864" marT="18288" marB="18288">
+                    <a:solidFill>
+                      <a:srgbClr val="FFFFFF"/>
+                    </a:solidFill>
+                  </a:tcPr>
+                </a:tc>
+                <a:tc>
+                  <a:txBody>
+                    <a:bodyPr wrap="square"/>
+                    <a:lstStyle/>
+                    <a:p>
+                      <a:r>
+                        <a:rPr sz="1100" b="0">
+                          <a:solidFill>
+                            <a:srgbClr val="282828"/>
+                          </a:solidFill>
+                          <a:latin typeface="Arial"/>
+                        </a:rPr>
+                        <a:t>0.999 / 4 pm</a:t>
+                      </a:r>
+                    </a:p>
+                  </a:txBody>
+                  <a:tcPr marL="54864" marR="54864" marT="18288" marB="18288">
+                    <a:solidFill>
+                      <a:srgbClr val="FFFFFF"/>
+                    </a:solidFill>
+                  </a:tcPr>
+                </a:tc>
+              </a:tr>
+              <a:tr h="468630">
+                <a:tc>
+                  <a:txBody>
+                    <a:bodyPr wrap="square"/>
+                    <a:lstStyle/>
+                    <a:p>
+                      <a:r>
+                        <a:rPr sz="1100" b="0">
+                          <a:solidFill>
+                            <a:srgbClr val="282828"/>
+                          </a:solidFill>
+                          <a:latin typeface="Arial"/>
+                        </a:rPr>
+                        <a:t>capture to 10%, single site / grid</a:t>
+                      </a:r>
+                    </a:p>
+                  </a:txBody>
+                  <a:tcPr marL="54864" marR="54864" marT="18288" marB="18288">
+                    <a:solidFill>
+                      <a:srgbClr val="ECF1F6"/>
+                    </a:solidFill>
+                  </a:tcPr>
+                </a:tc>
+                <a:tc>
+                  <a:txBody>
+                    <a:bodyPr wrap="square"/>
+                    <a:lstStyle/>
+                    <a:p>
+                      <a:r>
+                        <a:rPr sz="1100" b="0">
+                          <a:solidFill>
+                            <a:srgbClr val="282828"/>
+                          </a:solidFill>
+                          <a:latin typeface="Arial"/>
+                        </a:rPr>
+                        <a:t>480 nm and beyond / outside at the first rung</a:t>
+                      </a:r>
+                    </a:p>
+                  </a:txBody>
+                  <a:tcPr marL="54864" marR="54864" marT="18288" marB="18288">
+                    <a:solidFill>
+                      <a:srgbClr val="ECF1F6"/>
+                    </a:solidFill>
+                  </a:tcPr>
+                </a:tc>
+                <a:tc>
+                  <a:txBody>
+                    <a:bodyPr wrap="square"/>
+                    <a:lstStyle/>
+                    <a:p>
+                      <a:r>
+                        <a:rPr sz="1100" b="0">
+                          <a:solidFill>
+                            <a:srgbClr val="282828"/>
+                          </a:solidFill>
+                          <a:latin typeface="Arial"/>
+                        </a:rPr>
+                        <a:t>480 and beyond / 480 and beyond</a:t>
+                      </a:r>
+                    </a:p>
+                  </a:txBody>
+                  <a:tcPr marL="54864" marR="54864" marT="18288" marB="18288">
+                    <a:solidFill>
+                      <a:srgbClr val="ECF1F6"/>
+                    </a:solidFill>
+                  </a:tcPr>
+                </a:tc>
+                <a:tc>
+                  <a:txBody>
+                    <a:bodyPr wrap="square"/>
+                    <a:lstStyle/>
+                    <a:p>
+                      <a:r>
+                        <a:rPr sz="1100" b="0">
+                          <a:solidFill>
+                            <a:srgbClr val="282828"/>
+                          </a:solidFill>
+                          <a:latin typeface="Arial"/>
+                        </a:rPr>
+                        <a:t>322 / 480 and beyond</a:t>
+                      </a:r>
+                    </a:p>
+                  </a:txBody>
+                  <a:tcPr marL="54864" marR="54864" marT="18288" marB="18288">
+                    <a:solidFill>
+                      <a:srgbClr val="ECF1F6"/>
+                    </a:solidFill>
+                  </a:tcPr>
+                </a:tc>
+              </a:tr>
+              <a:tr h="280035">
+                <a:tc>
+                  <a:txBody>
+                    <a:bodyPr wrap="square"/>
+                    <a:lstStyle/>
+                    <a:p>
+                      <a:r>
+                        <a:rPr sz="1100" b="0">
+                          <a:solidFill>
+                            <a:srgbClr val="282828"/>
+                          </a:solidFill>
+                          <a:latin typeface="Arial"/>
+                        </a:rPr>
+                        <a:t>pupil image on the 96 mm beam</a:t>
+                      </a:r>
+                    </a:p>
+                  </a:txBody>
+                  <a:tcPr marL="54864" marR="54864" marT="18288" marB="18288">
+                    <a:solidFill>
+                      <a:srgbClr val="FFFFFF"/>
+                    </a:solidFill>
+                  </a:tcPr>
+                </a:tc>
+                <a:tc>
+                  <a:txBody>
+                    <a:bodyPr wrap="square"/>
+                    <a:lstStyle/>
+                    <a:p>
+                      <a:r>
+                        <a:rPr sz="1100" b="0">
+                          <a:solidFill>
+                            <a:srgbClr val="282828"/>
+                          </a:solidFill>
+                          <a:latin typeface="Arial"/>
+                        </a:rPr>
+                        <a:t>9.5 mm (341 px)</a:t>
+                      </a:r>
+                    </a:p>
+                  </a:txBody>
+                  <a:tcPr marL="54864" marR="54864" marT="18288" marB="18288">
+                    <a:solidFill>
+                      <a:srgbClr val="FFFFFF"/>
+                    </a:solidFill>
+                  </a:tcPr>
+                </a:tc>
+                <a:tc>
+                  <a:txBody>
+                    <a:bodyPr wrap="square"/>
+                    <a:lstStyle/>
+                    <a:p>
+                      <a:r>
+                        <a:rPr sz="1100" b="0">
+                          <a:solidFill>
+                            <a:srgbClr val="282828"/>
+                          </a:solidFill>
+                          <a:latin typeface="Arial"/>
+                        </a:rPr>
+                        <a:t>11.1 mm (384 px)</a:t>
+                      </a:r>
+                    </a:p>
+                  </a:txBody>
+                  <a:tcPr marL="54864" marR="54864" marT="18288" marB="18288">
+                    <a:solidFill>
+                      <a:srgbClr val="FFFFFF"/>
+                    </a:solidFill>
+                  </a:tcPr>
+                </a:tc>
+                <a:tc>
+                  <a:txBody>
+                    <a:bodyPr wrap="square"/>
+                    <a:lstStyle/>
+                    <a:p>
+                      <a:r>
+                        <a:rPr sz="1100" b="0">
+                          <a:solidFill>
+                            <a:srgbClr val="282828"/>
+                          </a:solidFill>
+                          <a:latin typeface="Arial"/>
+                        </a:rPr>
+                        <a:t>7.8 / 8.0 mm</a:t>
+                      </a:r>
+                    </a:p>
+                  </a:txBody>
+                  <a:tcPr marL="54864" marR="54864" marT="18288" marB="18288">
+                    <a:solidFill>
+                      <a:srgbClr val="FFFFFF"/>
+                    </a:solidFill>
+                  </a:tcPr>
+                </a:tc>
+              </a:tr>
+            </a:tbl>
+          </a:graphicData>
+        </a:graphic>
+      </p:graphicFrame>
+      <p:sp>
+        <p:nvSpPr>
+          <p:cNvPr id="5" name="TextBox 4"/>
+          <p:cNvSpPr txBox="1"/>
+          <p:nvPr/>
+        </p:nvSpPr>
+        <p:spPr>
+          <a:xfrm>
+            <a:off x="411480" y="3502152"/>
+            <a:ext cx="11368735" cy="274320"/>
+          </a:xfrm>
+          <a:prstGeom prst="rect">
+            <a:avLst/>
+          </a:prstGeom>
+          <a:noFill/>
+        </p:spPr>
+        <p:txBody>
+          <a:bodyPr wrap="square">
+            <a:spAutoFit/>
+          </a:bodyPr>
+          <a:lstStyle/>
+          <a:p>
+            <a:pPr>
+              <a:spcAft>
+                <a:spcPts val="600"/>
+              </a:spcAft>
+            </a:pPr>
+            <a:r>
+              <a:rPr sz="1500" b="0">
+                <a:solidFill>
+                  <a:srgbClr val="282828"/>
+                </a:solidFill>
+                <a:latin typeface="Arial"/>
+              </a:rPr>
+              <a:t>•  Read it as the redo's justification: with the 10 mm plates and the 2 mm windows in, the seed tail's null on the lens rig's misfed collimator reaches 92 nm, a third of a wave of wavefront, and the 112-site row at 1 nm falls to 0.75 through the fold, while one actuator still reads to 1 pm.  Package A (the collimator at its focus, the tail tuned on the reading) is what restores it; the mirror rig, already fed at its focus, holds its rows at 0.98 to 0.99 with a 26 nm fixed-pattern null the reference frame removes.</a:t>
+            </a:r>
+          </a:p>
+          <a:p>
+            <a:pPr>
+              <a:spcAft>
+                <a:spcPts val="600"/>
+              </a:spcAft>
+            </a:pPr>
+            <a:r>
+              <a:rPr sz="1500" b="0">
+                <a:solidFill>
+                  <a:srgbClr val="282828"/>
+                </a:solidFill>
+                <a:latin typeface="Arial"/>
+              </a:rPr>
+              <a:t>•  One clearance line moved: with the thicker plates and the larger beam the compensator sits 16 mm from the source beam against the 25 mm rule; it moves down the DM leg in the redo.</a:t>
+            </a:r>
+          </a:p>
+        </p:txBody>
+      </p:sp>
+      <p:sp>
+        <p:nvSpPr>
+          <p:cNvPr id="6" name="TextBox 5"/>
+          <p:cNvSpPr txBox="1"/>
+          <p:nvPr/>
+        </p:nvSpPr>
+        <p:spPr>
+          <a:xfrm>
+            <a:off x="411480" y="5552694"/>
+            <a:ext cx="11368735" cy="274320"/>
+          </a:xfrm>
+          <a:prstGeom prst="rect">
+            <a:avLst/>
+          </a:prstGeom>
+          <a:noFill/>
+        </p:spPr>
+        <p:txBody>
+          <a:bodyPr wrap="square">
+            <a:spAutoFit/>
+          </a:bodyPr>
+          <a:lstStyle/>
+          <a:p>
+            <a:pPr>
+              <a:spcAft>
+                <a:spcPts val="600"/>
+              </a:spcAft>
+            </a:pPr>
+            <a:r>
+              <a:rPr sz="1050" b="0">
+                <a:solidFill>
+                  <a:srgbClr val="6E6E6E"/>
+                </a:solidFill>
+                <a:latin typeface="Arial"/>
+              </a:rPr>
+              <a:t>Run tags sub96_lens, sub96_oap (the Mac, RUNBOOK_mac_cycle3a); the pupil stage and the sensors at 385 on these decks follow.</a:t>
+            </a:r>
+          </a:p>
+        </p:txBody>
+      </p:sp>
+    </p:spTree>
+  </p:cSld>
+  <p:clrMapOvr>
+    <a:masterClrMapping/>
+  </p:clrMapOvr>
+</p:sld>
+</file>
+
+<file path=ppt/slides/slide46.xml><?xml version="1.0" encoding="utf-8"?>
+<p:sld xmlns:a="http://schemas.openxmlformats.org/drawingml/2006/main" xmlns:p="http://schemas.openxmlformats.org/presentationml/2006/main" xmlns:r="http://schemas.openxmlformats.org/officeDocument/2006/relationships">
+  <p:cSld>
+    <p:spTree>
+      <p:nvGrpSpPr>
+        <p:cNvPr id="1" name=""/>
+        <p:cNvGrpSpPr/>
+        <p:nvPr/>
+      </p:nvGrpSpPr>
+      <p:grpSpPr/>
+      <p:sp>
+        <p:nvSpPr>
+          <p:cNvPr id="2" name="TextBox 1"/>
+          <p:cNvSpPr txBox="1"/>
+          <p:nvPr/>
+        </p:nvSpPr>
+        <p:spPr>
+          <a:xfrm>
+            <a:off x="411480" y="201168"/>
+            <a:ext cx="11368735" cy="914400"/>
+          </a:xfrm>
+          <a:prstGeom prst="rect">
+            <a:avLst/>
+          </a:prstGeom>
+          <a:noFill/>
+        </p:spPr>
+        <p:txBody>
+          <a:bodyPr wrap="square">
+            <a:spAutoFit/>
+          </a:bodyPr>
+          <a:lstStyle/>
+          <a:p>
+            <a:pPr>
+              <a:spcAft>
+                <a:spcPts val="400"/>
+              </a:spcAft>
+            </a:pPr>
+            <a:r>
+              <a:rPr sz="2400" b="1">
+                <a:solidFill>
+                  <a:srgbClr val="1F4E79"/>
+                </a:solidFill>
+                <a:latin typeface="Arial"/>
+              </a:rPr>
               <a:t>Backup: the interferometer on the mirror rig</a:t>
             </a:r>
           </a:p>
@@ -26287,7 +27067,7 @@
 </p:sld>
 </file>
 
-<file path=ppt/slides/slide46.xml><?xml version="1.0" encoding="utf-8"?>
+<file path=ppt/slides/slide47.xml><?xml version="1.0" encoding="utf-8"?>
 <p:sld xmlns:a="http://schemas.openxmlformats.org/drawingml/2006/main" xmlns:p="http://schemas.openxmlformats.org/presentationml/2006/main" xmlns:r="http://schemas.openxmlformats.org/officeDocument/2006/relationships">
   <p:cSld>
     <p:spTree>
@@ -26577,7 +27357,7 @@
 </p:sld>
 </file>
 
-<file path=ppt/slides/slide47.xml><?xml version="1.0" encoding="utf-8"?>
+<file path=ppt/slides/slide48.xml><?xml version="1.0" encoding="utf-8"?>
 <p:sld xmlns:a="http://schemas.openxmlformats.org/drawingml/2006/main" xmlns:p="http://schemas.openxmlformats.org/presentationml/2006/main" xmlns:r="http://schemas.openxmlformats.org/officeDocument/2006/relationships">
   <p:cSld>
     <p:spTree>
@@ -27433,7 +28213,7 @@
 </p:sld>
 </file>
 
-<file path=ppt/slides/slide48.xml><?xml version="1.0" encoding="utf-8"?>
+<file path=ppt/slides/slide49.xml><?xml version="1.0" encoding="utf-8"?>
 <p:sld xmlns:a="http://schemas.openxmlformats.org/drawingml/2006/main" xmlns:p="http://schemas.openxmlformats.org/presentationml/2006/main" xmlns:r="http://schemas.openxmlformats.org/officeDocument/2006/relationships">
   <p:cSld>
     <p:spTree>
@@ -28482,668 +29262,6 @@
                 <a:latin typeface="Arial"/>
               </a:rPr>
               <a:t>Run tags intra193_0, intra193, pcam193, pcam193r, pcam193ri, rw193_1e3/1e2/1e1, loop_lens_intra, loop_lens_cam.</a:t>
-            </a:r>
-          </a:p>
-        </p:txBody>
-      </p:sp>
-    </p:spTree>
-  </p:cSld>
-  <p:clrMapOvr>
-    <a:masterClrMapping/>
-  </p:clrMapOvr>
-</p:sld>
-</file>
-
-<file path=ppt/slides/slide49.xml><?xml version="1.0" encoding="utf-8"?>
-<p:sld xmlns:a="http://schemas.openxmlformats.org/drawingml/2006/main" xmlns:p="http://schemas.openxmlformats.org/presentationml/2006/main" xmlns:r="http://schemas.openxmlformats.org/officeDocument/2006/relationships">
-  <p:cSld>
-    <p:spTree>
-      <p:nvGrpSpPr>
-        <p:cNvPr id="1" name=""/>
-        <p:cNvGrpSpPr/>
-        <p:nvPr/>
-      </p:nvGrpSpPr>
-      <p:grpSpPr/>
-      <p:sp>
-        <p:nvSpPr>
-          <p:cNvPr id="2" name="TextBox 1"/>
-          <p:cNvSpPr txBox="1"/>
-          <p:nvPr/>
-        </p:nvSpPr>
-        <p:spPr>
-          <a:xfrm>
-            <a:off x="411480" y="201168"/>
-            <a:ext cx="11368735" cy="914400"/>
-          </a:xfrm>
-          <a:prstGeom prst="rect">
-            <a:avLst/>
-          </a:prstGeom>
-          <a:noFill/>
-        </p:spPr>
-        <p:txBody>
-          <a:bodyPr wrap="square">
-            <a:spAutoFit/>
-          </a:bodyPr>
-          <a:lstStyle/>
-          <a:p>
-            <a:pPr>
-              <a:spcAft>
-                <a:spcPts val="400"/>
-              </a:spcAft>
-            </a:pPr>
-            <a:r>
-              <a:rPr sz="2400" b="1">
-                <a:solidFill>
-                  <a:srgbClr val="1F4E79"/>
-                </a:solidFill>
-                <a:latin typeface="Arial"/>
-              </a:rPr>
-              <a:t>Backup: the vector sensor's polarization terms</a:t>
-            </a:r>
-          </a:p>
-          <a:p>
-            <a:pPr>
-              <a:spcAft>
-                <a:spcPts val="0"/>
-              </a:spcAft>
-            </a:pPr>
-            <a:r>
-              <a:rPr sz="1250" b="0">
-                <a:solidFill>
-                  <a:srgbClr val="6E6E6E"/>
-                </a:solidFill>
-                <a:latin typeface="Arial"/>
-              </a:rPr>
-              <a:t>The metasurface's retardance error, the arm's polarization aberration, and the analyzer, each from the engine's polarized traces of this bench</a:t>
-            </a:r>
-          </a:p>
-        </p:txBody>
-      </p:sp>
-      <p:sp>
-        <p:nvSpPr>
-          <p:cNvPr id="3" name="Rectangle 2"/>
-          <p:cNvSpPr/>
-          <p:nvPr/>
-        </p:nvSpPr>
-        <p:spPr>
-          <a:xfrm>
-            <a:off x="411480" y="1133856"/>
-            <a:ext cx="11368735" cy="20320"/>
-          </a:xfrm>
-          <a:prstGeom prst="rect">
-            <a:avLst/>
-          </a:prstGeom>
-          <a:solidFill>
-            <a:srgbClr val="B8C6D4"/>
-          </a:solidFill>
-          <a:ln>
-            <a:noFill/>
-          </a:ln>
-          <a:effectLst/>
-        </p:spPr>
-        <p:style>
-          <a:lnRef idx="1">
-            <a:schemeClr val="accent1"/>
-          </a:lnRef>
-          <a:fillRef idx="3">
-            <a:schemeClr val="accent1"/>
-          </a:fillRef>
-          <a:effectRef idx="2">
-            <a:schemeClr val="accent1"/>
-          </a:effectRef>
-          <a:fontRef idx="minor">
-            <a:schemeClr val="lt1"/>
-          </a:fontRef>
-        </p:style>
-        <p:txBody>
-          <a:bodyPr rtlCol="0" anchor="ctr"/>
-          <a:lstStyle/>
-          <a:p>
-            <a:pPr algn="ctr"/>
-          </a:p>
-        </p:txBody>
-      </p:sp>
-      <p:graphicFrame>
-        <p:nvGraphicFramePr>
-          <p:cNvPr id="4" name="Table 3"/>
-          <p:cNvGraphicFramePr>
-            <a:graphicFrameLocks noGrp="1"/>
-          </p:cNvGraphicFramePr>
-          <p:nvPr/>
-        </p:nvGraphicFramePr>
-        <p:xfrm>
-          <a:off x="411480" y="1298448"/>
-          <a:ext cx="5806439" cy="3377565"/>
-        </p:xfrm>
-        <a:graphic>
-          <a:graphicData uri="http://schemas.openxmlformats.org/drawingml/2006/table">
-            <a:tbl>
-              <a:tblPr firstRow="1" bandRow="1">
-                <a:tableStyleId>{5C22544A-7EE6-4342-B048-85BDC9FD1C3A}</a:tableStyleId>
-              </a:tblPr>
-              <a:tblGrid>
-                <a:gridCol w="1924420"/>
-                <a:gridCol w="1824881"/>
-                <a:gridCol w="2057138"/>
-              </a:tblGrid>
-              <a:tr h="468630">
-                <a:tc>
-                  <a:txBody>
-                    <a:bodyPr wrap="square"/>
-                    <a:lstStyle/>
-                    <a:p>
-                      <a:r>
-                        <a:rPr sz="1100" b="1">
-                          <a:solidFill>
-                            <a:srgbClr val="FFFFFF"/>
-                          </a:solidFill>
-                          <a:latin typeface="Arial"/>
-                        </a:rPr>
-                        <a:t>term</a:t>
-                      </a:r>
-                    </a:p>
-                  </a:txBody>
-                  <a:tcPr marL="54864" marR="54864" marT="18288" marB="18288">
-                    <a:solidFill>
-                      <a:srgbClr val="1F4E79"/>
-                    </a:solidFill>
-                  </a:tcPr>
-                </a:tc>
-                <a:tc>
-                  <a:txBody>
-                    <a:bodyPr wrap="square"/>
-                    <a:lstStyle/>
-                    <a:p>
-                      <a:r>
-                        <a:rPr sz="1100" b="1">
-                          <a:solidFill>
-                            <a:srgbClr val="FFFFFF"/>
-                          </a:solidFill>
-                          <a:latin typeface="Arial"/>
-                        </a:rPr>
-                        <a:t>uncalibrated, on 100 nm pokes (12 nm rms)</a:t>
-                      </a:r>
-                    </a:p>
-                  </a:txBody>
-                  <a:tcPr marL="54864" marR="54864" marT="18288" marB="18288">
-                    <a:solidFill>
-                      <a:srgbClr val="1F4E79"/>
-                    </a:solidFill>
-                  </a:tcPr>
-                </a:tc>
-                <a:tc>
-                  <a:txBody>
-                    <a:bodyPr wrap="square"/>
-                    <a:lstStyle/>
-                    <a:p>
-                      <a:r>
-                        <a:rPr sz="1100" b="1">
-                          <a:solidFill>
-                            <a:srgbClr val="FFFFFF"/>
-                          </a:solidFill>
-                          <a:latin typeface="Arial"/>
-                        </a:rPr>
-                        <a:t>through the matrix measured on the surface</a:t>
-                      </a:r>
-                    </a:p>
-                  </a:txBody>
-                  <a:tcPr marL="54864" marR="54864" marT="18288" marB="18288">
-                    <a:solidFill>
-                      <a:srgbClr val="1F4E79"/>
-                    </a:solidFill>
-                  </a:tcPr>
-                </a:tc>
-              </a:tr>
-              <a:tr h="657225">
-                <a:tc>
-                  <a:txBody>
-                    <a:bodyPr wrap="square"/>
-                    <a:lstStyle/>
-                    <a:p>
-                      <a:r>
-                        <a:rPr sz="1100" b="0">
-                          <a:solidFill>
-                            <a:srgbClr val="282828"/>
-                          </a:solidFill>
-                          <a:latin typeface="Arial"/>
-                        </a:rPr>
-                        <a:t>metasurface retardance error 0.02 / 0.05 / 0.10 / 0.20 rad</a:t>
-                      </a:r>
-                    </a:p>
-                  </a:txBody>
-                  <a:tcPr marL="54864" marR="54864" marT="18288" marB="18288">
-                    <a:solidFill>
-                      <a:srgbClr val="FFFFFF"/>
-                    </a:solidFill>
-                  </a:tcPr>
-                </a:tc>
-                <a:tc>
-                  <a:txBody>
-                    <a:bodyPr wrap="square"/>
-                    <a:lstStyle/>
-                    <a:p>
-                      <a:r>
-                        <a:rPr sz="1100" b="0">
-                          <a:solidFill>
-                            <a:srgbClr val="282828"/>
-                          </a:solidFill>
-                          <a:latin typeface="Arial"/>
-                        </a:rPr>
-                        <a:t>153 / 380 / 750 / 1461 pm</a:t>
-                      </a:r>
-                    </a:p>
-                  </a:txBody>
-                  <a:tcPr marL="54864" marR="54864" marT="18288" marB="18288">
-                    <a:solidFill>
-                      <a:srgbClr val="FFFFFF"/>
-                    </a:solidFill>
-                  </a:tcPr>
-                </a:tc>
-                <a:tc>
-                  <a:txBody>
-                    <a:bodyPr wrap="square"/>
-                    <a:lstStyle/>
-                    <a:p>
-                      <a:r>
-                        <a:rPr sz="1100" b="0">
-                          <a:solidFill>
-                            <a:srgbClr val="282828"/>
-                          </a:solidFill>
-                          <a:latin typeface="Arial"/>
-                        </a:rPr>
-                        <a:t>0.9934 / 4 pm at 0.10 and 0.20: the ideal rows</a:t>
-                      </a:r>
-                    </a:p>
-                  </a:txBody>
-                  <a:tcPr marL="54864" marR="54864" marT="18288" marB="18288">
-                    <a:solidFill>
-                      <a:srgbClr val="FFFFFF"/>
-                    </a:solidFill>
-                  </a:tcPr>
-                </a:tc>
-              </a:tr>
-              <a:tr h="657225">
-                <a:tc>
-                  <a:txBody>
-                    <a:bodyPr wrap="square"/>
-                    <a:lstStyle/>
-                    <a:p>
-                      <a:r>
-                        <a:rPr sz="1100" b="0">
-                          <a:solidFill>
-                            <a:srgbClr val="282828"/>
-                          </a:solidFill>
-                          <a:latin typeface="Arial"/>
-                        </a:rPr>
-                        <a:t>the arm, laser at 45° / 0° / 90° to the fold plane</a:t>
-                      </a:r>
-                    </a:p>
-                  </a:txBody>
-                  <a:tcPr marL="54864" marR="54864" marT="18288" marB="18288">
-                    <a:solidFill>
-                      <a:srgbClr val="ECF1F6"/>
-                    </a:solidFill>
-                  </a:tcPr>
-                </a:tc>
-                <a:tc>
-                  <a:txBody>
-                    <a:bodyPr wrap="square"/>
-                    <a:lstStyle/>
-                    <a:p>
-                      <a:r>
-                        <a:rPr sz="1100" b="0">
-                          <a:solidFill>
-                            <a:srgbClr val="282828"/>
-                          </a:solidFill>
-                          <a:latin typeface="Arial"/>
-                        </a:rPr>
-                        <a:t>9.0 / 17.2 / 11.2 pm (ideal 0.05)</a:t>
-                      </a:r>
-                    </a:p>
-                  </a:txBody>
-                  <a:tcPr marL="54864" marR="54864" marT="18288" marB="18288">
-                    <a:solidFill>
-                      <a:srgbClr val="ECF1F6"/>
-                    </a:solidFill>
-                  </a:tcPr>
-                </a:tc>
-                <a:tc>
-                  <a:txBody>
-                    <a:bodyPr wrap="square"/>
-                    <a:lstStyle/>
-                    <a:p>
-                      <a:r>
-                        <a:rPr sz="1100" b="0">
-                          <a:solidFill>
-                            <a:srgbClr val="282828"/>
-                          </a:solidFill>
-                          <a:latin typeface="Arial"/>
-                        </a:rPr>
-                        <a:t>nothing through 0.1 rad of channel phase; 10% gain loss at 0.3</a:t>
-                      </a:r>
-                    </a:p>
-                  </a:txBody>
-                  <a:tcPr marL="54864" marR="54864" marT="18288" marB="18288">
-                    <a:solidFill>
-                      <a:srgbClr val="ECF1F6"/>
-                    </a:solidFill>
-                  </a:tcPr>
-                </a:tc>
-              </a:tr>
-              <a:tr h="657225">
-                <a:tc>
-                  <a:txBody>
-                    <a:bodyPr wrap="square"/>
-                    <a:lstStyle/>
-                    <a:p>
-                      <a:r>
-                        <a:rPr sz="1100" b="0">
-                          <a:solidFill>
-                            <a:srgbClr val="282828"/>
-                          </a:solidFill>
-                          <a:latin typeface="Arial"/>
-                        </a:rPr>
-                        <a:t>the arm, design scan: 6 nm per rad of channel phase</a:t>
-                      </a:r>
-                    </a:p>
-                  </a:txBody>
-                  <a:tcPr marL="54864" marR="54864" marT="18288" marB="18288">
-                    <a:solidFill>
-                      <a:srgbClr val="FFFFFF"/>
-                    </a:solidFill>
-                  </a:tcPr>
-                </a:tc>
-                <a:tc>
-                  <a:txBody>
-                    <a:bodyPr wrap="square"/>
-                    <a:lstStyle/>
-                    <a:p>
-                      <a:r>
-                        <a:rPr sz="1100" b="0">
-                          <a:solidFill>
-                            <a:srgbClr val="282828"/>
-                          </a:solidFill>
-                          <a:latin typeface="Arial"/>
-                        </a:rPr>
-                        <a:t>59 / 178 / 597 / 1877 pm at 0.01 / 0.03 / 0.1 / 0.3 rad</a:t>
-                      </a:r>
-                    </a:p>
-                  </a:txBody>
-                  <a:tcPr marL="54864" marR="54864" marT="18288" marB="18288">
-                    <a:solidFill>
-                      <a:srgbClr val="FFFFFF"/>
-                    </a:solidFill>
-                  </a:tcPr>
-                </a:tc>
-                <a:tc>
-                  <a:txBody>
-                    <a:bodyPr wrap="square"/>
-                    <a:lstStyle/>
-                    <a:p>
-                      <a:r>
-                        <a:rPr sz="1100" b="0">
-                          <a:solidFill>
-                            <a:srgbClr val="282828"/>
-                          </a:solidFill>
-                          <a:latin typeface="Arial"/>
-                        </a:rPr>
-                        <a:t>—</a:t>
-                      </a:r>
-                    </a:p>
-                  </a:txBody>
-                  <a:tcPr marL="54864" marR="54864" marT="18288" marB="18288">
-                    <a:solidFill>
-                      <a:srgbClr val="FFFFFF"/>
-                    </a:solidFill>
-                  </a:tcPr>
-                </a:tc>
-              </a:tr>
-              <a:tr h="468630">
-                <a:tc>
-                  <a:txBody>
-                    <a:bodyPr wrap="square"/>
-                    <a:lstStyle/>
-                    <a:p>
-                      <a:r>
-                        <a:rPr sz="1100" b="0">
-                          <a:solidFill>
-                            <a:srgbClr val="282828"/>
-                          </a:solidFill>
-                          <a:latin typeface="Arial"/>
-                        </a:rPr>
-                        <a:t>analyzer: cube extinction alone</a:t>
-                      </a:r>
-                    </a:p>
-                  </a:txBody>
-                  <a:tcPr marL="54864" marR="54864" marT="18288" marB="18288">
-                    <a:solidFill>
-                      <a:srgbClr val="ECF1F6"/>
-                    </a:solidFill>
-                  </a:tcPr>
-                </a:tc>
-                <a:tc>
-                  <a:txBody>
-                    <a:bodyPr wrap="square"/>
-                    <a:lstStyle/>
-                    <a:p>
-                      <a:r>
-                        <a:rPr sz="1100" b="0">
-                          <a:solidFill>
-                            <a:srgbClr val="282828"/>
-                          </a:solidFill>
-                          <a:latin typeface="Arial"/>
-                        </a:rPr>
-                        <a:t>3.5 pm</a:t>
-                      </a:r>
-                    </a:p>
-                  </a:txBody>
-                  <a:tcPr marL="54864" marR="54864" marT="18288" marB="18288">
-                    <a:solidFill>
-                      <a:srgbClr val="ECF1F6"/>
-                    </a:solidFill>
-                  </a:tcPr>
-                </a:tc>
-                <a:tc>
-                  <a:txBody>
-                    <a:bodyPr wrap="square"/>
-                    <a:lstStyle/>
-                    <a:p>
-                      <a:r>
-                        <a:rPr sz="1100" b="0">
-                          <a:solidFill>
-                            <a:srgbClr val="282828"/>
-                          </a:solidFill>
-                          <a:latin typeface="Arial"/>
-                        </a:rPr>
-                        <a:t>0.9934 / 4 pm</a:t>
-                      </a:r>
-                    </a:p>
-                  </a:txBody>
-                  <a:tcPr marL="54864" marR="54864" marT="18288" marB="18288">
-                    <a:solidFill>
-                      <a:srgbClr val="ECF1F6"/>
-                    </a:solidFill>
-                  </a:tcPr>
-                </a:tc>
-              </a:tr>
-              <a:tr h="468630">
-                <a:tc>
-                  <a:txBody>
-                    <a:bodyPr wrap="square"/>
-                    <a:lstStyle/>
-                    <a:p>
-                      <a:r>
-                        <a:rPr sz="1100" b="0">
-                          <a:solidFill>
-                            <a:srgbClr val="282828"/>
-                          </a:solidFill>
-                          <a:latin typeface="Arial"/>
-                        </a:rPr>
-                        <a:t>analyzer: plate λ/300; 1° azimuth; λ/100</a:t>
-                      </a:r>
-                    </a:p>
-                  </a:txBody>
-                  <a:tcPr marL="54864" marR="54864" marT="18288" marB="18288">
-                    <a:solidFill>
-                      <a:srgbClr val="FFFFFF"/>
-                    </a:solidFill>
-                  </a:tcPr>
-                </a:tc>
-                <a:tc>
-                  <a:txBody>
-                    <a:bodyPr wrap="square"/>
-                    <a:lstStyle/>
-                    <a:p>
-                      <a:r>
-                        <a:rPr sz="1100" b="0">
-                          <a:solidFill>
-                            <a:srgbClr val="282828"/>
-                          </a:solidFill>
-                          <a:latin typeface="Arial"/>
-                        </a:rPr>
-                        <a:t>165; 263; 496 pm</a:t>
-                      </a:r>
-                    </a:p>
-                  </a:txBody>
-                  <a:tcPr marL="54864" marR="54864" marT="18288" marB="18288">
-                    <a:solidFill>
-                      <a:srgbClr val="FFFFFF"/>
-                    </a:solidFill>
-                  </a:tcPr>
-                </a:tc>
-                <a:tc>
-                  <a:txBody>
-                    <a:bodyPr wrap="square"/>
-                    <a:lstStyle/>
-                    <a:p>
-                      <a:r>
-                        <a:rPr sz="1100" b="0">
-                          <a:solidFill>
-                            <a:srgbClr val="282828"/>
-                          </a:solidFill>
-                          <a:latin typeface="Arial"/>
-                        </a:rPr>
-                        <a:t>0.9932 / 4; 0.9932 / 4; 0.9928 / 4 pm</a:t>
-                      </a:r>
-                    </a:p>
-                  </a:txBody>
-                  <a:tcPr marL="54864" marR="54864" marT="18288" marB="18288">
-                    <a:solidFill>
-                      <a:srgbClr val="FFFFFF"/>
-                    </a:solidFill>
-                  </a:tcPr>
-                </a:tc>
-              </a:tr>
-            </a:tbl>
-          </a:graphicData>
-        </a:graphic>
-      </p:graphicFrame>
-      <p:sp>
-        <p:nvSpPr>
-          <p:cNvPr id="5" name="TextBox 4"/>
-          <p:cNvSpPr txBox="1"/>
-          <p:nvPr/>
-        </p:nvSpPr>
-        <p:spPr>
-          <a:xfrm>
-            <a:off x="6400800" y="1298448"/>
-            <a:ext cx="5394960" cy="274320"/>
-          </a:xfrm>
-          <a:prstGeom prst="rect">
-            <a:avLst/>
-          </a:prstGeom>
-          <a:noFill/>
-        </p:spPr>
-        <p:txBody>
-          <a:bodyPr wrap="square">
-            <a:spAutoFit/>
-          </a:bodyPr>
-          <a:lstStyle/>
-          <a:p>
-            <a:pPr>
-              <a:spcAft>
-                <a:spcPts val="600"/>
-              </a:spcAft>
-            </a:pPr>
-            <a:r>
-              <a:rPr sz="1200" b="0">
-                <a:solidFill>
-                  <a:srgbClr val="282828"/>
-                </a:solidFill>
-                <a:latin typeface="Arial"/>
-              </a:rPr>
-              <a:t>•  The arm: six 7° glass faces give 5e-3 diattenuation and 0.9 mrad retardance; because the Jones matrix is real, the two circular channels differ in phase only, 1.6 mrad rms at the worst laser angle and 2e-5 along the fold plane's axis.  Rule: specify pupil-varying diattenuation, put the laser on the eigenaxis.</a:t>
-            </a:r>
-          </a:p>
-          <a:p>
-            <a:pPr>
-              <a:spcAft>
-                <a:spcPts val="600"/>
-              </a:spcAft>
-            </a:pPr>
-            <a:r>
-              <a:rPr sz="1200" b="0">
-                <a:solidFill>
-                  <a:srgbClr val="282828"/>
-                </a:solidFill>
-                <a:latin typeface="Arial"/>
-              </a:rPr>
-              <a:t>•  The analyzer: a plate retardance error δ couples the two images with amplitude δ/2, an azimuth error θ with amplitude θ, engine-exact, opposite signs in the two ports; the cube's finite extinction adds 4-6e-4 incoherently.  Spec a zero-order plate at λ/300, azimuth to 1°.</a:t>
-            </a:r>
-          </a:p>
-          <a:p>
-            <a:pPr>
-              <a:spcAft>
-                <a:spcPts val="600"/>
-              </a:spcAft>
-            </a:pPr>
-            <a:r>
-              <a:rPr sz="1200" b="0">
-                <a:solidFill>
-                  <a:srgbClr val="282828"/>
-                </a:solidFill>
-                <a:latin typeface="Arial"/>
-              </a:rPr>
-              <a:t>•  A three-number fit on the flat's two images recovers the metasurface's constants to five digits (0.048 pm).</a:t>
-            </a:r>
-          </a:p>
-        </p:txBody>
-      </p:sp>
-      <p:sp>
-        <p:nvSpPr>
-          <p:cNvPr id="6" name="TextBox 5"/>
-          <p:cNvSpPr txBox="1"/>
-          <p:nvPr/>
-        </p:nvSpPr>
-        <p:spPr>
-          <a:xfrm>
-            <a:off x="6400800" y="3934967"/>
-            <a:ext cx="5394960" cy="274320"/>
-          </a:xfrm>
-          <a:prstGeom prst="rect">
-            <a:avLst/>
-          </a:prstGeom>
-          <a:noFill/>
-        </p:spPr>
-        <p:txBody>
-          <a:bodyPr wrap="square">
-            <a:spAutoFit/>
-          </a:bodyPr>
-          <a:lstStyle/>
-          <a:p>
-            <a:pPr>
-              <a:spcAft>
-                <a:spcPts val="600"/>
-              </a:spcAft>
-            </a:pPr>
-            <a:r>
-              <a:rPr sz="1050" b="0">
-                <a:solidFill>
-                  <a:srgbClr val="6E6E6E"/>
-                </a:solidFill>
-                <a:latin typeface="Arial"/>
-              </a:rPr>
-              <a:t>Run tags v2g, v2loop, v3arm, v3s, v3loop, an193_cube/q300/q100/az1; zwfs_dm96 README V2-V4.</a:t>
             </a:r>
           </a:p>
         </p:txBody>
@@ -30167,6 +30285,668 @@
                 </a:solidFill>
                 <a:latin typeface="Arial"/>
               </a:rPr>
+              <a:t>Backup: the vector sensor's polarization terms</a:t>
+            </a:r>
+          </a:p>
+          <a:p>
+            <a:pPr>
+              <a:spcAft>
+                <a:spcPts val="0"/>
+              </a:spcAft>
+            </a:pPr>
+            <a:r>
+              <a:rPr sz="1250" b="0">
+                <a:solidFill>
+                  <a:srgbClr val="6E6E6E"/>
+                </a:solidFill>
+                <a:latin typeface="Arial"/>
+              </a:rPr>
+              <a:t>The metasurface's retardance error, the arm's polarization aberration, and the analyzer, each from the engine's polarized traces of this bench</a:t>
+            </a:r>
+          </a:p>
+        </p:txBody>
+      </p:sp>
+      <p:sp>
+        <p:nvSpPr>
+          <p:cNvPr id="3" name="Rectangle 2"/>
+          <p:cNvSpPr/>
+          <p:nvPr/>
+        </p:nvSpPr>
+        <p:spPr>
+          <a:xfrm>
+            <a:off x="411480" y="1133856"/>
+            <a:ext cx="11368735" cy="20320"/>
+          </a:xfrm>
+          <a:prstGeom prst="rect">
+            <a:avLst/>
+          </a:prstGeom>
+          <a:solidFill>
+            <a:srgbClr val="B8C6D4"/>
+          </a:solidFill>
+          <a:ln>
+            <a:noFill/>
+          </a:ln>
+          <a:effectLst/>
+        </p:spPr>
+        <p:style>
+          <a:lnRef idx="1">
+            <a:schemeClr val="accent1"/>
+          </a:lnRef>
+          <a:fillRef idx="3">
+            <a:schemeClr val="accent1"/>
+          </a:fillRef>
+          <a:effectRef idx="2">
+            <a:schemeClr val="accent1"/>
+          </a:effectRef>
+          <a:fontRef idx="minor">
+            <a:schemeClr val="lt1"/>
+          </a:fontRef>
+        </p:style>
+        <p:txBody>
+          <a:bodyPr rtlCol="0" anchor="ctr"/>
+          <a:lstStyle/>
+          <a:p>
+            <a:pPr algn="ctr"/>
+          </a:p>
+        </p:txBody>
+      </p:sp>
+      <p:graphicFrame>
+        <p:nvGraphicFramePr>
+          <p:cNvPr id="4" name="Table 3"/>
+          <p:cNvGraphicFramePr>
+            <a:graphicFrameLocks noGrp="1"/>
+          </p:cNvGraphicFramePr>
+          <p:nvPr/>
+        </p:nvGraphicFramePr>
+        <p:xfrm>
+          <a:off x="411480" y="1298448"/>
+          <a:ext cx="5806439" cy="3377565"/>
+        </p:xfrm>
+        <a:graphic>
+          <a:graphicData uri="http://schemas.openxmlformats.org/drawingml/2006/table">
+            <a:tbl>
+              <a:tblPr firstRow="1" bandRow="1">
+                <a:tableStyleId>{5C22544A-7EE6-4342-B048-85BDC9FD1C3A}</a:tableStyleId>
+              </a:tblPr>
+              <a:tblGrid>
+                <a:gridCol w="1924420"/>
+                <a:gridCol w="1824881"/>
+                <a:gridCol w="2057138"/>
+              </a:tblGrid>
+              <a:tr h="468630">
+                <a:tc>
+                  <a:txBody>
+                    <a:bodyPr wrap="square"/>
+                    <a:lstStyle/>
+                    <a:p>
+                      <a:r>
+                        <a:rPr sz="1100" b="1">
+                          <a:solidFill>
+                            <a:srgbClr val="FFFFFF"/>
+                          </a:solidFill>
+                          <a:latin typeface="Arial"/>
+                        </a:rPr>
+                        <a:t>term</a:t>
+                      </a:r>
+                    </a:p>
+                  </a:txBody>
+                  <a:tcPr marL="54864" marR="54864" marT="18288" marB="18288">
+                    <a:solidFill>
+                      <a:srgbClr val="1F4E79"/>
+                    </a:solidFill>
+                  </a:tcPr>
+                </a:tc>
+                <a:tc>
+                  <a:txBody>
+                    <a:bodyPr wrap="square"/>
+                    <a:lstStyle/>
+                    <a:p>
+                      <a:r>
+                        <a:rPr sz="1100" b="1">
+                          <a:solidFill>
+                            <a:srgbClr val="FFFFFF"/>
+                          </a:solidFill>
+                          <a:latin typeface="Arial"/>
+                        </a:rPr>
+                        <a:t>uncalibrated, on 100 nm pokes (12 nm rms)</a:t>
+                      </a:r>
+                    </a:p>
+                  </a:txBody>
+                  <a:tcPr marL="54864" marR="54864" marT="18288" marB="18288">
+                    <a:solidFill>
+                      <a:srgbClr val="1F4E79"/>
+                    </a:solidFill>
+                  </a:tcPr>
+                </a:tc>
+                <a:tc>
+                  <a:txBody>
+                    <a:bodyPr wrap="square"/>
+                    <a:lstStyle/>
+                    <a:p>
+                      <a:r>
+                        <a:rPr sz="1100" b="1">
+                          <a:solidFill>
+                            <a:srgbClr val="FFFFFF"/>
+                          </a:solidFill>
+                          <a:latin typeface="Arial"/>
+                        </a:rPr>
+                        <a:t>through the matrix measured on the surface</a:t>
+                      </a:r>
+                    </a:p>
+                  </a:txBody>
+                  <a:tcPr marL="54864" marR="54864" marT="18288" marB="18288">
+                    <a:solidFill>
+                      <a:srgbClr val="1F4E79"/>
+                    </a:solidFill>
+                  </a:tcPr>
+                </a:tc>
+              </a:tr>
+              <a:tr h="657225">
+                <a:tc>
+                  <a:txBody>
+                    <a:bodyPr wrap="square"/>
+                    <a:lstStyle/>
+                    <a:p>
+                      <a:r>
+                        <a:rPr sz="1100" b="0">
+                          <a:solidFill>
+                            <a:srgbClr val="282828"/>
+                          </a:solidFill>
+                          <a:latin typeface="Arial"/>
+                        </a:rPr>
+                        <a:t>metasurface retardance error 0.02 / 0.05 / 0.10 / 0.20 rad</a:t>
+                      </a:r>
+                    </a:p>
+                  </a:txBody>
+                  <a:tcPr marL="54864" marR="54864" marT="18288" marB="18288">
+                    <a:solidFill>
+                      <a:srgbClr val="FFFFFF"/>
+                    </a:solidFill>
+                  </a:tcPr>
+                </a:tc>
+                <a:tc>
+                  <a:txBody>
+                    <a:bodyPr wrap="square"/>
+                    <a:lstStyle/>
+                    <a:p>
+                      <a:r>
+                        <a:rPr sz="1100" b="0">
+                          <a:solidFill>
+                            <a:srgbClr val="282828"/>
+                          </a:solidFill>
+                          <a:latin typeface="Arial"/>
+                        </a:rPr>
+                        <a:t>153 / 380 / 750 / 1461 pm</a:t>
+                      </a:r>
+                    </a:p>
+                  </a:txBody>
+                  <a:tcPr marL="54864" marR="54864" marT="18288" marB="18288">
+                    <a:solidFill>
+                      <a:srgbClr val="FFFFFF"/>
+                    </a:solidFill>
+                  </a:tcPr>
+                </a:tc>
+                <a:tc>
+                  <a:txBody>
+                    <a:bodyPr wrap="square"/>
+                    <a:lstStyle/>
+                    <a:p>
+                      <a:r>
+                        <a:rPr sz="1100" b="0">
+                          <a:solidFill>
+                            <a:srgbClr val="282828"/>
+                          </a:solidFill>
+                          <a:latin typeface="Arial"/>
+                        </a:rPr>
+                        <a:t>0.9934 / 4 pm at 0.10 and 0.20: the ideal rows</a:t>
+                      </a:r>
+                    </a:p>
+                  </a:txBody>
+                  <a:tcPr marL="54864" marR="54864" marT="18288" marB="18288">
+                    <a:solidFill>
+                      <a:srgbClr val="FFFFFF"/>
+                    </a:solidFill>
+                  </a:tcPr>
+                </a:tc>
+              </a:tr>
+              <a:tr h="657225">
+                <a:tc>
+                  <a:txBody>
+                    <a:bodyPr wrap="square"/>
+                    <a:lstStyle/>
+                    <a:p>
+                      <a:r>
+                        <a:rPr sz="1100" b="0">
+                          <a:solidFill>
+                            <a:srgbClr val="282828"/>
+                          </a:solidFill>
+                          <a:latin typeface="Arial"/>
+                        </a:rPr>
+                        <a:t>the arm, laser at 45° / 0° / 90° to the fold plane</a:t>
+                      </a:r>
+                    </a:p>
+                  </a:txBody>
+                  <a:tcPr marL="54864" marR="54864" marT="18288" marB="18288">
+                    <a:solidFill>
+                      <a:srgbClr val="ECF1F6"/>
+                    </a:solidFill>
+                  </a:tcPr>
+                </a:tc>
+                <a:tc>
+                  <a:txBody>
+                    <a:bodyPr wrap="square"/>
+                    <a:lstStyle/>
+                    <a:p>
+                      <a:r>
+                        <a:rPr sz="1100" b="0">
+                          <a:solidFill>
+                            <a:srgbClr val="282828"/>
+                          </a:solidFill>
+                          <a:latin typeface="Arial"/>
+                        </a:rPr>
+                        <a:t>9.0 / 17.2 / 11.2 pm (ideal 0.05)</a:t>
+                      </a:r>
+                    </a:p>
+                  </a:txBody>
+                  <a:tcPr marL="54864" marR="54864" marT="18288" marB="18288">
+                    <a:solidFill>
+                      <a:srgbClr val="ECF1F6"/>
+                    </a:solidFill>
+                  </a:tcPr>
+                </a:tc>
+                <a:tc>
+                  <a:txBody>
+                    <a:bodyPr wrap="square"/>
+                    <a:lstStyle/>
+                    <a:p>
+                      <a:r>
+                        <a:rPr sz="1100" b="0">
+                          <a:solidFill>
+                            <a:srgbClr val="282828"/>
+                          </a:solidFill>
+                          <a:latin typeface="Arial"/>
+                        </a:rPr>
+                        <a:t>nothing through 0.1 rad of channel phase; 10% gain loss at 0.3</a:t>
+                      </a:r>
+                    </a:p>
+                  </a:txBody>
+                  <a:tcPr marL="54864" marR="54864" marT="18288" marB="18288">
+                    <a:solidFill>
+                      <a:srgbClr val="ECF1F6"/>
+                    </a:solidFill>
+                  </a:tcPr>
+                </a:tc>
+              </a:tr>
+              <a:tr h="657225">
+                <a:tc>
+                  <a:txBody>
+                    <a:bodyPr wrap="square"/>
+                    <a:lstStyle/>
+                    <a:p>
+                      <a:r>
+                        <a:rPr sz="1100" b="0">
+                          <a:solidFill>
+                            <a:srgbClr val="282828"/>
+                          </a:solidFill>
+                          <a:latin typeface="Arial"/>
+                        </a:rPr>
+                        <a:t>the arm, design scan: 6 nm per rad of channel phase</a:t>
+                      </a:r>
+                    </a:p>
+                  </a:txBody>
+                  <a:tcPr marL="54864" marR="54864" marT="18288" marB="18288">
+                    <a:solidFill>
+                      <a:srgbClr val="FFFFFF"/>
+                    </a:solidFill>
+                  </a:tcPr>
+                </a:tc>
+                <a:tc>
+                  <a:txBody>
+                    <a:bodyPr wrap="square"/>
+                    <a:lstStyle/>
+                    <a:p>
+                      <a:r>
+                        <a:rPr sz="1100" b="0">
+                          <a:solidFill>
+                            <a:srgbClr val="282828"/>
+                          </a:solidFill>
+                          <a:latin typeface="Arial"/>
+                        </a:rPr>
+                        <a:t>59 / 178 / 597 / 1877 pm at 0.01 / 0.03 / 0.1 / 0.3 rad</a:t>
+                      </a:r>
+                    </a:p>
+                  </a:txBody>
+                  <a:tcPr marL="54864" marR="54864" marT="18288" marB="18288">
+                    <a:solidFill>
+                      <a:srgbClr val="FFFFFF"/>
+                    </a:solidFill>
+                  </a:tcPr>
+                </a:tc>
+                <a:tc>
+                  <a:txBody>
+                    <a:bodyPr wrap="square"/>
+                    <a:lstStyle/>
+                    <a:p>
+                      <a:r>
+                        <a:rPr sz="1100" b="0">
+                          <a:solidFill>
+                            <a:srgbClr val="282828"/>
+                          </a:solidFill>
+                          <a:latin typeface="Arial"/>
+                        </a:rPr>
+                        <a:t>—</a:t>
+                      </a:r>
+                    </a:p>
+                  </a:txBody>
+                  <a:tcPr marL="54864" marR="54864" marT="18288" marB="18288">
+                    <a:solidFill>
+                      <a:srgbClr val="FFFFFF"/>
+                    </a:solidFill>
+                  </a:tcPr>
+                </a:tc>
+              </a:tr>
+              <a:tr h="468630">
+                <a:tc>
+                  <a:txBody>
+                    <a:bodyPr wrap="square"/>
+                    <a:lstStyle/>
+                    <a:p>
+                      <a:r>
+                        <a:rPr sz="1100" b="0">
+                          <a:solidFill>
+                            <a:srgbClr val="282828"/>
+                          </a:solidFill>
+                          <a:latin typeface="Arial"/>
+                        </a:rPr>
+                        <a:t>analyzer: cube extinction alone</a:t>
+                      </a:r>
+                    </a:p>
+                  </a:txBody>
+                  <a:tcPr marL="54864" marR="54864" marT="18288" marB="18288">
+                    <a:solidFill>
+                      <a:srgbClr val="ECF1F6"/>
+                    </a:solidFill>
+                  </a:tcPr>
+                </a:tc>
+                <a:tc>
+                  <a:txBody>
+                    <a:bodyPr wrap="square"/>
+                    <a:lstStyle/>
+                    <a:p>
+                      <a:r>
+                        <a:rPr sz="1100" b="0">
+                          <a:solidFill>
+                            <a:srgbClr val="282828"/>
+                          </a:solidFill>
+                          <a:latin typeface="Arial"/>
+                        </a:rPr>
+                        <a:t>3.5 pm</a:t>
+                      </a:r>
+                    </a:p>
+                  </a:txBody>
+                  <a:tcPr marL="54864" marR="54864" marT="18288" marB="18288">
+                    <a:solidFill>
+                      <a:srgbClr val="ECF1F6"/>
+                    </a:solidFill>
+                  </a:tcPr>
+                </a:tc>
+                <a:tc>
+                  <a:txBody>
+                    <a:bodyPr wrap="square"/>
+                    <a:lstStyle/>
+                    <a:p>
+                      <a:r>
+                        <a:rPr sz="1100" b="0">
+                          <a:solidFill>
+                            <a:srgbClr val="282828"/>
+                          </a:solidFill>
+                          <a:latin typeface="Arial"/>
+                        </a:rPr>
+                        <a:t>0.9934 / 4 pm</a:t>
+                      </a:r>
+                    </a:p>
+                  </a:txBody>
+                  <a:tcPr marL="54864" marR="54864" marT="18288" marB="18288">
+                    <a:solidFill>
+                      <a:srgbClr val="ECF1F6"/>
+                    </a:solidFill>
+                  </a:tcPr>
+                </a:tc>
+              </a:tr>
+              <a:tr h="468630">
+                <a:tc>
+                  <a:txBody>
+                    <a:bodyPr wrap="square"/>
+                    <a:lstStyle/>
+                    <a:p>
+                      <a:r>
+                        <a:rPr sz="1100" b="0">
+                          <a:solidFill>
+                            <a:srgbClr val="282828"/>
+                          </a:solidFill>
+                          <a:latin typeface="Arial"/>
+                        </a:rPr>
+                        <a:t>analyzer: plate λ/300; 1° azimuth; λ/100</a:t>
+                      </a:r>
+                    </a:p>
+                  </a:txBody>
+                  <a:tcPr marL="54864" marR="54864" marT="18288" marB="18288">
+                    <a:solidFill>
+                      <a:srgbClr val="FFFFFF"/>
+                    </a:solidFill>
+                  </a:tcPr>
+                </a:tc>
+                <a:tc>
+                  <a:txBody>
+                    <a:bodyPr wrap="square"/>
+                    <a:lstStyle/>
+                    <a:p>
+                      <a:r>
+                        <a:rPr sz="1100" b="0">
+                          <a:solidFill>
+                            <a:srgbClr val="282828"/>
+                          </a:solidFill>
+                          <a:latin typeface="Arial"/>
+                        </a:rPr>
+                        <a:t>165; 263; 496 pm</a:t>
+                      </a:r>
+                    </a:p>
+                  </a:txBody>
+                  <a:tcPr marL="54864" marR="54864" marT="18288" marB="18288">
+                    <a:solidFill>
+                      <a:srgbClr val="FFFFFF"/>
+                    </a:solidFill>
+                  </a:tcPr>
+                </a:tc>
+                <a:tc>
+                  <a:txBody>
+                    <a:bodyPr wrap="square"/>
+                    <a:lstStyle/>
+                    <a:p>
+                      <a:r>
+                        <a:rPr sz="1100" b="0">
+                          <a:solidFill>
+                            <a:srgbClr val="282828"/>
+                          </a:solidFill>
+                          <a:latin typeface="Arial"/>
+                        </a:rPr>
+                        <a:t>0.9932 / 4; 0.9932 / 4; 0.9928 / 4 pm</a:t>
+                      </a:r>
+                    </a:p>
+                  </a:txBody>
+                  <a:tcPr marL="54864" marR="54864" marT="18288" marB="18288">
+                    <a:solidFill>
+                      <a:srgbClr val="FFFFFF"/>
+                    </a:solidFill>
+                  </a:tcPr>
+                </a:tc>
+              </a:tr>
+            </a:tbl>
+          </a:graphicData>
+        </a:graphic>
+      </p:graphicFrame>
+      <p:sp>
+        <p:nvSpPr>
+          <p:cNvPr id="5" name="TextBox 4"/>
+          <p:cNvSpPr txBox="1"/>
+          <p:nvPr/>
+        </p:nvSpPr>
+        <p:spPr>
+          <a:xfrm>
+            <a:off x="6400800" y="1298448"/>
+            <a:ext cx="5394960" cy="274320"/>
+          </a:xfrm>
+          <a:prstGeom prst="rect">
+            <a:avLst/>
+          </a:prstGeom>
+          <a:noFill/>
+        </p:spPr>
+        <p:txBody>
+          <a:bodyPr wrap="square">
+            <a:spAutoFit/>
+          </a:bodyPr>
+          <a:lstStyle/>
+          <a:p>
+            <a:pPr>
+              <a:spcAft>
+                <a:spcPts val="600"/>
+              </a:spcAft>
+            </a:pPr>
+            <a:r>
+              <a:rPr sz="1200" b="0">
+                <a:solidFill>
+                  <a:srgbClr val="282828"/>
+                </a:solidFill>
+                <a:latin typeface="Arial"/>
+              </a:rPr>
+              <a:t>•  The arm: six 7° glass faces give 5e-3 diattenuation and 0.9 mrad retardance; because the Jones matrix is real, the two circular channels differ in phase only, 1.6 mrad rms at the worst laser angle and 2e-5 along the fold plane's axis.  Rule: specify pupil-varying diattenuation, put the laser on the eigenaxis.</a:t>
+            </a:r>
+          </a:p>
+          <a:p>
+            <a:pPr>
+              <a:spcAft>
+                <a:spcPts val="600"/>
+              </a:spcAft>
+            </a:pPr>
+            <a:r>
+              <a:rPr sz="1200" b="0">
+                <a:solidFill>
+                  <a:srgbClr val="282828"/>
+                </a:solidFill>
+                <a:latin typeface="Arial"/>
+              </a:rPr>
+              <a:t>•  The analyzer: a plate retardance error δ couples the two images with amplitude δ/2, an azimuth error θ with amplitude θ, engine-exact, opposite signs in the two ports; the cube's finite extinction adds 4-6e-4 incoherently.  Spec a zero-order plate at λ/300, azimuth to 1°.</a:t>
+            </a:r>
+          </a:p>
+          <a:p>
+            <a:pPr>
+              <a:spcAft>
+                <a:spcPts val="600"/>
+              </a:spcAft>
+            </a:pPr>
+            <a:r>
+              <a:rPr sz="1200" b="0">
+                <a:solidFill>
+                  <a:srgbClr val="282828"/>
+                </a:solidFill>
+                <a:latin typeface="Arial"/>
+              </a:rPr>
+              <a:t>•  A three-number fit on the flat's two images recovers the metasurface's constants to five digits (0.048 pm).</a:t>
+            </a:r>
+          </a:p>
+        </p:txBody>
+      </p:sp>
+      <p:sp>
+        <p:nvSpPr>
+          <p:cNvPr id="6" name="TextBox 5"/>
+          <p:cNvSpPr txBox="1"/>
+          <p:nvPr/>
+        </p:nvSpPr>
+        <p:spPr>
+          <a:xfrm>
+            <a:off x="6400800" y="3934967"/>
+            <a:ext cx="5394960" cy="274320"/>
+          </a:xfrm>
+          <a:prstGeom prst="rect">
+            <a:avLst/>
+          </a:prstGeom>
+          <a:noFill/>
+        </p:spPr>
+        <p:txBody>
+          <a:bodyPr wrap="square">
+            <a:spAutoFit/>
+          </a:bodyPr>
+          <a:lstStyle/>
+          <a:p>
+            <a:pPr>
+              <a:spcAft>
+                <a:spcPts val="600"/>
+              </a:spcAft>
+            </a:pPr>
+            <a:r>
+              <a:rPr sz="1050" b="0">
+                <a:solidFill>
+                  <a:srgbClr val="6E6E6E"/>
+                </a:solidFill>
+                <a:latin typeface="Arial"/>
+              </a:rPr>
+              <a:t>Run tags v2g, v2loop, v3arm, v3s, v3loop, an193_cube/q300/q100/az1; zwfs_dm96 README V2-V4.</a:t>
+            </a:r>
+          </a:p>
+        </p:txBody>
+      </p:sp>
+    </p:spTree>
+  </p:cSld>
+  <p:clrMapOvr>
+    <a:masterClrMapping/>
+  </p:clrMapOvr>
+</p:sld>
+</file>
+
+<file path=ppt/slides/slide51.xml><?xml version="1.0" encoding="utf-8"?>
+<p:sld xmlns:a="http://schemas.openxmlformats.org/drawingml/2006/main" xmlns:p="http://schemas.openxmlformats.org/presentationml/2006/main" xmlns:r="http://schemas.openxmlformats.org/officeDocument/2006/relationships">
+  <p:cSld>
+    <p:spTree>
+      <p:nvGrpSpPr>
+        <p:cNvPr id="1" name=""/>
+        <p:cNvGrpSpPr/>
+        <p:nvPr/>
+      </p:nvGrpSpPr>
+      <p:grpSpPr/>
+      <p:sp>
+        <p:nvSpPr>
+          <p:cNvPr id="2" name="TextBox 1"/>
+          <p:cNvSpPr txBox="1"/>
+          <p:nvPr/>
+        </p:nvSpPr>
+        <p:spPr>
+          <a:xfrm>
+            <a:off x="411480" y="201168"/>
+            <a:ext cx="11368735" cy="914400"/>
+          </a:xfrm>
+          <a:prstGeom prst="rect">
+            <a:avLst/>
+          </a:prstGeom>
+          <a:noFill/>
+        </p:spPr>
+        <p:txBody>
+          <a:bodyPr wrap="square">
+            <a:spAutoFit/>
+          </a:bodyPr>
+          <a:lstStyle/>
+          <a:p>
+            <a:pPr>
+              <a:spcAft>
+                <a:spcPts val="400"/>
+              </a:spcAft>
+            </a:pPr>
+            <a:r>
+              <a:rPr sz="2400" b="1">
+                <a:solidFill>
+                  <a:srgbClr val="1F4E79"/>
+                </a:solidFill>
+                <a:latin typeface="Arial"/>
+              </a:rPr>
               <a:t>Backup: the sensor model, sampling and color</a:t>
             </a:r>
           </a:p>
@@ -30413,7 +31193,7 @@
 </p:sld>
 </file>
 
-<file path=ppt/slides/slide51.xml><?xml version="1.0" encoding="utf-8"?>
+<file path=ppt/slides/slide52.xml><?xml version="1.0" encoding="utf-8"?>
 <p:sld xmlns:a="http://schemas.openxmlformats.org/drawingml/2006/main" xmlns:p="http://schemas.openxmlformats.org/presentationml/2006/main" xmlns:r="http://schemas.openxmlformats.org/officeDocument/2006/relationships">
   <p:cSld>
     <p:spTree>
@@ -31117,7 +31897,7 @@
 </p:sld>
 </file>
 
-<file path=ppt/slides/slide52.xml><?xml version="1.0" encoding="utf-8"?>
+<file path=ppt/slides/slide53.xml><?xml version="1.0" encoding="utf-8"?>
 <p:sld xmlns:a="http://schemas.openxmlformats.org/drawingml/2006/main" xmlns:p="http://schemas.openxmlformats.org/presentationml/2006/main" xmlns:r="http://schemas.openxmlformats.org/officeDocument/2006/relationships">
   <p:cSld>
     <p:spTree>
@@ -32111,7 +32891,7 @@
 </p:sld>
 </file>
 
-<file path=ppt/slides/slide53.xml><?xml version="1.0" encoding="utf-8"?>
+<file path=ppt/slides/slide54.xml><?xml version="1.0" encoding="utf-8"?>
 <p:sld xmlns:a="http://schemas.openxmlformats.org/drawingml/2006/main" xmlns:p="http://schemas.openxmlformats.org/presentationml/2006/main" xmlns:r="http://schemas.openxmlformats.org/officeDocument/2006/relationships">
   <p:cSld>
     <p:spTree>

</xml_diff>

<commit_message>
Mac cycle 3a jobs C+D folded: the pupil stage on the substrates decks (near-perfect on both rigs), the sensors at 385 with the mask plate (rows hold, capture 15-20% less); backup slide, brief section 7, slice
Co-Authored-By: Claude Fable 5.1 <noreply@anthropic.com>
</commit_message>
<xml_diff>
--- a/demo_session/deck_gauges.pptx
+++ b/demo_session/deck_gauges.pptx
@@ -25559,7 +25559,7 @@
         </p:nvGraphicFramePr>
         <p:xfrm>
           <a:off x="411480" y="1298448"/>
-          <a:ext cx="11368733" cy="2057400"/>
+          <a:ext cx="11368733" cy="3651885"/>
         </p:xfrm>
         <a:graphic>
           <a:graphicData uri="http://schemas.openxmlformats.org/drawingml/2006/table">
@@ -25568,10 +25568,10 @@
                 <a:tableStyleId>{5C22544A-7EE6-4342-B048-85BDC9FD1C3A}</a:tableStyleId>
               </a:tblPr>
               <a:tblGrid>
-                <a:gridCol w="3100564"/>
-                <a:gridCol w="2735791"/>
-                <a:gridCol w="2188633"/>
-                <a:gridCol w="3343745"/>
+                <a:gridCol w="4599850"/>
+                <a:gridCol w="1682871"/>
+                <a:gridCol w="3029169"/>
+                <a:gridCol w="2056843"/>
               </a:tblGrid>
               <a:tr h="468630">
                 <a:tc>
@@ -25753,7 +25753,7 @@
                   </a:tcPr>
                 </a:tc>
               </a:tr>
-              <a:tr h="280035">
+              <a:tr h="468630">
                 <a:tc>
                   <a:txBody>
                     <a:bodyPr wrap="square"/>
@@ -26109,6 +26109,276 @@
                   <a:tcPr marL="54864" marR="54864" marT="18288" marB="18288">
                     <a:solidFill>
                       <a:srgbClr val="FFFFFF"/>
+                    </a:solidFill>
+                  </a:tcPr>
+                </a:tc>
+              </a:tr>
+              <a:tr h="468630">
+                <a:tc>
+                  <a:txBody>
+                    <a:bodyPr wrap="square"/>
+                    <a:lstStyle/>
+                    <a:p>
+                      <a:r>
+                        <a:rPr sz="1100" b="0">
+                          <a:solidFill>
+                            <a:srgbClr val="282828"/>
+                          </a:solidFill>
+                          <a:latin typeface="Arial"/>
+                        </a:rPr>
+                        <a:t>pupil imaging on these decks (tg96_pupilsim): image surface vs the camera / Nyquist gain / distortion / 30 nm surface error</a:t>
+                      </a:r>
+                    </a:p>
+                  </a:txBody>
+                  <a:tcPr marL="54864" marR="54864" marT="18288" marB="18288">
+                    <a:solidFill>
+                      <a:srgbClr val="ECF1F6"/>
+                    </a:solidFill>
+                  </a:tcPr>
+                </a:tc>
+                <a:tc>
+                  <a:txBody>
+                    <a:bodyPr wrap="square"/>
+                    <a:lstStyle/>
+                    <a:p>
+                      <a:r>
+                        <a:rPr sz="1100" b="0">
+                          <a:solidFill>
+                            <a:srgbClr val="282828"/>
+                          </a:solidFill>
+                          <a:latin typeface="Arial"/>
+                        </a:rPr>
+                        <a:t>within ±0.3 mm / 0.9999 / 0.008 mm / 0.08 nm</a:t>
+                      </a:r>
+                    </a:p>
+                  </a:txBody>
+                  <a:tcPr marL="54864" marR="54864" marT="18288" marB="18288">
+                    <a:solidFill>
+                      <a:srgbClr val="ECF1F6"/>
+                    </a:solidFill>
+                  </a:tcPr>
+                </a:tc>
+                <a:tc>
+                  <a:txBody>
+                    <a:bodyPr wrap="square"/>
+                    <a:lstStyle/>
+                    <a:p>
+                      <a:r>
+                        <a:rPr sz="1100" b="0">
+                          <a:solidFill>
+                            <a:srgbClr val="282828"/>
+                          </a:solidFill>
+                          <a:latin typeface="Arial"/>
+                        </a:rPr>
+                        <a:t>within −0.6 to +0.4 mm / 0.9996 / 0.72 mm (the parabola pair's mapping) / 0.10 nm</a:t>
+                      </a:r>
+                    </a:p>
+                  </a:txBody>
+                  <a:tcPr marL="54864" marR="54864" marT="18288" marB="18288">
+                    <a:solidFill>
+                      <a:srgbClr val="ECF1F6"/>
+                    </a:solidFill>
+                  </a:tcPr>
+                </a:tc>
+                <a:tc>
+                  <a:txBody>
+                    <a:bodyPr wrap="square"/>
+                    <a:lstStyle/>
+                    <a:p>
+                      <a:r>
+                        <a:rPr sz="1100" b="0">
+                          <a:solidFill>
+                            <a:srgbClr val="282828"/>
+                          </a:solidFill>
+                          <a:latin typeface="Arial"/>
+                        </a:rPr>
+                        <a:t>tuned tail: 2.6 to 6 mm / 0.954 / 0.27 mm / 1.2 nm</a:t>
+                      </a:r>
+                    </a:p>
+                  </a:txBody>
+                  <a:tcPr marL="54864" marR="54864" marT="18288" marB="18288">
+                    <a:solidFill>
+                      <a:srgbClr val="ECF1F6"/>
+                    </a:solidFill>
+                  </a:tcPr>
+                </a:tc>
+              </a:tr>
+              <a:tr h="468630">
+                <a:tc>
+                  <a:txBody>
+                    <a:bodyPr wrap="square"/>
+                    <a:lstStyle/>
+                    <a:p>
+                      <a:r>
+                        <a:rPr sz="1100" b="0">
+                          <a:solidFill>
+                            <a:srgbClr val="282828"/>
+                          </a:solidFill>
+                          <a:latin typeface="Arial"/>
+                        </a:rPr>
+                        <a:t>the sensors on the mirror rig at 385 px, substrates in: stepped-Zernike rows, single / grid</a:t>
+                      </a:r>
+                    </a:p>
+                  </a:txBody>
+                  <a:tcPr marL="54864" marR="54864" marT="18288" marB="18288">
+                    <a:solidFill>
+                      <a:srgbClr val="FFFFFF"/>
+                    </a:solidFill>
+                  </a:tcPr>
+                </a:tc>
+                <a:tc>
+                  <a:txBody>
+                    <a:bodyPr wrap="square"/>
+                    <a:lstStyle/>
+                    <a:p>
+                      <a:r>
+                        <a:rPr sz="1100" b="0">
+                          <a:solidFill>
+                            <a:srgbClr val="282828"/>
+                          </a:solidFill>
+                          <a:latin typeface="Arial"/>
+                        </a:rPr>
+                        <a:t>—</a:t>
+                      </a:r>
+                    </a:p>
+                  </a:txBody>
+                  <a:tcPr marL="54864" marR="54864" marT="18288" marB="18288">
+                    <a:solidFill>
+                      <a:srgbClr val="FFFFFF"/>
+                    </a:solidFill>
+                  </a:tcPr>
+                </a:tc>
+                <a:tc>
+                  <a:txBody>
+                    <a:bodyPr wrap="square"/>
+                    <a:lstStyle/>
+                    <a:p>
+                      <a:r>
+                        <a:rPr sz="1100" b="0">
+                          <a:solidFill>
+                            <a:srgbClr val="282828"/>
+                          </a:solidFill>
+                          <a:latin typeface="Arial"/>
+                        </a:rPr>
+                        <a:t>0.993 / 5 pm; 0.995 / 4 pm</a:t>
+                      </a:r>
+                    </a:p>
+                  </a:txBody>
+                  <a:tcPr marL="54864" marR="54864" marT="18288" marB="18288">
+                    <a:solidFill>
+                      <a:srgbClr val="FFFFFF"/>
+                    </a:solidFill>
+                  </a:tcPr>
+                </a:tc>
+                <a:tc>
+                  <a:txBody>
+                    <a:bodyPr wrap="square"/>
+                    <a:lstStyle/>
+                    <a:p>
+                      <a:r>
+                        <a:rPr sz="1100" b="0">
+                          <a:solidFill>
+                            <a:srgbClr val="282828"/>
+                          </a:solidFill>
+                          <a:latin typeface="Arial"/>
+                        </a:rPr>
+                        <a:t>0.991 / 4; 0.999 / 4 (no substrates)</a:t>
+                      </a:r>
+                    </a:p>
+                  </a:txBody>
+                  <a:tcPr marL="54864" marR="54864" marT="18288" marB="18288">
+                    <a:solidFill>
+                      <a:srgbClr val="FFFFFF"/>
+                    </a:solidFill>
+                  </a:tcPr>
+                </a:tc>
+              </a:tr>
+              <a:tr h="468630">
+                <a:tc>
+                  <a:txBody>
+                    <a:bodyPr wrap="square"/>
+                    <a:lstStyle/>
+                    <a:p>
+                      <a:r>
+                        <a:rPr sz="1100" b="0">
+                          <a:solidFill>
+                            <a:srgbClr val="282828"/>
+                          </a:solidFill>
+                          <a:latin typeface="Arial"/>
+                        </a:rPr>
+                        <a:t>the sensors' capture to 10%: stepped / vector / pinhole</a:t>
+                      </a:r>
+                    </a:p>
+                  </a:txBody>
+                  <a:tcPr marL="54864" marR="54864" marT="18288" marB="18288">
+                    <a:solidFill>
+                      <a:srgbClr val="ECF1F6"/>
+                    </a:solidFill>
+                  </a:tcPr>
+                </a:tc>
+                <a:tc>
+                  <a:txBody>
+                    <a:bodyPr wrap="square"/>
+                    <a:lstStyle/>
+                    <a:p>
+                      <a:r>
+                        <a:rPr sz="1100" b="0">
+                          <a:solidFill>
+                            <a:srgbClr val="282828"/>
+                          </a:solidFill>
+                          <a:latin typeface="Arial"/>
+                        </a:rPr>
+                        <a:t>—</a:t>
+                      </a:r>
+                    </a:p>
+                  </a:txBody>
+                  <a:tcPr marL="54864" marR="54864" marT="18288" marB="18288">
+                    <a:solidFill>
+                      <a:srgbClr val="ECF1F6"/>
+                    </a:solidFill>
+                  </a:tcPr>
+                </a:tc>
+                <a:tc>
+                  <a:txBody>
+                    <a:bodyPr wrap="square"/>
+                    <a:lstStyle/>
+                    <a:p>
+                      <a:r>
+                        <a:rPr sz="1100" b="0">
+                          <a:solidFill>
+                            <a:srgbClr val="282828"/>
+                          </a:solidFill>
+                          <a:latin typeface="Arial"/>
+                        </a:rPr>
+                        <a:t>35 / 51 / 42 nm</a:t>
+                      </a:r>
+                    </a:p>
+                  </a:txBody>
+                  <a:tcPr marL="54864" marR="54864" marT="18288" marB="18288">
+                    <a:solidFill>
+                      <a:srgbClr val="ECF1F6"/>
+                    </a:solidFill>
+                  </a:tcPr>
+                </a:tc>
+                <a:tc>
+                  <a:txBody>
+                    <a:bodyPr wrap="square"/>
+                    <a:lstStyle/>
+                    <a:p>
+                      <a:r>
+                        <a:rPr sz="1100" b="0">
+                          <a:solidFill>
+                            <a:srgbClr val="282828"/>
+                          </a:solidFill>
+                          <a:latin typeface="Arial"/>
+                        </a:rPr>
+                        <a:t>36 / 59 / 52 nm (no substrates)</a:t>
+                      </a:r>
+                    </a:p>
+                  </a:txBody>
+                  <a:tcPr marL="54864" marR="54864" marT="18288" marB="18288">
+                    <a:solidFill>
+                      <a:srgbClr val="ECF1F6"/>
                     </a:solidFill>
                   </a:tcPr>
                 </a:tc>
@@ -26125,7 +26395,7 @@
         </p:nvSpPr>
         <p:spPr>
           <a:xfrm>
-            <a:off x="411480" y="3502152"/>
+            <a:off x="411480" y="5096637"/>
             <a:ext cx="11368735" cy="274320"/>
           </a:xfrm>
           <a:prstGeom prst="rect">
@@ -26167,6 +26437,22 @@
                 </a:solidFill>
                 <a:latin typeface="Arial"/>
               </a:rPr>
+              <a:t>•  The pupil image is not what limits either rig: on the seed tail with the substrates in, the DM images within a third of a millimeter of the camera on lenses (0.9999 at the actuator Nyquist, 0.08 nm on the working surface) and within 0.6 mm on mirrors; the lens rig's 92 nm null is the plate's spherical aberration and the misfed collimator, not the imaging.  The mask plate costs the sensors a little capture (vector 59 to 51 nm, pinhole 52 to 42) and no gain.</a:t>
+            </a:r>
+          </a:p>
+          <a:p>
+            <a:pPr>
+              <a:spcAft>
+                <a:spcPts val="600"/>
+              </a:spcAft>
+            </a:pPr>
+            <a:r>
+              <a:rPr sz="1500" b="0">
+                <a:solidFill>
+                  <a:srgbClr val="282828"/>
+                </a:solidFill>
+                <a:latin typeface="Arial"/>
+              </a:rPr>
               <a:t>•  One clearance line moved: with the thicker plates and the larger beam the compensator sits 16 mm from the source beam against the 25 mm rule; it moves down the DM leg in the redo.</a:t>
             </a:r>
           </a:p>
@@ -26180,7 +26466,7 @@
         </p:nvSpPr>
         <p:spPr>
           <a:xfrm>
-            <a:off x="411480" y="5552694"/>
+            <a:off x="411480" y="8277987"/>
             <a:ext cx="11368735" cy="274320"/>
           </a:xfrm>
           <a:prstGeom prst="rect">
@@ -26206,7 +26492,7 @@
                 </a:solidFill>
                 <a:latin typeface="Arial"/>
               </a:rPr>
-              <a:t>Run tags sub96_lens, sub96_oap (the Mac, RUNBOOK_mac_cycle3a); the pupil stage and the sensors at 385 on these decks follow.</a:t>
+              <a:t>Run tags sub96_lens, sub96_oap, pupilsim_sub96_lens, pupilsim_sub96_oap, sub96_oapsens (the Mac, RUNBOOK_mac_cycle3a, 2026-09-17).</a:t>
             </a:r>
           </a:p>
         </p:txBody>

</xml_diff>

<commit_message>
Package A passed (TO): the redo slide and brief section 8 carry the gate record; the distortion gate withdrawn, the grid-row gate added
Co-Authored-By: Claude Fable 5.1 <noreply@anthropic.com>
</commit_message>
<xml_diff>
--- a/demo_session/deck_gauges.pptx
+++ b/demo_session/deck_gauges.pptx
@@ -23504,7 +23504,7 @@
                 </a:solidFill>
                 <a:latin typeface="Arial"/>
               </a:rPr>
-              <a:t>•  Expected movement: the lens rig's rows and station figure improve; the pupil image grows to 9.8 mm; all 96×96 actuators in the lit set; the mirror rig's rows move only with the beam.</a:t>
+              <a:t>•  Package A passed on both rigs (TO, 2026-09-17 13:30): collimated, re-tuned on the reading, re-emitted.  Nyquist gain 1.0000 (lens) / 0.9994 (mirrors) worst; the 30 nm surface recovered to 42 pm (lens, 29× the record's tuned tail) and 92 pm (mirrors); single pokes 0.9998 peak; the lens rig's amplitude cross-talk 0.005 (was a third); certified at twice the sampling the tunes ran at.  Distortion is a mapping, not a gate.</a:t>
             </a:r>
           </a:p>
         </p:txBody>
@@ -23517,7 +23517,7 @@
         </p:nvSpPr>
         <p:spPr>
           <a:xfrm>
-            <a:off x="6400800" y="4867656"/>
+            <a:off x="6400800" y="5462015"/>
             <a:ext cx="5394960" cy="274320"/>
           </a:xfrm>
           <a:prstGeom prst="rect">
@@ -23543,7 +23543,7 @@
                 </a:solidFill>
                 <a:latin typeface="Arial"/>
               </a:rPr>
-              <a:t>The interim report of 2026-09-18 carries the current record, labeled; the redo lands in its next revision.  Plan: BRIEF_to_tg_redo.md (packages A0, A, B, C); tools tg96_pupilsim, tg96_pupil_options, tg96_pupil_s2s.</a:t>
+              <a:t>The interim report of 2026-09-18 carries the current record, labeled; the redo lands in its next revision.  Package B (the engine's plane-to-plane chain) and C (the runs) follow; the Mac carries C's mirror side.  Plan: BRIEF_to_tg_redo.md (packages A0, A, B, C); tools tg96_pupilsim, tg96_pupil_options, tg96_pupil_s2s.</a:t>
             </a:r>
           </a:p>
         </p:txBody>

</xml_diff>

<commit_message>
Mac cycle 3b folded: the redo bench's rows (lens grid row 0.754 -> 0.993, null 59 nm; mirrors unchanged) on the backup slide and in the brief; the sensors' seat scan failed on the mirror rig -> runbook job C with the explicit seat, note for TO; slice
Co-Authored-By: Claude Fable 5.1 <noreply@anthropic.com>
</commit_message>
<xml_diff>
--- a/demo_session/deck_gauges.pptx
+++ b/demo_session/deck_gauges.pptx
@@ -25559,7 +25559,7 @@
         </p:nvGraphicFramePr>
         <p:xfrm>
           <a:off x="411480" y="1298448"/>
-          <a:ext cx="11368733" cy="3651885"/>
+          <a:ext cx="11368733" cy="4972050"/>
         </p:xfrm>
         <a:graphic>
           <a:graphicData uri="http://schemas.openxmlformats.org/drawingml/2006/table">
@@ -25568,11 +25568,147 @@
                 <a:tableStyleId>{5C22544A-7EE6-4342-B048-85BDC9FD1C3A}</a:tableStyleId>
               </a:tblPr>
               <a:tblGrid>
-                <a:gridCol w="4599850"/>
-                <a:gridCol w="1682871"/>
-                <a:gridCol w="3029169"/>
-                <a:gridCol w="2056843"/>
+                <a:gridCol w="3217820"/>
+                <a:gridCol w="1177251"/>
+                <a:gridCol w="2119052"/>
+                <a:gridCol w="1308056"/>
+                <a:gridCol w="2107692"/>
+                <a:gridCol w="1438862"/>
               </a:tblGrid>
+              <a:tr h="657225">
+                <a:tc>
+                  <a:txBody>
+                    <a:bodyPr wrap="square"/>
+                    <a:lstStyle/>
+                    <a:p>
+                      <a:r>
+                        <a:rPr sz="1100" b="1">
+                          <a:solidFill>
+                            <a:srgbClr val="FFFFFF"/>
+                          </a:solidFill>
+                          <a:latin typeface="Arial"/>
+                        </a:rPr>
+                        <a:t>rows on the 30 nm surface, matrix on it (four-step)</a:t>
+                      </a:r>
+                    </a:p>
+                  </a:txBody>
+                  <a:tcPr marL="54864" marR="54864" marT="18288" marB="18288">
+                    <a:solidFill>
+                      <a:srgbClr val="1F4E79"/>
+                    </a:solidFill>
+                  </a:tcPr>
+                </a:tc>
+                <a:tc>
+                  <a:txBody>
+                    <a:bodyPr wrap="square"/>
+                    <a:lstStyle/>
+                    <a:p>
+                      <a:r>
+                        <a:rPr sz="1100" b="1">
+                          <a:solidFill>
+                            <a:srgbClr val="FFFFFF"/>
+                          </a:solidFill>
+                          <a:latin typeface="Arial"/>
+                        </a:rPr>
+                        <a:t>lens rig, seed tail, substrates in (cycle 3a)</a:t>
+                      </a:r>
+                    </a:p>
+                  </a:txBody>
+                  <a:tcPr marL="54864" marR="54864" marT="18288" marB="18288">
+                    <a:solidFill>
+                      <a:srgbClr val="1F4E79"/>
+                    </a:solidFill>
+                  </a:tcPr>
+                </a:tc>
+                <a:tc>
+                  <a:txBody>
+                    <a:bodyPr wrap="square"/>
+                    <a:lstStyle/>
+                    <a:p>
+                      <a:r>
+                        <a:rPr sz="1100" b="1">
+                          <a:solidFill>
+                            <a:srgbClr val="FFFFFF"/>
+                          </a:solidFill>
+                          <a:latin typeface="Arial"/>
+                        </a:rPr>
+                        <a:t>lens rig, redo bench (cycle 3b)</a:t>
+                      </a:r>
+                    </a:p>
+                  </a:txBody>
+                  <a:tcPr marL="54864" marR="54864" marT="18288" marB="18288">
+                    <a:solidFill>
+                      <a:srgbClr val="1F4E79"/>
+                    </a:solidFill>
+                  </a:tcPr>
+                </a:tc>
+                <a:tc>
+                  <a:txBody>
+                    <a:bodyPr wrap="square"/>
+                    <a:lstStyle/>
+                    <a:p>
+                      <a:r>
+                        <a:rPr sz="1100" b="1">
+                          <a:solidFill>
+                            <a:srgbClr val="FFFFFF"/>
+                          </a:solidFill>
+                          <a:latin typeface="Arial"/>
+                        </a:rPr>
+                        <a:t>mirror rig, seed tail, substrates in (3a)</a:t>
+                      </a:r>
+                    </a:p>
+                  </a:txBody>
+                  <a:tcPr marL="54864" marR="54864" marT="18288" marB="18288">
+                    <a:solidFill>
+                      <a:srgbClr val="1F4E79"/>
+                    </a:solidFill>
+                  </a:tcPr>
+                </a:tc>
+                <a:tc>
+                  <a:txBody>
+                    <a:bodyPr wrap="square"/>
+                    <a:lstStyle/>
+                    <a:p>
+                      <a:r>
+                        <a:rPr sz="1100" b="1">
+                          <a:solidFill>
+                            <a:srgbClr val="FFFFFF"/>
+                          </a:solidFill>
+                          <a:latin typeface="Arial"/>
+                        </a:rPr>
+                        <a:t>mirror rig, redo bench (3b)</a:t>
+                      </a:r>
+                    </a:p>
+                  </a:txBody>
+                  <a:tcPr marL="54864" marR="54864" marT="18288" marB="18288">
+                    <a:solidFill>
+                      <a:srgbClr val="1F4E79"/>
+                    </a:solidFill>
+                  </a:tcPr>
+                </a:tc>
+                <a:tc>
+                  <a:txBody>
+                    <a:bodyPr wrap="square"/>
+                    <a:lstStyle/>
+                    <a:p>
+                      <a:r>
+                        <a:rPr sz="1100" b="1">
+                          <a:solidFill>
+                            <a:srgbClr val="FFFFFF"/>
+                          </a:solidFill>
+                          <a:latin typeface="Arial"/>
+                        </a:rPr>
+                        <a:t>the record (tuned tail, no substrates, 77 / 82 mm beam)</a:t>
+                      </a:r>
+                    </a:p>
+                  </a:txBody>
+                  <a:tcPr marL="54864" marR="54864" marT="18288" marB="18288">
+                    <a:solidFill>
+                      <a:srgbClr val="1F4E79"/>
+                    </a:solidFill>
+                  </a:tcPr>
+                </a:tc>
+              </a:tr>
               <a:tr h="468630">
                 <a:tc>
                   <a:txBody>
@@ -25580,85 +25716,531 @@
                     <a:lstStyle/>
                     <a:p>
                       <a:r>
-                        <a:rPr sz="1100" b="1">
-                          <a:solidFill>
-                            <a:srgbClr val="FFFFFF"/>
-                          </a:solidFill>
-                          <a:latin typeface="Arial"/>
-                        </a:rPr>
-                        <a:t>rows on the 30 nm surface, matrix on it (four-step)</a:t>
-                      </a:r>
-                    </a:p>
-                  </a:txBody>
-                  <a:tcPr marL="54864" marR="54864" marT="18288" marB="18288">
-                    <a:solidFill>
-                      <a:srgbClr val="1F4E79"/>
-                    </a:solidFill>
-                  </a:tcPr>
-                </a:tc>
-                <a:tc>
-                  <a:txBody>
-                    <a:bodyPr wrap="square"/>
-                    <a:lstStyle/>
-                    <a:p>
-                      <a:r>
-                        <a:rPr sz="1100" b="1">
-                          <a:solidFill>
-                            <a:srgbClr val="FFFFFF"/>
-                          </a:solidFill>
-                          <a:latin typeface="Arial"/>
-                        </a:rPr>
-                        <a:t>lens rig, seed tail, substrates in</a:t>
-                      </a:r>
-                    </a:p>
-                  </a:txBody>
-                  <a:tcPr marL="54864" marR="54864" marT="18288" marB="18288">
-                    <a:solidFill>
-                      <a:srgbClr val="1F4E79"/>
-                    </a:solidFill>
-                  </a:tcPr>
-                </a:tc>
-                <a:tc>
-                  <a:txBody>
-                    <a:bodyPr wrap="square"/>
-                    <a:lstStyle/>
-                    <a:p>
-                      <a:r>
-                        <a:rPr sz="1100" b="1">
-                          <a:solidFill>
-                            <a:srgbClr val="FFFFFF"/>
-                          </a:solidFill>
-                          <a:latin typeface="Arial"/>
-                        </a:rPr>
-                        <a:t>mirror rig, seed tail, substrates in</a:t>
-                      </a:r>
-                    </a:p>
-                  </a:txBody>
-                  <a:tcPr marL="54864" marR="54864" marT="18288" marB="18288">
-                    <a:solidFill>
-                      <a:srgbClr val="1F4E79"/>
-                    </a:solidFill>
-                  </a:tcPr>
-                </a:tc>
-                <a:tc>
-                  <a:txBody>
-                    <a:bodyPr wrap="square"/>
-                    <a:lstStyle/>
-                    <a:p>
-                      <a:r>
-                        <a:rPr sz="1100" b="1">
-                          <a:solidFill>
-                            <a:srgbClr val="FFFFFF"/>
-                          </a:solidFill>
-                          <a:latin typeface="Arial"/>
-                        </a:rPr>
-                        <a:t>the record (tuned tail, no substrates, 77 / 82 mm beam)</a:t>
-                      </a:r>
-                    </a:p>
-                  </a:txBody>
-                  <a:tcPr marL="54864" marR="54864" marT="18288" marB="18288">
-                    <a:solidFill>
-                      <a:srgbClr val="1F4E79"/>
+                        <a:rPr sz="1100" b="0">
+                          <a:solidFill>
+                            <a:srgbClr val="282828"/>
+                          </a:solidFill>
+                          <a:latin typeface="Arial"/>
+                        </a:rPr>
+                        <a:t>flat-mirror null</a:t>
+                      </a:r>
+                    </a:p>
+                  </a:txBody>
+                  <a:tcPr marL="54864" marR="54864" marT="18288" marB="18288">
+                    <a:solidFill>
+                      <a:srgbClr val="FFFFFF"/>
+                    </a:solidFill>
+                  </a:tcPr>
+                </a:tc>
+                <a:tc>
+                  <a:txBody>
+                    <a:bodyPr wrap="square"/>
+                    <a:lstStyle/>
+                    <a:p>
+                      <a:r>
+                        <a:rPr sz="1100" b="0">
+                          <a:solidFill>
+                            <a:srgbClr val="282828"/>
+                          </a:solidFill>
+                          <a:latin typeface="Arial"/>
+                        </a:rPr>
+                        <a:t>92.4 nm rms</a:t>
+                      </a:r>
+                    </a:p>
+                  </a:txBody>
+                  <a:tcPr marL="54864" marR="54864" marT="18288" marB="18288">
+                    <a:solidFill>
+                      <a:srgbClr val="FFFFFF"/>
+                    </a:solidFill>
+                  </a:tcPr>
+                </a:tc>
+                <a:tc>
+                  <a:txBody>
+                    <a:bodyPr wrap="square"/>
+                    <a:lstStyle/>
+                    <a:p>
+                      <a:r>
+                        <a:rPr sz="1100" b="0">
+                          <a:solidFill>
+                            <a:srgbClr val="282828"/>
+                          </a:solidFill>
+                          <a:latin typeface="Arial"/>
+                        </a:rPr>
+                        <a:t>59.3 nm</a:t>
+                      </a:r>
+                    </a:p>
+                  </a:txBody>
+                  <a:tcPr marL="54864" marR="54864" marT="18288" marB="18288">
+                    <a:solidFill>
+                      <a:srgbClr val="FFFFFF"/>
+                    </a:solidFill>
+                  </a:tcPr>
+                </a:tc>
+                <a:tc>
+                  <a:txBody>
+                    <a:bodyPr wrap="square"/>
+                    <a:lstStyle/>
+                    <a:p>
+                      <a:r>
+                        <a:rPr sz="1100" b="0">
+                          <a:solidFill>
+                            <a:srgbClr val="282828"/>
+                          </a:solidFill>
+                          <a:latin typeface="Arial"/>
+                        </a:rPr>
+                        <a:t>26.3 nm</a:t>
+                      </a:r>
+                    </a:p>
+                  </a:txBody>
+                  <a:tcPr marL="54864" marR="54864" marT="18288" marB="18288">
+                    <a:solidFill>
+                      <a:srgbClr val="FFFFFF"/>
+                    </a:solidFill>
+                  </a:tcPr>
+                </a:tc>
+                <a:tc>
+                  <a:txBody>
+                    <a:bodyPr wrap="square"/>
+                    <a:lstStyle/>
+                    <a:p>
+                      <a:r>
+                        <a:rPr sz="1100" b="0">
+                          <a:solidFill>
+                            <a:srgbClr val="282828"/>
+                          </a:solidFill>
+                          <a:latin typeface="Arial"/>
+                        </a:rPr>
+                        <a:t>26.5 nm</a:t>
+                      </a:r>
+                    </a:p>
+                  </a:txBody>
+                  <a:tcPr marL="54864" marR="54864" marT="18288" marB="18288">
+                    <a:solidFill>
+                      <a:srgbClr val="FFFFFF"/>
+                    </a:solidFill>
+                  </a:tcPr>
+                </a:tc>
+                <a:tc>
+                  <a:txBody>
+                    <a:bodyPr wrap="square"/>
+                    <a:lstStyle/>
+                    <a:p>
+                      <a:r>
+                        <a:rPr sz="1100" b="0">
+                          <a:solidFill>
+                            <a:srgbClr val="282828"/>
+                          </a:solidFill>
+                          <a:latin typeface="Arial"/>
+                        </a:rPr>
+                        <a:t>0.13 nm lens / 0.03 mirrors</a:t>
+                      </a:r>
+                    </a:p>
+                  </a:txBody>
+                  <a:tcPr marL="54864" marR="54864" marT="18288" marB="18288">
+                    <a:solidFill>
+                      <a:srgbClr val="FFFFFF"/>
+                    </a:solidFill>
+                  </a:tcPr>
+                </a:tc>
+              </a:tr>
+              <a:tr h="657225">
+                <a:tc>
+                  <a:txBody>
+                    <a:bodyPr wrap="square"/>
+                    <a:lstStyle/>
+                    <a:p>
+                      <a:r>
+                        <a:rPr sz="1100" b="0">
+                          <a:solidFill>
+                            <a:srgbClr val="282828"/>
+                          </a:solidFill>
+                          <a:latin typeface="Arial"/>
+                        </a:rPr>
+                        <a:t>10 nm on one actuator: gain / error / SNR</a:t>
+                      </a:r>
+                    </a:p>
+                  </a:txBody>
+                  <a:tcPr marL="54864" marR="54864" marT="18288" marB="18288">
+                    <a:solidFill>
+                      <a:srgbClr val="ECF1F6"/>
+                    </a:solidFill>
+                  </a:tcPr>
+                </a:tc>
+                <a:tc>
+                  <a:txBody>
+                    <a:bodyPr wrap="square"/>
+                    <a:lstStyle/>
+                    <a:p>
+                      <a:r>
+                        <a:rPr sz="1100" b="0">
+                          <a:solidFill>
+                            <a:srgbClr val="282828"/>
+                          </a:solidFill>
+                          <a:latin typeface="Arial"/>
+                        </a:rPr>
+                        <a:t>1.003 / 1 pm / 10645</a:t>
+                      </a:r>
+                    </a:p>
+                  </a:txBody>
+                  <a:tcPr marL="54864" marR="54864" marT="18288" marB="18288">
+                    <a:solidFill>
+                      <a:srgbClr val="ECF1F6"/>
+                    </a:solidFill>
+                  </a:tcPr>
+                </a:tc>
+                <a:tc>
+                  <a:txBody>
+                    <a:bodyPr wrap="square"/>
+                    <a:lstStyle/>
+                    <a:p>
+                      <a:r>
+                        <a:rPr sz="1100" b="0">
+                          <a:solidFill>
+                            <a:srgbClr val="282828"/>
+                          </a:solidFill>
+                          <a:latin typeface="Arial"/>
+                        </a:rPr>
+                        <a:t>1.004 / 1.4 pm / 7741</a:t>
+                      </a:r>
+                    </a:p>
+                  </a:txBody>
+                  <a:tcPr marL="54864" marR="54864" marT="18288" marB="18288">
+                    <a:solidFill>
+                      <a:srgbClr val="ECF1F6"/>
+                    </a:solidFill>
+                  </a:tcPr>
+                </a:tc>
+                <a:tc>
+                  <a:txBody>
+                    <a:bodyPr wrap="square"/>
+                    <a:lstStyle/>
+                    <a:p>
+                      <a:r>
+                        <a:rPr sz="1100" b="0">
+                          <a:solidFill>
+                            <a:srgbClr val="282828"/>
+                          </a:solidFill>
+                          <a:latin typeface="Arial"/>
+                        </a:rPr>
+                        <a:t>0.986 / 2.2 pm / 6472</a:t>
+                      </a:r>
+                    </a:p>
+                  </a:txBody>
+                  <a:tcPr marL="54864" marR="54864" marT="18288" marB="18288">
+                    <a:solidFill>
+                      <a:srgbClr val="ECF1F6"/>
+                    </a:solidFill>
+                  </a:tcPr>
+                </a:tc>
+                <a:tc>
+                  <a:txBody>
+                    <a:bodyPr wrap="square"/>
+                    <a:lstStyle/>
+                    <a:p>
+                      <a:r>
+                        <a:rPr sz="1100" b="0">
+                          <a:solidFill>
+                            <a:srgbClr val="282828"/>
+                          </a:solidFill>
+                          <a:latin typeface="Arial"/>
+                        </a:rPr>
+                        <a:t>0.986 / 2.3 pm / 6044</a:t>
+                      </a:r>
+                    </a:p>
+                  </a:txBody>
+                  <a:tcPr marL="54864" marR="54864" marT="18288" marB="18288">
+                    <a:solidFill>
+                      <a:srgbClr val="ECF1F6"/>
+                    </a:solidFill>
+                  </a:tcPr>
+                </a:tc>
+                <a:tc>
+                  <a:txBody>
+                    <a:bodyPr wrap="square"/>
+                    <a:lstStyle/>
+                    <a:p>
+                      <a:r>
+                        <a:rPr sz="1100" b="0">
+                          <a:solidFill>
+                            <a:srgbClr val="282828"/>
+                          </a:solidFill>
+                          <a:latin typeface="Arial"/>
+                        </a:rPr>
+                        <a:t>0.992 / 2.2 pm (lens), 0.992 / 2.4 (mirrors)</a:t>
+                      </a:r>
+                    </a:p>
+                  </a:txBody>
+                  <a:tcPr marL="54864" marR="54864" marT="18288" marB="18288">
+                    <a:solidFill>
+                      <a:srgbClr val="ECF1F6"/>
+                    </a:solidFill>
+                  </a:tcPr>
+                </a:tc>
+              </a:tr>
+              <a:tr h="468630">
+                <a:tc>
+                  <a:txBody>
+                    <a:bodyPr wrap="square"/>
+                    <a:lstStyle/>
+                    <a:p>
+                      <a:r>
+                        <a:rPr sz="1100" b="0">
+                          <a:solidFill>
+                            <a:srgbClr val="282828"/>
+                          </a:solidFill>
+                          <a:latin typeface="Arial"/>
+                        </a:rPr>
+                        <a:t>1 nm on the grid (112-120 sites)</a:t>
+                      </a:r>
+                    </a:p>
+                  </a:txBody>
+                  <a:tcPr marL="54864" marR="54864" marT="18288" marB="18288">
+                    <a:solidFill>
+                      <a:srgbClr val="FFFFFF"/>
+                    </a:solidFill>
+                  </a:tcPr>
+                </a:tc>
+                <a:tc>
+                  <a:txBody>
+                    <a:bodyPr wrap="square"/>
+                    <a:lstStyle/>
+                    <a:p>
+                      <a:r>
+                        <a:rPr sz="1100" b="0">
+                          <a:solidFill>
+                            <a:srgbClr val="282828"/>
+                          </a:solidFill>
+                          <a:latin typeface="Arial"/>
+                        </a:rPr>
+                        <a:t>0.754 / 61.5 pm / 135</a:t>
+                      </a:r>
+                    </a:p>
+                  </a:txBody>
+                  <a:tcPr marL="54864" marR="54864" marT="18288" marB="18288">
+                    <a:solidFill>
+                      <a:srgbClr val="FFFFFF"/>
+                    </a:solidFill>
+                  </a:tcPr>
+                </a:tc>
+                <a:tc>
+                  <a:txBody>
+                    <a:bodyPr wrap="square"/>
+                    <a:lstStyle/>
+                    <a:p>
+                      <a:r>
+                        <a:rPr sz="1100" b="0">
+                          <a:solidFill>
+                            <a:srgbClr val="282828"/>
+                          </a:solidFill>
+                          <a:latin typeface="Arial"/>
+                        </a:rPr>
+                        <a:t>0.993 / 10 pm / 246</a:t>
+                      </a:r>
+                    </a:p>
+                  </a:txBody>
+                  <a:tcPr marL="54864" marR="54864" marT="18288" marB="18288">
+                    <a:solidFill>
+                      <a:srgbClr val="FFFFFF"/>
+                    </a:solidFill>
+                  </a:tcPr>
+                </a:tc>
+                <a:tc>
+                  <a:txBody>
+                    <a:bodyPr wrap="square"/>
+                    <a:lstStyle/>
+                    <a:p>
+                      <a:r>
+                        <a:rPr sz="1100" b="0">
+                          <a:solidFill>
+                            <a:srgbClr val="282828"/>
+                          </a:solidFill>
+                          <a:latin typeface="Arial"/>
+                        </a:rPr>
+                        <a:t>0.981 / 4.5 pm / 309</a:t>
+                      </a:r>
+                    </a:p>
+                  </a:txBody>
+                  <a:tcPr marL="54864" marR="54864" marT="18288" marB="18288">
+                    <a:solidFill>
+                      <a:srgbClr val="FFFFFF"/>
+                    </a:solidFill>
+                  </a:tcPr>
+                </a:tc>
+                <a:tc>
+                  <a:txBody>
+                    <a:bodyPr wrap="square"/>
+                    <a:lstStyle/>
+                    <a:p>
+                      <a:r>
+                        <a:rPr sz="1100" b="0">
+                          <a:solidFill>
+                            <a:srgbClr val="282828"/>
+                          </a:solidFill>
+                          <a:latin typeface="Arial"/>
+                        </a:rPr>
+                        <a:t>0.981 / 4.4 pm / 310</a:t>
+                      </a:r>
+                    </a:p>
+                  </a:txBody>
+                  <a:tcPr marL="54864" marR="54864" marT="18288" marB="18288">
+                    <a:solidFill>
+                      <a:srgbClr val="FFFFFF"/>
+                    </a:solidFill>
+                  </a:tcPr>
+                </a:tc>
+                <a:tc>
+                  <a:txBody>
+                    <a:bodyPr wrap="square"/>
+                    <a:lstStyle/>
+                    <a:p>
+                      <a:r>
+                        <a:rPr sz="1100" b="0">
+                          <a:solidFill>
+                            <a:srgbClr val="282828"/>
+                          </a:solidFill>
+                          <a:latin typeface="Arial"/>
+                        </a:rPr>
+                        <a:t>0.999 / 4 pm</a:t>
+                      </a:r>
+                    </a:p>
+                  </a:txBody>
+                  <a:tcPr marL="54864" marR="54864" marT="18288" marB="18288">
+                    <a:solidFill>
+                      <a:srgbClr val="FFFFFF"/>
+                    </a:solidFill>
+                  </a:tcPr>
+                </a:tc>
+              </a:tr>
+              <a:tr h="657225">
+                <a:tc>
+                  <a:txBody>
+                    <a:bodyPr wrap="square"/>
+                    <a:lstStyle/>
+                    <a:p>
+                      <a:r>
+                        <a:rPr sz="1100" b="0">
+                          <a:solidFill>
+                            <a:srgbClr val="282828"/>
+                          </a:solidFill>
+                          <a:latin typeface="Arial"/>
+                        </a:rPr>
+                        <a:t>capture to 10%, single site / grid</a:t>
+                      </a:r>
+                    </a:p>
+                  </a:txBody>
+                  <a:tcPr marL="54864" marR="54864" marT="18288" marB="18288">
+                    <a:solidFill>
+                      <a:srgbClr val="ECF1F6"/>
+                    </a:solidFill>
+                  </a:tcPr>
+                </a:tc>
+                <a:tc>
+                  <a:txBody>
+                    <a:bodyPr wrap="square"/>
+                    <a:lstStyle/>
+                    <a:p>
+                      <a:r>
+                        <a:rPr sz="1100" b="0">
+                          <a:solidFill>
+                            <a:srgbClr val="282828"/>
+                          </a:solidFill>
+                          <a:latin typeface="Arial"/>
+                        </a:rPr>
+                        <a:t>480 nm and beyond / outside at the first rung</a:t>
+                      </a:r>
+                    </a:p>
+                  </a:txBody>
+                  <a:tcPr marL="54864" marR="54864" marT="18288" marB="18288">
+                    <a:solidFill>
+                      <a:srgbClr val="ECF1F6"/>
+                    </a:solidFill>
+                  </a:tcPr>
+                </a:tc>
+                <a:tc>
+                  <a:txBody>
+                    <a:bodyPr wrap="square"/>
+                    <a:lstStyle/>
+                    <a:p>
+                      <a:r>
+                        <a:rPr sz="1100" b="0">
+                          <a:solidFill>
+                            <a:srgbClr val="282828"/>
+                          </a:solidFill>
+                          <a:latin typeface="Arial"/>
+                        </a:rPr>
+                        <a:t>480+ / 480+</a:t>
+                      </a:r>
+                    </a:p>
+                  </a:txBody>
+                  <a:tcPr marL="54864" marR="54864" marT="18288" marB="18288">
+                    <a:solidFill>
+                      <a:srgbClr val="ECF1F6"/>
+                    </a:solidFill>
+                  </a:tcPr>
+                </a:tc>
+                <a:tc>
+                  <a:txBody>
+                    <a:bodyPr wrap="square"/>
+                    <a:lstStyle/>
+                    <a:p>
+                      <a:r>
+                        <a:rPr sz="1100" b="0">
+                          <a:solidFill>
+                            <a:srgbClr val="282828"/>
+                          </a:solidFill>
+                          <a:latin typeface="Arial"/>
+                        </a:rPr>
+                        <a:t>480+ / 480+</a:t>
+                      </a:r>
+                    </a:p>
+                  </a:txBody>
+                  <a:tcPr marL="54864" marR="54864" marT="18288" marB="18288">
+                    <a:solidFill>
+                      <a:srgbClr val="ECF1F6"/>
+                    </a:solidFill>
+                  </a:tcPr>
+                </a:tc>
+                <a:tc>
+                  <a:txBody>
+                    <a:bodyPr wrap="square"/>
+                    <a:lstStyle/>
+                    <a:p>
+                      <a:r>
+                        <a:rPr sz="1100" b="0">
+                          <a:solidFill>
+                            <a:srgbClr val="282828"/>
+                          </a:solidFill>
+                          <a:latin typeface="Arial"/>
+                        </a:rPr>
+                        <a:t>480+ / 480+</a:t>
+                      </a:r>
+                    </a:p>
+                  </a:txBody>
+                  <a:tcPr marL="54864" marR="54864" marT="18288" marB="18288">
+                    <a:solidFill>
+                      <a:srgbClr val="ECF1F6"/>
+                    </a:solidFill>
+                  </a:tcPr>
+                </a:tc>
+                <a:tc>
+                  <a:txBody>
+                    <a:bodyPr wrap="square"/>
+                    <a:lstStyle/>
+                    <a:p>
+                      <a:r>
+                        <a:rPr sz="1100" b="0">
+                          <a:solidFill>
+                            <a:srgbClr val="282828"/>
+                          </a:solidFill>
+                          <a:latin typeface="Arial"/>
+                        </a:rPr>
+                        <a:t>322 / 480 and beyond</a:t>
+                      </a:r>
+                    </a:p>
+                  </a:txBody>
+                  <a:tcPr marL="54864" marR="54864" marT="18288" marB="18288">
+                    <a:solidFill>
+                      <a:srgbClr val="ECF1F6"/>
                     </a:solidFill>
                   </a:tcPr>
                 </a:tc>
@@ -25676,75 +26258,347 @@
                           </a:solidFill>
                           <a:latin typeface="Arial"/>
                         </a:rPr>
-                        <a:t>flat-mirror null</a:t>
-                      </a:r>
-                    </a:p>
-                  </a:txBody>
-                  <a:tcPr marL="54864" marR="54864" marT="18288" marB="18288">
-                    <a:solidFill>
-                      <a:srgbClr val="FFFFFF"/>
-                    </a:solidFill>
-                  </a:tcPr>
-                </a:tc>
-                <a:tc>
-                  <a:txBody>
-                    <a:bodyPr wrap="square"/>
-                    <a:lstStyle/>
-                    <a:p>
-                      <a:r>
-                        <a:rPr sz="1100" b="0">
-                          <a:solidFill>
-                            <a:srgbClr val="282828"/>
-                          </a:solidFill>
-                          <a:latin typeface="Arial"/>
-                        </a:rPr>
-                        <a:t>92.4 nm rms</a:t>
-                      </a:r>
-                    </a:p>
-                  </a:txBody>
-                  <a:tcPr marL="54864" marR="54864" marT="18288" marB="18288">
-                    <a:solidFill>
-                      <a:srgbClr val="FFFFFF"/>
-                    </a:solidFill>
-                  </a:tcPr>
-                </a:tc>
-                <a:tc>
-                  <a:txBody>
-                    <a:bodyPr wrap="square"/>
-                    <a:lstStyle/>
-                    <a:p>
-                      <a:r>
-                        <a:rPr sz="1100" b="0">
-                          <a:solidFill>
-                            <a:srgbClr val="282828"/>
-                          </a:solidFill>
-                          <a:latin typeface="Arial"/>
-                        </a:rPr>
-                        <a:t>26.3 nm</a:t>
-                      </a:r>
-                    </a:p>
-                  </a:txBody>
-                  <a:tcPr marL="54864" marR="54864" marT="18288" marB="18288">
-                    <a:solidFill>
-                      <a:srgbClr val="FFFFFF"/>
-                    </a:solidFill>
-                  </a:tcPr>
-                </a:tc>
-                <a:tc>
-                  <a:txBody>
-                    <a:bodyPr wrap="square"/>
-                    <a:lstStyle/>
-                    <a:p>
-                      <a:r>
-                        <a:rPr sz="1100" b="0">
-                          <a:solidFill>
-                            <a:srgbClr val="282828"/>
-                          </a:solidFill>
-                          <a:latin typeface="Arial"/>
-                        </a:rPr>
-                        <a:t>0.13 nm lens / 0.03 mirrors</a:t>
-                      </a:r>
-                    </a:p>
+                        <a:t>pupil image on the 96 mm beam</a:t>
+                      </a:r>
+                    </a:p>
+                  </a:txBody>
+                  <a:tcPr marL="54864" marR="54864" marT="18288" marB="18288">
+                    <a:solidFill>
+                      <a:srgbClr val="FFFFFF"/>
+                    </a:solidFill>
+                  </a:tcPr>
+                </a:tc>
+                <a:tc>
+                  <a:txBody>
+                    <a:bodyPr wrap="square"/>
+                    <a:lstStyle/>
+                    <a:p>
+                      <a:r>
+                        <a:rPr sz="1100" b="0">
+                          <a:solidFill>
+                            <a:srgbClr val="282828"/>
+                          </a:solidFill>
+                          <a:latin typeface="Arial"/>
+                        </a:rPr>
+                        <a:t>9.5 mm (341 px)</a:t>
+                      </a:r>
+                    </a:p>
+                  </a:txBody>
+                  <a:tcPr marL="54864" marR="54864" marT="18288" marB="18288">
+                    <a:solidFill>
+                      <a:srgbClr val="FFFFFF"/>
+                    </a:solidFill>
+                  </a:tcPr>
+                </a:tc>
+                <a:tc>
+                  <a:txBody>
+                    <a:bodyPr wrap="square"/>
+                    <a:lstStyle/>
+                    <a:p>
+                      <a:r>
+                        <a:rPr sz="1100" b="0">
+                          <a:solidFill>
+                            <a:srgbClr val="282828"/>
+                          </a:solidFill>
+                          <a:latin typeface="Arial"/>
+                        </a:rPr>
+                        <a:t>11.3 mm (384 px)</a:t>
+                      </a:r>
+                    </a:p>
+                  </a:txBody>
+                  <a:tcPr marL="54864" marR="54864" marT="18288" marB="18288">
+                    <a:solidFill>
+                      <a:srgbClr val="FFFFFF"/>
+                    </a:solidFill>
+                  </a:tcPr>
+                </a:tc>
+                <a:tc>
+                  <a:txBody>
+                    <a:bodyPr wrap="square"/>
+                    <a:lstStyle/>
+                    <a:p>
+                      <a:r>
+                        <a:rPr sz="1100" b="0">
+                          <a:solidFill>
+                            <a:srgbClr val="282828"/>
+                          </a:solidFill>
+                          <a:latin typeface="Arial"/>
+                        </a:rPr>
+                        <a:t>11.1 mm (384 px)</a:t>
+                      </a:r>
+                    </a:p>
+                  </a:txBody>
+                  <a:tcPr marL="54864" marR="54864" marT="18288" marB="18288">
+                    <a:solidFill>
+                      <a:srgbClr val="FFFFFF"/>
+                    </a:solidFill>
+                  </a:tcPr>
+                </a:tc>
+                <a:tc>
+                  <a:txBody>
+                    <a:bodyPr wrap="square"/>
+                    <a:lstStyle/>
+                    <a:p>
+                      <a:r>
+                        <a:rPr sz="1100" b="0">
+                          <a:solidFill>
+                            <a:srgbClr val="282828"/>
+                          </a:solidFill>
+                          <a:latin typeface="Arial"/>
+                        </a:rPr>
+                        <a:t>11.1 mm</a:t>
+                      </a:r>
+                    </a:p>
+                  </a:txBody>
+                  <a:tcPr marL="54864" marR="54864" marT="18288" marB="18288">
+                    <a:solidFill>
+                      <a:srgbClr val="FFFFFF"/>
+                    </a:solidFill>
+                  </a:tcPr>
+                </a:tc>
+                <a:tc>
+                  <a:txBody>
+                    <a:bodyPr wrap="square"/>
+                    <a:lstStyle/>
+                    <a:p>
+                      <a:r>
+                        <a:rPr sz="1100" b="0">
+                          <a:solidFill>
+                            <a:srgbClr val="282828"/>
+                          </a:solidFill>
+                          <a:latin typeface="Arial"/>
+                        </a:rPr>
+                        <a:t>7.8 / 8.0 mm</a:t>
+                      </a:r>
+                    </a:p>
+                  </a:txBody>
+                  <a:tcPr marL="54864" marR="54864" marT="18288" marB="18288">
+                    <a:solidFill>
+                      <a:srgbClr val="FFFFFF"/>
+                    </a:solidFill>
+                  </a:tcPr>
+                </a:tc>
+              </a:tr>
+              <a:tr h="657225">
+                <a:tc>
+                  <a:txBody>
+                    <a:bodyPr wrap="square"/>
+                    <a:lstStyle/>
+                    <a:p>
+                      <a:r>
+                        <a:rPr sz="1100" b="0">
+                          <a:solidFill>
+                            <a:srgbClr val="282828"/>
+                          </a:solidFill>
+                          <a:latin typeface="Arial"/>
+                        </a:rPr>
+                        <a:t>pupil imaging on these decks (tg96_pupilsim): image surface vs the camera / Nyquist gain / distortion / 30 nm surface error</a:t>
+                      </a:r>
+                    </a:p>
+                  </a:txBody>
+                  <a:tcPr marL="54864" marR="54864" marT="18288" marB="18288">
+                    <a:solidFill>
+                      <a:srgbClr val="ECF1F6"/>
+                    </a:solidFill>
+                  </a:tcPr>
+                </a:tc>
+                <a:tc>
+                  <a:txBody>
+                    <a:bodyPr wrap="square"/>
+                    <a:lstStyle/>
+                    <a:p>
+                      <a:r>
+                        <a:rPr sz="1100" b="0">
+                          <a:solidFill>
+                            <a:srgbClr val="282828"/>
+                          </a:solidFill>
+                          <a:latin typeface="Arial"/>
+                        </a:rPr>
+                        <a:t>within ±0.3 mm / 0.9999 / 0.008 mm / 0.08 nm</a:t>
+                      </a:r>
+                    </a:p>
+                  </a:txBody>
+                  <a:tcPr marL="54864" marR="54864" marT="18288" marB="18288">
+                    <a:solidFill>
+                      <a:srgbClr val="ECF1F6"/>
+                    </a:solidFill>
+                  </a:tcPr>
+                </a:tc>
+                <a:tc>
+                  <a:txBody>
+                    <a:bodyPr wrap="square"/>
+                    <a:lstStyle/>
+                    <a:p>
+                      <a:r>
+                        <a:rPr sz="1100" b="0">
+                          <a:solidFill>
+                            <a:srgbClr val="282828"/>
+                          </a:solidFill>
+                          <a:latin typeface="Arial"/>
+                        </a:rPr>
+                        <a:t>within −0.6 to +0.4 mm / 0.9996 / 0.72 mm (the parabola pair's mapping) / 0.10 nm</a:t>
+                      </a:r>
+                    </a:p>
+                  </a:txBody>
+                  <a:tcPr marL="54864" marR="54864" marT="18288" marB="18288">
+                    <a:solidFill>
+                      <a:srgbClr val="ECF1F6"/>
+                    </a:solidFill>
+                  </a:tcPr>
+                </a:tc>
+                <a:tc>
+                  <a:txBody>
+                    <a:bodyPr wrap="square"/>
+                    <a:lstStyle/>
+                    <a:p>
+                      <a:r>
+                        <a:rPr sz="1100" b="0">
+                          <a:solidFill>
+                            <a:srgbClr val="282828"/>
+                          </a:solidFill>
+                          <a:latin typeface="Arial"/>
+                        </a:rPr>
+                        <a:t>tuned tail: 2.6 to 6 mm / 0.954 / 0.27 mm / 1.2 nm</a:t>
+                      </a:r>
+                    </a:p>
+                  </a:txBody>
+                  <a:tcPr marL="54864" marR="54864" marT="18288" marB="18288">
+                    <a:solidFill>
+                      <a:srgbClr val="ECF1F6"/>
+                    </a:solidFill>
+                  </a:tcPr>
+                </a:tc>
+                <a:tc>
+                  <a:txBody>
+                    <a:bodyPr wrap="square"/>
+                    <a:lstStyle/>
+                    <a:p/>
+                  </a:txBody>
+                  <a:tcPr marL="54864" marR="54864" marT="18288" marB="18288">
+                    <a:solidFill>
+                      <a:srgbClr val="ECF1F6"/>
+                    </a:solidFill>
+                  </a:tcPr>
+                </a:tc>
+                <a:tc>
+                  <a:txBody>
+                    <a:bodyPr wrap="square"/>
+                    <a:lstStyle/>
+                    <a:p/>
+                  </a:txBody>
+                  <a:tcPr marL="54864" marR="54864" marT="18288" marB="18288">
+                    <a:solidFill>
+                      <a:srgbClr val="ECF1F6"/>
+                    </a:solidFill>
+                  </a:tcPr>
+                </a:tc>
+              </a:tr>
+              <a:tr h="657225">
+                <a:tc>
+                  <a:txBody>
+                    <a:bodyPr wrap="square"/>
+                    <a:lstStyle/>
+                    <a:p>
+                      <a:r>
+                        <a:rPr sz="1100" b="0">
+                          <a:solidFill>
+                            <a:srgbClr val="282828"/>
+                          </a:solidFill>
+                          <a:latin typeface="Arial"/>
+                        </a:rPr>
+                        <a:t>the sensors on the mirror rig at 385 px, substrates in: stepped-Zernike rows, single / grid</a:t>
+                      </a:r>
+                    </a:p>
+                  </a:txBody>
+                  <a:tcPr marL="54864" marR="54864" marT="18288" marB="18288">
+                    <a:solidFill>
+                      <a:srgbClr val="FFFFFF"/>
+                    </a:solidFill>
+                  </a:tcPr>
+                </a:tc>
+                <a:tc>
+                  <a:txBody>
+                    <a:bodyPr wrap="square"/>
+                    <a:lstStyle/>
+                    <a:p>
+                      <a:r>
+                        <a:rPr sz="1100" b="0">
+                          <a:solidFill>
+                            <a:srgbClr val="282828"/>
+                          </a:solidFill>
+                          <a:latin typeface="Arial"/>
+                        </a:rPr>
+                        <a:t>—</a:t>
+                      </a:r>
+                    </a:p>
+                  </a:txBody>
+                  <a:tcPr marL="54864" marR="54864" marT="18288" marB="18288">
+                    <a:solidFill>
+                      <a:srgbClr val="FFFFFF"/>
+                    </a:solidFill>
+                  </a:tcPr>
+                </a:tc>
+                <a:tc>
+                  <a:txBody>
+                    <a:bodyPr wrap="square"/>
+                    <a:lstStyle/>
+                    <a:p>
+                      <a:r>
+                        <a:rPr sz="1100" b="0">
+                          <a:solidFill>
+                            <a:srgbClr val="282828"/>
+                          </a:solidFill>
+                          <a:latin typeface="Arial"/>
+                        </a:rPr>
+                        <a:t>0.993 / 5 pm; 0.995 / 4 pm</a:t>
+                      </a:r>
+                    </a:p>
+                  </a:txBody>
+                  <a:tcPr marL="54864" marR="54864" marT="18288" marB="18288">
+                    <a:solidFill>
+                      <a:srgbClr val="FFFFFF"/>
+                    </a:solidFill>
+                  </a:tcPr>
+                </a:tc>
+                <a:tc>
+                  <a:txBody>
+                    <a:bodyPr wrap="square"/>
+                    <a:lstStyle/>
+                    <a:p>
+                      <a:r>
+                        <a:rPr sz="1100" b="0">
+                          <a:solidFill>
+                            <a:srgbClr val="282828"/>
+                          </a:solidFill>
+                          <a:latin typeface="Arial"/>
+                        </a:rPr>
+                        <a:t>0.991 / 4; 0.999 / 4 (no substrates)</a:t>
+                      </a:r>
+                    </a:p>
+                  </a:txBody>
+                  <a:tcPr marL="54864" marR="54864" marT="18288" marB="18288">
+                    <a:solidFill>
+                      <a:srgbClr val="FFFFFF"/>
+                    </a:solidFill>
+                  </a:tcPr>
+                </a:tc>
+                <a:tc>
+                  <a:txBody>
+                    <a:bodyPr wrap="square"/>
+                    <a:lstStyle/>
+                    <a:p/>
+                  </a:txBody>
+                  <a:tcPr marL="54864" marR="54864" marT="18288" marB="18288">
+                    <a:solidFill>
+                      <a:srgbClr val="FFFFFF"/>
+                    </a:solidFill>
+                  </a:tcPr>
+                </a:tc>
+                <a:tc>
+                  <a:txBody>
+                    <a:bodyPr wrap="square"/>
+                    <a:lstStyle/>
+                    <a:p/>
                   </a:txBody>
                   <a:tcPr marL="54864" marR="54864" marT="18288" marB="18288">
                     <a:solidFill>
@@ -25766,7 +26620,7 @@
                           </a:solidFill>
                           <a:latin typeface="Arial"/>
                         </a:rPr>
-                        <a:t>10 nm on one actuator: gain / error / SNR</a:t>
+                        <a:t>the sensors' capture to 10%: stepped / vector / pinhole</a:t>
                       </a:r>
                     </a:p>
                   </a:txBody>
@@ -25788,7 +26642,7 @@
                           </a:solidFill>
                           <a:latin typeface="Arial"/>
                         </a:rPr>
-                        <a:t>1.003 / 1 pm / 10645</a:t>
+                        <a:t>—</a:t>
                       </a:r>
                     </a:p>
                   </a:txBody>
@@ -25810,7 +26664,7 @@
                           </a:solidFill>
                           <a:latin typeface="Arial"/>
                         </a:rPr>
-                        <a:t>0.986 / 2.2 pm / 6472</a:t>
+                        <a:t>35 / 51 / 42 nm</a:t>
                       </a:r>
                     </a:p>
                   </a:txBody>
@@ -25832,7 +26686,7 @@
                           </a:solidFill>
                           <a:latin typeface="Arial"/>
                         </a:rPr>
-                        <a:t>0.992 / 2.2 pm (lens), 0.992 / 2.4 (mirrors)</a:t>
+                        <a:t>36 / 59 / 52 nm (no substrates)</a:t>
                       </a:r>
                     </a:p>
                   </a:txBody>
@@ -25842,113 +26696,11 @@
                     </a:solidFill>
                   </a:tcPr>
                 </a:tc>
-              </a:tr>
-              <a:tr h="280035">
-                <a:tc>
-                  <a:txBody>
-                    <a:bodyPr wrap="square"/>
-                    <a:lstStyle/>
-                    <a:p>
-                      <a:r>
-                        <a:rPr sz="1100" b="0">
-                          <a:solidFill>
-                            <a:srgbClr val="282828"/>
-                          </a:solidFill>
-                          <a:latin typeface="Arial"/>
-                        </a:rPr>
-                        <a:t>1 nm on a 112-site grid</a:t>
-                      </a:r>
-                    </a:p>
-                  </a:txBody>
-                  <a:tcPr marL="54864" marR="54864" marT="18288" marB="18288">
-                    <a:solidFill>
-                      <a:srgbClr val="FFFFFF"/>
-                    </a:solidFill>
-                  </a:tcPr>
-                </a:tc>
-                <a:tc>
-                  <a:txBody>
-                    <a:bodyPr wrap="square"/>
-                    <a:lstStyle/>
-                    <a:p>
-                      <a:r>
-                        <a:rPr sz="1100" b="0">
-                          <a:solidFill>
-                            <a:srgbClr val="282828"/>
-                          </a:solidFill>
-                          <a:latin typeface="Arial"/>
-                        </a:rPr>
-                        <a:t>0.754 / 61.5 pm / 135</a:t>
-                      </a:r>
-                    </a:p>
-                  </a:txBody>
-                  <a:tcPr marL="54864" marR="54864" marT="18288" marB="18288">
-                    <a:solidFill>
-                      <a:srgbClr val="FFFFFF"/>
-                    </a:solidFill>
-                  </a:tcPr>
-                </a:tc>
-                <a:tc>
-                  <a:txBody>
-                    <a:bodyPr wrap="square"/>
-                    <a:lstStyle/>
-                    <a:p>
-                      <a:r>
-                        <a:rPr sz="1100" b="0">
-                          <a:solidFill>
-                            <a:srgbClr val="282828"/>
-                          </a:solidFill>
-                          <a:latin typeface="Arial"/>
-                        </a:rPr>
-                        <a:t>0.981 / 4.5 pm / 309</a:t>
-                      </a:r>
-                    </a:p>
-                  </a:txBody>
-                  <a:tcPr marL="54864" marR="54864" marT="18288" marB="18288">
-                    <a:solidFill>
-                      <a:srgbClr val="FFFFFF"/>
-                    </a:solidFill>
-                  </a:tcPr>
-                </a:tc>
-                <a:tc>
-                  <a:txBody>
-                    <a:bodyPr wrap="square"/>
-                    <a:lstStyle/>
-                    <a:p>
-                      <a:r>
-                        <a:rPr sz="1100" b="0">
-                          <a:solidFill>
-                            <a:srgbClr val="282828"/>
-                          </a:solidFill>
-                          <a:latin typeface="Arial"/>
-                        </a:rPr>
-                        <a:t>0.999 / 4 pm</a:t>
-                      </a:r>
-                    </a:p>
-                  </a:txBody>
-                  <a:tcPr marL="54864" marR="54864" marT="18288" marB="18288">
-                    <a:solidFill>
-                      <a:srgbClr val="FFFFFF"/>
-                    </a:solidFill>
-                  </a:tcPr>
-                </a:tc>
-              </a:tr>
-              <a:tr h="468630">
-                <a:tc>
-                  <a:txBody>
-                    <a:bodyPr wrap="square"/>
-                    <a:lstStyle/>
-                    <a:p>
-                      <a:r>
-                        <a:rPr sz="1100" b="0">
-                          <a:solidFill>
-                            <a:srgbClr val="282828"/>
-                          </a:solidFill>
-                          <a:latin typeface="Arial"/>
-                        </a:rPr>
-                        <a:t>capture to 10%, single site / grid</a:t>
-                      </a:r>
-                    </a:p>
+                <a:tc>
+                  <a:txBody>
+                    <a:bodyPr wrap="square"/>
+                    <a:lstStyle/>
+                    <a:p/>
                   </a:txBody>
                   <a:tcPr marL="54864" marR="54864" marT="18288" marB="18288">
                     <a:solidFill>
@@ -25960,421 +26712,7 @@
                   <a:txBody>
                     <a:bodyPr wrap="square"/>
                     <a:lstStyle/>
-                    <a:p>
-                      <a:r>
-                        <a:rPr sz="1100" b="0">
-                          <a:solidFill>
-                            <a:srgbClr val="282828"/>
-                          </a:solidFill>
-                          <a:latin typeface="Arial"/>
-                        </a:rPr>
-                        <a:t>480 nm and beyond / outside at the first rung</a:t>
-                      </a:r>
-                    </a:p>
-                  </a:txBody>
-                  <a:tcPr marL="54864" marR="54864" marT="18288" marB="18288">
-                    <a:solidFill>
-                      <a:srgbClr val="ECF1F6"/>
-                    </a:solidFill>
-                  </a:tcPr>
-                </a:tc>
-                <a:tc>
-                  <a:txBody>
-                    <a:bodyPr wrap="square"/>
-                    <a:lstStyle/>
-                    <a:p>
-                      <a:r>
-                        <a:rPr sz="1100" b="0">
-                          <a:solidFill>
-                            <a:srgbClr val="282828"/>
-                          </a:solidFill>
-                          <a:latin typeface="Arial"/>
-                        </a:rPr>
-                        <a:t>480 and beyond / 480 and beyond</a:t>
-                      </a:r>
-                    </a:p>
-                  </a:txBody>
-                  <a:tcPr marL="54864" marR="54864" marT="18288" marB="18288">
-                    <a:solidFill>
-                      <a:srgbClr val="ECF1F6"/>
-                    </a:solidFill>
-                  </a:tcPr>
-                </a:tc>
-                <a:tc>
-                  <a:txBody>
-                    <a:bodyPr wrap="square"/>
-                    <a:lstStyle/>
-                    <a:p>
-                      <a:r>
-                        <a:rPr sz="1100" b="0">
-                          <a:solidFill>
-                            <a:srgbClr val="282828"/>
-                          </a:solidFill>
-                          <a:latin typeface="Arial"/>
-                        </a:rPr>
-                        <a:t>322 / 480 and beyond</a:t>
-                      </a:r>
-                    </a:p>
-                  </a:txBody>
-                  <a:tcPr marL="54864" marR="54864" marT="18288" marB="18288">
-                    <a:solidFill>
-                      <a:srgbClr val="ECF1F6"/>
-                    </a:solidFill>
-                  </a:tcPr>
-                </a:tc>
-              </a:tr>
-              <a:tr h="280035">
-                <a:tc>
-                  <a:txBody>
-                    <a:bodyPr wrap="square"/>
-                    <a:lstStyle/>
-                    <a:p>
-                      <a:r>
-                        <a:rPr sz="1100" b="0">
-                          <a:solidFill>
-                            <a:srgbClr val="282828"/>
-                          </a:solidFill>
-                          <a:latin typeface="Arial"/>
-                        </a:rPr>
-                        <a:t>pupil image on the 96 mm beam</a:t>
-                      </a:r>
-                    </a:p>
-                  </a:txBody>
-                  <a:tcPr marL="54864" marR="54864" marT="18288" marB="18288">
-                    <a:solidFill>
-                      <a:srgbClr val="FFFFFF"/>
-                    </a:solidFill>
-                  </a:tcPr>
-                </a:tc>
-                <a:tc>
-                  <a:txBody>
-                    <a:bodyPr wrap="square"/>
-                    <a:lstStyle/>
-                    <a:p>
-                      <a:r>
-                        <a:rPr sz="1100" b="0">
-                          <a:solidFill>
-                            <a:srgbClr val="282828"/>
-                          </a:solidFill>
-                          <a:latin typeface="Arial"/>
-                        </a:rPr>
-                        <a:t>9.5 mm (341 px)</a:t>
-                      </a:r>
-                    </a:p>
-                  </a:txBody>
-                  <a:tcPr marL="54864" marR="54864" marT="18288" marB="18288">
-                    <a:solidFill>
-                      <a:srgbClr val="FFFFFF"/>
-                    </a:solidFill>
-                  </a:tcPr>
-                </a:tc>
-                <a:tc>
-                  <a:txBody>
-                    <a:bodyPr wrap="square"/>
-                    <a:lstStyle/>
-                    <a:p>
-                      <a:r>
-                        <a:rPr sz="1100" b="0">
-                          <a:solidFill>
-                            <a:srgbClr val="282828"/>
-                          </a:solidFill>
-                          <a:latin typeface="Arial"/>
-                        </a:rPr>
-                        <a:t>11.1 mm (384 px)</a:t>
-                      </a:r>
-                    </a:p>
-                  </a:txBody>
-                  <a:tcPr marL="54864" marR="54864" marT="18288" marB="18288">
-                    <a:solidFill>
-                      <a:srgbClr val="FFFFFF"/>
-                    </a:solidFill>
-                  </a:tcPr>
-                </a:tc>
-                <a:tc>
-                  <a:txBody>
-                    <a:bodyPr wrap="square"/>
-                    <a:lstStyle/>
-                    <a:p>
-                      <a:r>
-                        <a:rPr sz="1100" b="0">
-                          <a:solidFill>
-                            <a:srgbClr val="282828"/>
-                          </a:solidFill>
-                          <a:latin typeface="Arial"/>
-                        </a:rPr>
-                        <a:t>7.8 / 8.0 mm</a:t>
-                      </a:r>
-                    </a:p>
-                  </a:txBody>
-                  <a:tcPr marL="54864" marR="54864" marT="18288" marB="18288">
-                    <a:solidFill>
-                      <a:srgbClr val="FFFFFF"/>
-                    </a:solidFill>
-                  </a:tcPr>
-                </a:tc>
-              </a:tr>
-              <a:tr h="468630">
-                <a:tc>
-                  <a:txBody>
-                    <a:bodyPr wrap="square"/>
-                    <a:lstStyle/>
-                    <a:p>
-                      <a:r>
-                        <a:rPr sz="1100" b="0">
-                          <a:solidFill>
-                            <a:srgbClr val="282828"/>
-                          </a:solidFill>
-                          <a:latin typeface="Arial"/>
-                        </a:rPr>
-                        <a:t>pupil imaging on these decks (tg96_pupilsim): image surface vs the camera / Nyquist gain / distortion / 30 nm surface error</a:t>
-                      </a:r>
-                    </a:p>
-                  </a:txBody>
-                  <a:tcPr marL="54864" marR="54864" marT="18288" marB="18288">
-                    <a:solidFill>
-                      <a:srgbClr val="ECF1F6"/>
-                    </a:solidFill>
-                  </a:tcPr>
-                </a:tc>
-                <a:tc>
-                  <a:txBody>
-                    <a:bodyPr wrap="square"/>
-                    <a:lstStyle/>
-                    <a:p>
-                      <a:r>
-                        <a:rPr sz="1100" b="0">
-                          <a:solidFill>
-                            <a:srgbClr val="282828"/>
-                          </a:solidFill>
-                          <a:latin typeface="Arial"/>
-                        </a:rPr>
-                        <a:t>within ±0.3 mm / 0.9999 / 0.008 mm / 0.08 nm</a:t>
-                      </a:r>
-                    </a:p>
-                  </a:txBody>
-                  <a:tcPr marL="54864" marR="54864" marT="18288" marB="18288">
-                    <a:solidFill>
-                      <a:srgbClr val="ECF1F6"/>
-                    </a:solidFill>
-                  </a:tcPr>
-                </a:tc>
-                <a:tc>
-                  <a:txBody>
-                    <a:bodyPr wrap="square"/>
-                    <a:lstStyle/>
-                    <a:p>
-                      <a:r>
-                        <a:rPr sz="1100" b="0">
-                          <a:solidFill>
-                            <a:srgbClr val="282828"/>
-                          </a:solidFill>
-                          <a:latin typeface="Arial"/>
-                        </a:rPr>
-                        <a:t>within −0.6 to +0.4 mm / 0.9996 / 0.72 mm (the parabola pair's mapping) / 0.10 nm</a:t>
-                      </a:r>
-                    </a:p>
-                  </a:txBody>
-                  <a:tcPr marL="54864" marR="54864" marT="18288" marB="18288">
-                    <a:solidFill>
-                      <a:srgbClr val="ECF1F6"/>
-                    </a:solidFill>
-                  </a:tcPr>
-                </a:tc>
-                <a:tc>
-                  <a:txBody>
-                    <a:bodyPr wrap="square"/>
-                    <a:lstStyle/>
-                    <a:p>
-                      <a:r>
-                        <a:rPr sz="1100" b="0">
-                          <a:solidFill>
-                            <a:srgbClr val="282828"/>
-                          </a:solidFill>
-                          <a:latin typeface="Arial"/>
-                        </a:rPr>
-                        <a:t>tuned tail: 2.6 to 6 mm / 0.954 / 0.27 mm / 1.2 nm</a:t>
-                      </a:r>
-                    </a:p>
-                  </a:txBody>
-                  <a:tcPr marL="54864" marR="54864" marT="18288" marB="18288">
-                    <a:solidFill>
-                      <a:srgbClr val="ECF1F6"/>
-                    </a:solidFill>
-                  </a:tcPr>
-                </a:tc>
-              </a:tr>
-              <a:tr h="468630">
-                <a:tc>
-                  <a:txBody>
-                    <a:bodyPr wrap="square"/>
-                    <a:lstStyle/>
-                    <a:p>
-                      <a:r>
-                        <a:rPr sz="1100" b="0">
-                          <a:solidFill>
-                            <a:srgbClr val="282828"/>
-                          </a:solidFill>
-                          <a:latin typeface="Arial"/>
-                        </a:rPr>
-                        <a:t>the sensors on the mirror rig at 385 px, substrates in: stepped-Zernike rows, single / grid</a:t>
-                      </a:r>
-                    </a:p>
-                  </a:txBody>
-                  <a:tcPr marL="54864" marR="54864" marT="18288" marB="18288">
-                    <a:solidFill>
-                      <a:srgbClr val="FFFFFF"/>
-                    </a:solidFill>
-                  </a:tcPr>
-                </a:tc>
-                <a:tc>
-                  <a:txBody>
-                    <a:bodyPr wrap="square"/>
-                    <a:lstStyle/>
-                    <a:p>
-                      <a:r>
-                        <a:rPr sz="1100" b="0">
-                          <a:solidFill>
-                            <a:srgbClr val="282828"/>
-                          </a:solidFill>
-                          <a:latin typeface="Arial"/>
-                        </a:rPr>
-                        <a:t>—</a:t>
-                      </a:r>
-                    </a:p>
-                  </a:txBody>
-                  <a:tcPr marL="54864" marR="54864" marT="18288" marB="18288">
-                    <a:solidFill>
-                      <a:srgbClr val="FFFFFF"/>
-                    </a:solidFill>
-                  </a:tcPr>
-                </a:tc>
-                <a:tc>
-                  <a:txBody>
-                    <a:bodyPr wrap="square"/>
-                    <a:lstStyle/>
-                    <a:p>
-                      <a:r>
-                        <a:rPr sz="1100" b="0">
-                          <a:solidFill>
-                            <a:srgbClr val="282828"/>
-                          </a:solidFill>
-                          <a:latin typeface="Arial"/>
-                        </a:rPr>
-                        <a:t>0.993 / 5 pm; 0.995 / 4 pm</a:t>
-                      </a:r>
-                    </a:p>
-                  </a:txBody>
-                  <a:tcPr marL="54864" marR="54864" marT="18288" marB="18288">
-                    <a:solidFill>
-                      <a:srgbClr val="FFFFFF"/>
-                    </a:solidFill>
-                  </a:tcPr>
-                </a:tc>
-                <a:tc>
-                  <a:txBody>
-                    <a:bodyPr wrap="square"/>
-                    <a:lstStyle/>
-                    <a:p>
-                      <a:r>
-                        <a:rPr sz="1100" b="0">
-                          <a:solidFill>
-                            <a:srgbClr val="282828"/>
-                          </a:solidFill>
-                          <a:latin typeface="Arial"/>
-                        </a:rPr>
-                        <a:t>0.991 / 4; 0.999 / 4 (no substrates)</a:t>
-                      </a:r>
-                    </a:p>
-                  </a:txBody>
-                  <a:tcPr marL="54864" marR="54864" marT="18288" marB="18288">
-                    <a:solidFill>
-                      <a:srgbClr val="FFFFFF"/>
-                    </a:solidFill>
-                  </a:tcPr>
-                </a:tc>
-              </a:tr>
-              <a:tr h="468630">
-                <a:tc>
-                  <a:txBody>
-                    <a:bodyPr wrap="square"/>
-                    <a:lstStyle/>
-                    <a:p>
-                      <a:r>
-                        <a:rPr sz="1100" b="0">
-                          <a:solidFill>
-                            <a:srgbClr val="282828"/>
-                          </a:solidFill>
-                          <a:latin typeface="Arial"/>
-                        </a:rPr>
-                        <a:t>the sensors' capture to 10%: stepped / vector / pinhole</a:t>
-                      </a:r>
-                    </a:p>
-                  </a:txBody>
-                  <a:tcPr marL="54864" marR="54864" marT="18288" marB="18288">
-                    <a:solidFill>
-                      <a:srgbClr val="ECF1F6"/>
-                    </a:solidFill>
-                  </a:tcPr>
-                </a:tc>
-                <a:tc>
-                  <a:txBody>
-                    <a:bodyPr wrap="square"/>
-                    <a:lstStyle/>
-                    <a:p>
-                      <a:r>
-                        <a:rPr sz="1100" b="0">
-                          <a:solidFill>
-                            <a:srgbClr val="282828"/>
-                          </a:solidFill>
-                          <a:latin typeface="Arial"/>
-                        </a:rPr>
-                        <a:t>—</a:t>
-                      </a:r>
-                    </a:p>
-                  </a:txBody>
-                  <a:tcPr marL="54864" marR="54864" marT="18288" marB="18288">
-                    <a:solidFill>
-                      <a:srgbClr val="ECF1F6"/>
-                    </a:solidFill>
-                  </a:tcPr>
-                </a:tc>
-                <a:tc>
-                  <a:txBody>
-                    <a:bodyPr wrap="square"/>
-                    <a:lstStyle/>
-                    <a:p>
-                      <a:r>
-                        <a:rPr sz="1100" b="0">
-                          <a:solidFill>
-                            <a:srgbClr val="282828"/>
-                          </a:solidFill>
-                          <a:latin typeface="Arial"/>
-                        </a:rPr>
-                        <a:t>35 / 51 / 42 nm</a:t>
-                      </a:r>
-                    </a:p>
-                  </a:txBody>
-                  <a:tcPr marL="54864" marR="54864" marT="18288" marB="18288">
-                    <a:solidFill>
-                      <a:srgbClr val="ECF1F6"/>
-                    </a:solidFill>
-                  </a:tcPr>
-                </a:tc>
-                <a:tc>
-                  <a:txBody>
-                    <a:bodyPr wrap="square"/>
-                    <a:lstStyle/>
-                    <a:p>
-                      <a:r>
-                        <a:rPr sz="1100" b="0">
-                          <a:solidFill>
-                            <a:srgbClr val="282828"/>
-                          </a:solidFill>
-                          <a:latin typeface="Arial"/>
-                        </a:rPr>
-                        <a:t>36 / 59 / 52 nm (no substrates)</a:t>
-                      </a:r>
-                    </a:p>
+                    <a:p/>
                   </a:txBody>
                   <a:tcPr marL="54864" marR="54864" marT="18288" marB="18288">
                     <a:solidFill>
@@ -26395,7 +26733,7 @@
         </p:nvSpPr>
         <p:spPr>
           <a:xfrm>
-            <a:off x="411480" y="5096637"/>
+            <a:off x="411480" y="6416802"/>
             <a:ext cx="11368735" cy="274320"/>
           </a:xfrm>
           <a:prstGeom prst="rect">
@@ -26437,6 +26775,22 @@
                 </a:solidFill>
                 <a:latin typeface="Arial"/>
               </a:rPr>
+              <a:t>•  The redo bench restores the lens rig's grid row (0.754 to 0.993) and leaves a 59 nm null; the mirror rig is unchanged by design.  The null that remains on both rigs is the mask plate's spherical aberration in the F/4.2 beam (a 2 mm plate: about 0.1 wave rms), a fixed pattern the reference frame removes and the reading-tuned tail does not chase; TO's null decomposition prices it.</a:t>
+            </a:r>
+          </a:p>
+          <a:p>
+            <a:pPr>
+              <a:spcAft>
+                <a:spcPts val="600"/>
+              </a:spcAft>
+            </a:pPr>
+            <a:r>
+              <a:rPr sz="1500" b="0">
+                <a:solidFill>
+                  <a:srgbClr val="282828"/>
+                </a:solidFill>
+                <a:latin typeface="Arial"/>
+              </a:rPr>
               <a:t>•  The pupil image is not what limits either rig: on the seed tail with the substrates in, the DM images within a third of a millimeter of the camera on lenses (0.9999 at the actuator Nyquist, 0.08 nm on the working surface) and within 0.6 mm on mirrors; the lens rig's 92 nm null is the plate's spherical aberration and the misfed collimator, not the imaging.  The mask plate costs the sensors a little capture (vector 59 to 51 nm, pinhole 52 to 42) and no gain.</a:t>
             </a:r>
           </a:p>
@@ -26466,7 +26820,7 @@
         </p:nvSpPr>
         <p:spPr>
           <a:xfrm>
-            <a:off x="411480" y="8277987"/>
+            <a:off x="411480" y="10728960"/>
             <a:ext cx="11368735" cy="274320"/>
           </a:xfrm>
           <a:prstGeom prst="rect">
@@ -26492,7 +26846,7 @@
                 </a:solidFill>
                 <a:latin typeface="Arial"/>
               </a:rPr>
-              <a:t>Run tags sub96_lens, sub96_oap, pupilsim_sub96_lens, pupilsim_sub96_oap, sub96_oapsens (the Mac, RUNBOOK_mac_cycle3a, 2026-09-17).</a:t>
+              <a:t>Run tags sub96_lens, sub96_oap, pupilsim_sub96_lens, pupilsim_sub96_oap, sub96_oapsens (cycle 3a); redo96_lens, redo96_oap (cycle 3b); the Mac, 2026-09-17.</a:t>
             </a:r>
           </a:p>
         </p:txBody>

</xml_diff>

<commit_message>
Cycle 3b complete: the sensors' rerun identical to 3a (the mirror rig's sensor bench unchanged); the backup slide's table completed with the redo-bench columns; brief, slice
Co-Authored-By: Claude Fable 5.1 <noreply@anthropic.com>
</commit_message>
<xml_diff>
--- a/demo_session/deck_gauges.pptx
+++ b/demo_session/deck_gauges.pptx
@@ -25559,7 +25559,7 @@
         </p:nvGraphicFramePr>
         <p:xfrm>
           <a:off x="411480" y="1298448"/>
-          <a:ext cx="11368733" cy="4972050"/>
+          <a:ext cx="11368732" cy="4972050"/>
         </p:xfrm>
         <a:graphic>
           <a:graphicData uri="http://schemas.openxmlformats.org/drawingml/2006/table">
@@ -25568,12 +25568,12 @@
                 <a:tableStyleId>{5C22544A-7EE6-4342-B048-85BDC9FD1C3A}</a:tableStyleId>
               </a:tblPr>
               <a:tblGrid>
-                <a:gridCol w="3217820"/>
-                <a:gridCol w="1177251"/>
-                <a:gridCol w="2119052"/>
-                <a:gridCol w="1308056"/>
-                <a:gridCol w="2107692"/>
-                <a:gridCol w="1438862"/>
+                <a:gridCol w="3345345"/>
+                <a:gridCol w="1223906"/>
+                <a:gridCol w="1740667"/>
+                <a:gridCol w="2203032"/>
+                <a:gridCol w="1359896"/>
+                <a:gridCol w="1495886"/>
               </a:tblGrid>
               <a:tr h="657225">
                 <a:tc>
@@ -26436,6 +26436,28 @@
                           </a:solidFill>
                           <a:latin typeface="Arial"/>
                         </a:rPr>
+                        <a:t>flat to 0.001 mm / 1.0000 / 0.04 mm / 0.04 nm (TO's gate record)</a:t>
+                      </a:r>
+                    </a:p>
+                  </a:txBody>
+                  <a:tcPr marL="54864" marR="54864" marT="18288" marB="18288">
+                    <a:solidFill>
+                      <a:srgbClr val="ECF1F6"/>
+                    </a:solidFill>
+                  </a:tcPr>
+                </a:tc>
+                <a:tc>
+                  <a:txBody>
+                    <a:bodyPr wrap="square"/>
+                    <a:lstStyle/>
+                    <a:p>
+                      <a:r>
+                        <a:rPr sz="1100" b="0">
+                          <a:solidFill>
+                            <a:srgbClr val="282828"/>
+                          </a:solidFill>
+                          <a:latin typeface="Arial"/>
+                        </a:rPr>
                         <a:t>within −0.6 to +0.4 mm / 0.9996 / 0.72 mm (the parabola pair's mapping) / 0.10 nm</a:t>
                       </a:r>
                     </a:p>
@@ -26458,33 +26480,31 @@
                           </a:solidFill>
                           <a:latin typeface="Arial"/>
                         </a:rPr>
+                        <a:t>tilt 0.43, defocus −0.45 / 0.9994 / 0.72 / 0.09 nm</a:t>
+                      </a:r>
+                    </a:p>
+                  </a:txBody>
+                  <a:tcPr marL="54864" marR="54864" marT="18288" marB="18288">
+                    <a:solidFill>
+                      <a:srgbClr val="ECF1F6"/>
+                    </a:solidFill>
+                  </a:tcPr>
+                </a:tc>
+                <a:tc>
+                  <a:txBody>
+                    <a:bodyPr wrap="square"/>
+                    <a:lstStyle/>
+                    <a:p>
+                      <a:r>
+                        <a:rPr sz="1100" b="0">
+                          <a:solidFill>
+                            <a:srgbClr val="282828"/>
+                          </a:solidFill>
+                          <a:latin typeface="Arial"/>
+                        </a:rPr>
                         <a:t>tuned tail: 2.6 to 6 mm / 0.954 / 0.27 mm / 1.2 nm</a:t>
                       </a:r>
                     </a:p>
-                  </a:txBody>
-                  <a:tcPr marL="54864" marR="54864" marT="18288" marB="18288">
-                    <a:solidFill>
-                      <a:srgbClr val="ECF1F6"/>
-                    </a:solidFill>
-                  </a:tcPr>
-                </a:tc>
-                <a:tc>
-                  <a:txBody>
-                    <a:bodyPr wrap="square"/>
-                    <a:lstStyle/>
-                    <a:p/>
-                  </a:txBody>
-                  <a:tcPr marL="54864" marR="54864" marT="18288" marB="18288">
-                    <a:solidFill>
-                      <a:srgbClr val="ECF1F6"/>
-                    </a:solidFill>
-                  </a:tcPr>
-                </a:tc>
-                <a:tc>
-                  <a:txBody>
-                    <a:bodyPr wrap="square"/>
-                    <a:lstStyle/>
-                    <a:p/>
                   </a:txBody>
                   <a:tcPr marL="54864" marR="54864" marT="18288" marB="18288">
                     <a:solidFill>
@@ -26550,6 +26570,28 @@
                           </a:solidFill>
                           <a:latin typeface="Arial"/>
                         </a:rPr>
+                        <a:t>—</a:t>
+                      </a:r>
+                    </a:p>
+                  </a:txBody>
+                  <a:tcPr marL="54864" marR="54864" marT="18288" marB="18288">
+                    <a:solidFill>
+                      <a:srgbClr val="FFFFFF"/>
+                    </a:solidFill>
+                  </a:tcPr>
+                </a:tc>
+                <a:tc>
+                  <a:txBody>
+                    <a:bodyPr wrap="square"/>
+                    <a:lstStyle/>
+                    <a:p>
+                      <a:r>
+                        <a:rPr sz="1100" b="0">
+                          <a:solidFill>
+                            <a:srgbClr val="282828"/>
+                          </a:solidFill>
+                          <a:latin typeface="Arial"/>
+                        </a:rPr>
                         <a:t>0.993 / 5 pm; 0.995 / 4 pm</a:t>
                       </a:r>
                     </a:p>
@@ -26572,33 +26614,31 @@
                           </a:solidFill>
                           <a:latin typeface="Arial"/>
                         </a:rPr>
+                        <a:t>identical (the sensor bench is the same)</a:t>
+                      </a:r>
+                    </a:p>
+                  </a:txBody>
+                  <a:tcPr marL="54864" marR="54864" marT="18288" marB="18288">
+                    <a:solidFill>
+                      <a:srgbClr val="FFFFFF"/>
+                    </a:solidFill>
+                  </a:tcPr>
+                </a:tc>
+                <a:tc>
+                  <a:txBody>
+                    <a:bodyPr wrap="square"/>
+                    <a:lstStyle/>
+                    <a:p>
+                      <a:r>
+                        <a:rPr sz="1100" b="0">
+                          <a:solidFill>
+                            <a:srgbClr val="282828"/>
+                          </a:solidFill>
+                          <a:latin typeface="Arial"/>
+                        </a:rPr>
                         <a:t>0.991 / 4; 0.999 / 4 (no substrates)</a:t>
                       </a:r>
                     </a:p>
-                  </a:txBody>
-                  <a:tcPr marL="54864" marR="54864" marT="18288" marB="18288">
-                    <a:solidFill>
-                      <a:srgbClr val="FFFFFF"/>
-                    </a:solidFill>
-                  </a:tcPr>
-                </a:tc>
-                <a:tc>
-                  <a:txBody>
-                    <a:bodyPr wrap="square"/>
-                    <a:lstStyle/>
-                    <a:p/>
-                  </a:txBody>
-                  <a:tcPr marL="54864" marR="54864" marT="18288" marB="18288">
-                    <a:solidFill>
-                      <a:srgbClr val="FFFFFF"/>
-                    </a:solidFill>
-                  </a:tcPr>
-                </a:tc>
-                <a:tc>
-                  <a:txBody>
-                    <a:bodyPr wrap="square"/>
-                    <a:lstStyle/>
-                    <a:p/>
                   </a:txBody>
                   <a:tcPr marL="54864" marR="54864" marT="18288" marB="18288">
                     <a:solidFill>
@@ -26664,6 +26704,28 @@
                           </a:solidFill>
                           <a:latin typeface="Arial"/>
                         </a:rPr>
+                        <a:t>—</a:t>
+                      </a:r>
+                    </a:p>
+                  </a:txBody>
+                  <a:tcPr marL="54864" marR="54864" marT="18288" marB="18288">
+                    <a:solidFill>
+                      <a:srgbClr val="ECF1F6"/>
+                    </a:solidFill>
+                  </a:tcPr>
+                </a:tc>
+                <a:tc>
+                  <a:txBody>
+                    <a:bodyPr wrap="square"/>
+                    <a:lstStyle/>
+                    <a:p>
+                      <a:r>
+                        <a:rPr sz="1100" b="0">
+                          <a:solidFill>
+                            <a:srgbClr val="282828"/>
+                          </a:solidFill>
+                          <a:latin typeface="Arial"/>
+                        </a:rPr>
                         <a:t>35 / 51 / 42 nm</a:t>
                       </a:r>
                     </a:p>
@@ -26686,33 +26748,31 @@
                           </a:solidFill>
                           <a:latin typeface="Arial"/>
                         </a:rPr>
+                        <a:t>identical</a:t>
+                      </a:r>
+                    </a:p>
+                  </a:txBody>
+                  <a:tcPr marL="54864" marR="54864" marT="18288" marB="18288">
+                    <a:solidFill>
+                      <a:srgbClr val="ECF1F6"/>
+                    </a:solidFill>
+                  </a:tcPr>
+                </a:tc>
+                <a:tc>
+                  <a:txBody>
+                    <a:bodyPr wrap="square"/>
+                    <a:lstStyle/>
+                    <a:p>
+                      <a:r>
+                        <a:rPr sz="1100" b="0">
+                          <a:solidFill>
+                            <a:srgbClr val="282828"/>
+                          </a:solidFill>
+                          <a:latin typeface="Arial"/>
+                        </a:rPr>
                         <a:t>36 / 59 / 52 nm (no substrates)</a:t>
                       </a:r>
                     </a:p>
-                  </a:txBody>
-                  <a:tcPr marL="54864" marR="54864" marT="18288" marB="18288">
-                    <a:solidFill>
-                      <a:srgbClr val="ECF1F6"/>
-                    </a:solidFill>
-                  </a:tcPr>
-                </a:tc>
-                <a:tc>
-                  <a:txBody>
-                    <a:bodyPr wrap="square"/>
-                    <a:lstStyle/>
-                    <a:p/>
-                  </a:txBody>
-                  <a:tcPr marL="54864" marR="54864" marT="18288" marB="18288">
-                    <a:solidFill>
-                      <a:srgbClr val="ECF1F6"/>
-                    </a:solidFill>
-                  </a:tcPr>
-                </a:tc>
-                <a:tc>
-                  <a:txBody>
-                    <a:bodyPr wrap="square"/>
-                    <a:lstStyle/>
-                    <a:p/>
                   </a:txBody>
                   <a:tcPr marL="54864" marR="54864" marT="18288" marB="18288">
                     <a:solidFill>
@@ -26846,7 +26906,7 @@
                 </a:solidFill>
                 <a:latin typeface="Arial"/>
               </a:rPr>
-              <a:t>Run tags sub96_lens, sub96_oap, pupilsim_sub96_lens, pupilsim_sub96_oap, sub96_oapsens (cycle 3a); redo96_lens, redo96_oap (cycle 3b); the Mac, 2026-09-17.</a:t>
+              <a:t>Run tags sub96_lens, sub96_oap, pupilsim_sub96_lens, pupilsim_sub96_oap, sub96_oapsens (cycle 3a); redo96_lens, redo96_oap (cycle 3b); redo96_oapsens (3b); the Mac, 2026-09-17.</a:t>
             </a:r>
           </a:p>
         </p:txBody>

</xml_diff>

<commit_message>
Crops: give the panels breathing room (the box was never the problem)
Slides 5, 11 and 20 read cramped (Dave).  The obvious cause -- the 0.15/0.85
side margins on the node boxes -- was not it: widening them to full width
changed the output by zero pixels, because the space gained was white that
trim() then removed again.  The box only SELECTS a panel; trim decides the
edge.

trim kept a FIXED 12 px, which is half a percent of a 2438 px render -- so
every panel sat flush against its own ink.  Now max(12, 2.5% of the trimmed
size), pasted onto a white canvas rather than taken from the source: a panel
whose ink runs to the edge of its box (the node panels do, vertically) cannot
give the margin back, and taking it from the source padded the sides while
leaving top and bottom flush.

The boxes stay at full width -- narrow ones buy nothing and risk content.

Co-Authored-By: Claude Opus 5 (1M context) <noreply@anthropic.com>
</commit_message>
<xml_diff>
--- a/demo_session/deck_gauges.pptx
+++ b/demo_session/deck_gauges.pptx
@@ -3886,8 +3886,8 @@
         </p:blipFill>
         <p:spPr>
           <a:xfrm>
-            <a:off x="3205553" y="1298448"/>
-            <a:ext cx="5780588" cy="3281172"/>
+            <a:off x="3309591" y="1298448"/>
+            <a:ext cx="5572512" cy="3281172"/>
           </a:xfrm>
           <a:prstGeom prst="rect">
             <a:avLst/>
@@ -8846,8 +8846,8 @@
         </p:blipFill>
         <p:spPr>
           <a:xfrm>
-            <a:off x="3312126" y="1298448"/>
-            <a:ext cx="5567442" cy="3446272"/>
+            <a:off x="3601256" y="1298448"/>
+            <a:ext cx="4989182" cy="3446272"/>
           </a:xfrm>
           <a:prstGeom prst="rect">
             <a:avLst/>
@@ -9861,8 +9861,8 @@
         </p:blipFill>
         <p:spPr>
           <a:xfrm>
-            <a:off x="3447982" y="1298448"/>
-            <a:ext cx="5295730" cy="3812032"/>
+            <a:off x="3485248" y="1298448"/>
+            <a:ext cx="5221198" cy="3812032"/>
           </a:xfrm>
           <a:prstGeom prst="rect">
             <a:avLst/>
@@ -17879,8 +17879,8 @@
         </p:blipFill>
         <p:spPr>
           <a:xfrm>
-            <a:off x="1986938" y="1298448"/>
-            <a:ext cx="2655523" cy="2384552"/>
+            <a:off x="2012287" y="1298448"/>
+            <a:ext cx="2604825" cy="2384552"/>
           </a:xfrm>
           <a:prstGeom prst="rect">
             <a:avLst/>
@@ -22772,8 +22772,8 @@
         </p:blipFill>
         <p:spPr>
           <a:xfrm>
-            <a:off x="1876107" y="1298448"/>
-            <a:ext cx="2877184" cy="1653032"/>
+            <a:off x="1927811" y="1298448"/>
+            <a:ext cx="2773776" cy="1653032"/>
           </a:xfrm>
           <a:prstGeom prst="rect">
             <a:avLst/>
@@ -22835,8 +22835,8 @@
         </p:blipFill>
         <p:spPr>
           <a:xfrm>
-            <a:off x="8177841" y="1298448"/>
-            <a:ext cx="1840876" cy="1653032"/>
+            <a:off x="8195414" y="1298448"/>
+            <a:ext cx="1805731" cy="1653032"/>
           </a:xfrm>
           <a:prstGeom prst="rect">
             <a:avLst/>
@@ -29044,8 +29044,8 @@
         </p:blipFill>
         <p:spPr>
           <a:xfrm>
-            <a:off x="2250210" y="1298448"/>
-            <a:ext cx="7691274" cy="1434592"/>
+            <a:off x="2390317" y="1298448"/>
+            <a:ext cx="7411060" cy="1434592"/>
           </a:xfrm>
           <a:prstGeom prst="rect">
             <a:avLst/>
@@ -33302,8 +33302,8 @@
         </p:blipFill>
         <p:spPr>
           <a:xfrm>
-            <a:off x="7379616" y="1298448"/>
-            <a:ext cx="3437327" cy="1965451"/>
+            <a:off x="7420327" y="1298448"/>
+            <a:ext cx="3355904" cy="1965451"/>
           </a:xfrm>
           <a:prstGeom prst="rect">
             <a:avLst/>
@@ -33365,8 +33365,8 @@
         </p:blipFill>
         <p:spPr>
           <a:xfrm>
-            <a:off x="7382356" y="3547872"/>
-            <a:ext cx="3431846" cy="1965451"/>
+            <a:off x="7443648" y="3547872"/>
+            <a:ext cx="3309263" cy="1965451"/>
           </a:xfrm>
           <a:prstGeom prst="rect">
             <a:avLst/>

</xml_diff>

<commit_message>
Deck: Dave's note placements on 4, 5 and 9 folded; edit copy synced
Three moves left over from the fit pass (the closing notes on the bench-layout,
splitter-angle and sensor-parts slides).  Folded, rebuilt, synced -- the build
and the edit copy now agree with zero deliberate differences, and no slide runs
past the bottom edge.

Co-Authored-By: Claude Opus 5 (1M context) <noreply@anthropic.com>
</commit_message>
<xml_diff>
--- a/demo_session/deck_gauges.pptx
+++ b/demo_session/deck_gauges.pptx
@@ -23211,7 +23211,7 @@
         </p:nvSpPr>
         <p:spPr>
           <a:xfrm>
-            <a:off x="411480" y="6505956"/>
+            <a:off x="411480" y="6364224"/>
             <a:ext cx="11368735" cy="274320"/>
           </a:xfrm>
           <a:prstGeom prst="rect">
@@ -29879,7 +29879,7 @@
         </p:nvSpPr>
         <p:spPr>
           <a:xfrm>
-            <a:off x="411480" y="6511671"/>
+            <a:off x="411480" y="6400800"/>
             <a:ext cx="11368735" cy="274320"/>
           </a:xfrm>
           <a:prstGeom prst="rect">
@@ -38779,7 +38779,7 @@
         </p:nvSpPr>
         <p:spPr>
           <a:xfrm>
-            <a:off x="411480" y="6422517"/>
+            <a:off x="292608" y="5742432"/>
             <a:ext cx="11368735" cy="274320"/>
           </a:xfrm>
           <a:prstGeom prst="rect">

</xml_diff>

<commit_message>
Deck: Dave's moves on the two pupil slides folded; edit copy synced at 57 slides
The caption and run-tag line on the pupil-quality slide moved under the figure
in the left column, and the method bullets on the pupil-imaging slide down a
little.  His copy was a slide behind (the summary insert), so the diff came
back in the old numbering -- the sidecar keys on TITLES, not numbers, so the
fold is unaffected by the renumber.

Co-Authored-By: Claude Opus 5 (1M context) <noreply@anthropic.com>
</commit_message>
<xml_diff>
--- a/demo_session/deck_gauges.pptx
+++ b/demo_session/deck_gauges.pptx
@@ -5505,8 +5505,8 @@
         </p:nvSpPr>
         <p:spPr>
           <a:xfrm>
-            <a:off x="402336" y="5193792"/>
-            <a:ext cx="6400800" cy="559307"/>
+            <a:off x="228600" y="4937760"/>
+            <a:ext cx="5943600" cy="559307"/>
           </a:xfrm>
           <a:prstGeom prst="rect">
             <a:avLst/>
@@ -5998,7 +5998,7 @@
         </p:nvSpPr>
         <p:spPr>
           <a:xfrm>
-            <a:off x="6400800" y="5715000"/>
+            <a:off x="548640" y="5742432"/>
             <a:ext cx="5394960" cy="274320"/>
           </a:xfrm>
           <a:prstGeom prst="rect">
@@ -6826,7 +6826,7 @@
         </p:nvSpPr>
         <p:spPr>
           <a:xfrm>
-            <a:off x="7086600" y="2496312"/>
+            <a:off x="7086600" y="2688336"/>
             <a:ext cx="4709160" cy="274320"/>
           </a:xfrm>
           <a:prstGeom prst="rect">

</xml_diff>

<commit_message>
deck_gauges slide 30: the redesigned mirror rig's capture re-run on the fixed bench (capt96_oap) -- 3 pm in 19 / 24 cycles from 100 / 200 nm, control set inside the DM aperture
Co-Authored-By: Claude Fable 5.1 <noreply@anthropic.com>
</commit_message>
<xml_diff>
--- a/demo_session/deck_gauges.pptx
+++ b/demo_session/deck_gauges.pptx
@@ -17306,7 +17306,7 @@
         </p:nvGraphicFramePr>
         <p:xfrm>
           <a:off x="411480" y="1298448"/>
-          <a:ext cx="5806439" cy="4029075"/>
+          <a:ext cx="5806438" cy="4783455"/>
         </p:xfrm>
         <a:graphic>
           <a:graphicData uri="http://schemas.openxmlformats.org/drawingml/2006/table">
@@ -17315,11 +17315,11 @@
                 <a:tableStyleId>{5C22544A-7EE6-4342-B048-85BDC9FD1C3A}</a:tableStyleId>
               </a:tblPr>
               <a:tblGrid>
-                <a:gridCol w="1470462"/>
-                <a:gridCol w="1093420"/>
-                <a:gridCol w="3242557"/>
+                <a:gridCol w="1104639"/>
+                <a:gridCol w="821398"/>
+                <a:gridCol w="3880401"/>
               </a:tblGrid>
-              <a:tr h="468630">
+              <a:tr h="657225">
                 <a:tc>
                   <a:txBody>
                     <a:bodyPr wrap="square"/>
@@ -17591,7 +17591,7 @@
                   </a:tcPr>
                 </a:tc>
               </a:tr>
-              <a:tr h="468630">
+              <a:tr h="657225">
                 <a:tc>
                   <a:txBody>
                     <a:bodyPr wrap="square"/>
@@ -17795,7 +17795,7 @@
                   </a:tcPr>
                 </a:tc>
               </a:tr>
-              <a:tr h="468630">
+              <a:tr h="657225">
                 <a:tc>
                   <a:txBody>
                     <a:bodyPr wrap="square"/>
@@ -17852,7 +17852,7 @@
                           </a:solidFill>
                           <a:latin typeface="Arial"/>
                         </a:rPr>
-                        <a:t>unwrap alone: 3 pm in 17 / 19 cycles from 100 / 200 nm, contraction 0.50</a:t>
+                        <a:t>unwrap alone: 3 pm in 19 / 24 cycles from 100 / 200 nm (2.98 pm at cycle 60), contraction 0.52 / 0.57; the 30 nm control holds at 2.97 pm</a:t>
                       </a:r>
                     </a:p>
                   </a:txBody>
@@ -17863,7 +17863,7 @@
                   </a:tcPr>
                 </a:tc>
               </a:tr>
-              <a:tr h="468630">
+              <a:tr h="657225">
                 <a:tc>
                   <a:txBody>
                     <a:bodyPr wrap="square"/>
@@ -18040,7 +18040,7 @@
                 </a:solidFill>
                 <a:latin typeface="Arial"/>
               </a:rPr>
-              <a:t>1e13 and 1e15 photons per cycle give the same convergence: capture is reference-limited, not light-limited.  Run tags cap_nouw, cap_uw, cap_state_uw_recal, descent193, descent_lens, descent_oap, oapdesc2.</a:t>
+              <a:t>1e13 and 1e15 photons per cycle give the same convergence: capture is reference-limited, not light-limited.  Run tags cap_nouw, cap_uw, cap_state_uw_recal, descent193, descent_lens, descent_oap, capt96_oap (the redesigned mirror rig, control set inside the DM aperture).</a:t>
             </a:r>
           </a:p>
         </p:txBody>

</xml_diff>

<commit_message>
deck_gauges slide 30: shorter row so the table keeps its height
Co-Authored-By: Claude Fable 5.1 <noreply@anthropic.com>
</commit_message>
<xml_diff>
--- a/demo_session/deck_gauges.pptx
+++ b/demo_session/deck_gauges.pptx
@@ -17306,7 +17306,7 @@
         </p:nvGraphicFramePr>
         <p:xfrm>
           <a:off x="411480" y="1298448"/>
-          <a:ext cx="5806438" cy="4783455"/>
+          <a:ext cx="5806438" cy="4594860"/>
         </p:xfrm>
         <a:graphic>
           <a:graphicData uri="http://schemas.openxmlformats.org/drawingml/2006/table">
@@ -17315,9 +17315,9 @@
                 <a:tableStyleId>{5C22544A-7EE6-4342-B048-85BDC9FD1C3A}</a:tableStyleId>
               </a:tblPr>
               <a:tblGrid>
-                <a:gridCol w="1104639"/>
-                <a:gridCol w="821398"/>
-                <a:gridCol w="3880401"/>
+                <a:gridCol w="1380799"/>
+                <a:gridCol w="1026748"/>
+                <a:gridCol w="3398891"/>
               </a:tblGrid>
               <a:tr h="657225">
                 <a:tc>
@@ -17591,7 +17591,7 @@
                   </a:tcPr>
                 </a:tc>
               </a:tr>
-              <a:tr h="657225">
+              <a:tr h="468630">
                 <a:tc>
                   <a:txBody>
                     <a:bodyPr wrap="square"/>
@@ -17852,7 +17852,7 @@
                           </a:solidFill>
                           <a:latin typeface="Arial"/>
                         </a:rPr>
-                        <a:t>unwrap alone: 3 pm in 19 / 24 cycles from 100 / 200 nm (2.98 pm at cycle 60), contraction 0.52 / 0.57; the 30 nm control holds at 2.97 pm</a:t>
+                        <a:t>unwrap alone: 3 pm in 19 / 24 cycles from 100 / 200 nm, contraction 0.52 / 0.57; control 2.97 pm</a:t>
                       </a:r>
                     </a:p>
                   </a:txBody>

</xml_diff>

<commit_message>
deck_gauges slide 30: one-line row (table geometry unchanged); the control-row fact in the run-tags note
Co-Authored-By: Claude Fable 5.1 <noreply@anthropic.com>
</commit_message>
<xml_diff>
--- a/demo_session/deck_gauges.pptx
+++ b/demo_session/deck_gauges.pptx
@@ -17306,7 +17306,7 @@
         </p:nvGraphicFramePr>
         <p:xfrm>
           <a:off x="411480" y="1298448"/>
-          <a:ext cx="5806438" cy="4594860"/>
+          <a:ext cx="5806439" cy="4029075"/>
         </p:xfrm>
         <a:graphic>
           <a:graphicData uri="http://schemas.openxmlformats.org/drawingml/2006/table">
@@ -17315,11 +17315,11 @@
                 <a:tableStyleId>{5C22544A-7EE6-4342-B048-85BDC9FD1C3A}</a:tableStyleId>
               </a:tblPr>
               <a:tblGrid>
-                <a:gridCol w="1380799"/>
-                <a:gridCol w="1026748"/>
-                <a:gridCol w="3398891"/>
+                <a:gridCol w="1470462"/>
+                <a:gridCol w="1093420"/>
+                <a:gridCol w="3242557"/>
               </a:tblGrid>
-              <a:tr h="657225">
+              <a:tr h="468630">
                 <a:tc>
                   <a:txBody>
                     <a:bodyPr wrap="square"/>
@@ -17795,7 +17795,7 @@
                   </a:tcPr>
                 </a:tc>
               </a:tr>
-              <a:tr h="657225">
+              <a:tr h="468630">
                 <a:tc>
                   <a:txBody>
                     <a:bodyPr wrap="square"/>
@@ -17852,7 +17852,7 @@
                           </a:solidFill>
                           <a:latin typeface="Arial"/>
                         </a:rPr>
-                        <a:t>unwrap alone: 3 pm in 19 / 24 cycles from 100 / 200 nm, contraction 0.52 / 0.57; control 2.97 pm</a:t>
+                        <a:t>unwrap alone: 3 pm in 19 / 24 cycles from 100 / 200 nm, contraction 0.52</a:t>
                       </a:r>
                     </a:p>
                   </a:txBody>
@@ -17863,7 +17863,7 @@
                   </a:tcPr>
                 </a:tc>
               </a:tr>
-              <a:tr h="657225">
+              <a:tr h="468630">
                 <a:tc>
                   <a:txBody>
                     <a:bodyPr wrap="square"/>
@@ -18040,7 +18040,7 @@
                 </a:solidFill>
                 <a:latin typeface="Arial"/>
               </a:rPr>
-              <a:t>1e13 and 1e15 photons per cycle give the same convergence: capture is reference-limited, not light-limited.  Run tags cap_nouw, cap_uw, cap_state_uw_recal, descent193, descent_lens, descent_oap, capt96_oap (the redesigned mirror rig, control set inside the DM aperture).</a:t>
+              <a:t>1e13 and 1e15 photons per cycle give the same convergence: capture is reference-limited, not light-limited.  Run tags cap_nouw, cap_uw, cap_state_uw_recal, descent193, descent_lens, descent_oap, capt96_oap (the redesigned mirror rig with the control set inside the DM aperture: 2.98 pm at cycle 60 from 100 and 200 nm, the 30 nm control at 2.97 pm).</a:t>
             </a:r>
           </a:p>
         </p:txBody>

</xml_diff>

<commit_message>
deck_gauges: slide 10 overlap fixed (P/SRI parts row to its backup slide, footnote shortened)
Co-Authored-By: Claude Fable 5.1 <noreply@anthropic.com>
</commit_message>
<xml_diff>
--- a/demo_session/deck_gauges.pptx
+++ b/demo_session/deck_gauges.pptx
@@ -3396,7 +3396,7 @@
         </p:nvGraphicFramePr>
         <p:xfrm>
           <a:off x="411480" y="1298448"/>
-          <a:ext cx="11368733" cy="4977765"/>
+          <a:ext cx="11368733" cy="3566160"/>
         </p:xfrm>
         <a:graphic>
           <a:graphicData uri="http://schemas.openxmlformats.org/drawingml/2006/table">
@@ -3405,12 +3405,12 @@
                 <a:tableStyleId>{5C22544A-7EE6-4342-B048-85BDC9FD1C3A}</a:tableStyleId>
               </a:tblPr>
               <a:tblGrid>
-                <a:gridCol w="2252980"/>
-                <a:gridCol w="3029232"/>
-                <a:gridCol w="2547765"/>
-                <a:gridCol w="762323"/>
+                <a:gridCol w="1671828"/>
+                <a:gridCol w="2188758"/>
+                <a:gridCol w="2918345"/>
+                <a:gridCol w="1026825"/>
                 <a:gridCol w="509524"/>
-                <a:gridCol w="2266909"/>
+                <a:gridCol w="3053453"/>
               </a:tblGrid>
               <a:tr h="280035">
                 <a:tc>
@@ -3425,7 +3425,7 @@
                           </a:solidFill>
                           <a:latin typeface="Arial"/>
                         </a:rPr>
-                        <a:t>configuration</a:t>
+                        <a:t>sensor</a:t>
                       </a:r>
                     </a:p>
                   </a:txBody>
@@ -3680,20 +3680,20 @@
                   </a:tcPr>
                 </a:tc>
               </a:tr>
-              <a:tr h="845820">
-                <a:tc>
-                  <a:txBody>
-                    <a:bodyPr wrap="square"/>
-                    <a:lstStyle/>
-                    <a:p>
-                      <a:r>
-                        <a:rPr sz="1100" b="0">
-                          <a:solidFill>
-                            <a:srgbClr val="282828"/>
-                          </a:solidFill>
-                          <a:latin typeface="Arial"/>
-                        </a:rPr>
-                        <a:t>vector Zernike</a:t>
+              <a:tr h="657225">
+                <a:tc>
+                  <a:txBody>
+                    <a:bodyPr wrap="square"/>
+                    <a:lstStyle/>
+                    <a:p>
+                      <a:r>
+                        <a:rPr sz="1100" b="0">
+                          <a:solidFill>
+                            <a:srgbClr val="282828"/>
+                          </a:solidFill>
+                          <a:latin typeface="Arial"/>
+                        </a:rPr>
+                        <a:t>vector</a:t>
                       </a:r>
                     </a:p>
                   </a:txBody>
@@ -3804,274 +3804,6 @@
                           <a:latin typeface="Arial"/>
                         </a:rPr>
                         <a:t>the two images with opposite dimple sign</a:t>
-                      </a:r>
-                    </a:p>
-                  </a:txBody>
-                  <a:tcPr marL="54864" marR="54864" marT="18288" marB="18288">
-                    <a:solidFill>
-                      <a:srgbClr val="ECF1F6"/>
-                    </a:solidFill>
-                  </a:tcPr>
-                </a:tc>
-              </a:tr>
-              <a:tr h="845820">
-                <a:tc>
-                  <a:txBody>
-                    <a:bodyPr wrap="square"/>
-                    <a:lstStyle/>
-                    <a:p>
-                      <a:r>
-                        <a:rPr sz="1100" b="0">
-                          <a:solidFill>
-                            <a:srgbClr val="282828"/>
-                          </a:solidFill>
-                          <a:latin typeface="Arial"/>
-                        </a:rPr>
-                        <a:t>vector Zernike, split form</a:t>
-                      </a:r>
-                    </a:p>
-                  </a:txBody>
-                  <a:tcPr marL="54864" marR="54864" marT="18288" marB="18288">
-                    <a:solidFill>
-                      <a:srgbClr val="FFFFFF"/>
-                    </a:solidFill>
-                  </a:tcPr>
-                </a:tc>
-                <a:tc>
-                  <a:txBody>
-                    <a:bodyPr wrap="square"/>
-                    <a:lstStyle/>
-                    <a:p>
-                      <a:r>
-                        <a:rPr sz="1100" b="0">
-                          <a:solidFill>
-                            <a:srgbClr val="282828"/>
-                          </a:solidFill>
-                          <a:latin typeface="Arial"/>
-                        </a:rPr>
-                        <a:t>quarter-wave plate; polarizing cube; camera B</a:t>
-                      </a:r>
-                    </a:p>
-                  </a:txBody>
-                  <a:tcPr marL="54864" marR="54864" marT="18288" marB="18288">
-                    <a:solidFill>
-                      <a:srgbClr val="FFFFFF"/>
-                    </a:solidFill>
-                  </a:tcPr>
-                </a:tc>
-                <a:tc>
-                  <a:txBody>
-                    <a:bodyPr wrap="square"/>
-                    <a:lstStyle/>
-                    <a:p>
-                      <a:r>
-                        <a:rPr sz="1100" b="0">
-                          <a:solidFill>
-                            <a:srgbClr val="282828"/>
-                          </a:solidFill>
-                          <a:latin typeface="Arial"/>
-                        </a:rPr>
-                        <a:t>zero-order plate at λ/300 on a 2 mm substrate; 12.7 mm cemented MacNeille cube; a second sCMOS like camera A</a:t>
-                      </a:r>
-                    </a:p>
-                  </a:txBody>
-                  <a:tcPr marL="54864" marR="54864" marT="18288" marB="18288">
-                    <a:solidFill>
-                      <a:srgbClr val="FFFFFF"/>
-                    </a:solidFill>
-                  </a:tcPr>
-                </a:tc>
-                <a:tc>
-                  <a:txBody>
-                    <a:bodyPr wrap="square"/>
-                    <a:lstStyle/>
-                    <a:p>
-                      <a:r>
-                        <a:rPr sz="1100" b="0">
-                          <a:solidFill>
-                            <a:srgbClr val="282828"/>
-                          </a:solidFill>
-                          <a:latin typeface="Arial"/>
-                        </a:rPr>
-                        <a:t>AR; ZnS / cryolite</a:t>
-                      </a:r>
-                    </a:p>
-                  </a:txBody>
-                  <a:tcPr marL="54864" marR="54864" marT="18288" marB="18288">
-                    <a:solidFill>
-                      <a:srgbClr val="FFFFFF"/>
-                    </a:solidFill>
-                  </a:tcPr>
-                </a:tc>
-                <a:tc>
-                  <a:txBody>
-                    <a:bodyPr wrap="square"/>
-                    <a:lstStyle/>
-                    <a:p>
-                      <a:r>
-                        <a:rPr sz="1100" b="0">
-                          <a:solidFill>
-                            <a:srgbClr val="282828"/>
-                          </a:solidFill>
-                          <a:latin typeface="Arial"/>
-                        </a:rPr>
-                        <a:t>3</a:t>
-                      </a:r>
-                    </a:p>
-                  </a:txBody>
-                  <a:tcPr marL="54864" marR="54864" marT="18288" marB="18288">
-                    <a:solidFill>
-                      <a:srgbClr val="FFFFFF"/>
-                    </a:solidFill>
-                  </a:tcPr>
-                </a:tc>
-                <a:tc>
-                  <a:txBody>
-                    <a:bodyPr wrap="square"/>
-                    <a:lstStyle/>
-                    <a:p>
-                      <a:r>
-                        <a:rPr sz="1100" b="0">
-                          <a:solidFill>
-                            <a:srgbClr val="282828"/>
-                          </a:solidFill>
-                          <a:latin typeface="Arial"/>
-                        </a:rPr>
-                        <a:t>separates the two circular states onto two cameras, both frames at once</a:t>
-                      </a:r>
-                    </a:p>
-                  </a:txBody>
-                  <a:tcPr marL="54864" marR="54864" marT="18288" marB="18288">
-                    <a:solidFill>
-                      <a:srgbClr val="FFFFFF"/>
-                    </a:solidFill>
-                  </a:tcPr>
-                </a:tc>
-              </a:tr>
-              <a:tr h="845820">
-                <a:tc>
-                  <a:txBody>
-                    <a:bodyPr wrap="square"/>
-                    <a:lstStyle/>
-                    <a:p>
-                      <a:r>
-                        <a:rPr sz="1100" b="0">
-                          <a:solidFill>
-                            <a:srgbClr val="282828"/>
-                          </a:solidFill>
-                          <a:latin typeface="Arial"/>
-                        </a:rPr>
-                        <a:t>vector Zernike, snapshot form</a:t>
-                      </a:r>
-                    </a:p>
-                  </a:txBody>
-                  <a:tcPr marL="54864" marR="54864" marT="18288" marB="18288">
-                    <a:solidFill>
-                      <a:srgbClr val="ECF1F6"/>
-                    </a:solidFill>
-                  </a:tcPr>
-                </a:tc>
-                <a:tc>
-                  <a:txBody>
-                    <a:bodyPr wrap="square"/>
-                    <a:lstStyle/>
-                    <a:p>
-                      <a:r>
-                        <a:rPr sz="1100" b="0">
-                          <a:solidFill>
-                            <a:srgbClr val="282828"/>
-                          </a:solidFill>
-                          <a:latin typeface="Arial"/>
-                        </a:rPr>
-                        <a:t>quarter-wave plate; the interferometer's polarization camera in place of camera A</a:t>
-                      </a:r>
-                    </a:p>
-                  </a:txBody>
-                  <a:tcPr marL="54864" marR="54864" marT="18288" marB="18288">
-                    <a:solidFill>
-                      <a:srgbClr val="ECF1F6"/>
-                    </a:solidFill>
-                  </a:tcPr>
-                </a:tc>
-                <a:tc>
-                  <a:txBody>
-                    <a:bodyPr wrap="square"/>
-                    <a:lstStyle/>
-                    <a:p>
-                      <a:r>
-                        <a:rPr sz="1100" b="0">
-                          <a:solidFill>
-                            <a:srgbClr val="282828"/>
-                          </a:solidFill>
-                          <a:latin typeface="Arial"/>
-                        </a:rPr>
-                        <a:t>the same zero-order plate; the micro-polarizer array already on the bench for the snapshot interferometer</a:t>
-                      </a:r>
-                    </a:p>
-                  </a:txBody>
-                  <a:tcPr marL="54864" marR="54864" marT="18288" marB="18288">
-                    <a:solidFill>
-                      <a:srgbClr val="ECF1F6"/>
-                    </a:solidFill>
-                  </a:tcPr>
-                </a:tc>
-                <a:tc>
-                  <a:txBody>
-                    <a:bodyPr wrap="square"/>
-                    <a:lstStyle/>
-                    <a:p>
-                      <a:r>
-                        <a:rPr sz="1100" b="0">
-                          <a:solidFill>
-                            <a:srgbClr val="282828"/>
-                          </a:solidFill>
-                          <a:latin typeface="Arial"/>
-                        </a:rPr>
-                        <a:t>AR</a:t>
-                      </a:r>
-                    </a:p>
-                  </a:txBody>
-                  <a:tcPr marL="54864" marR="54864" marT="18288" marB="18288">
-                    <a:solidFill>
-                      <a:srgbClr val="ECF1F6"/>
-                    </a:solidFill>
-                  </a:tcPr>
-                </a:tc>
-                <a:tc>
-                  <a:txBody>
-                    <a:bodyPr wrap="square"/>
-                    <a:lstStyle/>
-                    <a:p>
-                      <a:r>
-                        <a:rPr sz="1100" b="0">
-                          <a:solidFill>
-                            <a:srgbClr val="282828"/>
-                          </a:solidFill>
-                          <a:latin typeface="Arial"/>
-                        </a:rPr>
-                        <a:t>2</a:t>
-                      </a:r>
-                    </a:p>
-                  </a:txBody>
-                  <a:tcPr marL="54864" marR="54864" marT="18288" marB="18288">
-                    <a:solidFill>
-                      <a:srgbClr val="ECF1F6"/>
-                    </a:solidFill>
-                  </a:tcPr>
-                </a:tc>
-                <a:tc>
-                  <a:txBody>
-                    <a:bodyPr wrap="square"/>
-                    <a:lstStyle/>
-                    <a:p>
-                      <a:r>
-                        <a:rPr sz="1100" b="0">
-                          <a:solidFill>
-                            <a:srgbClr val="282828"/>
-                          </a:solidFill>
-                          <a:latin typeface="Arial"/>
-                        </a:rPr>
-                        <a:t>the same two states read on one camera: one detector, no split leg to align, at a quarter of the pixels per state</a:t>
                       </a:r>
                     </a:p>
                   </a:txBody>
@@ -4095,6 +3827,274 @@
                           </a:solidFill>
                           <a:latin typeface="Arial"/>
                         </a:rPr>
+                        <a:t>vector, split form</a:t>
+                      </a:r>
+                    </a:p>
+                  </a:txBody>
+                  <a:tcPr marL="54864" marR="54864" marT="18288" marB="18288">
+                    <a:solidFill>
+                      <a:srgbClr val="FFFFFF"/>
+                    </a:solidFill>
+                  </a:tcPr>
+                </a:tc>
+                <a:tc>
+                  <a:txBody>
+                    <a:bodyPr wrap="square"/>
+                    <a:lstStyle/>
+                    <a:p>
+                      <a:r>
+                        <a:rPr sz="1100" b="0">
+                          <a:solidFill>
+                            <a:srgbClr val="282828"/>
+                          </a:solidFill>
+                          <a:latin typeface="Arial"/>
+                        </a:rPr>
+                        <a:t>quarter-wave plate; polarizing cube; camera B</a:t>
+                      </a:r>
+                    </a:p>
+                  </a:txBody>
+                  <a:tcPr marL="54864" marR="54864" marT="18288" marB="18288">
+                    <a:solidFill>
+                      <a:srgbClr val="FFFFFF"/>
+                    </a:solidFill>
+                  </a:tcPr>
+                </a:tc>
+                <a:tc>
+                  <a:txBody>
+                    <a:bodyPr wrap="square"/>
+                    <a:lstStyle/>
+                    <a:p>
+                      <a:r>
+                        <a:rPr sz="1100" b="0">
+                          <a:solidFill>
+                            <a:srgbClr val="282828"/>
+                          </a:solidFill>
+                          <a:latin typeface="Arial"/>
+                        </a:rPr>
+                        <a:t>zero-order plate at λ/300 on a 2 mm substrate; 12.7 mm cemented MacNeille cube; a second sCMOS like camera A</a:t>
+                      </a:r>
+                    </a:p>
+                  </a:txBody>
+                  <a:tcPr marL="54864" marR="54864" marT="18288" marB="18288">
+                    <a:solidFill>
+                      <a:srgbClr val="FFFFFF"/>
+                    </a:solidFill>
+                  </a:tcPr>
+                </a:tc>
+                <a:tc>
+                  <a:txBody>
+                    <a:bodyPr wrap="square"/>
+                    <a:lstStyle/>
+                    <a:p>
+                      <a:r>
+                        <a:rPr sz="1100" b="0">
+                          <a:solidFill>
+                            <a:srgbClr val="282828"/>
+                          </a:solidFill>
+                          <a:latin typeface="Arial"/>
+                        </a:rPr>
+                        <a:t>AR; ZnS / cryolite</a:t>
+                      </a:r>
+                    </a:p>
+                  </a:txBody>
+                  <a:tcPr marL="54864" marR="54864" marT="18288" marB="18288">
+                    <a:solidFill>
+                      <a:srgbClr val="FFFFFF"/>
+                    </a:solidFill>
+                  </a:tcPr>
+                </a:tc>
+                <a:tc>
+                  <a:txBody>
+                    <a:bodyPr wrap="square"/>
+                    <a:lstStyle/>
+                    <a:p>
+                      <a:r>
+                        <a:rPr sz="1100" b="0">
+                          <a:solidFill>
+                            <a:srgbClr val="282828"/>
+                          </a:solidFill>
+                          <a:latin typeface="Arial"/>
+                        </a:rPr>
+                        <a:t>3</a:t>
+                      </a:r>
+                    </a:p>
+                  </a:txBody>
+                  <a:tcPr marL="54864" marR="54864" marT="18288" marB="18288">
+                    <a:solidFill>
+                      <a:srgbClr val="FFFFFF"/>
+                    </a:solidFill>
+                  </a:tcPr>
+                </a:tc>
+                <a:tc>
+                  <a:txBody>
+                    <a:bodyPr wrap="square"/>
+                    <a:lstStyle/>
+                    <a:p>
+                      <a:r>
+                        <a:rPr sz="1100" b="0">
+                          <a:solidFill>
+                            <a:srgbClr val="282828"/>
+                          </a:solidFill>
+                          <a:latin typeface="Arial"/>
+                        </a:rPr>
+                        <a:t>separates the two circular states onto two cameras, both frames at once</a:t>
+                      </a:r>
+                    </a:p>
+                  </a:txBody>
+                  <a:tcPr marL="54864" marR="54864" marT="18288" marB="18288">
+                    <a:solidFill>
+                      <a:srgbClr val="FFFFFF"/>
+                    </a:solidFill>
+                  </a:tcPr>
+                </a:tc>
+              </a:tr>
+              <a:tr h="657225">
+                <a:tc>
+                  <a:txBody>
+                    <a:bodyPr wrap="square"/>
+                    <a:lstStyle/>
+                    <a:p>
+                      <a:r>
+                        <a:rPr sz="1100" b="0">
+                          <a:solidFill>
+                            <a:srgbClr val="282828"/>
+                          </a:solidFill>
+                          <a:latin typeface="Arial"/>
+                        </a:rPr>
+                        <a:t>vector, snapshot form</a:t>
+                      </a:r>
+                    </a:p>
+                  </a:txBody>
+                  <a:tcPr marL="54864" marR="54864" marT="18288" marB="18288">
+                    <a:solidFill>
+                      <a:srgbClr val="ECF1F6"/>
+                    </a:solidFill>
+                  </a:tcPr>
+                </a:tc>
+                <a:tc>
+                  <a:txBody>
+                    <a:bodyPr wrap="square"/>
+                    <a:lstStyle/>
+                    <a:p>
+                      <a:r>
+                        <a:rPr sz="1100" b="0">
+                          <a:solidFill>
+                            <a:srgbClr val="282828"/>
+                          </a:solidFill>
+                          <a:latin typeface="Arial"/>
+                        </a:rPr>
+                        <a:t>quarter-wave plate; the interferometer's polarization camera in place of camera A</a:t>
+                      </a:r>
+                    </a:p>
+                  </a:txBody>
+                  <a:tcPr marL="54864" marR="54864" marT="18288" marB="18288">
+                    <a:solidFill>
+                      <a:srgbClr val="ECF1F6"/>
+                    </a:solidFill>
+                  </a:tcPr>
+                </a:tc>
+                <a:tc>
+                  <a:txBody>
+                    <a:bodyPr wrap="square"/>
+                    <a:lstStyle/>
+                    <a:p>
+                      <a:r>
+                        <a:rPr sz="1100" b="0">
+                          <a:solidFill>
+                            <a:srgbClr val="282828"/>
+                          </a:solidFill>
+                          <a:latin typeface="Arial"/>
+                        </a:rPr>
+                        <a:t>the same zero-order plate; the micro-polarizer array already on the bench for the snapshot interferometer</a:t>
+                      </a:r>
+                    </a:p>
+                  </a:txBody>
+                  <a:tcPr marL="54864" marR="54864" marT="18288" marB="18288">
+                    <a:solidFill>
+                      <a:srgbClr val="ECF1F6"/>
+                    </a:solidFill>
+                  </a:tcPr>
+                </a:tc>
+                <a:tc>
+                  <a:txBody>
+                    <a:bodyPr wrap="square"/>
+                    <a:lstStyle/>
+                    <a:p>
+                      <a:r>
+                        <a:rPr sz="1100" b="0">
+                          <a:solidFill>
+                            <a:srgbClr val="282828"/>
+                          </a:solidFill>
+                          <a:latin typeface="Arial"/>
+                        </a:rPr>
+                        <a:t>AR</a:t>
+                      </a:r>
+                    </a:p>
+                  </a:txBody>
+                  <a:tcPr marL="54864" marR="54864" marT="18288" marB="18288">
+                    <a:solidFill>
+                      <a:srgbClr val="ECF1F6"/>
+                    </a:solidFill>
+                  </a:tcPr>
+                </a:tc>
+                <a:tc>
+                  <a:txBody>
+                    <a:bodyPr wrap="square"/>
+                    <a:lstStyle/>
+                    <a:p>
+                      <a:r>
+                        <a:rPr sz="1100" b="0">
+                          <a:solidFill>
+                            <a:srgbClr val="282828"/>
+                          </a:solidFill>
+                          <a:latin typeface="Arial"/>
+                        </a:rPr>
+                        <a:t>2</a:t>
+                      </a:r>
+                    </a:p>
+                  </a:txBody>
+                  <a:tcPr marL="54864" marR="54864" marT="18288" marB="18288">
+                    <a:solidFill>
+                      <a:srgbClr val="ECF1F6"/>
+                    </a:solidFill>
+                  </a:tcPr>
+                </a:tc>
+                <a:tc>
+                  <a:txBody>
+                    <a:bodyPr wrap="square"/>
+                    <a:lstStyle/>
+                    <a:p>
+                      <a:r>
+                        <a:rPr sz="1100" b="0">
+                          <a:solidFill>
+                            <a:srgbClr val="282828"/>
+                          </a:solidFill>
+                          <a:latin typeface="Arial"/>
+                        </a:rPr>
+                        <a:t>the same two states read on one camera: one detector, no split leg to align, at a quarter of the pixels per state</a:t>
+                      </a:r>
+                    </a:p>
+                  </a:txBody>
+                  <a:tcPr marL="54864" marR="54864" marT="18288" marB="18288">
+                    <a:solidFill>
+                      <a:srgbClr val="ECF1F6"/>
+                    </a:solidFill>
+                  </a:tcPr>
+                </a:tc>
+              </a:tr>
+              <a:tr h="657225">
+                <a:tc>
+                  <a:txBody>
+                    <a:bodyPr wrap="square"/>
+                    <a:lstStyle/>
+                    <a:p>
+                      <a:r>
+                        <a:rPr sz="1100" b="0">
+                          <a:solidFill>
+                            <a:srgbClr val="282828"/>
+                          </a:solidFill>
+                          <a:latin typeface="Arial"/>
+                        </a:rPr>
                         <a:t>stepped pinhole</a:t>
                       </a:r>
                     </a:p>
@@ -4212,140 +4212,6 @@
                   <a:tcPr marL="54864" marR="54864" marT="18288" marB="18288">
                     <a:solidFill>
                       <a:srgbClr val="FFFFFF"/>
-                    </a:solidFill>
-                  </a:tcPr>
-                </a:tc>
-              </a:tr>
-              <a:tr h="845820">
-                <a:tc>
-                  <a:txBody>
-                    <a:bodyPr wrap="square"/>
-                    <a:lstStyle/>
-                    <a:p>
-                      <a:r>
-                        <a:rPr sz="1100" b="0">
-                          <a:solidFill>
-                            <a:srgbClr val="282828"/>
-                          </a:solidFill>
-                          <a:latin typeface="Arial"/>
-                        </a:rPr>
-                        <a:t>P/SRI (backup)</a:t>
-                      </a:r>
-                    </a:p>
-                  </a:txBody>
-                  <a:tcPr marL="54864" marR="54864" marT="18288" marB="18288">
-                    <a:solidFill>
-                      <a:srgbClr val="ECF1F6"/>
-                    </a:solidFill>
-                  </a:tcPr>
-                </a:tc>
-                <a:tc>
-                  <a:txBody>
-                    <a:bodyPr wrap="square"/>
-                    <a:lstStyle/>
-                    <a:p>
-                      <a:r>
-                        <a:rPr sz="1100" b="0">
-                          <a:solidFill>
-                            <a:srgbClr val="282828"/>
-                          </a:solidFill>
-                          <a:latin typeface="Arial"/>
-                        </a:rPr>
-                        <a:t>pickoff plate; lens Lr1; pinhole into a single-mode waveguide with a thermo-optic phase shifter; lens Lr2; two folds; compensator; recombiner; camera C</a:t>
-                      </a:r>
-                    </a:p>
-                  </a:txBody>
-                  <a:tcPr marL="54864" marR="54864" marT="18288" marB="18288">
-                    <a:solidFill>
-                      <a:srgbClr val="ECF1F6"/>
-                    </a:solidFill>
-                  </a:tcPr>
-                </a:tc>
-                <a:tc>
-                  <a:txBody>
-                    <a:bodyPr wrap="square"/>
-                    <a:lstStyle/>
-                    <a:p>
-                      <a:r>
-                        <a:rPr sz="1100" b="0">
-                          <a:solidFill>
-                            <a:srgbClr val="282828"/>
-                          </a:solidFill>
-                          <a:latin typeface="Arial"/>
-                        </a:rPr>
-                        <a:t>60/40 plate at 45°; f 300 mm F/2.9; 3.7 µm; f 300 mm mirrored; 150 mm flats at 45°; 21.9 mm of glass; 50/50 plate at 45°; sCMOS</a:t>
-                      </a:r>
-                    </a:p>
-                  </a:txBody>
-                  <a:tcPr marL="54864" marR="54864" marT="18288" marB="18288">
-                    <a:solidFill>
-                      <a:srgbClr val="ECF1F6"/>
-                    </a:solidFill>
-                  </a:tcPr>
-                </a:tc>
-                <a:tc>
-                  <a:txBody>
-                    <a:bodyPr wrap="square"/>
-                    <a:lstStyle/>
-                    <a:p>
-                      <a:r>
-                        <a:rPr sz="1100" b="0">
-                          <a:solidFill>
-                            <a:srgbClr val="282828"/>
-                          </a:solidFill>
-                          <a:latin typeface="Arial"/>
-                        </a:rPr>
-                        <a:t>AR; protected-metal folds</a:t>
-                      </a:r>
-                    </a:p>
-                  </a:txBody>
-                  <a:tcPr marL="54864" marR="54864" marT="18288" marB="18288">
-                    <a:solidFill>
-                      <a:srgbClr val="ECF1F6"/>
-                    </a:solidFill>
-                  </a:tcPr>
-                </a:tc>
-                <a:tc>
-                  <a:txBody>
-                    <a:bodyPr wrap="square"/>
-                    <a:lstStyle/>
-                    <a:p>
-                      <a:r>
-                        <a:rPr sz="1100" b="0">
-                          <a:solidFill>
-                            <a:srgbClr val="282828"/>
-                          </a:solidFill>
-                          <a:latin typeface="Arial"/>
-                        </a:rPr>
-                        <a:t>9</a:t>
-                      </a:r>
-                    </a:p>
-                  </a:txBody>
-                  <a:tcPr marL="54864" marR="54864" marT="18288" marB="18288">
-                    <a:solidFill>
-                      <a:srgbClr val="ECF1F6"/>
-                    </a:solidFill>
-                  </a:tcPr>
-                </a:tc>
-                <a:tc>
-                  <a:txBody>
-                    <a:bodyPr wrap="square"/>
-                    <a:lstStyle/>
-                    <a:p>
-                      <a:r>
-                        <a:rPr sz="1100" b="0">
-                          <a:solidFill>
-                            <a:srgbClr val="282828"/>
-                          </a:solidFill>
-                          <a:latin typeface="Arial"/>
-                        </a:rPr>
-                        <a:t>the two-arm form with a reference that does not move with the surface</a:t>
-                      </a:r>
-                    </a:p>
-                  </a:txBody>
-                  <a:tcPr marL="54864" marR="54864" marT="18288" marB="18288">
-                    <a:solidFill>
-                      <a:srgbClr val="ECF1F6"/>
                     </a:solidFill>
                   </a:tcPr>
                 </a:tc>
@@ -4388,7 +4254,7 @@
                 </a:solidFill>
                 <a:latin typeface="Arial"/>
               </a:rPr>
-              <a:t>The vector sensor is the one configuration with a choice of readout: the split form buys full pixel count per state, the snapshot form reuses the interferometer's own camera.  The Zernike, vector and pinhole plates share one substrate on the seat.  Full parts tables with vendors' classes are in each lane's README.  What the photonic reference is, and is not, in these numbers: the P/SRI arm's reference is modeled as the recollimated LP01 mode of a single-mode fiber, with the pickoff fraction, the coupling into the mode, and a miscalibration of the phase steps all priced.  The waveguide itself is not a traced element and the thermo-optic shifter is an ideal phase per frame, so the photonic option is costed as an ideal device on a real mode: its own loss, dispersion and thermal drift are the next thing to model, not something already in these numbers.</a:t>
+              <a:t>The vector sensor is the one configuration with a choice of readout: the split form buys full pixel count per state, the snapshot form reuses the interferometer's camera.  The Zernike, vector and pinhole plates share one substrate on the seat; full parts tables are in each lane's README.  The P/SRI's nine parts are on its backup slide.</a:t>
             </a:r>
           </a:p>
         </p:txBody>
@@ -26668,6 +26534,45 @@
                 <a:latin typeface="Arial"/>
               </a:rPr>
               <a:t>Run tags pin20_1024, pin10_2048, pin20_loop, pin10_loop, pfdeck, pfdeck_frz, pdi193se_sh5, pdi193se_ls; layouts psri_layout.png and psri_render.png in pdi_dm96.</a:t>
+            </a:r>
+          </a:p>
+        </p:txBody>
+      </p:sp>
+      <p:sp>
+        <p:nvSpPr>
+          <p:cNvPr id="7" name="TextBox 6"/>
+          <p:cNvSpPr txBox="1"/>
+          <p:nvPr/>
+        </p:nvSpPr>
+        <p:spPr>
+          <a:xfrm>
+            <a:off x="6400800" y="4458462"/>
+            <a:ext cx="5394960" cy="274320"/>
+          </a:xfrm>
+          <a:prstGeom prst="rect">
+            <a:avLst/>
+          </a:prstGeom>
+          <a:noFill/>
+        </p:spPr>
+        <p:txBody>
+          <a:bodyPr wrap="square">
+            <a:spAutoFit/>
+          </a:bodyPr>
+          <a:lstStyle/>
+          <a:p>
+            <a:pPr>
+              <a:spcAft>
+                <a:spcPts val="600"/>
+              </a:spcAft>
+            </a:pPr>
+            <a:r>
+              <a:rPr sz="1050" b="0">
+                <a:solidFill>
+                  <a:srgbClr val="6E6E6E"/>
+                </a:solidFill>
+                <a:latin typeface="Arial"/>
+              </a:rPr>
+              <a:t>P/SRI parts (9): a 60/40 pickoff plate; two f 300 mm F/2.9 lenses; a 3.7 µm pinhole into a single-mode waveguide with a thermo-optic phase shifter; two 150 mm protected-metal folds; a 50/50 recombiner; camera C (sCMOS).  Its photonic reference is modeled as the recollimated LP01 mode of a single-mode fiber (pickoff fraction, coupling and phase-step miscalibration priced); the waveguide's own loss, dispersion and thermal drift are not yet in these numbers.</a:t>
             </a:r>
           </a:p>
         </p:txBody>

</xml_diff>

<commit_message>
deck_gauges (+ short): 'Capture range, second half' on the built bench -- the sensors' off-null photons (vector 4.6e13 -> 4.5e15 from 30 to 160 nm) and re-measured gains (0.94-0.99, floors 6-50 pm); the interferometer falls 7.0e14 -> 4.4e14; every row now the bench as built; edit copies synced
Co-Authored-By: Claude Fable 5.1 <noreply@anthropic.com>
</commit_message>
<xml_diff>
--- a/demo_session/deck_gauges.pptx
+++ b/demo_session/deck_gauges.pptx
@@ -12611,7 +12611,7 @@
                 </a:solidFill>
                 <a:latin typeface="Arial"/>
               </a:rPr>
-              <a:t>The matrix re-measured on the surface holds the gain; the light for 1 pm then rises 5-40× for the self-referenced sensors and not at all for the P/SRI</a:t>
+              <a:t>The matrix re-measured on the surface holds the gain to 1-6 %; the light for 1 pm then rises 30-100× for the self-referenced sensors between 30 and 160 nm (vector 4.6e13 → 4.5e15) and falls for the interferometer (7.0e14 → 4.4e14), whose reference does not move with the surface</a:t>
             </a:r>
           </a:p>
         </p:txBody>
@@ -12670,7 +12670,7 @@
         </p:nvGraphicFramePr>
         <p:xfrm>
           <a:off x="411480" y="1298448"/>
-          <a:ext cx="11368734" cy="4406265"/>
+          <a:ext cx="11368734" cy="3657600"/>
         </p:xfrm>
         <a:graphic>
           <a:graphicData uri="http://schemas.openxmlformats.org/drawingml/2006/table">
@@ -12718,7 +12718,7 @@
                           </a:solidFill>
                           <a:latin typeface="Arial"/>
                         </a:rPr>
-                        <a:t>1 nm on 47 sites, matrix re-measured at 60 / 90 / 120 / 160 nm: gain / floor</a:t>
+                        <a:t>1 nm on the grid sites, matrix re-measured at 60 / 120 / 160 nm: gain / floor</a:t>
                       </a:r>
                     </a:p>
                   </a:txBody>
@@ -12764,125 +12764,57 @@
                           </a:solidFill>
                           <a:latin typeface="Arial"/>
                         </a:rPr>
-                        <a:t>Zernike linear</a:t>
-                      </a:r>
-                    </a:p>
-                  </a:txBody>
-                  <a:tcPr marL="54864" marR="54864" marT="18288" marB="18288">
-                    <a:solidFill>
-                      <a:srgbClr val="FFFFFF"/>
-                    </a:solidFill>
-                  </a:tcPr>
-                </a:tc>
-                <a:tc>
-                  <a:txBody>
-                    <a:bodyPr wrap="square"/>
-                    <a:lstStyle/>
-                    <a:p>
-                      <a:r>
-                        <a:rPr sz="1100" b="0">
-                          <a:solidFill>
-                            <a:srgbClr val="282828"/>
-                          </a:solidFill>
-                          <a:latin typeface="Arial"/>
-                        </a:rPr>
-                        <a:t>0.96 / 25, 0.95 / 21, 0.96 / 17, 0.97 / 13 pm</a:t>
-                      </a:r>
-                    </a:p>
-                  </a:txBody>
-                  <a:tcPr marL="54864" marR="54864" marT="18288" marB="18288">
-                    <a:solidFill>
-                      <a:srgbClr val="FFFFFF"/>
-                    </a:solidFill>
-                  </a:tcPr>
-                </a:tc>
-                <a:tc>
-                  <a:txBody>
-                    <a:bodyPr wrap="square"/>
-                    <a:lstStyle/>
-                    <a:p>
-                      <a:r>
-                        <a:rPr sz="1100" b="0">
-                          <a:solidFill>
-                            <a:srgbClr val="282828"/>
-                          </a:solidFill>
-                          <a:latin typeface="Arial"/>
-                        </a:rPr>
-                        <a:t>9.2e13, 1.8e14, 6.2e14, 4.6e14</a:t>
-                      </a:r>
-                    </a:p>
-                  </a:txBody>
-                  <a:tcPr marL="54864" marR="54864" marT="18288" marB="18288">
-                    <a:solidFill>
-                      <a:srgbClr val="FFFFFF"/>
-                    </a:solidFill>
-                  </a:tcPr>
-                </a:tc>
-              </a:tr>
-              <a:tr h="280035">
-                <a:tc>
-                  <a:txBody>
-                    <a:bodyPr wrap="square"/>
-                    <a:lstStyle/>
-                    <a:p>
-                      <a:r>
-                        <a:rPr sz="1100" b="0">
-                          <a:solidFill>
-                            <a:srgbClr val="282828"/>
-                          </a:solidFill>
-                          <a:latin typeface="Arial"/>
-                        </a:rPr>
-                        <a:t>Zernike stepped</a:t>
-                      </a:r>
-                    </a:p>
-                  </a:txBody>
-                  <a:tcPr marL="54864" marR="54864" marT="18288" marB="18288">
-                    <a:solidFill>
-                      <a:srgbClr val="ECF1F6"/>
-                    </a:solidFill>
-                  </a:tcPr>
-                </a:tc>
-                <a:tc>
-                  <a:txBody>
-                    <a:bodyPr wrap="square"/>
-                    <a:lstStyle/>
-                    <a:p>
-                      <a:r>
-                        <a:rPr sz="1100" b="0">
-                          <a:solidFill>
-                            <a:srgbClr val="282828"/>
-                          </a:solidFill>
-                          <a:latin typeface="Arial"/>
-                        </a:rPr>
-                        <a:t>0.93 / 59, 0.96 / 29, 0.97 / 22, 0.97 / 20 pm</a:t>
-                      </a:r>
-                    </a:p>
-                  </a:txBody>
-                  <a:tcPr marL="54864" marR="54864" marT="18288" marB="18288">
-                    <a:solidFill>
-                      <a:srgbClr val="ECF1F6"/>
-                    </a:solidFill>
-                  </a:tcPr>
-                </a:tc>
-                <a:tc>
-                  <a:txBody>
-                    <a:bodyPr wrap="square"/>
-                    <a:lstStyle/>
-                    <a:p>
-                      <a:r>
-                        <a:rPr sz="1100" b="0">
-                          <a:solidFill>
-                            <a:srgbClr val="282828"/>
-                          </a:solidFill>
-                          <a:latin typeface="Arial"/>
-                        </a:rPr>
-                        <a:t>8.8e13, then 1e15 class</a:t>
-                      </a:r>
-                    </a:p>
-                  </a:txBody>
-                  <a:tcPr marL="54864" marR="54864" marT="18288" marB="18288">
-                    <a:solidFill>
-                      <a:srgbClr val="ECF1F6"/>
+                        <a:t>stepped Zernike</a:t>
+                      </a:r>
+                    </a:p>
+                  </a:txBody>
+                  <a:tcPr marL="54864" marR="54864" marT="18288" marB="18288">
+                    <a:solidFill>
+                      <a:srgbClr val="FFFFFF"/>
+                    </a:solidFill>
+                  </a:tcPr>
+                </a:tc>
+                <a:tc>
+                  <a:txBody>
+                    <a:bodyPr wrap="square"/>
+                    <a:lstStyle/>
+                    <a:p>
+                      <a:r>
+                        <a:rPr sz="1100" b="0">
+                          <a:solidFill>
+                            <a:srgbClr val="282828"/>
+                          </a:solidFill>
+                          <a:latin typeface="Arial"/>
+                        </a:rPr>
+                        <a:t>0.94 / 50, 0.99 / 26, 0.99 / 26 pm</a:t>
+                      </a:r>
+                    </a:p>
+                  </a:txBody>
+                  <a:tcPr marL="54864" marR="54864" marT="18288" marB="18288">
+                    <a:solidFill>
+                      <a:srgbClr val="FFFFFF"/>
+                    </a:solidFill>
+                  </a:tcPr>
+                </a:tc>
+                <a:tc>
+                  <a:txBody>
+                    <a:bodyPr wrap="square"/>
+                    <a:lstStyle/>
+                    <a:p>
+                      <a:r>
+                        <a:rPr sz="1100" b="0">
+                          <a:solidFill>
+                            <a:srgbClr val="282828"/>
+                          </a:solidFill>
+                          <a:latin typeface="Arial"/>
+                        </a:rPr>
+                        <a:t>1.2e14, 5.3e14, 4.6e15, 7.5e15</a:t>
+                      </a:r>
+                    </a:p>
+                  </a:txBody>
+                  <a:tcPr marL="54864" marR="54864" marT="18288" marB="18288">
+                    <a:solidFill>
+                      <a:srgbClr val="FFFFFF"/>
                     </a:solidFill>
                   </a:tcPr>
                 </a:tc>
@@ -12906,51 +12838,51 @@
                   </a:txBody>
                   <a:tcPr marL="54864" marR="54864" marT="18288" marB="18288">
                     <a:solidFill>
-                      <a:srgbClr val="FFFFFF"/>
-                    </a:solidFill>
-                  </a:tcPr>
-                </a:tc>
-                <a:tc>
-                  <a:txBody>
-                    <a:bodyPr wrap="square"/>
-                    <a:lstStyle/>
-                    <a:p>
-                      <a:r>
-                        <a:rPr sz="1100" b="0">
-                          <a:solidFill>
-                            <a:srgbClr val="282828"/>
-                          </a:solidFill>
-                          <a:latin typeface="Arial"/>
-                        </a:rPr>
-                        <a:t>1.00 / 3, 0.96 / 47, 0.97 / 23, 0.97 / 21 pm</a:t>
-                      </a:r>
-                    </a:p>
-                  </a:txBody>
-                  <a:tcPr marL="54864" marR="54864" marT="18288" marB="18288">
-                    <a:solidFill>
-                      <a:srgbClr val="FFFFFF"/>
-                    </a:solidFill>
-                  </a:tcPr>
-                </a:tc>
-                <a:tc>
-                  <a:txBody>
-                    <a:bodyPr wrap="square"/>
-                    <a:lstStyle/>
-                    <a:p>
-                      <a:r>
-                        <a:rPr sz="1100" b="0">
-                          <a:solidFill>
-                            <a:srgbClr val="282828"/>
-                          </a:solidFill>
-                          <a:latin typeface="Arial"/>
-                        </a:rPr>
-                        <a:t>6.1e13, 1.1e14, 2.2e15, 2.4e15</a:t>
-                      </a:r>
-                    </a:p>
-                  </a:txBody>
-                  <a:tcPr marL="54864" marR="54864" marT="18288" marB="18288">
-                    <a:solidFill>
-                      <a:srgbClr val="FFFFFF"/>
+                      <a:srgbClr val="ECF1F6"/>
+                    </a:solidFill>
+                  </a:tcPr>
+                </a:tc>
+                <a:tc>
+                  <a:txBody>
+                    <a:bodyPr wrap="square"/>
+                    <a:lstStyle/>
+                    <a:p>
+                      <a:r>
+                        <a:rPr sz="1100" b="0">
+                          <a:solidFill>
+                            <a:srgbClr val="282828"/>
+                          </a:solidFill>
+                          <a:latin typeface="Arial"/>
+                        </a:rPr>
+                        <a:t>0.99 / 6, 0.99 / 26, 0.99 / 26 pm</a:t>
+                      </a:r>
+                    </a:p>
+                  </a:txBody>
+                  <a:tcPr marL="54864" marR="54864" marT="18288" marB="18288">
+                    <a:solidFill>
+                      <a:srgbClr val="ECF1F6"/>
+                    </a:solidFill>
+                  </a:tcPr>
+                </a:tc>
+                <a:tc>
+                  <a:txBody>
+                    <a:bodyPr wrap="square"/>
+                    <a:lstStyle/>
+                    <a:p>
+                      <a:r>
+                        <a:rPr sz="1100" b="0">
+                          <a:solidFill>
+                            <a:srgbClr val="282828"/>
+                          </a:solidFill>
+                          <a:latin typeface="Arial"/>
+                        </a:rPr>
+                        <a:t>4.6e13, 1.4e14, 2.4e15, 4.5e15</a:t>
+                      </a:r>
+                    </a:p>
+                  </a:txBody>
+                  <a:tcPr marL="54864" marR="54864" marT="18288" marB="18288">
+                    <a:solidFill>
+                      <a:srgbClr val="ECF1F6"/>
                     </a:solidFill>
                   </a:tcPr>
                 </a:tc>
@@ -12974,51 +12906,51 @@
                   </a:txBody>
                   <a:tcPr marL="54864" marR="54864" marT="18288" marB="18288">
                     <a:solidFill>
-                      <a:srgbClr val="ECF1F6"/>
-                    </a:solidFill>
-                  </a:tcPr>
-                </a:tc>
-                <a:tc>
-                  <a:txBody>
-                    <a:bodyPr wrap="square"/>
-                    <a:lstStyle/>
-                    <a:p>
-                      <a:r>
-                        <a:rPr sz="1100" b="0">
-                          <a:solidFill>
-                            <a:srgbClr val="282828"/>
-                          </a:solidFill>
-                          <a:latin typeface="Arial"/>
-                        </a:rPr>
-                        <a:t>1.00 / 3, 0.96 / 41, 0.97 / 19, 0.97 / 17 pm</a:t>
-                      </a:r>
-                    </a:p>
-                  </a:txBody>
-                  <a:tcPr marL="54864" marR="54864" marT="18288" marB="18288">
-                    <a:solidFill>
-                      <a:srgbClr val="ECF1F6"/>
-                    </a:solidFill>
-                  </a:tcPr>
-                </a:tc>
-                <a:tc>
-                  <a:txBody>
-                    <a:bodyPr wrap="square"/>
-                    <a:lstStyle/>
-                    <a:p>
-                      <a:r>
-                        <a:rPr sz="1100" b="0">
-                          <a:solidFill>
-                            <a:srgbClr val="282828"/>
-                          </a:solidFill>
-                          <a:latin typeface="Arial"/>
-                        </a:rPr>
-                        <a:t>9.8e13, 1.7e14, tens of times more at 120-160</a:t>
-                      </a:r>
-                    </a:p>
-                  </a:txBody>
-                  <a:tcPr marL="54864" marR="54864" marT="18288" marB="18288">
-                    <a:solidFill>
-                      <a:srgbClr val="ECF1F6"/>
+                      <a:srgbClr val="FFFFFF"/>
+                    </a:solidFill>
+                  </a:tcPr>
+                </a:tc>
+                <a:tc>
+                  <a:txBody>
+                    <a:bodyPr wrap="square"/>
+                    <a:lstStyle/>
+                    <a:p>
+                      <a:r>
+                        <a:rPr sz="1100" b="0">
+                          <a:solidFill>
+                            <a:srgbClr val="282828"/>
+                          </a:solidFill>
+                          <a:latin typeface="Arial"/>
+                        </a:rPr>
+                        <a:t>0.98 / 16, 0.99 / 26, 0.99 / 26 pm</a:t>
+                      </a:r>
+                    </a:p>
+                  </a:txBody>
+                  <a:tcPr marL="54864" marR="54864" marT="18288" marB="18288">
+                    <a:solidFill>
+                      <a:srgbClr val="FFFFFF"/>
+                    </a:solidFill>
+                  </a:tcPr>
+                </a:tc>
+                <a:tc>
+                  <a:txBody>
+                    <a:bodyPr wrap="square"/>
+                    <a:lstStyle/>
+                    <a:p>
+                      <a:r>
+                        <a:rPr sz="1100" b="0">
+                          <a:solidFill>
+                            <a:srgbClr val="282828"/>
+                          </a:solidFill>
+                          <a:latin typeface="Arial"/>
+                        </a:rPr>
+                        <a:t>1.5e14, 3.0e14, 3.0e15, 7.3e15</a:t>
+                      </a:r>
+                    </a:p>
+                  </a:txBody>
+                  <a:tcPr marL="54864" marR="54864" marT="18288" marB="18288">
+                    <a:solidFill>
+                      <a:srgbClr val="FFFFFF"/>
                     </a:solidFill>
                   </a:tcPr>
                 </a:tc>
@@ -13036,57 +12968,57 @@
                           </a:solidFill>
                           <a:latin typeface="Arial"/>
                         </a:rPr>
-                        <a:t>P/SRI</a:t>
-                      </a:r>
-                    </a:p>
-                  </a:txBody>
-                  <a:tcPr marL="54864" marR="54864" marT="18288" marB="18288">
-                    <a:solidFill>
-                      <a:srgbClr val="FFFFFF"/>
-                    </a:solidFill>
-                  </a:tcPr>
-                </a:tc>
-                <a:tc>
-                  <a:txBody>
-                    <a:bodyPr wrap="square"/>
-                    <a:lstStyle/>
-                    <a:p>
-                      <a:r>
-                        <a:rPr sz="1100" b="0">
-                          <a:solidFill>
-                            <a:srgbClr val="282828"/>
-                          </a:solidFill>
-                          <a:latin typeface="Arial"/>
-                        </a:rPr>
-                        <a:t>1.000 / 3, 1.001 / 2, 1.001 / 2, 1.002 / 2 pm</a:t>
-                      </a:r>
-                    </a:p>
-                  </a:txBody>
-                  <a:tcPr marL="54864" marR="54864" marT="18288" marB="18288">
-                    <a:solidFill>
-                      <a:srgbClr val="FFFFFF"/>
-                    </a:solidFill>
-                  </a:tcPr>
-                </a:tc>
-                <a:tc>
-                  <a:txBody>
-                    <a:bodyPr wrap="square"/>
-                    <a:lstStyle/>
-                    <a:p>
-                      <a:r>
-                        <a:rPr sz="1100" b="0">
-                          <a:solidFill>
-                            <a:srgbClr val="282828"/>
-                          </a:solidFill>
-                          <a:latin typeface="Arial"/>
-                        </a:rPr>
-                        <a:t>3.7e14, 4.1e14, 6.6e14, 3.7e14</a:t>
-                      </a:r>
-                    </a:p>
-                  </a:txBody>
-                  <a:tcPr marL="54864" marR="54864" marT="18288" marB="18288">
-                    <a:solidFill>
-                      <a:srgbClr val="FFFFFF"/>
+                        <a:t>interferometer, lens rig</a:t>
+                      </a:r>
+                    </a:p>
+                  </a:txBody>
+                  <a:tcPr marL="54864" marR="54864" marT="18288" marB="18288">
+                    <a:solidFill>
+                      <a:srgbClr val="ECF1F6"/>
+                    </a:solidFill>
+                  </a:tcPr>
+                </a:tc>
+                <a:tc>
+                  <a:txBody>
+                    <a:bodyPr wrap="square"/>
+                    <a:lstStyle/>
+                    <a:p>
+                      <a:r>
+                        <a:rPr sz="1100" b="0">
+                          <a:solidFill>
+                            <a:srgbClr val="282828"/>
+                          </a:solidFill>
+                          <a:latin typeface="Arial"/>
+                        </a:rPr>
+                        <a:t>1.001 / 2, 0.996 / 2, 0.996 / 2 pm</a:t>
+                      </a:r>
+                    </a:p>
+                  </a:txBody>
+                  <a:tcPr marL="54864" marR="54864" marT="18288" marB="18288">
+                    <a:solidFill>
+                      <a:srgbClr val="ECF1F6"/>
+                    </a:solidFill>
+                  </a:tcPr>
+                </a:tc>
+                <a:tc>
+                  <a:txBody>
+                    <a:bodyPr wrap="square"/>
+                    <a:lstStyle/>
+                    <a:p>
+                      <a:r>
+                        <a:rPr sz="1100" b="0">
+                          <a:solidFill>
+                            <a:srgbClr val="282828"/>
+                          </a:solidFill>
+                          <a:latin typeface="Arial"/>
+                        </a:rPr>
+                        <a:t>9.9e14, 8.6e14, 5.9e14, 6.6e14</a:t>
+                      </a:r>
+                    </a:p>
+                  </a:txBody>
+                  <a:tcPr marL="54864" marR="54864" marT="18288" marB="18288">
+                    <a:solidFill>
+                      <a:srgbClr val="ECF1F6"/>
                     </a:solidFill>
                   </a:tcPr>
                 </a:tc>
@@ -13104,74 +13036,6 @@
                           </a:solidFill>
                           <a:latin typeface="Arial"/>
                         </a:rPr>
-                        <a:t>interferometer, lens rig</a:t>
-                      </a:r>
-                    </a:p>
-                  </a:txBody>
-                  <a:tcPr marL="54864" marR="54864" marT="18288" marB="18288">
-                    <a:solidFill>
-                      <a:srgbClr val="ECF1F6"/>
-                    </a:solidFill>
-                  </a:tcPr>
-                </a:tc>
-                <a:tc>
-                  <a:txBody>
-                    <a:bodyPr wrap="square"/>
-                    <a:lstStyle/>
-                    <a:p>
-                      <a:r>
-                        <a:rPr sz="1100" b="0">
-                          <a:solidFill>
-                            <a:srgbClr val="282828"/>
-                          </a:solidFill>
-                          <a:latin typeface="Arial"/>
-                        </a:rPr>
-                        <a:t>1.001 / 2, 0.998 / 2, 0.996 / 2, 0.996 / 2 pm</a:t>
-                      </a:r>
-                    </a:p>
-                  </a:txBody>
-                  <a:tcPr marL="54864" marR="54864" marT="18288" marB="18288">
-                    <a:solidFill>
-                      <a:srgbClr val="ECF1F6"/>
-                    </a:solidFill>
-                  </a:tcPr>
-                </a:tc>
-                <a:tc>
-                  <a:txBody>
-                    <a:bodyPr wrap="square"/>
-                    <a:lstStyle/>
-                    <a:p>
-                      <a:r>
-                        <a:rPr sz="1100" b="0">
-                          <a:solidFill>
-                            <a:srgbClr val="282828"/>
-                          </a:solidFill>
-                          <a:latin typeface="Arial"/>
-                        </a:rPr>
-                        <a:t>9.9e14, 8.6e14, 5.9e14, 6.6e14</a:t>
-                      </a:r>
-                    </a:p>
-                  </a:txBody>
-                  <a:tcPr marL="54864" marR="54864" marT="18288" marB="18288">
-                    <a:solidFill>
-                      <a:srgbClr val="ECF1F6"/>
-                    </a:solidFill>
-                  </a:tcPr>
-                </a:tc>
-              </a:tr>
-              <a:tr h="468630">
-                <a:tc>
-                  <a:txBody>
-                    <a:bodyPr wrap="square"/>
-                    <a:lstStyle/>
-                    <a:p>
-                      <a:r>
-                        <a:rPr sz="1100" b="0">
-                          <a:solidFill>
-                            <a:srgbClr val="282828"/>
-                          </a:solidFill>
-                          <a:latin typeface="Arial"/>
-                        </a:rPr>
                         <a:t>interferometer, mirror rig</a:t>
                       </a:r>
                     </a:p>
@@ -13194,7 +13058,7 @@
                           </a:solidFill>
                           <a:latin typeface="Arial"/>
                         </a:rPr>
-                        <a:t>0.989 / 2, 0.993 / 2, 0.995 / 2, 0.995 / 2 pm</a:t>
+                        <a:t>0.989 / 2, 0.995 / 2, 0.995 / 2 pm</a:t>
                       </a:r>
                     </a:p>
                   </a:txBody>
@@ -13307,7 +13171,7 @@
         </p:nvSpPr>
         <p:spPr>
           <a:xfrm>
-            <a:off x="411480" y="5851017"/>
+            <a:off x="411480" y="5102352"/>
             <a:ext cx="11368735" cy="274320"/>
           </a:xfrm>
           <a:prstGeom prst="rect">
@@ -13351,7 +13215,7 @@
                 </a:solidFill>
                 <a:latin typeface="Arial"/>
               </a:rPr>
-              <a:t> off null, a self-referenced sensor keeps its accuracy through recalibration but pays in light (2e15 photons is 0.8 mJ, 3 s of a 1 mW laser); the two-arm instruments pay nothing because their reference does not move with the surface.</a:t>
+              <a:t> off null, a self-referenced sensor keeps its gain through recalibration but pays in light (4.5e15 photons is 1.4 mJ, 6 s of a 1 mW laser at 25 % throughput) and its floor rises to 26 pm; the interferometer pays nothing because its reference does not move with the surface.</a:t>
             </a:r>
           </a:p>
         </p:txBody>
@@ -13364,7 +13228,7 @@
         </p:nvSpPr>
         <p:spPr>
           <a:xfrm>
-            <a:off x="411480" y="6770751"/>
+            <a:off x="411480" y="6022086"/>
             <a:ext cx="11368735" cy="274320"/>
           </a:xfrm>
           <a:prstGeom prst="rect">
@@ -13390,7 +13254,7 @@
                 </a:solidFill>
                 <a:latin typeface="Arial"/>
               </a:rPr>
-              <a:t>Interferometer rows: redo96_lensph, redo96_oapph (the built rigs; the re-measured matrix on each surface, 1 nm on 112 sites).  Sensor rows: cap385_b60-b160, cap385p_b60-b160, noise193_b30-b160, noise193p_b30-b160 at 385 px, pending their repeat on the built bench.  Photons are per measurement, all frames summed, 6 noise realizations per point.</a:t>
+              <a:t>All rows on the built bench.  Interferometer: redo96_lensph, redo96_oapph (the re-measured matrix on each surface, 1 nm on 112 sites).  Sensors, mirror rig at 193 px: redo96_senscap_b60/b120/b160 (1 nm on 77 grid sites, matrix re-measured on the surface), redo96_sensnoise and redo96_sensnoise_b60/b120/b160 (photons).  Photons are per measurement, all frames summed, 6 noise realizations per point.</a:t>
             </a:r>
           </a:p>
         </p:txBody>

</xml_diff>

<commit_message>
deck_gauges (+ short): the stepped Zernike's 4.8 nm raw residual explained as a GAIN error (reference amplitude taken from the flat; the matrix on the surface absorbs it; the capture-range limit) on the four-strip slide and the scalar station backup slide; edit copies synced (Dave 2026-10-07)
Co-Authored-By: Claude Fable 5.1 <noreply@anthropic.com>
</commit_message>
<xml_diff>
--- a/demo_session/deck_gauges.pptx
+++ b/demo_session/deck_gauges.pptx
@@ -7729,7 +7729,7 @@
                 </a:solidFill>
                 <a:latin typeface="Arial"/>
               </a:rPr>
-              <a:t> (fourth column) is the core of the focal spot spread back over the pupil: on the working surface it has changed, so the raw four-frame map carries a 4.8 nm bias.  The matrix measured on the surface absorbs it, which is how the stepped reading reaches 5 pm on its rows.</a:t>
+              <a:t> (fourth column) is the core of the focal spot spread back over the pupil, and the inversion takes its amplitude from the flat.  On the 30 nm surface (0.6 rad rms of wavefront phase, double pass) the core is weaker, the recovered phase scales as one over that amplitude, and the raw map reads the surface about 16 % low -- 4.8 nm, shaped like the surface: a gain error, not noise.  The matrix measured on the surface absorbs it, which is how the stepped reading reaches 5 pm on its rows; left as calibrated on the flat, it is what limits the self-referenced sensors' capture range to 36-70 nm.</a:t>
             </a:r>
           </a:p>
         </p:txBody>
@@ -7742,7 +7742,7 @@
         </p:nvSpPr>
         <p:spPr>
           <a:xfrm>
-            <a:off x="411480" y="5016246"/>
+            <a:off x="411480" y="5759196"/>
             <a:ext cx="11368735" cy="274320"/>
           </a:xfrm>
           <a:prstGeom prst="rect">
@@ -11069,8 +11069,65 @@
         </p:nvSpPr>
         <p:spPr>
           <a:xfrm>
-            <a:off x="411480" y="5943600"/>
-            <a:ext cx="11338560" cy="274320"/>
+            <a:off x="411480" y="5788152"/>
+            <a:ext cx="11384280" cy="274320"/>
+          </a:xfrm>
+          <a:prstGeom prst="rect">
+            <a:avLst/>
+          </a:prstGeom>
+          <a:noFill/>
+        </p:spPr>
+        <p:txBody>
+          <a:bodyPr wrap="square">
+            <a:spAutoFit/>
+          </a:bodyPr>
+          <a:lstStyle/>
+          <a:p>
+            <a:pPr>
+              <a:spcAft>
+                <a:spcPts val="600"/>
+              </a:spcAft>
+            </a:pPr>
+            <a:r>
+              <a:rPr sz="1100" b="0">
+                <a:solidFill>
+                  <a:srgbClr val="282828"/>
+                </a:solidFill>
+                <a:latin typeface="Arial"/>
+              </a:rPr>
+              <a:t>•  </a:t>
+            </a:r>
+            <a:r>
+              <a:rPr sz="1100" b="1">
+                <a:solidFill>
+                  <a:srgbClr val="282828"/>
+                </a:solidFill>
+                <a:latin typeface="Arial"/>
+              </a:rPr>
+              <a:t>The stepped Zernike's 4.8 nm is a gain error, not noise:</a:t>
+            </a:r>
+            <a:r>
+              <a:rPr sz="1100" b="0">
+                <a:solidFill>
+                  <a:srgbClr val="282828"/>
+                </a:solidFill>
+                <a:latin typeface="Arial"/>
+              </a:rPr>
+              <a:t> its inversion takes the reference wave's amplitude from the flat, and on the 30 nm surface the focal core that makes it is weaker, so the raw map reads about 16 % low, shaped like the surface; the matrix measured on the surface absorbs it (5 pm calibrated).  The vector pair's two simultaneous frames divide the reference out: 25 pm raw.</a:t>
+            </a:r>
+          </a:p>
+        </p:txBody>
+      </p:sp>
+      <p:sp>
+        <p:nvSpPr>
+          <p:cNvPr id="13" name="TextBox 12"/>
+          <p:cNvSpPr txBox="1"/>
+          <p:nvPr/>
+        </p:nvSpPr>
+        <p:spPr>
+          <a:xfrm>
+            <a:off x="411480" y="6382512"/>
+            <a:ext cx="11384280" cy="274320"/>
           </a:xfrm>
           <a:prstGeom prst="rect">
             <a:avLst/>

</xml_diff>

<commit_message>
deck_gauges (+ short): Dave's 08:06 geometry on the four-strip slide folded into both sidecars (strips wider and cropped, captions left; footnote below the new bullet); edit copies synced
Co-Authored-By: Claude Fable 5.1 <noreply@anthropic.com>
</commit_message>
<xml_diff>
--- a/demo_session/deck_gauges.pptx
+++ b/demo_session/deck_gauges.pptx
@@ -10825,8 +10825,8 @@
         </p:blipFill>
         <p:spPr>
           <a:xfrm>
-            <a:off x="5696712" y="1133856"/>
-            <a:ext cx="6144768" cy="1225296"/>
+            <a:off x="4800600" y="1060704"/>
+            <a:ext cx="7287768" cy="1453896"/>
           </a:xfrm>
           <a:prstGeom prst="rect">
             <a:avLst/>
@@ -10841,8 +10841,8 @@
         </p:nvSpPr>
         <p:spPr>
           <a:xfrm>
-            <a:off x="411480" y="1179576"/>
-            <a:ext cx="4206240" cy="724408"/>
+            <a:off x="228600" y="1371600"/>
+            <a:ext cx="3886200" cy="724408"/>
           </a:xfrm>
           <a:prstGeom prst="rect">
             <a:avLst/>
@@ -10882,14 +10882,15 @@
         </p:nvPicPr>
         <p:blipFill>
           <a:blip r:embed="rId3"/>
+          <a:srcRect r="2040" t="10160" b="12700"/>
           <a:stretch>
             <a:fillRect/>
           </a:stretch>
         </p:blipFill>
         <p:spPr>
           <a:xfrm>
-            <a:off x="5422392" y="2432304"/>
-            <a:ext cx="6419088" cy="1051560"/>
+            <a:off x="4233672" y="2487168"/>
+            <a:ext cx="7790688" cy="1005840"/>
           </a:xfrm>
           <a:prstGeom prst="rect">
             <a:avLst/>
@@ -10904,8 +10905,8 @@
         </p:nvSpPr>
         <p:spPr>
           <a:xfrm>
-            <a:off x="411480" y="2478024"/>
-            <a:ext cx="4206240" cy="889508"/>
+            <a:off x="228600" y="2578608"/>
+            <a:ext cx="3886200" cy="1054608"/>
           </a:xfrm>
           <a:prstGeom prst="rect">
             <a:avLst/>
@@ -10945,14 +10946,15 @@
         </p:nvPicPr>
         <p:blipFill>
           <a:blip r:embed="rId4"/>
+          <a:srcRect r="2130" t="10080" b="10710"/>
           <a:stretch>
             <a:fillRect/>
           </a:stretch>
         </p:blipFill>
         <p:spPr>
           <a:xfrm>
-            <a:off x="5422392" y="3557016"/>
-            <a:ext cx="6419088" cy="1051560"/>
+            <a:off x="4215384" y="3566160"/>
+            <a:ext cx="7781544" cy="1033271"/>
           </a:xfrm>
           <a:prstGeom prst="rect">
             <a:avLst/>
@@ -10967,8 +10969,8 @@
         </p:nvSpPr>
         <p:spPr>
           <a:xfrm>
-            <a:off x="411480" y="3602736"/>
-            <a:ext cx="4206240" cy="559307"/>
+            <a:off x="182880" y="3794760"/>
+            <a:ext cx="3931920" cy="559307"/>
           </a:xfrm>
           <a:prstGeom prst="rect">
             <a:avLst/>
@@ -11008,14 +11010,15 @@
         </p:nvPicPr>
         <p:blipFill>
           <a:blip r:embed="rId5"/>
+          <a:srcRect r="1580" t="10550" b="11620"/>
           <a:stretch>
             <a:fillRect/>
           </a:stretch>
         </p:blipFill>
         <p:spPr>
           <a:xfrm>
-            <a:off x="5422392" y="4681728"/>
-            <a:ext cx="6419088" cy="1051560"/>
+            <a:off x="4215384" y="4709160"/>
+            <a:ext cx="7827264" cy="1014984"/>
           </a:xfrm>
           <a:prstGeom prst="rect">
             <a:avLst/>
@@ -11030,8 +11033,8 @@
         </p:nvSpPr>
         <p:spPr>
           <a:xfrm>
-            <a:off x="411480" y="4727448"/>
-            <a:ext cx="4206240" cy="724408"/>
+            <a:off x="182880" y="4937760"/>
+            <a:ext cx="3931920" cy="724408"/>
           </a:xfrm>
           <a:prstGeom prst="rect">
             <a:avLst/>
@@ -11126,8 +11129,8 @@
         </p:nvSpPr>
         <p:spPr>
           <a:xfrm>
-            <a:off x="411480" y="6382512"/>
-            <a:ext cx="11384280" cy="274320"/>
+            <a:off x="411480" y="6327648"/>
+            <a:ext cx="11338560" cy="274320"/>
           </a:xfrm>
           <a:prstGeom prst="rect">
             <a:avLst/>

</xml_diff>

<commit_message>
deck_gauges (+ short): the four station figures re-run on the mirror rig with one DM command and a shared format (xlabels with the rms values and the fitted gain, one colorbar per row) -- interferometer 463 pm gain 0.987, stepped Zernike 7.1 nm gain 0.78 (the gain error named), vector 863 pm gain 0.993 (200 pm arm term on the flat), pinhole 730 pm gain 0.981; strips at true aspect; backup station slides, captions and run tags (redo96_oapstn2, stations193_oap) updated
Co-Authored-By: Claude Fable 5.1 <noreply@anthropic.com>
</commit_message>
<xml_diff>
--- a/demo_session/deck_gauges.pptx
+++ b/demo_session/deck_gauges.pptx
@@ -5135,7 +5135,7 @@
       </p:sp>
       <p:pic>
         <p:nvPicPr>
-          <p:cNvPr id="4" name="Picture 3" descr="redo96_oapstn_stations.png"/>
+          <p:cNvPr id="4" name="Picture 3" descr="redo96_oapstn2_stations.png"/>
           <p:cNvPicPr>
             <a:picLocks noChangeAspect="1"/>
           </p:cNvPicPr>
@@ -5149,8 +5149,8 @@
         </p:blipFill>
         <p:spPr>
           <a:xfrm>
-            <a:off x="2028583" y="1298448"/>
-            <a:ext cx="8134528" cy="2531872"/>
+            <a:off x="1713761" y="1298448"/>
+            <a:ext cx="8764172" cy="2531872"/>
           </a:xfrm>
           <a:prstGeom prst="rect">
             <a:avLst/>
@@ -5287,7 +5287,7 @@
                 </a:solidFill>
                 <a:latin typeface="Arial"/>
               </a:rPr>
-              <a:t>Run tag redo96_oapstn (the mirror rig).  The lens rig's figure exists but its absolute residual reads 51 nm against the engine — a fold of the phase, not an imaging error (its differential rows read the same as the mirror rig's); under investigation, so it is not shown.</a:t>
+              <a:t>Run tag redo96_oapstn2 (the mirror rig; the DM's full-lattice 30 nm command, seed 7, the same surface in every station figure).  The lens rig's figure exists but its absolute residual reads 51 nm against the engine — a fold of the phase, not an imaging error (its differential rows read the same as the mirror rig's); under investigation, so it is not shown.</a:t>
             </a:r>
           </a:p>
         </p:txBody>
@@ -7565,7 +7565,7 @@
                 </a:solidFill>
                 <a:latin typeface="Arial"/>
               </a:rPr>
-              <a:t>The key signals along the train for the flat mirror and for the 30 nm working surface: the raw pixel map on the working surface is off by 4.8 nm because the sensor's reference is made from the beam, which is why the response matrix is measured on the surface</a:t>
+              <a:t>The key signals along the train for the flat mirror and for the 30 nm working surface: the raw pixel map reads the surface 22 % low (7.1 nm rms, gain 0.78) because the sensor's reference is made from the beam, which is why the response matrix is measured on the surface</a:t>
             </a:r>
           </a:p>
         </p:txBody>
@@ -7616,7 +7616,7 @@
       </p:sp>
       <p:pic>
         <p:nvPicPr>
-          <p:cNvPr id="4" name="Picture 3" descr="stations193_stations_S.png"/>
+          <p:cNvPr id="4" name="Picture 3" descr="stations193_oap_stations_S.png"/>
           <p:cNvPicPr>
             <a:picLocks noChangeAspect="1"/>
           </p:cNvPicPr>
@@ -7630,8 +7630,8 @@
         </p:blipFill>
         <p:spPr>
           <a:xfrm>
-            <a:off x="2167487" y="1298448"/>
-            <a:ext cx="7856720" cy="2183892"/>
+            <a:off x="2493141" y="1298448"/>
+            <a:ext cx="7205411" cy="2018792"/>
           </a:xfrm>
           <a:prstGeom prst="rect">
             <a:avLst/>
@@ -7646,8 +7646,8 @@
         </p:nvSpPr>
         <p:spPr>
           <a:xfrm>
-            <a:off x="411480" y="3500628"/>
-            <a:ext cx="11368735" cy="559307"/>
+            <a:off x="411480" y="3335528"/>
+            <a:ext cx="11368735" cy="724408"/>
           </a:xfrm>
           <a:prstGeom prst="rect">
             <a:avLst/>
@@ -7672,7 +7672,7 @@
                 </a:solidFill>
                 <a:latin typeface="Arial"/>
               </a:rPr>
-              <a:t>Row 1 the flat mirror, row 2 the 30 nm working surface.  Left to right: the mirror command; the focal spot at the mask (log scale) with the dimple's footprint; the dimple's phase; the reference wave the dimple makes at the detector; the clear frame and the first depth frame of the four; the surface recovered from the four frames; the raw map minus the engine's own field at the detector (0 on the flat, 4.8 nm rms on the working surface).  The runner's own figure, run stations193 at 193 pixels per pupil.</a:t>
+              <a:t>Row 1 the flat mirror, row 2 the 30 nm working surface.  Left to right: the mirror command; the focal spot at the mask (log scale) with the dimple's footprint; the dimple's phase; the reference wave the dimple makes at the detector; the clear frame and the first depth frame of the four; the surface recovered from the four frames; the raw map minus the engine's own field at the detector (0 on the flat, 7.1 nm rms on the working surface, gain 0.78).  The runner's own figure, run stations193_oap on the mirror rig at 193 pixels per pupil.</a:t>
             </a:r>
           </a:p>
         </p:txBody>
@@ -7685,7 +7685,7 @@
         </p:nvSpPr>
         <p:spPr>
           <a:xfrm>
-            <a:off x="411480" y="4096512"/>
+            <a:off x="411480" y="4096511"/>
             <a:ext cx="11368735" cy="274320"/>
           </a:xfrm>
           <a:prstGeom prst="rect">
@@ -7729,7 +7729,7 @@
                 </a:solidFill>
                 <a:latin typeface="Arial"/>
               </a:rPr>
-              <a:t> (fourth column) is the core of the focal spot spread back over the pupil, and the inversion takes its amplitude from the flat.  On the 30 nm surface (0.6 rad rms of wavefront phase, double pass) the core is weaker, the recovered phase scales as one over that amplitude, and the raw map reads the surface about 16 % low -- 4.8 nm, shaped like the surface: a gain error, not noise.  The matrix measured on the surface absorbs it, which is how the stepped reading reaches 5 pm on its rows; left as calibrated on the flat, it is what limits the self-referenced sensors' capture range to 36-70 nm.</a:t>
+              <a:t> (fourth column) is the core of the focal spot spread back over the pupil, and the inversion takes its amplitude from the flat.  On the 30 nm surface (0.6 rad rms of wavefront phase, double pass) the core is weaker, the recovered phase scales as one over that amplitude, and the raw map reads the surface 22 % low -- gain 0.78, 7.1 nm rms, shaped like the surface: a gain error, not noise.  The matrix measured on the surface absorbs it, which is how the stepped reading reaches 5 pm on its rows; left as calibrated on the flat, it is what limits the self-referenced sensors' capture range to 36-70 nm.</a:t>
             </a:r>
           </a:p>
         </p:txBody>
@@ -9418,7 +9418,7 @@
                 </a:solidFill>
                 <a:latin typeface="Arial"/>
               </a:rPr>
-              <a:t>The two images taken at once, and a raw map within 25 pm of the engine's field on the 30 nm working surface: the pixel-by-pixel solve needs no calibration to read the surface</a:t>
+              <a:t>The two images taken at once, and a raw map at gain 0.993 against the engine's field on the 30 nm working surface: the pixel-by-pixel solve needs no reference amplitude from the flat; what remains (863 pm, 200 of them already on the flat) is the mirror rig's arm term</a:t>
             </a:r>
           </a:p>
         </p:txBody>
@@ -9469,7 +9469,7 @@
       </p:sp>
       <p:pic>
         <p:nvPicPr>
-          <p:cNvPr id="4" name="Picture 3" descr="stations193_stations_V.png"/>
+          <p:cNvPr id="4" name="Picture 3" descr="stations193_oap_stations_V.png"/>
           <p:cNvPicPr>
             <a:picLocks noChangeAspect="1"/>
           </p:cNvPicPr>
@@ -9483,8 +9483,8 @@
         </p:blipFill>
         <p:spPr>
           <a:xfrm>
-            <a:off x="2167487" y="1298448"/>
-            <a:ext cx="7856720" cy="2183892"/>
+            <a:off x="2198506" y="1298448"/>
+            <a:ext cx="7794681" cy="2183892"/>
           </a:xfrm>
           <a:prstGeom prst="rect">
             <a:avLst/>
@@ -9621,7 +9621,7 @@
                 </a:solidFill>
                 <a:latin typeface="Arial"/>
               </a:rPr>
-              <a:t>The 25 pm is the raw absolute map's error on a 30 nm surface with the flat's calibration; on the same surface the calibrated reading is 0.9935 / 4 pm.</a:t>
+              <a:t>The 863 pm is the raw absolute map's error on the 30 nm surface with the flat's calibration, at gain 0.993; 200 pm of it is there on the flat too -- the mirror rig's uncalibrated metasurface-arm term, which the calibration absorbs.  On the same surface the calibrated reading is 0.9935 / 4 pm.  Run stations193_oap.</a:t>
             </a:r>
           </a:p>
         </p:txBody>
@@ -10484,7 +10484,7 @@
                 </a:solidFill>
                 <a:latin typeface="Arial"/>
               </a:rPr>
-              <a:t>The pinhole passes the core as the reference, the attenuated surround passes the rest; the first step frame and the shutter frame; a raw map within 0.18 nm of the engine's field on the working surface</a:t>
+              <a:t>The pinhole passes the core as the reference, the attenuated surround passes the rest; the first step frame and the shutter frame; a raw map at gain 0.981, 0.73 nm rms against the engine's field on the working surface</a:t>
             </a:r>
           </a:p>
         </p:txBody>
@@ -10535,7 +10535,7 @@
       </p:sp>
       <p:pic>
         <p:nvPicPr>
-          <p:cNvPr id="4" name="Picture 3" descr="stations193_stations_P.png"/>
+          <p:cNvPr id="4" name="Picture 3" descr="stations193_oap_stations_P.png"/>
           <p:cNvPicPr>
             <a:picLocks noChangeAspect="1"/>
           </p:cNvPicPr>
@@ -10549,8 +10549,8 @@
         </p:blipFill>
         <p:spPr>
           <a:xfrm>
-            <a:off x="2162193" y="1298448"/>
-            <a:ext cx="7867309" cy="2183892"/>
+            <a:off x="2198506" y="1298448"/>
+            <a:ext cx="7794681" cy="2183892"/>
           </a:xfrm>
           <a:prstGeom prst="rect">
             <a:avLst/>
@@ -10687,7 +10687,7 @@
                 </a:solidFill>
                 <a:latin typeface="Arial"/>
               </a:rPr>
-              <a:t>The 0.18 nm is the raw map's error with the flat's calibration; through the matrix on the surface the pinhole reads 0.9935 / 4 pm, the same as the vector dimple.</a:t>
+              <a:t>The 0.73 nm (gain 0.981) is the raw map's error with the flat's calibration, run stations193_oap on the mirror rig; through the matrix on the surface the pinhole reads 0.9935 / 4 pm, the same as the vector dimple.</a:t>
             </a:r>
           </a:p>
         </p:txBody>
@@ -10825,8 +10825,8 @@
         </p:blipFill>
         <p:spPr>
           <a:xfrm>
-            <a:off x="4800600" y="1060704"/>
-            <a:ext cx="7287768" cy="1453896"/>
+            <a:off x="5212080" y="1060704"/>
+            <a:ext cx="6629400" cy="1225296"/>
           </a:xfrm>
           <a:prstGeom prst="rect">
             <a:avLst/>
@@ -10841,8 +10841,8 @@
         </p:nvSpPr>
         <p:spPr>
           <a:xfrm>
-            <a:off x="228600" y="1371600"/>
-            <a:ext cx="3886200" cy="724408"/>
+            <a:off x="228600" y="1170432"/>
+            <a:ext cx="3931920" cy="724408"/>
           </a:xfrm>
           <a:prstGeom prst="rect">
             <a:avLst/>
@@ -10867,7 +10867,7 @@
                 </a:solidFill>
                 <a:latin typeface="Arial"/>
               </a:rPr>
-              <a:t>Interferometer (hybrid, mirror rig): the command; the test and reference arms at the camera; two of the four phase-stepped frames; the recovered surface; the raw map minus the engine's field, 463 pm (1.5 %).</a:t>
+              <a:t>Interferometer (hybrid): the command; the test and reference arms at the camera; two of the four phase-stepped frames; the recovered surface, 25.8 nm rms; the raw map minus the engine's field, 463 pm, gain 0.987.</a:t>
             </a:r>
           </a:p>
         </p:txBody>
@@ -10882,15 +10882,14 @@
         </p:nvPicPr>
         <p:blipFill>
           <a:blip r:embed="rId3"/>
-          <a:srcRect r="2040" t="10160" b="12700"/>
           <a:stretch>
             <a:fillRect/>
           </a:stretch>
         </p:blipFill>
         <p:spPr>
           <a:xfrm>
-            <a:off x="4233672" y="2487168"/>
-            <a:ext cx="7790688" cy="1005840"/>
+            <a:off x="5212080" y="2340864"/>
+            <a:ext cx="6629400" cy="1161288"/>
           </a:xfrm>
           <a:prstGeom prst="rect">
             <a:avLst/>
@@ -10905,8 +10904,8 @@
         </p:nvSpPr>
         <p:spPr>
           <a:xfrm>
-            <a:off x="228600" y="2578608"/>
-            <a:ext cx="3886200" cy="1054608"/>
+            <a:off x="228600" y="2450592"/>
+            <a:ext cx="3931920" cy="889508"/>
           </a:xfrm>
           <a:prstGeom prst="rect">
             <a:avLst/>
@@ -10931,7 +10930,7 @@
                 </a:solidFill>
                 <a:latin typeface="Arial"/>
               </a:rPr>
-              <a:t>Stepped Zernike: the focal spot with the dimple's footprint; the dimple's phase; the reference wave the dimple makes from the beam; the clear frame and the first depth frame; the recovered surface; raw map minus the engine, 4.8 nm (the beam-made reference, which the matrix measured on the surface absorbs).</a:t>
+              <a:t>Stepped Zernike: the focal spot with the dimple's footprint; the dimple's phase; the reference wave the dimple makes from the beam; the clear frame and the first depth frame; the recovered surface, 24.6 nm rms; raw map minus the engine 7.1 nm, gain 0.78.</a:t>
             </a:r>
           </a:p>
         </p:txBody>
@@ -10946,15 +10945,14 @@
         </p:nvPicPr>
         <p:blipFill>
           <a:blip r:embed="rId4"/>
-          <a:srcRect r="2130" t="10080" b="10710"/>
           <a:stretch>
             <a:fillRect/>
           </a:stretch>
         </p:blipFill>
         <p:spPr>
           <a:xfrm>
-            <a:off x="4215384" y="3566160"/>
-            <a:ext cx="7781544" cy="1033271"/>
+            <a:off x="5212080" y="3557016"/>
+            <a:ext cx="6629400" cy="1143000"/>
           </a:xfrm>
           <a:prstGeom prst="rect">
             <a:avLst/>
@@ -10969,8 +10967,8 @@
         </p:nvSpPr>
         <p:spPr>
           <a:xfrm>
-            <a:off x="182880" y="3794760"/>
-            <a:ext cx="3931920" cy="559307"/>
+            <a:off x="182880" y="3666744"/>
+            <a:ext cx="3977639" cy="724408"/>
           </a:xfrm>
           <a:prstGeom prst="rect">
             <a:avLst/>
@@ -10995,7 +10993,7 @@
                 </a:solidFill>
                 <a:latin typeface="Arial"/>
               </a:rPr>
-              <a:t>Vector Zernike: the metasurface (+90° on one circular state, −90° on the other); camera A and camera B, both frames at once; the pixel-by-pixel solve; raw map minus the engine, 25 pm.</a:t>
+              <a:t>Vector Zernike: the metasurface (+90° on one circular state, −90° on the other); camera A and camera B, both frames at once; the pixel-by-pixel solve, 31.1 nm rms; raw map minus the engine 863 pm, gain 0.993 (200 pm of it on the flat: the arm term).</a:t>
             </a:r>
           </a:p>
         </p:txBody>
@@ -11010,15 +11008,14 @@
         </p:nvPicPr>
         <p:blipFill>
           <a:blip r:embed="rId5"/>
-          <a:srcRect r="1580" t="10550" b="11620"/>
           <a:stretch>
             <a:fillRect/>
           </a:stretch>
         </p:blipFill>
         <p:spPr>
           <a:xfrm>
-            <a:off x="4215384" y="4709160"/>
-            <a:ext cx="7827264" cy="1014984"/>
+            <a:off x="5212080" y="4754880"/>
+            <a:ext cx="6629400" cy="1143000"/>
           </a:xfrm>
           <a:prstGeom prst="rect">
             <a:avLst/>
@@ -11033,8 +11030,8 @@
         </p:nvSpPr>
         <p:spPr>
           <a:xfrm>
-            <a:off x="182880" y="4937760"/>
-            <a:ext cx="3931920" cy="724408"/>
+            <a:off x="182880" y="4864608"/>
+            <a:ext cx="3977639" cy="724408"/>
           </a:xfrm>
           <a:prstGeom prst="rect">
             <a:avLst/>
@@ -11059,7 +11056,7 @@
                 </a:solidFill>
                 <a:latin typeface="Arial"/>
               </a:rPr>
-              <a:t>Stepped pinhole: the pinhole plate (clear pinhole, the surround at 0.72); the first step frame and the shutter frame (the pinhole's light alone); the recovered surface; raw map minus the engine, 184 pm.</a:t>
+              <a:t>Stepped pinhole: the pinhole plate (clear pinhole, the surround at 0.72); the first step frame and the shutter frame (the pinhole's light alone); the recovered surface, 30.7 nm rms; raw map minus the engine 730 pm, gain 0.981.</a:t>
             </a:r>
           </a:p>
         </p:txBody>
@@ -11072,7 +11069,7 @@
         </p:nvSpPr>
         <p:spPr>
           <a:xfrm>
-            <a:off x="411480" y="5788152"/>
+            <a:off x="411480" y="5998464"/>
             <a:ext cx="11384280" cy="274320"/>
           </a:xfrm>
           <a:prstGeom prst="rect">
@@ -11092,7 +11089,7 @@
               </a:spcAft>
             </a:pPr>
             <a:r>
-              <a:rPr sz="1100" b="0">
+              <a:rPr sz="1000" b="0">
                 <a:solidFill>
                   <a:srgbClr val="282828"/>
                 </a:solidFill>
@@ -11101,22 +11098,22 @@
               <a:t>•  </a:t>
             </a:r>
             <a:r>
-              <a:rPr sz="1100" b="1">
+              <a:rPr sz="1000" b="1">
                 <a:solidFill>
                   <a:srgbClr val="282828"/>
                 </a:solidFill>
                 <a:latin typeface="Arial"/>
               </a:rPr>
-              <a:t>The stepped Zernike's 4.8 nm is a gain error, not noise:</a:t>
-            </a:r>
-            <a:r>
-              <a:rPr sz="1100" b="0">
+              <a:t>The stepped Zernike's 7.1 nm is a gain error, not noise:</a:t>
+            </a:r>
+            <a:r>
+              <a:rPr sz="1000" b="0">
                 <a:solidFill>
                   <a:srgbClr val="282828"/>
                 </a:solidFill>
                 <a:latin typeface="Arial"/>
               </a:rPr>
-              <a:t> its inversion takes the reference wave's amplitude from the flat, and on the 30 nm surface the focal core that makes it is weaker, so the raw map reads about 16 % low, shaped like the surface; the matrix measured on the surface absorbs it (5 pm calibrated).  The vector pair's two simultaneous frames divide the reference out: 25 pm raw.</a:t>
+              <a:t> its inversion takes the reference wave's amplitude from the flat; on the 30 nm surface the focal core is weaker, so the raw map reads 22 % low (gain 0.78), shaped like the surface, and the matrix measured on the surface absorbs it (5 pm calibrated).  The vector pair's two simultaneous frames need no amplitude from the flat: gain 0.993.</a:t>
             </a:r>
           </a:p>
         </p:txBody>
@@ -11129,8 +11126,8 @@
         </p:nvSpPr>
         <p:spPr>
           <a:xfrm>
-            <a:off x="411480" y="6327648"/>
-            <a:ext cx="11338560" cy="274320"/>
+            <a:off x="411480" y="6455664"/>
+            <a:ext cx="11384280" cy="274320"/>
           </a:xfrm>
           <a:prstGeom prst="rect">
             <a:avLst/>
@@ -11155,7 +11152,7 @@
                 </a:solidFill>
                 <a:latin typeface="Arial"/>
               </a:rPr>
-              <a:t>Row 2 of each gauge's station-by-station figure (the full figures, with the flat mirror as row 1, are in the backup).  Run tags redo96_oapstn (interferometer) and stations193 (the three sensors, 193 pixels per pupil).</a:t>
+              <a:t>Row 2 of each station figure, mirror rig, the same DM command in all four (30 nm rms over the lattice, seed 7); the full figures are in the backup.  The interferometer's camera sees 25.8 nm rms of it, the sensors' 31: the detector legs image the pupil differently (the pupil-image slide), and each matrix is measured through its own train.  Runs redo96_oapstn2, stations193_oap.</a:t>
             </a:r>
           </a:p>
         </p:txBody>
@@ -34238,7 +34235,7 @@
                 </a:solidFill>
                 <a:latin typeface="Arial"/>
               </a:rPr>
-              <a:t> (tg_psi_dm96_oap/runs): lens_deck, lens_deck_se2, lens_deck_se5, loop_lens, loop_lens_cam, loop_lens_intra, loop_lens_se2, descent_lens, oap_deck, loop_oap, descent_oap, oap_bareAl, oap_coat, oap_jones, zoap (the 7° rigs); lens22, lens22g, lens22h, node22t, fold1-4, loss, loss_src, loss_a2, conj, zseat, zseat2, oap22d, oapdraw3, oap22d_tail, tailA, tailB, oapifo2, oapifol2, oapdesc2, oapuw2, lensuw2, thk22, sub22, aoi_lens22, aoi_oap22, gate3_win, gate3_lens, wrapoap, wraplens, stnoap, stnlens, pupilq_lens, pupilq_oap (the 22.5° bench and the redesigned reflective rig); pdi_dm96/runs/psriclear2 (the P/SRI bench through the clearance tool).  Reports REPORT_gauge_ifo.md (CCMac) with REPORT_oap.md, REPORT_bench_realism.md and REPORT_reflective.md (TO), and README.md.</a:t>
+              <a:t> (tg_psi_dm96_oap/runs): lens_deck, lens_deck_se2, lens_deck_se5, loop_lens, loop_lens_cam, loop_lens_intra, loop_lens_se2, descent_lens, oap_deck, loop_oap, descent_oap, oap_bareAl, oap_coat, oap_jones, zoap (the 7° rigs); lens22, lens22g, lens22h, node22t, fold1-4, loss, loss_src, loss_a2, conj, zseat, zseat2, oap22d, oapdraw3, oap22d_tail, tailA, tailB, oapifo2, oapifol2, oapdesc2, oapuw2, lensuw2, thk22, sub22, aoi_lens22, aoi_oap22, gate3_win, gate3_lens, wrapoap, wraplens, stnoap, stnlens, pupilq_lens, pupilq_oap (the 22.5° bench and the redesigned reflective rig); pdi_dm96/runs/psriclear2 (the P/SRI bench through the clearance tool).  Reports REPORT_gauge_ifo.md (CCMac) with REPORT_oap.md, REPORT_bench_realism.md and REPORT_reflective.md (TO), and README.md, redo96_oapstn2.</a:t>
             </a:r>
           </a:p>
           <a:p>
@@ -34272,7 +34269,7 @@
                 </a:solidFill>
                 <a:latin typeface="Arial"/>
               </a:rPr>
-              <a:t> (zwfs_dm96/runs): matbase, matbase385, m2048, m2048_lat, cap385, cap385_b60-b160, noise193_b30-b160, rec193full, loop193, loop385, v193base, v193noise, vloop193, fold_diag, v2g, v2loop, v3arm, v3s, v3loop, an193_ref/cube/q300/q100/az1/bound/clear, stations193, gate22_193, sub22, thk22 (the 22.5° bench with substrates and thicknesses), oapsens22, oapsens22n, vqw22, vmap22, oaploop22, oapnoise22 (the sensors on the redesigned mirror rig).  README.md (CCL) and deck_zwfs.md.</a:t>
+              <a:t> (zwfs_dm96/runs): matbase, matbase385, m2048, m2048_lat, cap385, cap385_b60-b160, noise193_b30-b160, rec193full, loop193, loop385, v193base, v193noise, vloop193, fold_diag, v2g, v2loop, v3arm, v3s, v3loop, an193_ref/cube/q300/q100/az1/bound/clear, stations193, gate22_193, sub22, thk22 (the 22.5° bench with substrates and thicknesses), oapsens22, oapsens22n, vqw22, vmap22, oaploop22, oapnoise22 (the sensors on the redesigned mirror rig).  README.md (CCL) and deck_zwfs.md, stations193_oap.</a:t>
             </a:r>
           </a:p>
           <a:p>

</xml_diff>

<commit_message>
deck_gauges (+ short) slide 2: the accuracy rows carry the reading's gain first (10 nm change through the matrix 1.004 / 0.986, floors 1.4 / 2.3 pm), the raw 30 nm map against the engine (1.5 %, 463 pm, mirror rig; lens rig not scored, phase fold), and the pupil-imaging term (0.13 / 0.29 %) as its smaller part; stale footnote numbers (1.001 / 0.993) replaced by the redo bench's; edit copies synced (Dave: the raw-map numbers were 5-10x the slide-2 accuracy)
Co-Authored-By: Claude Fable 5.1 <noreply@anthropic.com>
</commit_message>
<xml_diff>
--- a/demo_session/deck_gauges.pptx
+++ b/demo_session/deck_gauges.pptx
@@ -14506,7 +14506,7 @@
         </p:nvGraphicFramePr>
         <p:xfrm>
           <a:off x="411480" y="1298448"/>
-          <a:ext cx="11368734" cy="1960245"/>
+          <a:ext cx="11368733" cy="2806065"/>
         </p:xfrm>
         <a:graphic>
           <a:graphicData uri="http://schemas.openxmlformats.org/drawingml/2006/table">
@@ -14515,12 +14515,12 @@
                 <a:tableStyleId>{5C22544A-7EE6-4342-B048-85BDC9FD1C3A}</a:tableStyleId>
               </a:tblPr>
               <a:tblGrid>
-                <a:gridCol w="2884116"/>
-                <a:gridCol w="6157978"/>
-                <a:gridCol w="1163320"/>
-                <a:gridCol w="1163320"/>
+                <a:gridCol w="1951109"/>
+                <a:gridCol w="5642398"/>
+                <a:gridCol w="1740178"/>
+                <a:gridCol w="2035048"/>
               </a:tblGrid>
-              <a:tr h="280035">
+              <a:tr h="468630">
                 <a:tc>
                   <a:txBody>
                     <a:bodyPr wrap="square"/>
@@ -14606,6 +14606,176 @@
                   <a:tcPr marL="54864" marR="54864" marT="18288" marB="18288">
                     <a:solidFill>
                       <a:srgbClr val="1F4E79"/>
+                    </a:solidFill>
+                  </a:tcPr>
+                </a:tc>
+              </a:tr>
+              <a:tr h="468630">
+                <a:tc>
+                  <a:txBody>
+                    <a:bodyPr wrap="square"/>
+                    <a:lstStyle/>
+                    <a:p>
+                      <a:r>
+                        <a:rPr sz="1100" b="0">
+                          <a:solidFill>
+                            <a:srgbClr val="282828"/>
+                          </a:solidFill>
+                          <a:latin typeface="Arial"/>
+                        </a:rPr>
+                        <a:t>accuracy</a:t>
+                      </a:r>
+                    </a:p>
+                  </a:txBody>
+                  <a:tcPr marL="54864" marR="54864" marT="18288" marB="18288">
+                    <a:solidFill>
+                      <a:srgbClr val="FFFFFF"/>
+                    </a:solidFill>
+                  </a:tcPr>
+                </a:tc>
+                <a:tc>
+                  <a:txBody>
+                    <a:bodyPr wrap="square"/>
+                    <a:lstStyle/>
+                    <a:p>
+                      <a:r>
+                        <a:rPr sz="1100" b="0">
+                          <a:solidFill>
+                            <a:srgbClr val="282828"/>
+                          </a:solidFill>
+                          <a:latin typeface="Arial"/>
+                        </a:rPr>
+                        <a:t>a 10 nm change on one actuator, read through the matrix measured on the 30 nm surface: gain (error) / floor</a:t>
+                      </a:r>
+                    </a:p>
+                  </a:txBody>
+                  <a:tcPr marL="54864" marR="54864" marT="18288" marB="18288">
+                    <a:solidFill>
+                      <a:srgbClr val="FFFFFF"/>
+                    </a:solidFill>
+                  </a:tcPr>
+                </a:tc>
+                <a:tc>
+                  <a:txBody>
+                    <a:bodyPr wrap="square"/>
+                    <a:lstStyle/>
+                    <a:p>
+                      <a:r>
+                        <a:rPr sz="1100" b="0">
+                          <a:solidFill>
+                            <a:srgbClr val="282828"/>
+                          </a:solidFill>
+                          <a:latin typeface="Arial"/>
+                        </a:rPr>
+                        <a:t>1.004 (0.4 %) / 1.4 pm</a:t>
+                      </a:r>
+                    </a:p>
+                  </a:txBody>
+                  <a:tcPr marL="54864" marR="54864" marT="18288" marB="18288">
+                    <a:solidFill>
+                      <a:srgbClr val="FFFFFF"/>
+                    </a:solidFill>
+                  </a:tcPr>
+                </a:tc>
+                <a:tc>
+                  <a:txBody>
+                    <a:bodyPr wrap="square"/>
+                    <a:lstStyle/>
+                    <a:p>
+                      <a:r>
+                        <a:rPr sz="1100" b="0">
+                          <a:solidFill>
+                            <a:srgbClr val="282828"/>
+                          </a:solidFill>
+                          <a:latin typeface="Arial"/>
+                        </a:rPr>
+                        <a:t>0.986 (1.4 %) / 2.3 pm</a:t>
+                      </a:r>
+                    </a:p>
+                  </a:txBody>
+                  <a:tcPr marL="54864" marR="54864" marT="18288" marB="18288">
+                    <a:solidFill>
+                      <a:srgbClr val="FFFFFF"/>
+                    </a:solidFill>
+                  </a:tcPr>
+                </a:tc>
+              </a:tr>
+              <a:tr h="468630">
+                <a:tc>
+                  <a:txBody>
+                    <a:bodyPr wrap="square"/>
+                    <a:lstStyle/>
+                    <a:p/>
+                  </a:txBody>
+                  <a:tcPr marL="54864" marR="54864" marT="18288" marB="18288">
+                    <a:solidFill>
+                      <a:srgbClr val="ECF1F6"/>
+                    </a:solidFill>
+                  </a:tcPr>
+                </a:tc>
+                <a:tc>
+                  <a:txBody>
+                    <a:bodyPr wrap="square"/>
+                    <a:lstStyle/>
+                    <a:p>
+                      <a:r>
+                        <a:rPr sz="1100" b="0">
+                          <a:solidFill>
+                            <a:srgbClr val="282828"/>
+                          </a:solidFill>
+                          <a:latin typeface="Arial"/>
+                        </a:rPr>
+                        <a:t>the raw map of the 30 nm surface against the engine's field at the camera, before any calibration</a:t>
+                      </a:r>
+                    </a:p>
+                  </a:txBody>
+                  <a:tcPr marL="54864" marR="54864" marT="18288" marB="18288">
+                    <a:solidFill>
+                      <a:srgbClr val="ECF1F6"/>
+                    </a:solidFill>
+                  </a:tcPr>
+                </a:tc>
+                <a:tc>
+                  <a:txBody>
+                    <a:bodyPr wrap="square"/>
+                    <a:lstStyle/>
+                    <a:p>
+                      <a:r>
+                        <a:rPr sz="1100" b="0">
+                          <a:solidFill>
+                            <a:srgbClr val="282828"/>
+                          </a:solidFill>
+                          <a:latin typeface="Arial"/>
+                        </a:rPr>
+                        <a:t>not scored (a phase fold; backup)</a:t>
+                      </a:r>
+                    </a:p>
+                  </a:txBody>
+                  <a:tcPr marL="54864" marR="54864" marT="18288" marB="18288">
+                    <a:solidFill>
+                      <a:srgbClr val="ECF1F6"/>
+                    </a:solidFill>
+                  </a:tcPr>
+                </a:tc>
+                <a:tc>
+                  <a:txBody>
+                    <a:bodyPr wrap="square"/>
+                    <a:lstStyle/>
+                    <a:p>
+                      <a:r>
+                        <a:rPr sz="1100" b="0">
+                          <a:solidFill>
+                            <a:srgbClr val="282828"/>
+                          </a:solidFill>
+                          <a:latin typeface="Arial"/>
+                        </a:rPr>
+                        <a:t>1.5 % (463 pm), gain 0.987</a:t>
+                      </a:r>
+                    </a:p>
+                  </a:txBody>
+                  <a:tcPr marL="54864" marR="54864" marT="18288" marB="18288">
+                    <a:solidFill>
+                      <a:srgbClr val="ECF1F6"/>
                     </a:solidFill>
                   </a:tcPr>
                 </a:tc>
@@ -14615,81 +14785,71 @@
                   <a:txBody>
                     <a:bodyPr wrap="square"/>
                     <a:lstStyle/>
-                    <a:p>
-                      <a:r>
-                        <a:rPr sz="1100" b="0">
-                          <a:solidFill>
-                            <a:srgbClr val="282828"/>
-                          </a:solidFill>
-                          <a:latin typeface="Arial"/>
-                        </a:rPr>
-                        <a:t>accuracy</a:t>
-                      </a:r>
-                    </a:p>
-                  </a:txBody>
-                  <a:tcPr marL="54864" marR="54864" marT="18288" marB="18288">
-                    <a:solidFill>
-                      <a:srgbClr val="FFFFFF"/>
-                    </a:solidFill>
-                  </a:tcPr>
-                </a:tc>
-                <a:tc>
-                  <a:txBody>
-                    <a:bodyPr wrap="square"/>
-                    <a:lstStyle/>
-                    <a:p>
-                      <a:r>
-                        <a:rPr sz="1100" b="0">
-                          <a:solidFill>
-                            <a:srgbClr val="282828"/>
-                          </a:solidFill>
-                          <a:latin typeface="Arial"/>
-                        </a:rPr>
-                        <a:t>the imaging's error in reading a 30 nm working surface, piston and tilt removed</a:t>
-                      </a:r>
-                    </a:p>
-                  </a:txBody>
-                  <a:tcPr marL="54864" marR="54864" marT="18288" marB="18288">
-                    <a:solidFill>
-                      <a:srgbClr val="FFFFFF"/>
-                    </a:solidFill>
-                  </a:tcPr>
-                </a:tc>
-                <a:tc>
-                  <a:txBody>
-                    <a:bodyPr wrap="square"/>
-                    <a:lstStyle/>
-                    <a:p>
-                      <a:r>
-                        <a:rPr sz="1100" b="0">
-                          <a:solidFill>
-                            <a:srgbClr val="282828"/>
-                          </a:solidFill>
-                          <a:latin typeface="Arial"/>
-                        </a:rPr>
-                        <a:t>0.13 % (42 pm)</a:t>
-                      </a:r>
-                    </a:p>
-                  </a:txBody>
-                  <a:tcPr marL="54864" marR="54864" marT="18288" marB="18288">
-                    <a:solidFill>
-                      <a:srgbClr val="FFFFFF"/>
-                    </a:solidFill>
-                  </a:tcPr>
-                </a:tc>
-                <a:tc>
-                  <a:txBody>
-                    <a:bodyPr wrap="square"/>
-                    <a:lstStyle/>
-                    <a:p>
-                      <a:r>
-                        <a:rPr sz="1100" b="0">
-                          <a:solidFill>
-                            <a:srgbClr val="282828"/>
-                          </a:solidFill>
-                          <a:latin typeface="Arial"/>
-                        </a:rPr>
-                        <a:t>0.29 % (92 pm)</a:t>
+                    <a:p/>
+                  </a:txBody>
+                  <a:tcPr marL="54864" marR="54864" marT="18288" marB="18288">
+                    <a:solidFill>
+                      <a:srgbClr val="FFFFFF"/>
+                    </a:solidFill>
+                  </a:tcPr>
+                </a:tc>
+                <a:tc>
+                  <a:txBody>
+                    <a:bodyPr wrap="square"/>
+                    <a:lstStyle/>
+                    <a:p>
+                      <a:r>
+                        <a:rPr sz="1100" b="0">
+                          <a:solidFill>
+                            <a:srgbClr val="282828"/>
+                          </a:solidFill>
+                          <a:latin typeface="Arial"/>
+                        </a:rPr>
+                        <a:t>of which the pupil imaging, piston and tilt removed; in the top spatial band</a:t>
+                      </a:r>
+                    </a:p>
+                  </a:txBody>
+                  <a:tcPr marL="54864" marR="54864" marT="18288" marB="18288">
+                    <a:solidFill>
+                      <a:srgbClr val="FFFFFF"/>
+                    </a:solidFill>
+                  </a:tcPr>
+                </a:tc>
+                <a:tc>
+                  <a:txBody>
+                    <a:bodyPr wrap="square"/>
+                    <a:lstStyle/>
+                    <a:p>
+                      <a:r>
+                        <a:rPr sz="1100" b="0">
+                          <a:solidFill>
+                            <a:srgbClr val="282828"/>
+                          </a:solidFill>
+                          <a:latin typeface="Arial"/>
+                        </a:rPr>
+                        <a:t>0.13 % (42 pm); 0.5 %</a:t>
+                      </a:r>
+                    </a:p>
+                  </a:txBody>
+                  <a:tcPr marL="54864" marR="54864" marT="18288" marB="18288">
+                    <a:solidFill>
+                      <a:srgbClr val="FFFFFF"/>
+                    </a:solidFill>
+                  </a:tcPr>
+                </a:tc>
+                <a:tc>
+                  <a:txBody>
+                    <a:bodyPr wrap="square"/>
+                    <a:lstStyle/>
+                    <a:p>
+                      <a:r>
+                        <a:rPr sz="1100" b="0">
+                          <a:solidFill>
+                            <a:srgbClr val="282828"/>
+                          </a:solidFill>
+                          <a:latin typeface="Arial"/>
+                        </a:rPr>
+                        <a:t>0.29 % (92 pm); 0.9 %</a:t>
                       </a:r>
                     </a:p>
                   </a:txBody>
@@ -14705,7 +14865,17 @@
                   <a:txBody>
                     <a:bodyPr wrap="square"/>
                     <a:lstStyle/>
-                    <a:p/>
+                    <a:p>
+                      <a:r>
+                        <a:rPr sz="1100" b="0">
+                          <a:solidFill>
+                            <a:srgbClr val="282828"/>
+                          </a:solidFill>
+                          <a:latin typeface="Arial"/>
+                        </a:rPr>
+                        <a:t>precision</a:t>
+                      </a:r>
+                    </a:p>
                   </a:txBody>
                   <a:tcPr marL="54864" marR="54864" marT="18288" marB="18288">
                     <a:solidFill>
@@ -14725,7 +14895,7 @@
                           </a:solidFill>
                           <a:latin typeface="Arial"/>
                         </a:rPr>
-                        <a:t>the same, in the top spatial band (at the actuator Nyquist)</a:t>
+                        <a:t>one measurement, photon-limited, at 1e14 / 1e15 photons</a:t>
                       </a:r>
                     </a:p>
                   </a:txBody>
@@ -14747,7 +14917,7 @@
                           </a:solidFill>
                           <a:latin typeface="Arial"/>
                         </a:rPr>
-                        <a:t>0.5 %</a:t>
+                        <a:t>2.3 / 0.7 pm</a:t>
                       </a:r>
                     </a:p>
                   </a:txBody>
@@ -14769,7 +14939,7 @@
                           </a:solidFill>
                           <a:latin typeface="Arial"/>
                         </a:rPr>
-                        <a:t>0.9 %</a:t>
+                        <a:t>2.1 / 0.7 pm</a:t>
                       </a:r>
                     </a:p>
                   </a:txBody>
@@ -14793,73 +14963,73 @@
                           </a:solidFill>
                           <a:latin typeface="Arial"/>
                         </a:rPr>
-                        <a:t>precision</a:t>
-                      </a:r>
-                    </a:p>
-                  </a:txBody>
-                  <a:tcPr marL="54864" marR="54864" marT="18288" marB="18288">
-                    <a:solidFill>
-                      <a:srgbClr val="FFFFFF"/>
-                    </a:solidFill>
-                  </a:tcPr>
-                </a:tc>
-                <a:tc>
-                  <a:txBody>
-                    <a:bodyPr wrap="square"/>
-                    <a:lstStyle/>
-                    <a:p>
-                      <a:r>
-                        <a:rPr sz="1100" b="0">
-                          <a:solidFill>
-                            <a:srgbClr val="282828"/>
-                          </a:solidFill>
-                          <a:latin typeface="Arial"/>
-                        </a:rPr>
-                        <a:t>one measurement, photon-limited, at 1e14 / 1e15 photons</a:t>
-                      </a:r>
-                    </a:p>
-                  </a:txBody>
-                  <a:tcPr marL="54864" marR="54864" marT="18288" marB="18288">
-                    <a:solidFill>
-                      <a:srgbClr val="FFFFFF"/>
-                    </a:solidFill>
-                  </a:tcPr>
-                </a:tc>
-                <a:tc>
-                  <a:txBody>
-                    <a:bodyPr wrap="square"/>
-                    <a:lstStyle/>
-                    <a:p>
-                      <a:r>
-                        <a:rPr sz="1100" b="0">
-                          <a:solidFill>
-                            <a:srgbClr val="282828"/>
-                          </a:solidFill>
-                          <a:latin typeface="Arial"/>
-                        </a:rPr>
-                        <a:t>2.3 / 0.7 pm</a:t>
-                      </a:r>
-                    </a:p>
-                  </a:txBody>
-                  <a:tcPr marL="54864" marR="54864" marT="18288" marB="18288">
-                    <a:solidFill>
-                      <a:srgbClr val="FFFFFF"/>
-                    </a:solidFill>
-                  </a:tcPr>
-                </a:tc>
-                <a:tc>
-                  <a:txBody>
-                    <a:bodyPr wrap="square"/>
-                    <a:lstStyle/>
-                    <a:p>
-                      <a:r>
-                        <a:rPr sz="1100" b="0">
-                          <a:solidFill>
-                            <a:srgbClr val="282828"/>
-                          </a:solidFill>
-                          <a:latin typeface="Arial"/>
-                        </a:rPr>
-                        <a:t>2.1 / 0.7 pm</a:t>
+                        <a:t>repeatability</a:t>
+                      </a:r>
+                    </a:p>
+                  </a:txBody>
+                  <a:tcPr marL="54864" marR="54864" marT="18288" marB="18288">
+                    <a:solidFill>
+                      <a:srgbClr val="FFFFFF"/>
+                    </a:solidFill>
+                  </a:tcPr>
+                </a:tc>
+                <a:tc>
+                  <a:txBody>
+                    <a:bodyPr wrap="square"/>
+                    <a:lstStyle/>
+                    <a:p>
+                      <a:r>
+                        <a:rPr sz="1100" b="0">
+                          <a:solidFill>
+                            <a:srgbClr val="282828"/>
+                          </a:solidFill>
+                          <a:latin typeface="Arial"/>
+                        </a:rPr>
+                        <a:t>the same surface held in a servo, rms over 30 cycles, same photons</a:t>
+                      </a:r>
+                    </a:p>
+                  </a:txBody>
+                  <a:tcPr marL="54864" marR="54864" marT="18288" marB="18288">
+                    <a:solidFill>
+                      <a:srgbClr val="FFFFFF"/>
+                    </a:solidFill>
+                  </a:tcPr>
+                </a:tc>
+                <a:tc>
+                  <a:txBody>
+                    <a:bodyPr wrap="square"/>
+                    <a:lstStyle/>
+                    <a:p>
+                      <a:r>
+                        <a:rPr sz="1100" b="0">
+                          <a:solidFill>
+                            <a:srgbClr val="282828"/>
+                          </a:solidFill>
+                          <a:latin typeface="Arial"/>
+                        </a:rPr>
+                        <a:t>1.4 / 0.5 pm</a:t>
+                      </a:r>
+                    </a:p>
+                  </a:txBody>
+                  <a:tcPr marL="54864" marR="54864" marT="18288" marB="18288">
+                    <a:solidFill>
+                      <a:srgbClr val="FFFFFF"/>
+                    </a:solidFill>
+                  </a:tcPr>
+                </a:tc>
+                <a:tc>
+                  <a:txBody>
+                    <a:bodyPr wrap="square"/>
+                    <a:lstStyle/>
+                    <a:p>
+                      <a:r>
+                        <a:rPr sz="1100" b="0">
+                          <a:solidFill>
+                            <a:srgbClr val="282828"/>
+                          </a:solidFill>
+                          <a:latin typeface="Arial"/>
+                        </a:rPr>
+                        <a:t>1.3 / 0.4 pm</a:t>
                       </a:r>
                     </a:p>
                   </a:txBody>
@@ -14883,7 +15053,7 @@
                           </a:solidFill>
                           <a:latin typeface="Arial"/>
                         </a:rPr>
-                        <a:t>repeatability</a:t>
+                        <a:t>hold</a:t>
                       </a:r>
                     </a:p>
                   </a:txBody>
@@ -14905,7 +15075,7 @@
                           </a:solidFill>
                           <a:latin typeface="Arial"/>
                         </a:rPr>
-                        <a:t>the same surface held in a servo, rms over 30 cycles, same photons</a:t>
+                        <a:t>photons per cycle to keep the surface inside 3 pm</a:t>
                       </a:r>
                     </a:p>
                   </a:txBody>
@@ -14927,7 +15097,7 @@
                           </a:solidFill>
                           <a:latin typeface="Arial"/>
                         </a:rPr>
-                        <a:t>1.4 / 0.5 pm</a:t>
+                        <a:t>2.3e13</a:t>
                       </a:r>
                     </a:p>
                   </a:txBody>
@@ -14949,7 +15119,7 @@
                           </a:solidFill>
                           <a:latin typeface="Arial"/>
                         </a:rPr>
-                        <a:t>1.3 / 0.4 pm</a:t>
+                        <a:t>2.0e13</a:t>
                       </a:r>
                     </a:p>
                   </a:txBody>
@@ -14965,101 +15135,11 @@
                   <a:txBody>
                     <a:bodyPr wrap="square"/>
                     <a:lstStyle/>
-                    <a:p>
-                      <a:r>
-                        <a:rPr sz="1100" b="0">
-                          <a:solidFill>
-                            <a:srgbClr val="282828"/>
-                          </a:solidFill>
-                          <a:latin typeface="Arial"/>
-                        </a:rPr>
-                        <a:t>hold</a:t>
-                      </a:r>
-                    </a:p>
-                  </a:txBody>
-                  <a:tcPr marL="54864" marR="54864" marT="18288" marB="18288">
-                    <a:solidFill>
-                      <a:srgbClr val="FFFFFF"/>
-                    </a:solidFill>
-                  </a:tcPr>
-                </a:tc>
-                <a:tc>
-                  <a:txBody>
-                    <a:bodyPr wrap="square"/>
-                    <a:lstStyle/>
-                    <a:p>
-                      <a:r>
-                        <a:rPr sz="1100" b="0">
-                          <a:solidFill>
-                            <a:srgbClr val="282828"/>
-                          </a:solidFill>
-                          <a:latin typeface="Arial"/>
-                        </a:rPr>
-                        <a:t>photons per cycle to keep the surface inside 3 pm</a:t>
-                      </a:r>
-                    </a:p>
-                  </a:txBody>
-                  <a:tcPr marL="54864" marR="54864" marT="18288" marB="18288">
-                    <a:solidFill>
-                      <a:srgbClr val="FFFFFF"/>
-                    </a:solidFill>
-                  </a:tcPr>
-                </a:tc>
-                <a:tc>
-                  <a:txBody>
-                    <a:bodyPr wrap="square"/>
-                    <a:lstStyle/>
-                    <a:p>
-                      <a:r>
-                        <a:rPr sz="1100" b="0">
-                          <a:solidFill>
-                            <a:srgbClr val="282828"/>
-                          </a:solidFill>
-                          <a:latin typeface="Arial"/>
-                        </a:rPr>
-                        <a:t>2.3e13</a:t>
-                      </a:r>
-                    </a:p>
-                  </a:txBody>
-                  <a:tcPr marL="54864" marR="54864" marT="18288" marB="18288">
-                    <a:solidFill>
-                      <a:srgbClr val="FFFFFF"/>
-                    </a:solidFill>
-                  </a:tcPr>
-                </a:tc>
-                <a:tc>
-                  <a:txBody>
-                    <a:bodyPr wrap="square"/>
-                    <a:lstStyle/>
-                    <a:p>
-                      <a:r>
-                        <a:rPr sz="1100" b="0">
-                          <a:solidFill>
-                            <a:srgbClr val="282828"/>
-                          </a:solidFill>
-                          <a:latin typeface="Arial"/>
-                        </a:rPr>
-                        <a:t>2.0e13</a:t>
-                      </a:r>
-                    </a:p>
-                  </a:txBody>
-                  <a:tcPr marL="54864" marR="54864" marT="18288" marB="18288">
-                    <a:solidFill>
-                      <a:srgbClr val="FFFFFF"/>
-                    </a:solidFill>
-                  </a:tcPr>
-                </a:tc>
-              </a:tr>
-              <a:tr h="280035">
-                <a:tc>
-                  <a:txBody>
-                    <a:bodyPr wrap="square"/>
-                    <a:lstStyle/>
                     <a:p/>
                   </a:txBody>
                   <a:tcPr marL="54864" marR="54864" marT="18288" marB="18288">
                     <a:solidFill>
-                      <a:srgbClr val="ECF1F6"/>
+                      <a:srgbClr val="FFFFFF"/>
                     </a:solidFill>
                   </a:tcPr>
                 </a:tc>
@@ -15081,7 +15161,7 @@
                   </a:txBody>
                   <a:tcPr marL="54864" marR="54864" marT="18288" marB="18288">
                     <a:solidFill>
-                      <a:srgbClr val="ECF1F6"/>
+                      <a:srgbClr val="FFFFFF"/>
                     </a:solidFill>
                   </a:tcPr>
                 </a:tc>
@@ -15103,7 +15183,7 @@
                   </a:txBody>
                   <a:tcPr marL="54864" marR="54864" marT="18288" marB="18288">
                     <a:solidFill>
-                      <a:srgbClr val="ECF1F6"/>
+                      <a:srgbClr val="FFFFFF"/>
                     </a:solidFill>
                   </a:tcPr>
                 </a:tc>
@@ -15125,7 +15205,7 @@
                   </a:txBody>
                   <a:tcPr marL="54864" marR="54864" marT="18288" marB="18288">
                     <a:solidFill>
-                      <a:srgbClr val="ECF1F6"/>
+                      <a:srgbClr val="FFFFFF"/>
                     </a:solidFill>
                   </a:tcPr>
                 </a:tc>
@@ -15142,7 +15222,7 @@
         </p:nvSpPr>
         <p:spPr>
           <a:xfrm>
-            <a:off x="411480" y="3404997"/>
+            <a:off x="411480" y="4250817"/>
             <a:ext cx="11368735" cy="274320"/>
           </a:xfrm>
           <a:prstGeom prst="rect">
@@ -15162,7 +15242,7 @@
               </a:spcAft>
             </a:pPr>
             <a:r>
-              <a:rPr sz="1500" b="0">
+              <a:rPr sz="1200" b="0">
                 <a:solidFill>
                   <a:srgbClr val="282828"/>
                 </a:solidFill>
@@ -15171,7 +15251,7 @@
               <a:t>•  </a:t>
             </a:r>
             <a:r>
-              <a:rPr sz="1500" b="1">
+              <a:rPr sz="1200" b="1">
                 <a:solidFill>
                   <a:srgbClr val="282828"/>
                 </a:solidFill>
@@ -15180,7 +15260,7 @@
               <a:t>Picometer measurement is photon-limited, not bench-limited.</a:t>
             </a:r>
             <a:r>
-              <a:rPr sz="1500" b="0">
+              <a:rPr sz="1200" b="0">
                 <a:solidFill>
                   <a:srgbClr val="282828"/>
                 </a:solidFill>
@@ -15189,7 +15269,7 @@
               <a:t>  One measurement at 1e15 photons — 0.31 mJ, about 1.3 s of a 1 mW laser — repeats to 0.7 pm, and a servo fed at that rate holds under half a picometer.  Both front ends agree to within 10 %.  For scale, </a:t>
             </a:r>
             <a:r>
-              <a:rPr sz="1500" b="1">
+              <a:rPr sz="1200" b="1">
                 <a:solidFill>
                   <a:srgbClr val="282828"/>
                 </a:solidFill>
@@ -15198,7 +15278,7 @@
               <a:t>Steeves et al. (2020, Optica 7, 1267) demonstrate 1.6 pm in 4.3 s on a real interferometer</a:t>
             </a:r>
             <a:r>
-              <a:rPr sz="1500" b="0">
+              <a:rPr sz="1200" b="0">
                 <a:solidFill>
                   <a:srgbClr val="282828"/>
                 </a:solidFill>
@@ -15214,7 +15294,7 @@
               </a:spcAft>
             </a:pPr>
             <a:r>
-              <a:rPr sz="1500" b="0">
+              <a:rPr sz="1200" b="0">
                 <a:solidFill>
                   <a:srgbClr val="282828"/>
                 </a:solidFill>
@@ -15223,22 +15303,22 @@
               <a:t>•  </a:t>
             </a:r>
             <a:r>
-              <a:rPr sz="1500" b="1">
+              <a:rPr sz="1200" b="1">
                 <a:solidFill>
                   <a:srgbClr val="282828"/>
                 </a:solidFill>
                 <a:latin typeface="Arial"/>
               </a:rPr>
-              <a:t>Accuracy is systematic and proportional</a:t>
-            </a:r>
-            <a:r>
-              <a:rPr sz="1500" b="0">
+              <a:t>Accuracy is a gain: systematic and proportional to the figure read.</a:t>
+            </a:r>
+            <a:r>
+              <a:rPr sz="1200" b="0">
                 <a:solidFill>
                   <a:srgbClr val="282828"/>
                 </a:solidFill>
                 <a:latin typeface="Arial"/>
               </a:rPr>
-              <a:t> — a fraction of the figure read, so 30 nm costs tens of picometers and a 200 nm capture figure costs hundreds.  It holds because the response matrix is measured on the surface, not assumed geometric.</a:t>
+              <a:t>  Raw, the four-step reads the 30 nm surface 1.3 % low on the mirror rig (463 pm); through the matrix measured on the surface a 10 nm change reads at gain 1.004 on lenses and 0.986 on mirrors, with floors of 1.4 and 2.3 pm.  The pupil imaging is the smaller part (0.13 % / 0.29 %); the gain is the polarization snapshot's, and the matrix measured on the surface is what carries it.</a:t>
             </a:r>
           </a:p>
           <a:p>
@@ -15248,7 +15328,7 @@
               </a:spcAft>
             </a:pPr>
             <a:r>
-              <a:rPr sz="1500" b="0">
+              <a:rPr sz="1200" b="0">
                 <a:solidFill>
                   <a:srgbClr val="282828"/>
                 </a:solidFill>
@@ -15257,7 +15337,7 @@
               <a:t>•  </a:t>
             </a:r>
             <a:r>
-              <a:rPr sz="1500" b="1">
+              <a:rPr sz="1200" b="1">
                 <a:solidFill>
                   <a:srgbClr val="282828"/>
                 </a:solidFill>
@@ -15266,7 +15346,7 @@
               <a:t>One disturbance is not photon-limited:</a:t>
             </a:r>
             <a:r>
-              <a:rPr sz="1500" b="0">
+              <a:rPr sz="1200" b="0">
                 <a:solidFill>
                   <a:srgbClr val="282828"/>
                 </a:solidFill>
@@ -15285,7 +15365,7 @@
         </p:nvSpPr>
         <p:spPr>
           <a:xfrm>
-            <a:off x="457200" y="5760720"/>
+            <a:off x="457200" y="6199632"/>
             <a:ext cx="11365992" cy="274320"/>
           </a:xfrm>
           <a:prstGeom prst="rect">
@@ -15311,7 +15391,7 @@
                 </a:solidFill>
                 <a:latin typeface="Arial"/>
               </a:rPr>
-              <a:t>The table is the interferometer's, the one gauge scored on both front ends; the three sensors, scored on the mirror rig, read within 1 % and 2 pm of it on the same surface (the side-by-side slide).  A 10 nm single-actuator change, what the servo corrects, reads against truth to 1.5 pm at gain 1.001 on lenses and 1.8 pm at 0.993 on mirrors.  Run tags are on the provenance slide and on each slide that derives a number.</a:t>
+              <a:t>The table is the interferometer's, the one gauge scored on both front ends; the three sensors, scored on the mirror rig, read within 1 % and 2 pm of it on the same surface (the side-by-side slide).  The raw-map row is the station-by-station figure's number (run redo96_oapstn2); the lens rig's raw absolute map folds the phase (51 nm against the engine, backup) and is not scored, while its differential rows read as the mirror rig's.  Run tags are on the provenance slide and on each slide that derives a number.</a:t>
             </a:r>
           </a:p>
         </p:txBody>

</xml_diff>

<commit_message>
deck_gauges (+ short): the lens rig's raw map scored -- 350 pm, gain 0.993, once the four-step's sign is set by a +50 nm push; the '51 nm fold' was the sign (the two rigs' polarization inputs give opposite fringe directions; the matrix carries it, an absolute map does not); slide 2 raw-map row filled, backup footnote rewritten
Co-Authored-By: Claude Fable 5.1 <noreply@anthropic.com>
</commit_message>
<xml_diff>
--- a/demo_session/deck_gauges.pptx
+++ b/demo_session/deck_gauges.pptx
@@ -5287,7 +5287,7 @@
                 </a:solidFill>
                 <a:latin typeface="Arial"/>
               </a:rPr>
-              <a:t>Run tag redo96_oapstn2 (the mirror rig; the DM's full-lattice 30 nm command, seed 7, the same surface in every station figure).  The lens rig's figure exists but its absolute residual reads 51 nm against the engine — a fold of the phase, not an imaging error (its differential rows read the same as the mirror rig's); under investigation, so it is not shown.</a:t>
+              <a:t>Run tag redo96_oapstn2 (the mirror rig; the DM's full-lattice 30 nm command, seed 7, the same surface in every station figure).  The lens rig's figure (redo96_lensstn2) reads 350 pm at gain 0.993 once the four-step's sign is set by a +50 nm push: the two rigs' polarization inputs ('collimated' on lenses, at the source on mirrors) give opposite fringe directions with the analyzer, so the lens rig's raw map came out as the negative of the surface (the 51 nm residual of the 09-17 figure was 2 x the surface, not a fold); every differential row carries the sign in its matrix and never saw it.</a:t>
             </a:r>
           </a:p>
         </p:txBody>
@@ -14506,7 +14506,7 @@
         </p:nvGraphicFramePr>
         <p:xfrm>
           <a:off x="411480" y="1298448"/>
-          <a:ext cx="11368733" cy="2806065"/>
+          <a:ext cx="11368734" cy="2994660"/>
         </p:xfrm>
         <a:graphic>
           <a:graphicData uri="http://schemas.openxmlformats.org/drawingml/2006/table">
@@ -14515,9 +14515,9 @@
                 <a:tableStyleId>{5C22544A-7EE6-4342-B048-85BDC9FD1C3A}</a:tableStyleId>
               </a:tblPr>
               <a:tblGrid>
-                <a:gridCol w="1951109"/>
-                <a:gridCol w="5642398"/>
-                <a:gridCol w="1740178"/>
+                <a:gridCol w="1875344"/>
+                <a:gridCol w="5423294"/>
+                <a:gridCol w="2035048"/>
                 <a:gridCol w="2035048"/>
               </a:tblGrid>
               <a:tr h="468630">
@@ -14747,7 +14747,7 @@
                           </a:solidFill>
                           <a:latin typeface="Arial"/>
                         </a:rPr>
-                        <a:t>not scored (a phase fold; backup)</a:t>
+                        <a:t>1.4 % (350 pm), gain 0.993</a:t>
                       </a:r>
                     </a:p>
                   </a:txBody>
@@ -14780,7 +14780,7 @@
                   </a:tcPr>
                 </a:tc>
               </a:tr>
-              <a:tr h="280035">
+              <a:tr h="468630">
                 <a:tc>
                   <a:txBody>
                     <a:bodyPr wrap="square"/>
@@ -15222,7 +15222,7 @@
         </p:nvSpPr>
         <p:spPr>
           <a:xfrm>
-            <a:off x="411480" y="4250817"/>
+            <a:off x="411480" y="4439412"/>
             <a:ext cx="11368735" cy="274320"/>
           </a:xfrm>
           <a:prstGeom prst="rect">
@@ -15318,7 +15318,7 @@
                 </a:solidFill>
                 <a:latin typeface="Arial"/>
               </a:rPr>
-              <a:t>  Raw, the four-step reads the 30 nm surface 1.3 % low on the mirror rig (463 pm); through the matrix measured on the surface a 10 nm change reads at gain 1.004 on lenses and 0.986 on mirrors, with floors of 1.4 and 2.3 pm.  The pupil imaging is the smaller part (0.13 % / 0.29 %); the gain is the polarization snapshot's, and the matrix measured on the surface is what carries it.</a:t>
+              <a:t>  Raw, the four-step reads the 30 nm surface 0.7 % low on lenses (350 pm) and 1.3 % low on mirrors (463 pm); through the matrix measured on the surface a 10 nm change reads at gain 1.004 on lenses and 0.986 on mirrors, with floors of 1.4 and 2.3 pm.  The pupil imaging is the smaller part (0.13 % / 0.29 %); the gain is the polarization snapshot's, and the matrix measured on the surface is what carries it.</a:t>
             </a:r>
           </a:p>
           <a:p>
@@ -15391,7 +15391,7 @@
                 </a:solidFill>
                 <a:latin typeface="Arial"/>
               </a:rPr>
-              <a:t>The table is the interferometer's, the one gauge scored on both front ends; the three sensors, scored on the mirror rig, read within 1 % and 2 pm of it on the same surface (the side-by-side slide).  The raw-map row is the station-by-station figure's number (run redo96_oapstn2); the lens rig's raw absolute map folds the phase (51 nm against the engine, backup) and is not scored, while its differential rows read as the mirror rig's.  Run tags are on the provenance slide and on each slide that derives a number.</a:t>
+              <a:t>The table is the interferometer's, the one gauge scored on both front ends; the three sensors, scored on the mirror rig, read within 1 % and 2 pm of it on the same surface (the side-by-side slide).  The raw-map row is the station-by-station figure's number (runs redo96_lensstn2, redo96_oapstn2), the four-step's sign set by a +50 nm push as on a real interferometer: the two rigs' polarization inputs give opposite fringe directions, which the matrix carries and an absolute map does not (the lens rig's earlier 51 nm 'fold' was the sign).  Run tags are on the provenance slide and on each slide that derives a number.</a:t>
             </a:r>
           </a:p>
         </p:txBody>

</xml_diff>

<commit_message>
deck_gauges (+ short): the hybrid's piezo four-step reads the 30 nm surface at gain 1.0000 / 0.01 pm on both rigs against the snapshot's 0.993 / 0.987 (350 / 463 pm) -- the raw-map error is the polarization snapshot's and the piezo leg is its calibration (Dave's question); slide 2 row, the form slide, the strips caption and the backup footnote carry it; interferometer strip now 8 columns
Co-Authored-By: Claude Fable 5.1 <noreply@anthropic.com>
</commit_message>
<xml_diff>
--- a/demo_session/deck_gauges.pptx
+++ b/demo_session/deck_gauges.pptx
@@ -4429,7 +4429,7 @@
                 </a:solidFill>
                 <a:latin typeface="Arial"/>
               </a:rPr>
-              <a:t> the test beam from the mirror interferes with the flat's beam; four frames at four phase steps give the phase at every pixel.  The snapshot form takes the four frames at once through polarization optics (no drift within a scan); the piezo form steps the flat in time (no polarization systematics).  Each removes the other's error.</a:t>
+              <a:t> the test beam from the mirror interferes with the flat's beam; four frames at four phase steps give the phase at every pixel.  The snapshot form takes the four frames at once through polarization optics (no drift within a scan); the piezo form steps the flat in time (no polarization systematics).  Each removes the other's error, measured: on the 30 nm surface the snapshot's raw map reads the engine's field at gain 0.993 (lenses) / 0.987 (mirrors), the piezo four-step at gain 1.0000, 0.01 pm (station figures) -- the piezo leg sets the snapshot's gain, the snapshot then reads every change without drift.</a:t>
             </a:r>
           </a:p>
           <a:p>
@@ -5149,8 +5149,8 @@
         </p:blipFill>
         <p:spPr>
           <a:xfrm>
-            <a:off x="1713761" y="1298448"/>
-            <a:ext cx="8764172" cy="2531872"/>
+            <a:off x="1226862" y="1298448"/>
+            <a:ext cx="9737969" cy="2531872"/>
           </a:xfrm>
           <a:prstGeom prst="rect">
             <a:avLst/>
@@ -5287,7 +5287,7 @@
                 </a:solidFill>
                 <a:latin typeface="Arial"/>
               </a:rPr>
-              <a:t>Run tag redo96_oapstn2 (the mirror rig; the DM's full-lattice 30 nm command, seed 7, the same surface in every station figure).  The lens rig's figure (redo96_lensstn2) reads 350 pm at gain 0.993 once the four-step's sign is set by a +50 nm push: the two rigs' polarization inputs ('collimated' on lenses, at the source on mirrors) give opposite fringe directions with the analyzer, so the lens rig's raw map came out as the negative of the surface (the 51 nm residual of the 09-17 figure was 2 x the surface, not a fold); every differential row carries the sign in its matrix and never saw it.</a:t>
+              <a:t>Run tag redo96_oapstn2 (the mirror rig; the DM's full-lattice 30 nm command, seed 7, the same surface in every station figure).  The lens rig's figure (redo96_lensstn2) reads 350 pm at gain 0.993 once the four-step's sign is set by a +50 nm push: the two rigs' polarization inputs ('collimated' on lenses, at the source on mirrors) give opposite fringe directions with the analyzer, so the lens rig's raw map came out as the negative of the surface (the 51 nm residual of the 09-17 figure was 2 x the surface, not a fold); every differential row carries the sign in its matrix and never saw it.  The eighth column is the hybrid's piezo four-step on the same frames' fields: 0.01 pm, gain 1.0000 on both rigs -- the snapshot's gain is a polarization term and the piezo leg is its calibration.</a:t>
             </a:r>
           </a:p>
         </p:txBody>
@@ -10826,7 +10826,7 @@
         <p:spPr>
           <a:xfrm>
             <a:off x="5212080" y="1060704"/>
-            <a:ext cx="6629400" cy="1225296"/>
+            <a:ext cx="6629400" cy="1124712"/>
           </a:xfrm>
           <a:prstGeom prst="rect">
             <a:avLst/>
@@ -10842,7 +10842,7 @@
         <p:spPr>
           <a:xfrm>
             <a:off x="228600" y="1170432"/>
-            <a:ext cx="3931920" cy="724408"/>
+            <a:ext cx="3931920" cy="889508"/>
           </a:xfrm>
           <a:prstGeom prst="rect">
             <a:avLst/>
@@ -10867,7 +10867,7 @@
                 </a:solidFill>
                 <a:latin typeface="Arial"/>
               </a:rPr>
-              <a:t>Interferometer (hybrid): the command; the test and reference arms at the camera; two of the four phase-stepped frames; the recovered surface, 25.8 nm rms; the raw map minus the engine's field, 463 pm, gain 0.987.</a:t>
+              <a:t>Interferometer (hybrid): the command; the test and reference arms at the camera; two of the four phase-stepped frames; the recovered surface, 25.8 nm rms; the snapshot's raw map minus the engine's field, 463 pm, gain 0.987; the piezo four-step's, 0.01 pm, gain 1.0000.</a:t>
             </a:r>
           </a:p>
         </p:txBody>
@@ -10888,7 +10888,7 @@
         </p:blipFill>
         <p:spPr>
           <a:xfrm>
-            <a:off x="5212080" y="2340864"/>
+            <a:off x="5212080" y="2240280"/>
             <a:ext cx="6629400" cy="1161288"/>
           </a:xfrm>
           <a:prstGeom prst="rect">
@@ -10904,7 +10904,7 @@
         </p:nvSpPr>
         <p:spPr>
           <a:xfrm>
-            <a:off x="228600" y="2450592"/>
+            <a:off x="228600" y="2350008"/>
             <a:ext cx="3931920" cy="889508"/>
           </a:xfrm>
           <a:prstGeom prst="rect">
@@ -10951,7 +10951,7 @@
         </p:blipFill>
         <p:spPr>
           <a:xfrm>
-            <a:off x="5212080" y="3557016"/>
+            <a:off x="5212080" y="3456432"/>
             <a:ext cx="6629400" cy="1143000"/>
           </a:xfrm>
           <a:prstGeom prst="rect">
@@ -10967,7 +10967,7 @@
         </p:nvSpPr>
         <p:spPr>
           <a:xfrm>
-            <a:off x="182880" y="3666744"/>
+            <a:off x="182880" y="3566160"/>
             <a:ext cx="3977639" cy="724408"/>
           </a:xfrm>
           <a:prstGeom prst="rect">
@@ -11014,7 +11014,7 @@
         </p:blipFill>
         <p:spPr>
           <a:xfrm>
-            <a:off x="5212080" y="4754880"/>
+            <a:off x="5212080" y="4654296"/>
             <a:ext cx="6629400" cy="1143000"/>
           </a:xfrm>
           <a:prstGeom prst="rect">
@@ -11030,7 +11030,7 @@
         </p:nvSpPr>
         <p:spPr>
           <a:xfrm>
-            <a:off x="182880" y="4864608"/>
+            <a:off x="182880" y="4764024"/>
             <a:ext cx="3977639" cy="724408"/>
           </a:xfrm>
           <a:prstGeom prst="rect">
@@ -11069,7 +11069,7 @@
         </p:nvSpPr>
         <p:spPr>
           <a:xfrm>
-            <a:off x="411480" y="5998464"/>
+            <a:off x="411480" y="5897880"/>
             <a:ext cx="11384280" cy="274320"/>
           </a:xfrm>
           <a:prstGeom prst="rect">
@@ -11126,7 +11126,7 @@
         </p:nvSpPr>
         <p:spPr>
           <a:xfrm>
-            <a:off x="411480" y="6455664"/>
+            <a:off x="411480" y="6355080"/>
             <a:ext cx="11384280" cy="274320"/>
           </a:xfrm>
           <a:prstGeom prst="rect">
@@ -14506,7 +14506,7 @@
         </p:nvGraphicFramePr>
         <p:xfrm>
           <a:off x="411480" y="1298448"/>
-          <a:ext cx="11368734" cy="2994660"/>
+          <a:ext cx="11368733" cy="2806065"/>
         </p:xfrm>
         <a:graphic>
           <a:graphicData uri="http://schemas.openxmlformats.org/drawingml/2006/table">
@@ -14515,10 +14515,10 @@
                 <a:tableStyleId>{5C22544A-7EE6-4342-B048-85BDC9FD1C3A}</a:tableStyleId>
               </a:tblPr>
               <a:tblGrid>
-                <a:gridCol w="1875344"/>
-                <a:gridCol w="5423294"/>
-                <a:gridCol w="2035048"/>
-                <a:gridCol w="2035048"/>
+                <a:gridCol w="1450493"/>
+                <a:gridCol w="6076392"/>
+                <a:gridCol w="1920924"/>
+                <a:gridCol w="1920924"/>
               </a:tblGrid>
               <a:tr h="468630">
                 <a:tc>
@@ -14725,7 +14725,7 @@
                           </a:solidFill>
                           <a:latin typeface="Arial"/>
                         </a:rPr>
-                        <a:t>the raw map of the 30 nm surface against the engine's field at the camera, before any calibration</a:t>
+                        <a:t>the raw map of the 30 nm surface against the engine's field at the camera, before any calibration: the polarization snapshot / the hybrid's piezo four-step</a:t>
                       </a:r>
                     </a:p>
                   </a:txBody>
@@ -14747,7 +14747,7 @@
                           </a:solidFill>
                           <a:latin typeface="Arial"/>
                         </a:rPr>
-                        <a:t>1.4 % (350 pm), gain 0.993</a:t>
+                        <a:t>1.4 % (350 pm), gain 0.993 / 0.01 pm, gain 1.0000</a:t>
                       </a:r>
                     </a:p>
                   </a:txBody>
@@ -14769,7 +14769,7 @@
                           </a:solidFill>
                           <a:latin typeface="Arial"/>
                         </a:rPr>
-                        <a:t>1.5 % (463 pm), gain 0.987</a:t>
+                        <a:t>1.5 % (463 pm), gain 0.987 / 0.01 pm, gain 1.0000</a:t>
                       </a:r>
                     </a:p>
                   </a:txBody>
@@ -14780,7 +14780,7 @@
                   </a:tcPr>
                 </a:tc>
               </a:tr>
-              <a:tr h="468630">
+              <a:tr h="280035">
                 <a:tc>
                   <a:txBody>
                     <a:bodyPr wrap="square"/>
@@ -15222,7 +15222,7 @@
         </p:nvSpPr>
         <p:spPr>
           <a:xfrm>
-            <a:off x="411480" y="4439412"/>
+            <a:off x="411480" y="4250817"/>
             <a:ext cx="11368735" cy="274320"/>
           </a:xfrm>
           <a:prstGeom prst="rect">
@@ -15242,7 +15242,7 @@
               </a:spcAft>
             </a:pPr>
             <a:r>
-              <a:rPr sz="1200" b="0">
+              <a:rPr sz="1100" b="0">
                 <a:solidFill>
                   <a:srgbClr val="282828"/>
                 </a:solidFill>
@@ -15251,7 +15251,7 @@
               <a:t>•  </a:t>
             </a:r>
             <a:r>
-              <a:rPr sz="1200" b="1">
+              <a:rPr sz="1100" b="1">
                 <a:solidFill>
                   <a:srgbClr val="282828"/>
                 </a:solidFill>
@@ -15260,16 +15260,16 @@
               <a:t>Picometer measurement is photon-limited, not bench-limited.</a:t>
             </a:r>
             <a:r>
-              <a:rPr sz="1200" b="0">
+              <a:rPr sz="1100" b="0">
                 <a:solidFill>
                   <a:srgbClr val="282828"/>
                 </a:solidFill>
                 <a:latin typeface="Arial"/>
               </a:rPr>
-              <a:t>  One measurement at 1e15 photons — 0.31 mJ, about 1.3 s of a 1 mW laser — repeats to 0.7 pm, and a servo fed at that rate holds under half a picometer.  Both front ends agree to within 10 %.  For scale, </a:t>
-            </a:r>
-            <a:r>
-              <a:rPr sz="1200" b="1">
+              <a:t>  One measurement at 1e15 photons — 0.31 mJ, 1.3 s of a 1 mW laser — repeats to 0.7 pm, and a servo fed at that rate holds under half a picometer; both front ends agree within 10 %.  For scale, </a:t>
+            </a:r>
+            <a:r>
+              <a:rPr sz="1100" b="1">
                 <a:solidFill>
                   <a:srgbClr val="282828"/>
                 </a:solidFill>
@@ -15278,13 +15278,13 @@
               <a:t>Steeves et al. (2020, Optica 7, 1267) demonstrate 1.6 pm in 4.3 s on a real interferometer</a:t>
             </a:r>
             <a:r>
-              <a:rPr sz="1200" b="0">
+              <a:rPr sz="1100" b="0">
                 <a:solidFill>
                   <a:srgbClr val="282828"/>
                 </a:solidFill>
                 <a:latin typeface="Arial"/>
               </a:rPr>
-              <a:t>: ours is photon-limited only, carrying no vibration, thermal drift or detector systematics, so it is the floor this design allows rather than a prediction of the built bench — and agreeing within a factor of two is the check that the model is in the right regime.</a:t>
+              <a:t>: ours is photon-limited only (no vibration, thermal drift or detector systematics), the floor this design allows rather than a prediction of the built bench; agreeing within a factor of two says the model is in the right regime.</a:t>
             </a:r>
           </a:p>
           <a:p>
@@ -15294,7 +15294,7 @@
               </a:spcAft>
             </a:pPr>
             <a:r>
-              <a:rPr sz="1200" b="0">
+              <a:rPr sz="1100" b="0">
                 <a:solidFill>
                   <a:srgbClr val="282828"/>
                 </a:solidFill>
@@ -15303,7 +15303,7 @@
               <a:t>•  </a:t>
             </a:r>
             <a:r>
-              <a:rPr sz="1200" b="1">
+              <a:rPr sz="1100" b="1">
                 <a:solidFill>
                   <a:srgbClr val="282828"/>
                 </a:solidFill>
@@ -15312,13 +15312,13 @@
               <a:t>Accuracy is a gain: systematic and proportional to the figure read.</a:t>
             </a:r>
             <a:r>
-              <a:rPr sz="1200" b="0">
+              <a:rPr sz="1100" b="0">
                 <a:solidFill>
                   <a:srgbClr val="282828"/>
                 </a:solidFill>
                 <a:latin typeface="Arial"/>
               </a:rPr>
-              <a:t>  Raw, the four-step reads the 30 nm surface 0.7 % low on lenses (350 pm) and 1.3 % low on mirrors (463 pm); through the matrix measured on the surface a 10 nm change reads at gain 1.004 on lenses and 0.986 on mirrors, with floors of 1.4 and 2.3 pm.  The pupil imaging is the smaller part (0.13 % / 0.29 %); the gain is the polarization snapshot's, and the matrix measured on the surface is what carries it.</a:t>
+              <a:t>  Raw, the four-step reads the 30 nm surface 0.7 % low on lenses (350 pm) and 1.3 % low on mirrors (463 pm); through the matrix measured on the surface a 10 nm change reads at gain 1.004 on lenses and 0.986 on mirrors, with floors of 1.4 and 2.3 pm.  The gain is the polarization snapshot's -- the hybrid's piezo four-step reads the same surface at gain 1.0000 against the engine, which is what its absolute-calibration leg is for -- and the matrix measured on the surface carries it; the pupil imaging is the smaller part (0.13 % / 0.29 %).</a:t>
             </a:r>
           </a:p>
           <a:p>
@@ -15328,7 +15328,7 @@
               </a:spcAft>
             </a:pPr>
             <a:r>
-              <a:rPr sz="1200" b="0">
+              <a:rPr sz="1100" b="0">
                 <a:solidFill>
                   <a:srgbClr val="282828"/>
                 </a:solidFill>
@@ -15337,7 +15337,7 @@
               <a:t>•  </a:t>
             </a:r>
             <a:r>
-              <a:rPr sz="1200" b="1">
+              <a:rPr sz="1100" b="1">
                 <a:solidFill>
                   <a:srgbClr val="282828"/>
                 </a:solidFill>
@@ -15346,7 +15346,7 @@
               <a:t>One disturbance is not photon-limited:</a:t>
             </a:r>
             <a:r>
-              <a:rPr sz="1200" b="0">
+              <a:rPr sz="1100" b="0">
                 <a:solidFill>
                   <a:srgbClr val="282828"/>
                 </a:solidFill>
@@ -15365,7 +15365,7 @@
         </p:nvSpPr>
         <p:spPr>
           <a:xfrm>
-            <a:off x="457200" y="6199632"/>
+            <a:off x="457200" y="6327648"/>
             <a:ext cx="11365992" cy="274320"/>
           </a:xfrm>
           <a:prstGeom prst="rect">
@@ -15391,7 +15391,7 @@
                 </a:solidFill>
                 <a:latin typeface="Arial"/>
               </a:rPr>
-              <a:t>The table is the interferometer's, the one gauge scored on both front ends; the three sensors, scored on the mirror rig, read within 1 % and 2 pm of it on the same surface (the side-by-side slide).  The raw-map row is the station-by-station figure's number (runs redo96_lensstn2, redo96_oapstn2), the four-step's sign set by a +50 nm push as on a real interferometer: the two rigs' polarization inputs give opposite fringe directions, which the matrix carries and an absolute map does not (the lens rig's earlier 51 nm 'fold' was the sign).  Run tags are on the provenance slide and on each slide that derives a number.</a:t>
+              <a:t>The table is the interferometer's, the one gauge scored on both front ends; the three sensors, scored on the mirror rig, read within 1 % and 2 pm of it (the side-by-side slide).  The raw-map rows are the station figures' (runs redo96_lensstn2, redo96_oapstn2), the snapshot's sign set by a +50 nm push: the two rigs' polarization inputs run the fringe opposite ways, which the matrix carries and an absolute map does not.  Run tags are on the provenance slide and on each slide that derives a number.</a:t>
             </a:r>
           </a:p>
         </p:txBody>

</xml_diff>